<commit_message>
Presentation: add 'A flaw of machine learning, or of the question?' slide (24) and script
Co-Authored-By: Claude Opus 5.5 <noreply@anthropic.com>
</commit_message>
<xml_diff>
--- a/presentation/SPY_Model_Presentation.pptx
+++ b/presentation/SPY_Model_Presentation.pptx
@@ -30,9 +30,10 @@
     <p:sldId id="278" r:id="rId24"/>
     <p:sldId id="279" r:id="rId25"/>
     <p:sldId id="280" r:id="rId26"/>
+    <p:sldId id="281" r:id="rId27"/>
   </p:sldIdLst>
   <p:notesMasterIdLst>
-    <p:notesMasterId r:id="rId27"/>
+    <p:notesMasterId r:id="rId28"/>
   </p:notesMasterIdLst>
   <p:sldSz cx="12192000" cy="6858000"/>
   <p:notesSz cx="6858000" cy="12192000"/>
@@ -131,7 +132,7 @@
   <p:extLst>
     <p:ext uri="{521415D9-36F7-43E2-AB2F-B90AF26B5E84}">
       <p14:sectionLst xmlns:p14="http://schemas.microsoft.com/office/powerpoint/2010/main">
-        <p14:section name="The question" id="{11e0b75e-bd86-5d9d-22b2-e7afaf5999c8}">
+        <p14:section name="The question" id="{a48fe4d6-686a-2ade-567e-e5558e8b0ae4}">
           <p14:sldIdLst>
             <p14:sldId id="256"/>
             <p14:sldId id="257"/>
@@ -140,7 +141,7 @@
             <p14:sldId id="260"/>
           </p14:sldIdLst>
         </p14:section>
-        <p14:section name="How the model works" id="{0fafce9b-ae75-184c-d592-584cb09dfc1b}">
+        <p14:section name="How the model works" id="{652dff78-8756-06b7-81b2-50b9b84ed9e6}">
           <p14:sldIdLst>
             <p14:sldId id="261"/>
             <p14:sldId id="262"/>
@@ -150,7 +151,7 @@
             <p14:sldId id="266"/>
           </p14:sldIdLst>
         </p14:section>
-        <p14:section name="What happened" id="{8a682346-2999-72b7-f3a2-866de0eccdba}">
+        <p14:section name="What happened" id="{d9fe69da-9cf8-52c8-1add-da88636d47da}">
           <p14:sldIdLst>
             <p14:sldId id="267"/>
             <p14:sldId id="268"/>
@@ -158,7 +159,7 @@
             <p14:sldId id="270"/>
           </p14:sldIdLst>
         </p14:section>
-        <p14:section name="Version 2" id="{51ab5132-9e7d-ae07-6e0a-188b36b004ed}">
+        <p14:section name="Version 2" id="{7e8a73f7-c95c-edf8-ed4f-b5f33d0e949d}">
           <p14:sldIdLst>
             <p14:sldId id="271"/>
             <p14:sldId id="272"/>
@@ -167,17 +168,18 @@
             <p14:sldId id="275"/>
           </p14:sldIdLst>
         </p14:section>
-        <p14:section name="Version 3" id="{94935d15-ec86-c074-2bfa-59fd3f3f3af9}">
+        <p14:section name="Version 3" id="{2239644b-4aa0-08fd-2857-4115fd8ed6ce}">
           <p14:sldIdLst>
             <p14:sldId id="276"/>
             <p14:sldId id="277"/>
             <p14:sldId id="278"/>
           </p14:sldIdLst>
         </p14:section>
-        <p14:section name="Wrap-up" id="{1beb2156-e078-46d5-66ef-14f2958e409e}">
+        <p14:section name="Wrap-up" id="{1e260044-1c85-ce86-2434-9ecf3bb5b72b}">
           <p14:sldIdLst>
             <p14:sldId id="279"/>
             <p14:sldId id="280"/>
+            <p14:sldId id="281"/>
           </p14:sldIdLst>
         </p14:section>
       </p14:sectionLst>
@@ -5472,6 +5474,94 @@
             <a:fld id="{F7021451-1387-4CA6-816F-3879F97B5CBC}" type="slidenum">
               <a:rPr lang="en-US"/>
               <a:t>25</a:t>
+            </a:fld>
+            <a:endParaRPr lang="en-US"/>
+          </a:p>
+        </p:txBody>
+      </p:sp>
+    </p:spTree>
+    <p:extLst>
+      <p:ext uri="{BB962C8B-B14F-4D97-AF65-F5344CB8AC3E}">
+        <p14:creationId xmlns:p14="http://schemas.microsoft.com/office/powerpoint/2010/main" val="1024086991"/>
+      </p:ext>
+    </p:extLst>
+  </p:cSld>
+  <p:clrMapOvr>
+    <a:masterClrMapping/>
+  </p:clrMapOvr>
+</p:notes>
+</file>
+
+<file path=ppt/notesSlides/notesSlide26.xml><?xml version="1.0" encoding="utf-8"?>
+<p:notes xmlns:a="http://schemas.openxmlformats.org/drawingml/2006/main" xmlns:r="http://schemas.openxmlformats.org/officeDocument/2006/relationships" xmlns:p="http://schemas.openxmlformats.org/presentationml/2006/main">
+  <p:cSld>
+    <p:spTree>
+      <p:nvGrpSpPr>
+        <p:cNvPr id="1" name=""/>
+        <p:cNvGrpSpPr/>
+        <p:nvPr/>
+      </p:nvGrpSpPr>
+      <p:grpSpPr>
+        <a:xfrm>
+          <a:off x="0" y="0"/>
+          <a:ext cx="0" cy="0"/>
+          <a:chOff x="0" y="0"/>
+          <a:chExt cx="0" cy="0"/>
+        </a:xfrm>
+      </p:grpSpPr>
+      <p:sp>
+        <p:nvSpPr>
+          <p:cNvPr id="2" name="Slide Image Placeholder 1"/>
+          <p:cNvSpPr>
+            <a:spLocks noGrp="1" noRot="1" noChangeAspect="1"/>
+          </p:cNvSpPr>
+          <p:nvPr>
+            <p:ph type="sldImg"/>
+          </p:nvPr>
+        </p:nvSpPr>
+        <p:spPr/>
+      </p:sp>
+      <p:sp>
+        <p:nvSpPr>
+          <p:cNvPr id="3" name="Notes Placeholder 2"/>
+          <p:cNvSpPr>
+            <a:spLocks noGrp="1"/>
+          </p:cNvSpPr>
+          <p:nvPr>
+            <p:ph type="body" idx="1"/>
+          </p:nvPr>
+        </p:nvSpPr>
+        <p:spPr/>
+        <p:txBody>
+          <a:bodyPr/>
+          <a:lstStyle/>
+          <a:p>
+            <a:r>
+              <a:rPr lang="en-US" dirty="0"/>
+              <a:t/>
+            </a:r>
+            <a:endParaRPr lang="en-US" dirty="0"/>
+          </a:p>
+        </p:txBody>
+      </p:sp>
+      <p:sp>
+        <p:nvSpPr>
+          <p:cNvPr id="4" name="Slide Number Placeholder 3"/>
+          <p:cNvSpPr>
+            <a:spLocks noGrp="1"/>
+          </p:cNvSpPr>
+          <p:nvPr>
+            <p:ph type="sldNum" sz="quarter" idx="10"/>
+          </p:nvPr>
+        </p:nvSpPr>
+        <p:spPr/>
+        <p:txBody>
+          <a:bodyPr/>
+          <a:lstStyle/>
+          <a:p>
+            <a:fld id="{F7021451-1387-4CA6-816F-3879F97B5CBC}" type="slidenum">
+              <a:rPr lang="en-US"/>
+              <a:t>26</a:t>
             </a:fld>
             <a:endParaRPr lang="en-US"/>
           </a:p>
@@ -16878,7 +16968,7 @@
                 <a:ea typeface="Cambria" pitchFamily="34" charset="-122"/>
                 <a:cs typeface="Cambria" pitchFamily="34" charset="-120"/>
               </a:rPr>
-              <a:t>What we learned</a:t>
+              <a:t>A flaw of machine learning, or of the question?</a:t>
             </a:r>
             <a:endParaRPr lang="en-US" sz="3200" dirty="0"/>
           </a:p>
@@ -16892,12 +16982,114 @@
         </p:nvSpPr>
         <p:spPr>
           <a:xfrm>
-            <a:off x="548640" y="1417320"/>
-            <a:ext cx="5468112" cy="2103120"/>
+            <a:off x="548640" y="1371600"/>
+            <a:ext cx="11094415" cy="1024128"/>
           </a:xfrm>
           <a:prstGeom prst="roundRect">
             <a:avLst>
-              <a:gd name="adj" fmla="val 5217"/>
+              <a:gd name="adj" fmla="val 8929"/>
+            </a:avLst>
+          </a:prstGeom>
+          <a:solidFill>
+            <a:srgbClr val="FBEDE4"/>
+          </a:solidFill>
+          <a:ln w="12700">
+            <a:solidFill>
+              <a:srgbClr val="FBEDE4"/>
+            </a:solidFill>
+            <a:prstDash val="solid"/>
+          </a:ln>
+        </p:spPr>
+      </p:sp>
+      <p:sp>
+        <p:nvSpPr>
+          <p:cNvPr id="4" name="Text 2"/>
+          <p:cNvSpPr txBox="1"/>
+          <p:nvPr/>
+        </p:nvSpPr>
+        <p:spPr>
+          <a:xfrm>
+            <a:off x="822960" y="1371600"/>
+            <a:ext cx="3291840" cy="1024128"/>
+          </a:xfrm>
+          <a:prstGeom prst="rect">
+            <a:avLst/>
+          </a:prstGeom>
+          <a:noFill/>
+          <a:ln/>
+        </p:spPr>
+        <p:txBody>
+          <a:bodyPr wrap="square" lIns="0" tIns="0" rIns="0" bIns="0" rtlCol="0" anchor="ctr"/>
+          <a:lstStyle/>
+          <a:p>
+            <a:pPr indent="0" marL="0">
+              <a:buNone/>
+            </a:pPr>
+            <a:r>
+              <a:rPr lang="en-US" sz="1900" b="1" dirty="0">
+                <a:solidFill>
+                  <a:schemeClr val="tx1"/>
+                </a:solidFill>
+                <a:latin typeface="Cambria" pitchFamily="34" charset="0"/>
+                <a:ea typeface="Cambria" pitchFamily="34" charset="-122"/>
+                <a:cs typeface="Cambria" pitchFamily="34" charset="-120"/>
+              </a:rPr>
+              <a:t>Mostly the question</a:t>
+            </a:r>
+            <a:endParaRPr lang="en-US" sz="1900" dirty="0"/>
+          </a:p>
+        </p:txBody>
+      </p:sp>
+      <p:sp>
+        <p:nvSpPr>
+          <p:cNvPr id="5" name="Text 3"/>
+          <p:cNvSpPr txBox="1"/>
+          <p:nvPr/>
+        </p:nvSpPr>
+        <p:spPr>
+          <a:xfrm>
+            <a:off x="4297680" y="1371600"/>
+            <a:ext cx="7116775" cy="1024128"/>
+          </a:xfrm>
+          <a:prstGeom prst="rect">
+            <a:avLst/>
+          </a:prstGeom>
+          <a:noFill/>
+          <a:ln/>
+        </p:spPr>
+        <p:txBody>
+          <a:bodyPr wrap="square" lIns="0" tIns="0" rIns="0" bIns="0" rtlCol="0" anchor="ctr"/>
+          <a:lstStyle/>
+          <a:p>
+            <a:pPr indent="0" marL="0">
+              <a:buNone/>
+            </a:pPr>
+            <a:r>
+              <a:rPr lang="en-US" sz="1600" dirty="0">
+                <a:solidFill>
+                  <a:schemeClr val="tx2"/>
+                </a:solidFill>
+              </a:rPr>
+              <a:t>We asked for next week’s direction of the world’s most-watched fund, using only its own public price history. Simple patterns there get traded away, and no algorithm can find information that isn’t in the data.</a:t>
+            </a:r>
+            <a:endParaRPr lang="en-US" sz="1600" dirty="0"/>
+          </a:p>
+        </p:txBody>
+      </p:sp>
+      <p:sp>
+        <p:nvSpPr>
+          <p:cNvPr id="6" name="Shape 4"/>
+          <p:cNvSpPr/>
+          <p:nvPr/>
+        </p:nvSpPr>
+        <p:spPr>
+          <a:xfrm>
+            <a:off x="548640" y="2514600"/>
+            <a:ext cx="11094415" cy="1024128"/>
+          </a:xfrm>
+          <a:prstGeom prst="roundRect">
+            <a:avLst>
+              <a:gd name="adj" fmla="val 8929"/>
             </a:avLst>
           </a:prstGeom>
           <a:solidFill>
@@ -16913,39 +17105,14 @@
       </p:sp>
       <p:sp>
         <p:nvSpPr>
-          <p:cNvPr id="4" name="Shape 2"/>
-          <p:cNvSpPr/>
-          <p:nvPr/>
-        </p:nvSpPr>
-        <p:spPr>
-          <a:xfrm>
-            <a:off x="777240" y="1645920"/>
-            <a:ext cx="438912" cy="438912"/>
-          </a:xfrm>
-          <a:prstGeom prst="ellipse">
-            <a:avLst/>
-          </a:prstGeom>
-          <a:solidFill>
-            <a:schemeClr val="accent1"/>
-          </a:solidFill>
-          <a:ln w="12700">
-            <a:solidFill>
-              <a:schemeClr val="accent1"/>
-            </a:solidFill>
-            <a:prstDash val="solid"/>
-          </a:ln>
-        </p:spPr>
-      </p:sp>
-      <p:sp>
-        <p:nvSpPr>
-          <p:cNvPr id="5" name="Text 3"/>
+          <p:cNvPr id="7" name="Text 5"/>
           <p:cNvSpPr txBox="1"/>
           <p:nvPr/>
         </p:nvSpPr>
         <p:spPr>
           <a:xfrm>
-            <a:off x="777240" y="1645920"/>
-            <a:ext cx="438912" cy="438912"/>
+            <a:off x="822960" y="2514600"/>
+            <a:ext cx="3291840" cy="1024128"/>
           </a:xfrm>
           <a:prstGeom prst="rect">
             <a:avLst/>
@@ -16957,47 +17124,11 @@
           <a:bodyPr wrap="square" lIns="0" tIns="0" rIns="0" bIns="0" rtlCol="0" anchor="ctr"/>
           <a:lstStyle/>
           <a:p>
-            <a:pPr algn="ctr" indent="0" marL="0">
-              <a:buNone/>
-            </a:pPr>
-            <a:r>
-              <a:rPr lang="en-US" sz="1600" b="1" dirty="0">
-                <a:solidFill>
-                  <a:schemeClr val="bg1"/>
-                </a:solidFill>
-              </a:rPr>
-              <a:t>1</a:t>
-            </a:r>
-            <a:endParaRPr lang="en-US" sz="1600" dirty="0"/>
-          </a:p>
-        </p:txBody>
-      </p:sp>
-      <p:sp>
-        <p:nvSpPr>
-          <p:cNvPr id="6" name="Text 4"/>
-          <p:cNvSpPr txBox="1"/>
-          <p:nvPr/>
-        </p:nvSpPr>
-        <p:spPr>
-          <a:xfrm>
-            <a:off x="1371600" y="1645920"/>
-            <a:ext cx="4416552" cy="594360"/>
-          </a:xfrm>
-          <a:prstGeom prst="rect">
-            <a:avLst/>
-          </a:prstGeom>
-          <a:noFill/>
-          <a:ln/>
-        </p:spPr>
-        <p:txBody>
-          <a:bodyPr wrap="square" lIns="0" tIns="0" rIns="0" bIns="0" rtlCol="0" anchor="ctr"/>
-          <a:lstStyle/>
-          <a:p>
             <a:pPr indent="0" marL="0">
               <a:buNone/>
             </a:pPr>
             <a:r>
-              <a:rPr lang="en-US" sz="1800" b="1" dirty="0">
+              <a:rPr lang="en-US" sz="1900" b="1" dirty="0">
                 <a:solidFill>
                   <a:schemeClr val="tx1"/>
                 </a:solidFill>
@@ -17005,31 +17136,31 @@
                 <a:ea typeface="Cambria" pitchFamily="34" charset="-122"/>
                 <a:cs typeface="Cambria" pitchFamily="34" charset="-120"/>
               </a:rPr>
-              <a:t>Size is predictable; direction isn’t</a:t>
-            </a:r>
-            <a:endParaRPr lang="en-US" sz="1800" dirty="0"/>
-          </a:p>
-        </p:txBody>
-      </p:sp>
-      <p:sp>
-        <p:nvSpPr>
-          <p:cNvPr id="7" name="Text 5"/>
+              <a:t>Partly our own limits</a:t>
+            </a:r>
+            <a:endParaRPr lang="en-US" sz="1900" dirty="0"/>
+          </a:p>
+        </p:txBody>
+      </p:sp>
+      <p:sp>
+        <p:nvSpPr>
+          <p:cNvPr id="8" name="Text 6"/>
           <p:cNvSpPr txBox="1"/>
           <p:nvPr/>
         </p:nvSpPr>
         <p:spPr>
           <a:xfrm>
-            <a:off x="777240" y="2350008"/>
-            <a:ext cx="5010912" cy="987552"/>
-          </a:xfrm>
-          <a:prstGeom prst="rect">
-            <a:avLst/>
-          </a:prstGeom>
-          <a:noFill/>
-          <a:ln/>
-        </p:spPr>
-        <p:txBody>
-          <a:bodyPr wrap="square" lIns="0" tIns="0" rIns="0" bIns="0" rtlCol="0" anchor="t"/>
+            <a:off x="4297680" y="2514600"/>
+            <a:ext cx="7116775" cy="1024128"/>
+          </a:xfrm>
+          <a:prstGeom prst="rect">
+            <a:avLst/>
+          </a:prstGeom>
+          <a:noFill/>
+          <a:ln/>
+        </p:spPr>
+        <p:txBody>
+          <a:bodyPr wrap="square" lIns="0" tIns="0" rIns="0" bIns="0" rtlCol="0" anchor="ctr"/>
           <a:lstStyle/>
           <a:p>
             <a:pPr indent="0" marL="0">
@@ -17041,7 +17172,7 @@
                   <a:schemeClr val="tx2"/>
                 </a:solidFill>
               </a:rPr>
-              <a:t>Big-move weeks cluster together, so the model can see them coming. Which way they go is close to a coin flip.</a:t>
+              <a:t>One fund, all in or all out, price data only, a one-week horizon. Lifting these makes the task easier, but wouldn’t flip the result: even with zero fees, v1 still lost.</a:t>
             </a:r>
             <a:endParaRPr lang="en-US" sz="1600" dirty="0"/>
           </a:p>
@@ -17049,18 +17180,18 @@
       </p:sp>
       <p:sp>
         <p:nvSpPr>
-          <p:cNvPr id="8" name="Shape 6"/>
+          <p:cNvPr id="9" name="Shape 7"/>
           <p:cNvSpPr/>
           <p:nvPr/>
         </p:nvSpPr>
         <p:spPr>
           <a:xfrm>
-            <a:off x="6172200" y="1417320"/>
-            <a:ext cx="5468112" cy="2103120"/>
+            <a:off x="548640" y="3657600"/>
+            <a:ext cx="11094415" cy="1024128"/>
           </a:xfrm>
           <a:prstGeom prst="roundRect">
             <a:avLst>
-              <a:gd name="adj" fmla="val 5217"/>
+              <a:gd name="adj" fmla="val 8929"/>
             </a:avLst>
           </a:prstGeom>
           <a:solidFill>
@@ -17076,39 +17207,14 @@
       </p:sp>
       <p:sp>
         <p:nvSpPr>
-          <p:cNvPr id="9" name="Shape 7"/>
-          <p:cNvSpPr/>
-          <p:nvPr/>
-        </p:nvSpPr>
-        <p:spPr>
-          <a:xfrm>
-            <a:off x="6400800" y="1645920"/>
-            <a:ext cx="438912" cy="438912"/>
-          </a:xfrm>
-          <a:prstGeom prst="ellipse">
-            <a:avLst/>
-          </a:prstGeom>
-          <a:solidFill>
-            <a:schemeClr val="accent1"/>
-          </a:solidFill>
-          <a:ln w="12700">
-            <a:solidFill>
-              <a:schemeClr val="accent1"/>
-            </a:solidFill>
-            <a:prstDash val="solid"/>
-          </a:ln>
-        </p:spPr>
-      </p:sp>
-      <p:sp>
-        <p:nvSpPr>
           <p:cNvPr id="10" name="Text 8"/>
           <p:cNvSpPr txBox="1"/>
           <p:nvPr/>
         </p:nvSpPr>
         <p:spPr>
           <a:xfrm>
-            <a:off x="6400800" y="1645920"/>
-            <a:ext cx="438912" cy="438912"/>
+            <a:off x="822960" y="3657600"/>
+            <a:ext cx="3291840" cy="1024128"/>
           </a:xfrm>
           <a:prstGeom prst="rect">
             <a:avLst/>
@@ -17120,47 +17226,11 @@
           <a:bodyPr wrap="square" lIns="0" tIns="0" rIns="0" bIns="0" rtlCol="0" anchor="ctr"/>
           <a:lstStyle/>
           <a:p>
-            <a:pPr algn="ctr" indent="0" marL="0">
-              <a:buNone/>
-            </a:pPr>
-            <a:r>
-              <a:rPr lang="en-US" sz="1600" b="1" dirty="0">
-                <a:solidFill>
-                  <a:schemeClr val="bg1"/>
-                </a:solidFill>
-              </a:rPr>
-              <a:t>2</a:t>
-            </a:r>
-            <a:endParaRPr lang="en-US" sz="1600" dirty="0"/>
-          </a:p>
-        </p:txBody>
-      </p:sp>
-      <p:sp>
-        <p:nvSpPr>
-          <p:cNvPr id="11" name="Text 9"/>
-          <p:cNvSpPr txBox="1"/>
-          <p:nvPr/>
-        </p:nvSpPr>
-        <p:spPr>
-          <a:xfrm>
-            <a:off x="6995160" y="1645920"/>
-            <a:ext cx="4416552" cy="438912"/>
-          </a:xfrm>
-          <a:prstGeom prst="rect">
-            <a:avLst/>
-          </a:prstGeom>
-          <a:noFill/>
-          <a:ln/>
-        </p:spPr>
-        <p:txBody>
-          <a:bodyPr wrap="square" lIns="0" tIns="0" rIns="0" bIns="0" rtlCol="0" anchor="ctr"/>
-          <a:lstStyle/>
-          <a:p>
             <a:pPr indent="0" marL="0">
               <a:buNone/>
             </a:pPr>
             <a:r>
-              <a:rPr lang="en-US" sz="1800" b="1" dirty="0">
+              <a:rPr lang="en-US" sz="1900" b="1" dirty="0">
                 <a:solidFill>
                   <a:schemeClr val="tx1"/>
                 </a:solidFill>
@@ -17168,31 +17238,31 @@
                 <a:ea typeface="Cambria" pitchFamily="34" charset="-122"/>
                 <a:cs typeface="Cambria" pitchFamily="34" charset="-120"/>
               </a:rPr>
-              <a:t>Sitting in cash has a cost</a:t>
-            </a:r>
-            <a:endParaRPr lang="en-US" sz="1800" dirty="0"/>
-          </a:p>
-        </p:txBody>
-      </p:sp>
-      <p:sp>
-        <p:nvSpPr>
-          <p:cNvPr id="12" name="Text 10"/>
+              <a:t>Where machine learning does help</a:t>
+            </a:r>
+            <a:endParaRPr lang="en-US" sz="1900" dirty="0"/>
+          </a:p>
+        </p:txBody>
+      </p:sp>
+      <p:sp>
+        <p:nvSpPr>
+          <p:cNvPr id="11" name="Text 9"/>
           <p:cNvSpPr txBox="1"/>
           <p:nvPr/>
         </p:nvSpPr>
         <p:spPr>
           <a:xfrm>
-            <a:off x="6400800" y="2194560"/>
-            <a:ext cx="5010912" cy="1143000"/>
-          </a:xfrm>
-          <a:prstGeom prst="rect">
-            <a:avLst/>
-          </a:prstGeom>
-          <a:noFill/>
-          <a:ln/>
-        </p:spPr>
-        <p:txBody>
-          <a:bodyPr wrap="square" lIns="0" tIns="0" rIns="0" bIns="0" rtlCol="0" anchor="t"/>
+            <a:off x="4297680" y="3657600"/>
+            <a:ext cx="7116775" cy="1024128"/>
+          </a:xfrm>
+          <a:prstGeom prst="rect">
+            <a:avLst/>
+          </a:prstGeom>
+          <a:noFill/>
+          <a:ln/>
+        </p:spPr>
+        <p:txBody>
+          <a:bodyPr wrap="square" lIns="0" tIns="0" rIns="0" bIns="0" rtlCol="0" anchor="ctr"/>
           <a:lstStyle/>
           <a:p>
             <a:pPr indent="0" marL="0">
@@ -17204,7 +17274,7 @@
                   <a:schemeClr val="tx2"/>
                 </a:solidFill>
               </a:rPr>
-              <a:t>The market mostly goes up. Without real timing skill, every day out of the market loses money on average.</a:t>
+              <a:t>Ranking many assets against each other, forecasting risk to size positions, and using data most people don’t have. Even there the edges are usually small and shrink after costs.</a:t>
             </a:r>
             <a:endParaRPr lang="en-US" sz="1600" dirty="0"/>
           </a:p>
@@ -17212,18 +17282,18 @@
       </p:sp>
       <p:sp>
         <p:nvSpPr>
-          <p:cNvPr id="13" name="Shape 11"/>
+          <p:cNvPr id="12" name="Shape 10"/>
           <p:cNvSpPr/>
           <p:nvPr/>
         </p:nvSpPr>
         <p:spPr>
           <a:xfrm>
-            <a:off x="548640" y="3703320"/>
-            <a:ext cx="5468112" cy="2103120"/>
+            <a:off x="548640" y="4800600"/>
+            <a:ext cx="11094415" cy="1024128"/>
           </a:xfrm>
           <a:prstGeom prst="roundRect">
             <a:avLst>
-              <a:gd name="adj" fmla="val 5217"/>
+              <a:gd name="adj" fmla="val 8929"/>
             </a:avLst>
           </a:prstGeom>
           <a:solidFill>
@@ -17239,39 +17309,14 @@
       </p:sp>
       <p:sp>
         <p:nvSpPr>
-          <p:cNvPr id="14" name="Shape 12"/>
-          <p:cNvSpPr/>
-          <p:nvPr/>
-        </p:nvSpPr>
-        <p:spPr>
-          <a:xfrm>
-            <a:off x="777240" y="3931920"/>
-            <a:ext cx="438912" cy="438912"/>
-          </a:xfrm>
-          <a:prstGeom prst="ellipse">
-            <a:avLst/>
-          </a:prstGeom>
-          <a:solidFill>
-            <a:schemeClr val="accent1"/>
-          </a:solidFill>
-          <a:ln w="12700">
-            <a:solidFill>
-              <a:schemeClr val="accent1"/>
-            </a:solidFill>
-            <a:prstDash val="solid"/>
-          </a:ln>
-        </p:spPr>
-      </p:sp>
-      <p:sp>
-        <p:nvSpPr>
-          <p:cNvPr id="15" name="Text 13"/>
+          <p:cNvPr id="13" name="Text 11"/>
           <p:cNvSpPr txBox="1"/>
           <p:nvPr/>
         </p:nvSpPr>
         <p:spPr>
           <a:xfrm>
-            <a:off x="777240" y="3931920"/>
-            <a:ext cx="438912" cy="438912"/>
+            <a:off x="822960" y="4800600"/>
+            <a:ext cx="3291840" cy="1024128"/>
           </a:xfrm>
           <a:prstGeom prst="rect">
             <a:avLst/>
@@ -17283,47 +17328,11 @@
           <a:bodyPr wrap="square" lIns="0" tIns="0" rIns="0" bIns="0" rtlCol="0" anchor="ctr"/>
           <a:lstStyle/>
           <a:p>
-            <a:pPr algn="ctr" indent="0" marL="0">
-              <a:buNone/>
-            </a:pPr>
-            <a:r>
-              <a:rPr lang="en-US" sz="1600" b="1" dirty="0">
-                <a:solidFill>
-                  <a:schemeClr val="bg1"/>
-                </a:solidFill>
-              </a:rPr>
-              <a:t>3</a:t>
-            </a:r>
-            <a:endParaRPr lang="en-US" sz="1600" dirty="0"/>
-          </a:p>
-        </p:txBody>
-      </p:sp>
-      <p:sp>
-        <p:nvSpPr>
-          <p:cNvPr id="16" name="Text 14"/>
-          <p:cNvSpPr txBox="1"/>
-          <p:nvPr/>
-        </p:nvSpPr>
-        <p:spPr>
-          <a:xfrm>
-            <a:off x="1371600" y="3931920"/>
-            <a:ext cx="4416552" cy="438912"/>
-          </a:xfrm>
-          <a:prstGeom prst="rect">
-            <a:avLst/>
-          </a:prstGeom>
-          <a:noFill/>
-          <a:ln/>
-        </p:spPr>
-        <p:txBody>
-          <a:bodyPr wrap="square" lIns="0" tIns="0" rIns="0" bIns="0" rtlCol="0" anchor="ctr"/>
-          <a:lstStyle/>
-          <a:p>
             <a:pPr indent="0" marL="0">
               <a:buNone/>
             </a:pPr>
             <a:r>
-              <a:rPr lang="en-US" sz="1800" b="1" dirty="0">
+              <a:rPr lang="en-US" sz="1900" b="1" dirty="0">
                 <a:solidFill>
                   <a:schemeClr val="tx1"/>
                 </a:solidFill>
@@ -17331,31 +17340,31 @@
                 <a:ea typeface="Cambria" pitchFamily="34" charset="-122"/>
                 <a:cs typeface="Cambria" pitchFamily="34" charset="-120"/>
               </a:rPr>
-              <a:t>The past changes</a:t>
-            </a:r>
-            <a:endParaRPr lang="en-US" sz="1800" dirty="0"/>
-          </a:p>
-        </p:txBody>
-      </p:sp>
-      <p:sp>
-        <p:nvSpPr>
-          <p:cNvPr id="17" name="Text 15"/>
+              <a:t>The fair bar</a:t>
+            </a:r>
+            <a:endParaRPr lang="en-US" sz="1900" dirty="0"/>
+          </a:p>
+        </p:txBody>
+      </p:sp>
+      <p:sp>
+        <p:nvSpPr>
+          <p:cNvPr id="14" name="Text 12"/>
           <p:cNvSpPr txBox="1"/>
           <p:nvPr/>
         </p:nvSpPr>
         <p:spPr>
           <a:xfrm>
-            <a:off x="777240" y="4480560"/>
-            <a:ext cx="5010912" cy="1143000"/>
-          </a:xfrm>
-          <a:prstGeom prst="rect">
-            <a:avLst/>
-          </a:prstGeom>
-          <a:noFill/>
-          <a:ln/>
-        </p:spPr>
-        <p:txBody>
-          <a:bodyPr wrap="square" lIns="0" tIns="0" rIns="0" bIns="0" rtlCol="0" anchor="t"/>
+            <a:off x="4297680" y="4800600"/>
+            <a:ext cx="7116775" cy="1024128"/>
+          </a:xfrm>
+          <a:prstGeom prst="rect">
+            <a:avLst/>
+          </a:prstGeom>
+          <a:noFill/>
+          <a:ln/>
+        </p:spPr>
+        <p:txBody>
+          <a:bodyPr wrap="square" lIns="0" tIns="0" rIns="0" bIns="0" rtlCol="0" anchor="ctr"/>
           <a:lstStyle/>
           <a:p>
             <a:pPr indent="0" marL="0">
@@ -17367,170 +17376,7 @@
                   <a:schemeClr val="tx2"/>
                 </a:solidFill>
               </a:rPr>
-              <a:t>A signal that helped from 2010 to 2020 actually misled the model in 2022.</a:t>
-            </a:r>
-            <a:endParaRPr lang="en-US" sz="1600" dirty="0"/>
-          </a:p>
-        </p:txBody>
-      </p:sp>
-      <p:sp>
-        <p:nvSpPr>
-          <p:cNvPr id="18" name="Shape 16"/>
-          <p:cNvSpPr/>
-          <p:nvPr/>
-        </p:nvSpPr>
-        <p:spPr>
-          <a:xfrm>
-            <a:off x="6172200" y="3703320"/>
-            <a:ext cx="5468112" cy="2103120"/>
-          </a:xfrm>
-          <a:prstGeom prst="roundRect">
-            <a:avLst>
-              <a:gd name="adj" fmla="val 5217"/>
-            </a:avLst>
-          </a:prstGeom>
-          <a:solidFill>
-            <a:schemeClr val="bg2"/>
-          </a:solidFill>
-          <a:ln w="12700">
-            <a:solidFill>
-              <a:schemeClr val="bg2"/>
-            </a:solidFill>
-            <a:prstDash val="solid"/>
-          </a:ln>
-        </p:spPr>
-      </p:sp>
-      <p:sp>
-        <p:nvSpPr>
-          <p:cNvPr id="19" name="Shape 17"/>
-          <p:cNvSpPr/>
-          <p:nvPr/>
-        </p:nvSpPr>
-        <p:spPr>
-          <a:xfrm>
-            <a:off x="6400800" y="3931920"/>
-            <a:ext cx="438912" cy="438912"/>
-          </a:xfrm>
-          <a:prstGeom prst="ellipse">
-            <a:avLst/>
-          </a:prstGeom>
-          <a:solidFill>
-            <a:schemeClr val="accent1"/>
-          </a:solidFill>
-          <a:ln w="12700">
-            <a:solidFill>
-              <a:schemeClr val="accent1"/>
-            </a:solidFill>
-            <a:prstDash val="solid"/>
-          </a:ln>
-        </p:spPr>
-      </p:sp>
-      <p:sp>
-        <p:nvSpPr>
-          <p:cNvPr id="20" name="Text 18"/>
-          <p:cNvSpPr txBox="1"/>
-          <p:nvPr/>
-        </p:nvSpPr>
-        <p:spPr>
-          <a:xfrm>
-            <a:off x="6400800" y="3931920"/>
-            <a:ext cx="438912" cy="438912"/>
-          </a:xfrm>
-          <a:prstGeom prst="rect">
-            <a:avLst/>
-          </a:prstGeom>
-          <a:noFill/>
-          <a:ln/>
-        </p:spPr>
-        <p:txBody>
-          <a:bodyPr wrap="square" lIns="0" tIns="0" rIns="0" bIns="0" rtlCol="0" anchor="ctr"/>
-          <a:lstStyle/>
-          <a:p>
-            <a:pPr algn="ctr" indent="0" marL="0">
-              <a:buNone/>
-            </a:pPr>
-            <a:r>
-              <a:rPr lang="en-US" sz="1600" b="1" dirty="0">
-                <a:solidFill>
-                  <a:schemeClr val="bg1"/>
-                </a:solidFill>
-              </a:rPr>
-              <a:t>4</a:t>
-            </a:r>
-            <a:endParaRPr lang="en-US" sz="1600" dirty="0"/>
-          </a:p>
-        </p:txBody>
-      </p:sp>
-      <p:sp>
-        <p:nvSpPr>
-          <p:cNvPr id="21" name="Text 19"/>
-          <p:cNvSpPr txBox="1"/>
-          <p:nvPr/>
-        </p:nvSpPr>
-        <p:spPr>
-          <a:xfrm>
-            <a:off x="6995160" y="3931920"/>
-            <a:ext cx="4416552" cy="438912"/>
-          </a:xfrm>
-          <a:prstGeom prst="rect">
-            <a:avLst/>
-          </a:prstGeom>
-          <a:noFill/>
-          <a:ln/>
-        </p:spPr>
-        <p:txBody>
-          <a:bodyPr wrap="square" lIns="0" tIns="0" rIns="0" bIns="0" rtlCol="0" anchor="ctr"/>
-          <a:lstStyle/>
-          <a:p>
-            <a:pPr indent="0" marL="0">
-              <a:buNone/>
-            </a:pPr>
-            <a:r>
-              <a:rPr lang="en-US" sz="1800" b="1" dirty="0">
-                <a:solidFill>
-                  <a:schemeClr val="tx1"/>
-                </a:solidFill>
-                <a:latin typeface="Cambria" pitchFamily="34" charset="0"/>
-                <a:ea typeface="Cambria" pitchFamily="34" charset="-122"/>
-                <a:cs typeface="Cambria" pitchFamily="34" charset="-120"/>
-              </a:rPr>
-              <a:t>Good predictions ≠ good trades</a:t>
-            </a:r>
-            <a:endParaRPr lang="en-US" sz="1800" dirty="0"/>
-          </a:p>
-        </p:txBody>
-      </p:sp>
-      <p:sp>
-        <p:nvSpPr>
-          <p:cNvPr id="22" name="Text 20"/>
-          <p:cNvSpPr txBox="1"/>
-          <p:nvPr/>
-        </p:nvSpPr>
-        <p:spPr>
-          <a:xfrm>
-            <a:off x="6400800" y="4480560"/>
-            <a:ext cx="5010912" cy="1143000"/>
-          </a:xfrm>
-          <a:prstGeom prst="rect">
-            <a:avLst/>
-          </a:prstGeom>
-          <a:noFill/>
-          <a:ln/>
-        </p:spPr>
-        <p:txBody>
-          <a:bodyPr wrap="square" lIns="0" tIns="0" rIns="0" bIns="0" rtlCol="0" anchor="t"/>
-          <a:lstStyle/>
-          <a:p>
-            <a:pPr indent="0" marL="0">
-              <a:buNone/>
-            </a:pPr>
-            <a:r>
-              <a:rPr lang="en-US" sz="1600" dirty="0">
-                <a:solidFill>
-                  <a:schemeClr val="tx2"/>
-                </a:solidFill>
-              </a:rPr>
-              <a:t>Settings that improve the prediction score can distort the odds a trading rule relies on. With honest odds (v3), the best rule was not to trade.</a:t>
+              <a:t>Return for the risk taken, and beating random timing — not simply “more money than Buy &amp; Hold”. That is how we judged every version.</a:t>
             </a:r>
             <a:endParaRPr lang="en-US" sz="1600" dirty="0"/>
           </a:p>
@@ -17616,100 +17462,686 @@
         </p:nvSpPr>
         <p:spPr>
           <a:xfrm>
-            <a:off x="548640" y="1097280"/>
-            <a:ext cx="10789920" cy="2560320"/>
-          </a:xfrm>
-          <a:prstGeom prst="rect">
-            <a:avLst/>
-          </a:prstGeom>
-          <a:noFill/>
-          <a:ln/>
-        </p:spPr>
-        <p:txBody>
-          <a:bodyPr wrap="square" rtlCol="0" anchor="b"/>
+            <a:off x="548640" y="365760"/>
+            <a:ext cx="11094415" cy="822960"/>
+          </a:xfrm>
+          <a:prstGeom prst="rect">
+            <a:avLst/>
+          </a:prstGeom>
+          <a:noFill/>
+          <a:ln/>
+        </p:spPr>
+        <p:txBody>
+          <a:bodyPr wrap="square" rtlCol="0" anchor="ctr"/>
           <a:lstStyle/>
           <a:p>
             <a:pPr indent="0" marL="0">
               <a:buNone/>
             </a:pPr>
             <a:r>
-              <a:rPr lang="en-US" sz="4000" b="1" dirty="0">
-                <a:solidFill>
-                  <a:schemeClr val="bg1"/>
+              <a:rPr lang="en-US" sz="3200" b="1" dirty="0">
+                <a:solidFill>
+                  <a:schemeClr val="tx1"/>
                 </a:solidFill>
                 <a:latin typeface="Cambria" pitchFamily="34" charset="0"/>
                 <a:ea typeface="Cambria" pitchFamily="34" charset="-122"/>
                 <a:cs typeface="Cambria" pitchFamily="34" charset="-120"/>
               </a:rPr>
-              <a:t>Questions?</a:t>
-            </a:r>
-            <a:endParaRPr lang="en-US" sz="4000" dirty="0"/>
-          </a:p>
-        </p:txBody>
-      </p:sp>
-      <p:sp>
-        <p:nvSpPr>
-          <p:cNvPr id="3" name="Text 0"/>
+              <a:t>What we learned</a:t>
+            </a:r>
+            <a:endParaRPr lang="en-US" sz="3200" dirty="0"/>
+          </a:p>
+        </p:txBody>
+      </p:sp>
+      <p:sp>
+        <p:nvSpPr>
+          <p:cNvPr id="3" name="Shape 1"/>
           <p:cNvSpPr/>
-          <p:nvPr>
-            <p:ph idx="101" type="body" hasCustomPrompt="1"/>
-          </p:nvPr>
-        </p:nvSpPr>
-        <p:spPr>
-          <a:xfrm>
-            <a:off x="548640" y="3931920"/>
-            <a:ext cx="10424160" cy="2103120"/>
-          </a:xfrm>
-          <a:prstGeom prst="rect">
-            <a:avLst/>
-          </a:prstGeom>
-          <a:noFill/>
-          <a:ln/>
-        </p:spPr>
-        <p:txBody>
-          <a:bodyPr wrap="square" rtlCol="0" anchor="t"/>
+          <p:nvPr/>
+        </p:nvSpPr>
+        <p:spPr>
+          <a:xfrm>
+            <a:off x="548640" y="1417320"/>
+            <a:ext cx="5468112" cy="2103120"/>
+          </a:xfrm>
+          <a:prstGeom prst="roundRect">
+            <a:avLst>
+              <a:gd name="adj" fmla="val 5217"/>
+            </a:avLst>
+          </a:prstGeom>
+          <a:solidFill>
+            <a:schemeClr val="bg2"/>
+          </a:solidFill>
+          <a:ln w="12700">
+            <a:solidFill>
+              <a:schemeClr val="bg2"/>
+            </a:solidFill>
+            <a:prstDash val="solid"/>
+          </a:ln>
+        </p:spPr>
+      </p:sp>
+      <p:sp>
+        <p:nvSpPr>
+          <p:cNvPr id="4" name="Shape 2"/>
+          <p:cNvSpPr/>
+          <p:nvPr/>
+        </p:nvSpPr>
+        <p:spPr>
+          <a:xfrm>
+            <a:off x="777240" y="1645920"/>
+            <a:ext cx="438912" cy="438912"/>
+          </a:xfrm>
+          <a:prstGeom prst="ellipse">
+            <a:avLst/>
+          </a:prstGeom>
+          <a:solidFill>
+            <a:schemeClr val="accent1"/>
+          </a:solidFill>
+          <a:ln w="12700">
+            <a:solidFill>
+              <a:schemeClr val="accent1"/>
+            </a:solidFill>
+            <a:prstDash val="solid"/>
+          </a:ln>
+        </p:spPr>
+      </p:sp>
+      <p:sp>
+        <p:nvSpPr>
+          <p:cNvPr id="5" name="Text 3"/>
+          <p:cNvSpPr txBox="1"/>
+          <p:nvPr/>
+        </p:nvSpPr>
+        <p:spPr>
+          <a:xfrm>
+            <a:off x="777240" y="1645920"/>
+            <a:ext cx="438912" cy="438912"/>
+          </a:xfrm>
+          <a:prstGeom prst="rect">
+            <a:avLst/>
+          </a:prstGeom>
+          <a:noFill/>
+          <a:ln/>
+        </p:spPr>
+        <p:txBody>
+          <a:bodyPr wrap="square" lIns="0" tIns="0" rIns="0" bIns="0" rtlCol="0" anchor="ctr"/>
+          <a:lstStyle/>
+          <a:p>
+            <a:pPr algn="ctr" indent="0" marL="0">
+              <a:buNone/>
+            </a:pPr>
+            <a:r>
+              <a:rPr lang="en-US" sz="1600" b="1" dirty="0">
+                <a:solidFill>
+                  <a:schemeClr val="bg1"/>
+                </a:solidFill>
+              </a:rPr>
+              <a:t>1</a:t>
+            </a:r>
+            <a:endParaRPr lang="en-US" sz="1600" dirty="0"/>
+          </a:p>
+        </p:txBody>
+      </p:sp>
+      <p:sp>
+        <p:nvSpPr>
+          <p:cNvPr id="6" name="Text 4"/>
+          <p:cNvSpPr txBox="1"/>
+          <p:nvPr/>
+        </p:nvSpPr>
+        <p:spPr>
+          <a:xfrm>
+            <a:off x="1371600" y="1645920"/>
+            <a:ext cx="4416552" cy="594360"/>
+          </a:xfrm>
+          <a:prstGeom prst="rect">
+            <a:avLst/>
+          </a:prstGeom>
+          <a:noFill/>
+          <a:ln/>
+        </p:spPr>
+        <p:txBody>
+          <a:bodyPr wrap="square" lIns="0" tIns="0" rIns="0" bIns="0" rtlCol="0" anchor="ctr"/>
           <a:lstStyle/>
           <a:p>
             <a:pPr indent="0" marL="0">
               <a:buNone/>
             </a:pPr>
             <a:r>
-              <a:rPr lang="en-US" sz="2100" dirty="0">
-                <a:solidFill>
-                  <a:schemeClr val="bg2"/>
-                </a:solidFill>
-              </a:rPr>
-              <a:t>$100,000 in 2023–24 → $156,546 by waiting, $123,714 with v1, $121,812 with v2. With honest odds, v3’s best rule is not to trade.</a:t>
-            </a:r>
-            <a:endParaRPr lang="en-US" sz="2100" dirty="0"/>
-          </a:p>
+              <a:rPr lang="en-US" sz="1800" b="1" dirty="0">
+                <a:solidFill>
+                  <a:schemeClr val="tx1"/>
+                </a:solidFill>
+                <a:latin typeface="Cambria" pitchFamily="34" charset="0"/>
+                <a:ea typeface="Cambria" pitchFamily="34" charset="-122"/>
+                <a:cs typeface="Cambria" pitchFamily="34" charset="-120"/>
+              </a:rPr>
+              <a:t>Size is predictable; direction isn’t</a:t>
+            </a:r>
+            <a:endParaRPr lang="en-US" sz="1800" dirty="0"/>
+          </a:p>
+        </p:txBody>
+      </p:sp>
+      <p:sp>
+        <p:nvSpPr>
+          <p:cNvPr id="7" name="Text 5"/>
+          <p:cNvSpPr txBox="1"/>
+          <p:nvPr/>
+        </p:nvSpPr>
+        <p:spPr>
+          <a:xfrm>
+            <a:off x="777240" y="2350008"/>
+            <a:ext cx="5010912" cy="987552"/>
+          </a:xfrm>
+          <a:prstGeom prst="rect">
+            <a:avLst/>
+          </a:prstGeom>
+          <a:noFill/>
+          <a:ln/>
+        </p:spPr>
+        <p:txBody>
+          <a:bodyPr wrap="square" lIns="0" tIns="0" rIns="0" bIns="0" rtlCol="0" anchor="t"/>
+          <a:lstStyle/>
           <a:p>
             <a:pPr indent="0" marL="0">
               <a:buNone/>
             </a:pPr>
             <a:r>
-              <a:rPr lang="en-US" sz="2100" dirty="0">
-                <a:solidFill>
-                  <a:schemeClr val="bg2"/>
-                </a:solidFill>
-              </a:rPr>
-              <a:t> </a:t>
-            </a:r>
-            <a:endParaRPr lang="en-US" sz="2100" dirty="0"/>
-          </a:p>
+              <a:rPr lang="en-US" sz="1600" dirty="0">
+                <a:solidFill>
+                  <a:schemeClr val="tx2"/>
+                </a:solidFill>
+              </a:rPr>
+              <a:t>Big-move weeks cluster together, so the model can see them coming. Which way they go is close to a coin flip.</a:t>
+            </a:r>
+            <a:endParaRPr lang="en-US" sz="1600" dirty="0"/>
+          </a:p>
+        </p:txBody>
+      </p:sp>
+      <p:sp>
+        <p:nvSpPr>
+          <p:cNvPr id="8" name="Shape 6"/>
+          <p:cNvSpPr/>
+          <p:nvPr/>
+        </p:nvSpPr>
+        <p:spPr>
+          <a:xfrm>
+            <a:off x="6172200" y="1417320"/>
+            <a:ext cx="5468112" cy="2103120"/>
+          </a:xfrm>
+          <a:prstGeom prst="roundRect">
+            <a:avLst>
+              <a:gd name="adj" fmla="val 5217"/>
+            </a:avLst>
+          </a:prstGeom>
+          <a:solidFill>
+            <a:schemeClr val="bg2"/>
+          </a:solidFill>
+          <a:ln w="12700">
+            <a:solidFill>
+              <a:schemeClr val="bg2"/>
+            </a:solidFill>
+            <a:prstDash val="solid"/>
+          </a:ln>
+        </p:spPr>
+      </p:sp>
+      <p:sp>
+        <p:nvSpPr>
+          <p:cNvPr id="9" name="Shape 7"/>
+          <p:cNvSpPr/>
+          <p:nvPr/>
+        </p:nvSpPr>
+        <p:spPr>
+          <a:xfrm>
+            <a:off x="6400800" y="1645920"/>
+            <a:ext cx="438912" cy="438912"/>
+          </a:xfrm>
+          <a:prstGeom prst="ellipse">
+            <a:avLst/>
+          </a:prstGeom>
+          <a:solidFill>
+            <a:schemeClr val="accent1"/>
+          </a:solidFill>
+          <a:ln w="12700">
+            <a:solidFill>
+              <a:schemeClr val="accent1"/>
+            </a:solidFill>
+            <a:prstDash val="solid"/>
+          </a:ln>
+        </p:spPr>
+      </p:sp>
+      <p:sp>
+        <p:nvSpPr>
+          <p:cNvPr id="10" name="Text 8"/>
+          <p:cNvSpPr txBox="1"/>
+          <p:nvPr/>
+        </p:nvSpPr>
+        <p:spPr>
+          <a:xfrm>
+            <a:off x="6400800" y="1645920"/>
+            <a:ext cx="438912" cy="438912"/>
+          </a:xfrm>
+          <a:prstGeom prst="rect">
+            <a:avLst/>
+          </a:prstGeom>
+          <a:noFill/>
+          <a:ln/>
+        </p:spPr>
+        <p:txBody>
+          <a:bodyPr wrap="square" lIns="0" tIns="0" rIns="0" bIns="0" rtlCol="0" anchor="ctr"/>
+          <a:lstStyle/>
+          <a:p>
+            <a:pPr algn="ctr" indent="0" marL="0">
+              <a:buNone/>
+            </a:pPr>
+            <a:r>
+              <a:rPr lang="en-US" sz="1600" b="1" dirty="0">
+                <a:solidFill>
+                  <a:schemeClr val="bg1"/>
+                </a:solidFill>
+              </a:rPr>
+              <a:t>2</a:t>
+            </a:r>
+            <a:endParaRPr lang="en-US" sz="1600" dirty="0"/>
+          </a:p>
+        </p:txBody>
+      </p:sp>
+      <p:sp>
+        <p:nvSpPr>
+          <p:cNvPr id="11" name="Text 9"/>
+          <p:cNvSpPr txBox="1"/>
+          <p:nvPr/>
+        </p:nvSpPr>
+        <p:spPr>
+          <a:xfrm>
+            <a:off x="6995160" y="1645920"/>
+            <a:ext cx="4416552" cy="438912"/>
+          </a:xfrm>
+          <a:prstGeom prst="rect">
+            <a:avLst/>
+          </a:prstGeom>
+          <a:noFill/>
+          <a:ln/>
+        </p:spPr>
+        <p:txBody>
+          <a:bodyPr wrap="square" lIns="0" tIns="0" rIns="0" bIns="0" rtlCol="0" anchor="ctr"/>
+          <a:lstStyle/>
           <a:p>
             <a:pPr indent="0" marL="0">
               <a:buNone/>
             </a:pPr>
             <a:r>
-              <a:rPr lang="en-US" sz="1800" dirty="0">
-                <a:solidFill>
-                  <a:schemeClr val="accent4"/>
-                </a:solidFill>
-              </a:rPr>
-              <a:t>github.com/TKCH121/spy</a:t>
-            </a:r>
-            <a:endParaRPr lang="en-US" sz="2100" dirty="0"/>
+              <a:rPr lang="en-US" sz="1800" b="1" dirty="0">
+                <a:solidFill>
+                  <a:schemeClr val="tx1"/>
+                </a:solidFill>
+                <a:latin typeface="Cambria" pitchFamily="34" charset="0"/>
+                <a:ea typeface="Cambria" pitchFamily="34" charset="-122"/>
+                <a:cs typeface="Cambria" pitchFamily="34" charset="-120"/>
+              </a:rPr>
+              <a:t>Sitting in cash has a cost</a:t>
+            </a:r>
+            <a:endParaRPr lang="en-US" sz="1800" dirty="0"/>
+          </a:p>
+        </p:txBody>
+      </p:sp>
+      <p:sp>
+        <p:nvSpPr>
+          <p:cNvPr id="12" name="Text 10"/>
+          <p:cNvSpPr txBox="1"/>
+          <p:nvPr/>
+        </p:nvSpPr>
+        <p:spPr>
+          <a:xfrm>
+            <a:off x="6400800" y="2194560"/>
+            <a:ext cx="5010912" cy="1143000"/>
+          </a:xfrm>
+          <a:prstGeom prst="rect">
+            <a:avLst/>
+          </a:prstGeom>
+          <a:noFill/>
+          <a:ln/>
+        </p:spPr>
+        <p:txBody>
+          <a:bodyPr wrap="square" lIns="0" tIns="0" rIns="0" bIns="0" rtlCol="0" anchor="t"/>
+          <a:lstStyle/>
+          <a:p>
+            <a:pPr indent="0" marL="0">
+              <a:buNone/>
+            </a:pPr>
+            <a:r>
+              <a:rPr lang="en-US" sz="1600" dirty="0">
+                <a:solidFill>
+                  <a:schemeClr val="tx2"/>
+                </a:solidFill>
+              </a:rPr>
+              <a:t>The market mostly goes up. Without real timing skill, every day out of the market loses money on average.</a:t>
+            </a:r>
+            <a:endParaRPr lang="en-US" sz="1600" dirty="0"/>
+          </a:p>
+        </p:txBody>
+      </p:sp>
+      <p:sp>
+        <p:nvSpPr>
+          <p:cNvPr id="13" name="Shape 11"/>
+          <p:cNvSpPr/>
+          <p:nvPr/>
+        </p:nvSpPr>
+        <p:spPr>
+          <a:xfrm>
+            <a:off x="548640" y="3703320"/>
+            <a:ext cx="5468112" cy="2103120"/>
+          </a:xfrm>
+          <a:prstGeom prst="roundRect">
+            <a:avLst>
+              <a:gd name="adj" fmla="val 5217"/>
+            </a:avLst>
+          </a:prstGeom>
+          <a:solidFill>
+            <a:schemeClr val="bg2"/>
+          </a:solidFill>
+          <a:ln w="12700">
+            <a:solidFill>
+              <a:schemeClr val="bg2"/>
+            </a:solidFill>
+            <a:prstDash val="solid"/>
+          </a:ln>
+        </p:spPr>
+      </p:sp>
+      <p:sp>
+        <p:nvSpPr>
+          <p:cNvPr id="14" name="Shape 12"/>
+          <p:cNvSpPr/>
+          <p:nvPr/>
+        </p:nvSpPr>
+        <p:spPr>
+          <a:xfrm>
+            <a:off x="777240" y="3931920"/>
+            <a:ext cx="438912" cy="438912"/>
+          </a:xfrm>
+          <a:prstGeom prst="ellipse">
+            <a:avLst/>
+          </a:prstGeom>
+          <a:solidFill>
+            <a:schemeClr val="accent1"/>
+          </a:solidFill>
+          <a:ln w="12700">
+            <a:solidFill>
+              <a:schemeClr val="accent1"/>
+            </a:solidFill>
+            <a:prstDash val="solid"/>
+          </a:ln>
+        </p:spPr>
+      </p:sp>
+      <p:sp>
+        <p:nvSpPr>
+          <p:cNvPr id="15" name="Text 13"/>
+          <p:cNvSpPr txBox="1"/>
+          <p:nvPr/>
+        </p:nvSpPr>
+        <p:spPr>
+          <a:xfrm>
+            <a:off x="777240" y="3931920"/>
+            <a:ext cx="438912" cy="438912"/>
+          </a:xfrm>
+          <a:prstGeom prst="rect">
+            <a:avLst/>
+          </a:prstGeom>
+          <a:noFill/>
+          <a:ln/>
+        </p:spPr>
+        <p:txBody>
+          <a:bodyPr wrap="square" lIns="0" tIns="0" rIns="0" bIns="0" rtlCol="0" anchor="ctr"/>
+          <a:lstStyle/>
+          <a:p>
+            <a:pPr algn="ctr" indent="0" marL="0">
+              <a:buNone/>
+            </a:pPr>
+            <a:r>
+              <a:rPr lang="en-US" sz="1600" b="1" dirty="0">
+                <a:solidFill>
+                  <a:schemeClr val="bg1"/>
+                </a:solidFill>
+              </a:rPr>
+              <a:t>3</a:t>
+            </a:r>
+            <a:endParaRPr lang="en-US" sz="1600" dirty="0"/>
+          </a:p>
+        </p:txBody>
+      </p:sp>
+      <p:sp>
+        <p:nvSpPr>
+          <p:cNvPr id="16" name="Text 14"/>
+          <p:cNvSpPr txBox="1"/>
+          <p:nvPr/>
+        </p:nvSpPr>
+        <p:spPr>
+          <a:xfrm>
+            <a:off x="1371600" y="3931920"/>
+            <a:ext cx="4416552" cy="438912"/>
+          </a:xfrm>
+          <a:prstGeom prst="rect">
+            <a:avLst/>
+          </a:prstGeom>
+          <a:noFill/>
+          <a:ln/>
+        </p:spPr>
+        <p:txBody>
+          <a:bodyPr wrap="square" lIns="0" tIns="0" rIns="0" bIns="0" rtlCol="0" anchor="ctr"/>
+          <a:lstStyle/>
+          <a:p>
+            <a:pPr indent="0" marL="0">
+              <a:buNone/>
+            </a:pPr>
+            <a:r>
+              <a:rPr lang="en-US" sz="1800" b="1" dirty="0">
+                <a:solidFill>
+                  <a:schemeClr val="tx1"/>
+                </a:solidFill>
+                <a:latin typeface="Cambria" pitchFamily="34" charset="0"/>
+                <a:ea typeface="Cambria" pitchFamily="34" charset="-122"/>
+                <a:cs typeface="Cambria" pitchFamily="34" charset="-120"/>
+              </a:rPr>
+              <a:t>The past changes</a:t>
+            </a:r>
+            <a:endParaRPr lang="en-US" sz="1800" dirty="0"/>
+          </a:p>
+        </p:txBody>
+      </p:sp>
+      <p:sp>
+        <p:nvSpPr>
+          <p:cNvPr id="17" name="Text 15"/>
+          <p:cNvSpPr txBox="1"/>
+          <p:nvPr/>
+        </p:nvSpPr>
+        <p:spPr>
+          <a:xfrm>
+            <a:off x="777240" y="4480560"/>
+            <a:ext cx="5010912" cy="1143000"/>
+          </a:xfrm>
+          <a:prstGeom prst="rect">
+            <a:avLst/>
+          </a:prstGeom>
+          <a:noFill/>
+          <a:ln/>
+        </p:spPr>
+        <p:txBody>
+          <a:bodyPr wrap="square" lIns="0" tIns="0" rIns="0" bIns="0" rtlCol="0" anchor="t"/>
+          <a:lstStyle/>
+          <a:p>
+            <a:pPr indent="0" marL="0">
+              <a:buNone/>
+            </a:pPr>
+            <a:r>
+              <a:rPr lang="en-US" sz="1600" dirty="0">
+                <a:solidFill>
+                  <a:schemeClr val="tx2"/>
+                </a:solidFill>
+              </a:rPr>
+              <a:t>A signal that helped from 2010 to 2020 actually misled the model in 2022.</a:t>
+            </a:r>
+            <a:endParaRPr lang="en-US" sz="1600" dirty="0"/>
+          </a:p>
+        </p:txBody>
+      </p:sp>
+      <p:sp>
+        <p:nvSpPr>
+          <p:cNvPr id="18" name="Shape 16"/>
+          <p:cNvSpPr/>
+          <p:nvPr/>
+        </p:nvSpPr>
+        <p:spPr>
+          <a:xfrm>
+            <a:off x="6172200" y="3703320"/>
+            <a:ext cx="5468112" cy="2103120"/>
+          </a:xfrm>
+          <a:prstGeom prst="roundRect">
+            <a:avLst>
+              <a:gd name="adj" fmla="val 5217"/>
+            </a:avLst>
+          </a:prstGeom>
+          <a:solidFill>
+            <a:schemeClr val="bg2"/>
+          </a:solidFill>
+          <a:ln w="12700">
+            <a:solidFill>
+              <a:schemeClr val="bg2"/>
+            </a:solidFill>
+            <a:prstDash val="solid"/>
+          </a:ln>
+        </p:spPr>
+      </p:sp>
+      <p:sp>
+        <p:nvSpPr>
+          <p:cNvPr id="19" name="Shape 17"/>
+          <p:cNvSpPr/>
+          <p:nvPr/>
+        </p:nvSpPr>
+        <p:spPr>
+          <a:xfrm>
+            <a:off x="6400800" y="3931920"/>
+            <a:ext cx="438912" cy="438912"/>
+          </a:xfrm>
+          <a:prstGeom prst="ellipse">
+            <a:avLst/>
+          </a:prstGeom>
+          <a:solidFill>
+            <a:schemeClr val="accent1"/>
+          </a:solidFill>
+          <a:ln w="12700">
+            <a:solidFill>
+              <a:schemeClr val="accent1"/>
+            </a:solidFill>
+            <a:prstDash val="solid"/>
+          </a:ln>
+        </p:spPr>
+      </p:sp>
+      <p:sp>
+        <p:nvSpPr>
+          <p:cNvPr id="20" name="Text 18"/>
+          <p:cNvSpPr txBox="1"/>
+          <p:nvPr/>
+        </p:nvSpPr>
+        <p:spPr>
+          <a:xfrm>
+            <a:off x="6400800" y="3931920"/>
+            <a:ext cx="438912" cy="438912"/>
+          </a:xfrm>
+          <a:prstGeom prst="rect">
+            <a:avLst/>
+          </a:prstGeom>
+          <a:noFill/>
+          <a:ln/>
+        </p:spPr>
+        <p:txBody>
+          <a:bodyPr wrap="square" lIns="0" tIns="0" rIns="0" bIns="0" rtlCol="0" anchor="ctr"/>
+          <a:lstStyle/>
+          <a:p>
+            <a:pPr algn="ctr" indent="0" marL="0">
+              <a:buNone/>
+            </a:pPr>
+            <a:r>
+              <a:rPr lang="en-US" sz="1600" b="1" dirty="0">
+                <a:solidFill>
+                  <a:schemeClr val="bg1"/>
+                </a:solidFill>
+              </a:rPr>
+              <a:t>4</a:t>
+            </a:r>
+            <a:endParaRPr lang="en-US" sz="1600" dirty="0"/>
+          </a:p>
+        </p:txBody>
+      </p:sp>
+      <p:sp>
+        <p:nvSpPr>
+          <p:cNvPr id="21" name="Text 19"/>
+          <p:cNvSpPr txBox="1"/>
+          <p:nvPr/>
+        </p:nvSpPr>
+        <p:spPr>
+          <a:xfrm>
+            <a:off x="6995160" y="3931920"/>
+            <a:ext cx="4416552" cy="438912"/>
+          </a:xfrm>
+          <a:prstGeom prst="rect">
+            <a:avLst/>
+          </a:prstGeom>
+          <a:noFill/>
+          <a:ln/>
+        </p:spPr>
+        <p:txBody>
+          <a:bodyPr wrap="square" lIns="0" tIns="0" rIns="0" bIns="0" rtlCol="0" anchor="ctr"/>
+          <a:lstStyle/>
+          <a:p>
+            <a:pPr indent="0" marL="0">
+              <a:buNone/>
+            </a:pPr>
+            <a:r>
+              <a:rPr lang="en-US" sz="1800" b="1" dirty="0">
+                <a:solidFill>
+                  <a:schemeClr val="tx1"/>
+                </a:solidFill>
+                <a:latin typeface="Cambria" pitchFamily="34" charset="0"/>
+                <a:ea typeface="Cambria" pitchFamily="34" charset="-122"/>
+                <a:cs typeface="Cambria" pitchFamily="34" charset="-120"/>
+              </a:rPr>
+              <a:t>Good predictions ≠ good trades</a:t>
+            </a:r>
+            <a:endParaRPr lang="en-US" sz="1800" dirty="0"/>
+          </a:p>
+        </p:txBody>
+      </p:sp>
+      <p:sp>
+        <p:nvSpPr>
+          <p:cNvPr id="22" name="Text 20"/>
+          <p:cNvSpPr txBox="1"/>
+          <p:nvPr/>
+        </p:nvSpPr>
+        <p:spPr>
+          <a:xfrm>
+            <a:off x="6400800" y="4480560"/>
+            <a:ext cx="5010912" cy="1143000"/>
+          </a:xfrm>
+          <a:prstGeom prst="rect">
+            <a:avLst/>
+          </a:prstGeom>
+          <a:noFill/>
+          <a:ln/>
+        </p:spPr>
+        <p:txBody>
+          <a:bodyPr wrap="square" lIns="0" tIns="0" rIns="0" bIns="0" rtlCol="0" anchor="t"/>
+          <a:lstStyle/>
+          <a:p>
+            <a:pPr indent="0" marL="0">
+              <a:buNone/>
+            </a:pPr>
+            <a:r>
+              <a:rPr lang="en-US" sz="1600" dirty="0">
+                <a:solidFill>
+                  <a:schemeClr val="tx2"/>
+                </a:solidFill>
+              </a:rPr>
+              <a:t>Settings that improve the prediction score can distort the odds a trading rule relies on. With honest odds (v3), the best rule was not to trade.</a:t>
+            </a:r>
+            <a:endParaRPr lang="en-US" sz="1600" dirty="0"/>
           </a:p>
         </p:txBody>
       </p:sp>
@@ -17753,6 +18185,183 @@
             <a:fld id="{F7021451-1387-4CA6-816F-3879F97B5CBC}" type="slidenum">
               <a:rPr b="0" lang="en-US"/>
               <a:t>25</a:t>
+            </a:fld>
+            <a:endParaRPr lang="en-US"/>
+          </a:p>
+        </p:txBody>
+      </p:sp>
+    </p:spTree>
+  </p:cSld>
+  <p:clrMapOvr>
+    <a:masterClrMapping/>
+  </p:clrMapOvr>
+</p:sld>
+</file>
+
+<file path=ppt/slides/slide26.xml><?xml version="1.0" encoding="utf-8"?>
+<p:sld xmlns:a="http://schemas.openxmlformats.org/drawingml/2006/main" xmlns:r="http://schemas.openxmlformats.org/officeDocument/2006/relationships" xmlns:p="http://schemas.openxmlformats.org/presentationml/2006/main">
+  <p:cSld name="Slide 26">
+    <p:spTree>
+      <p:nvGrpSpPr>
+        <p:cNvPr id="1" name=""/>
+        <p:cNvGrpSpPr/>
+        <p:nvPr/>
+      </p:nvGrpSpPr>
+      <p:grpSpPr>
+        <a:xfrm>
+          <a:off x="0" y="0"/>
+          <a:ext cx="0" cy="0"/>
+          <a:chOff x="0" y="0"/>
+          <a:chExt cx="0" cy="0"/>
+        </a:xfrm>
+      </p:grpSpPr>
+      <p:sp>
+        <p:nvSpPr>
+          <p:cNvPr id="2" name="Text 0"/>
+          <p:cNvSpPr/>
+          <p:nvPr>
+            <p:ph idx="100" type="title" hasCustomPrompt="1"/>
+          </p:nvPr>
+        </p:nvSpPr>
+        <p:spPr>
+          <a:xfrm>
+            <a:off x="548640" y="1097280"/>
+            <a:ext cx="10789920" cy="2560320"/>
+          </a:xfrm>
+          <a:prstGeom prst="rect">
+            <a:avLst/>
+          </a:prstGeom>
+          <a:noFill/>
+          <a:ln/>
+        </p:spPr>
+        <p:txBody>
+          <a:bodyPr wrap="square" rtlCol="0" anchor="b"/>
+          <a:lstStyle/>
+          <a:p>
+            <a:pPr indent="0" marL="0">
+              <a:buNone/>
+            </a:pPr>
+            <a:r>
+              <a:rPr lang="en-US" sz="4000" b="1" dirty="0">
+                <a:solidFill>
+                  <a:schemeClr val="bg1"/>
+                </a:solidFill>
+                <a:latin typeface="Cambria" pitchFamily="34" charset="0"/>
+                <a:ea typeface="Cambria" pitchFamily="34" charset="-122"/>
+                <a:cs typeface="Cambria" pitchFamily="34" charset="-120"/>
+              </a:rPr>
+              <a:t>Questions?</a:t>
+            </a:r>
+            <a:endParaRPr lang="en-US" sz="4000" dirty="0"/>
+          </a:p>
+        </p:txBody>
+      </p:sp>
+      <p:sp>
+        <p:nvSpPr>
+          <p:cNvPr id="3" name="Text 0"/>
+          <p:cNvSpPr/>
+          <p:nvPr>
+            <p:ph idx="101" type="body" hasCustomPrompt="1"/>
+          </p:nvPr>
+        </p:nvSpPr>
+        <p:spPr>
+          <a:xfrm>
+            <a:off x="548640" y="3931920"/>
+            <a:ext cx="10424160" cy="2103120"/>
+          </a:xfrm>
+          <a:prstGeom prst="rect">
+            <a:avLst/>
+          </a:prstGeom>
+          <a:noFill/>
+          <a:ln/>
+        </p:spPr>
+        <p:txBody>
+          <a:bodyPr wrap="square" rtlCol="0" anchor="t"/>
+          <a:lstStyle/>
+          <a:p>
+            <a:pPr indent="0" marL="0">
+              <a:buNone/>
+            </a:pPr>
+            <a:r>
+              <a:rPr lang="en-US" sz="2100" dirty="0">
+                <a:solidFill>
+                  <a:schemeClr val="bg2"/>
+                </a:solidFill>
+              </a:rPr>
+              <a:t>$100,000 in 2023–24 → $156,546 by waiting, $123,714 with v1, $121,812 with v2. With honest odds, v3’s best rule is not to trade.</a:t>
+            </a:r>
+            <a:endParaRPr lang="en-US" sz="2100" dirty="0"/>
+          </a:p>
+          <a:p>
+            <a:pPr indent="0" marL="0">
+              <a:buNone/>
+            </a:pPr>
+            <a:r>
+              <a:rPr lang="en-US" sz="2100" dirty="0">
+                <a:solidFill>
+                  <a:schemeClr val="bg2"/>
+                </a:solidFill>
+              </a:rPr>
+              <a:t> </a:t>
+            </a:r>
+            <a:endParaRPr lang="en-US" sz="2100" dirty="0"/>
+          </a:p>
+          <a:p>
+            <a:pPr indent="0" marL="0">
+              <a:buNone/>
+            </a:pPr>
+            <a:r>
+              <a:rPr lang="en-US" sz="1800" dirty="0">
+                <a:solidFill>
+                  <a:schemeClr val="accent4"/>
+                </a:solidFill>
+              </a:rPr>
+              <a:t>github.com/TKCH121/spy</a:t>
+            </a:r>
+            <a:endParaRPr lang="en-US" sz="2100" dirty="0"/>
+          </a:p>
+        </p:txBody>
+      </p:sp>
+      <p:sp>
+        <p:nvSpPr>
+          <p:cNvPr id="25" name="Slide Number Placeholder 0"/>
+          <p:cNvSpPr>
+            <a:spLocks noGrp="1"/>
+          </p:cNvSpPr>
+          <p:nvPr>
+            <p:ph type="sldNum" sz="quarter" idx="4294967295"/>
+          </p:nvPr>
+        </p:nvSpPr>
+        <p:spPr>
+          <a:xfrm>
+            <a:off x="11155680" y="6355080"/>
+            <a:ext cx="548640" cy="320040"/>
+          </a:xfrm>
+          <a:prstGeom prst="rect">
+            <a:avLst/>
+          </a:prstGeom>
+          <a:extLst>
+            <a:ext uri="{C572A759-6A51-4108-AA02-DFA0A04FC94B}">
+              <ma14:wrappingTextBoxFlag xmlns:ma14="http://schemas.microsoft.com/office/mac/drawingml/2011/main" val="0"/>
+            </a:ext>
+          </a:extLst>
+        </p:spPr>
+        <p:txBody>
+          <a:bodyPr/>
+          <a:lstStyle>
+            <a:lvl1pPr>
+              <a:defRPr sz="1200">
+                <a:solidFill>
+                  <a:schemeClr val="accent3"/>
+                </a:solidFill>
+              </a:defRPr>
+            </a:lvl1pPr>
+          </a:lstStyle>
+          <a:p>
+            <a:pPr algn="r"/>
+            <a:fld id="{F7021451-1387-4CA6-816F-3879F97B5CBC}" type="slidenum">
+              <a:rPr b="0" lang="en-US"/>
+              <a:t>26</a:t>
             </a:fld>
             <a:endParaRPr lang="en-US"/>
           </a:p>

</xml_diff>

<commit_message>
Presentation: add class-imbalance slide (21) linking v1-v3, and its script
Co-Authored-By: Claude Opus 5.5 <noreply@anthropic.com>
</commit_message>
<xml_diff>
--- a/presentation/SPY_Model_Presentation.pptx
+++ b/presentation/SPY_Model_Presentation.pptx
@@ -31,9 +31,10 @@
     <p:sldId id="279" r:id="rId25"/>
     <p:sldId id="280" r:id="rId26"/>
     <p:sldId id="281" r:id="rId27"/>
+    <p:sldId id="282" r:id="rId28"/>
   </p:sldIdLst>
   <p:notesMasterIdLst>
-    <p:notesMasterId r:id="rId28"/>
+    <p:notesMasterId r:id="rId29"/>
   </p:notesMasterIdLst>
   <p:sldSz cx="12192000" cy="6858000"/>
   <p:notesSz cx="6858000" cy="12192000"/>
@@ -132,7 +133,7 @@
   <p:extLst>
     <p:ext uri="{521415D9-36F7-43E2-AB2F-B90AF26B5E84}">
       <p14:sectionLst xmlns:p14="http://schemas.microsoft.com/office/powerpoint/2010/main">
-        <p14:section name="The question" id="{a48fe4d6-686a-2ade-567e-e5558e8b0ae4}">
+        <p14:section name="The question" id="{6c37e3c1-ba90-9022-cf64-476bff283aa0}">
           <p14:sldIdLst>
             <p14:sldId id="256"/>
             <p14:sldId id="257"/>
@@ -141,7 +142,7 @@
             <p14:sldId id="260"/>
           </p14:sldIdLst>
         </p14:section>
-        <p14:section name="How the model works" id="{652dff78-8756-06b7-81b2-50b9b84ed9e6}">
+        <p14:section name="How the model works" id="{556de192-f166-815a-fddd-07cc68ee6aa1}">
           <p14:sldIdLst>
             <p14:sldId id="261"/>
             <p14:sldId id="262"/>
@@ -151,7 +152,7 @@
             <p14:sldId id="266"/>
           </p14:sldIdLst>
         </p14:section>
-        <p14:section name="What happened" id="{d9fe69da-9cf8-52c8-1add-da88636d47da}">
+        <p14:section name="What happened" id="{f812ec2d-409f-d848-b6be-c07514ecfe93}">
           <p14:sldIdLst>
             <p14:sldId id="267"/>
             <p14:sldId id="268"/>
@@ -159,27 +160,28 @@
             <p14:sldId id="270"/>
           </p14:sldIdLst>
         </p14:section>
-        <p14:section name="Version 2" id="{7e8a73f7-c95c-edf8-ed4f-b5f33d0e949d}">
+        <p14:section name="Version 2" id="{33e48b7a-6001-b8c3-91e1-9ca89066c82f}">
           <p14:sldIdLst>
             <p14:sldId id="271"/>
             <p14:sldId id="272"/>
             <p14:sldId id="273"/>
             <p14:sldId id="274"/>
             <p14:sldId id="275"/>
+            <p14:sldId id="276"/>
           </p14:sldIdLst>
         </p14:section>
-        <p14:section name="Version 3" id="{2239644b-4aa0-08fd-2857-4115fd8ed6ce}">
+        <p14:section name="Version 3" id="{796f2796-6a90-8111-6e5b-bd168408cb54}">
           <p14:sldIdLst>
-            <p14:sldId id="276"/>
             <p14:sldId id="277"/>
             <p14:sldId id="278"/>
+            <p14:sldId id="279"/>
           </p14:sldIdLst>
         </p14:section>
-        <p14:section name="Wrap-up" id="{1e260044-1c85-ce86-2434-9ecf3bb5b72b}">
+        <p14:section name="Wrap-up" id="{eebb2f6c-3dfa-8398-3df0-e1a9898f8449}">
           <p14:sldIdLst>
-            <p14:sldId id="279"/>
             <p14:sldId id="280"/>
             <p14:sldId id="281"/>
+            <p14:sldId id="282"/>
           </p14:sldIdLst>
         </p14:section>
       </p14:sectionLst>
@@ -5562,6 +5564,94 @@
             <a:fld id="{F7021451-1387-4CA6-816F-3879F97B5CBC}" type="slidenum">
               <a:rPr lang="en-US"/>
               <a:t>26</a:t>
+            </a:fld>
+            <a:endParaRPr lang="en-US"/>
+          </a:p>
+        </p:txBody>
+      </p:sp>
+    </p:spTree>
+    <p:extLst>
+      <p:ext uri="{BB962C8B-B14F-4D97-AF65-F5344CB8AC3E}">
+        <p14:creationId xmlns:p14="http://schemas.microsoft.com/office/powerpoint/2010/main" val="1024086991"/>
+      </p:ext>
+    </p:extLst>
+  </p:cSld>
+  <p:clrMapOvr>
+    <a:masterClrMapping/>
+  </p:clrMapOvr>
+</p:notes>
+</file>
+
+<file path=ppt/notesSlides/notesSlide27.xml><?xml version="1.0" encoding="utf-8"?>
+<p:notes xmlns:a="http://schemas.openxmlformats.org/drawingml/2006/main" xmlns:r="http://schemas.openxmlformats.org/officeDocument/2006/relationships" xmlns:p="http://schemas.openxmlformats.org/presentationml/2006/main">
+  <p:cSld>
+    <p:spTree>
+      <p:nvGrpSpPr>
+        <p:cNvPr id="1" name=""/>
+        <p:cNvGrpSpPr/>
+        <p:nvPr/>
+      </p:nvGrpSpPr>
+      <p:grpSpPr>
+        <a:xfrm>
+          <a:off x="0" y="0"/>
+          <a:ext cx="0" cy="0"/>
+          <a:chOff x="0" y="0"/>
+          <a:chExt cx="0" cy="0"/>
+        </a:xfrm>
+      </p:grpSpPr>
+      <p:sp>
+        <p:nvSpPr>
+          <p:cNvPr id="2" name="Slide Image Placeholder 1"/>
+          <p:cNvSpPr>
+            <a:spLocks noGrp="1" noRot="1" noChangeAspect="1"/>
+          </p:cNvSpPr>
+          <p:nvPr>
+            <p:ph type="sldImg"/>
+          </p:nvPr>
+        </p:nvSpPr>
+        <p:spPr/>
+      </p:sp>
+      <p:sp>
+        <p:nvSpPr>
+          <p:cNvPr id="3" name="Notes Placeholder 2"/>
+          <p:cNvSpPr>
+            <a:spLocks noGrp="1"/>
+          </p:cNvSpPr>
+          <p:nvPr>
+            <p:ph type="body" idx="1"/>
+          </p:nvPr>
+        </p:nvSpPr>
+        <p:spPr/>
+        <p:txBody>
+          <a:bodyPr/>
+          <a:lstStyle/>
+          <a:p>
+            <a:r>
+              <a:rPr lang="en-US" dirty="0"/>
+              <a:t/>
+            </a:r>
+            <a:endParaRPr lang="en-US" dirty="0"/>
+          </a:p>
+        </p:txBody>
+      </p:sp>
+      <p:sp>
+        <p:nvSpPr>
+          <p:cNvPr id="4" name="Slide Number Placeholder 3"/>
+          <p:cNvSpPr>
+            <a:spLocks noGrp="1"/>
+          </p:cNvSpPr>
+          <p:nvPr>
+            <p:ph type="sldNum" sz="quarter" idx="10"/>
+          </p:nvPr>
+        </p:nvSpPr>
+        <p:spPr/>
+        <p:txBody>
+          <a:bodyPr/>
+          <a:lstStyle/>
+          <a:p>
+            <a:fld id="{F7021451-1387-4CA6-816F-3879F97B5CBC}" type="slidenum">
+              <a:rPr lang="en-US"/>
+              <a:t>27</a:t>
             </a:fld>
             <a:endParaRPr lang="en-US"/>
           </a:p>
@@ -15507,42 +15597,464 @@
                 <a:ea typeface="Cambria" pitchFamily="34" charset="-122"/>
                 <a:cs typeface="Cambria" pitchFamily="34" charset="-120"/>
               </a:rPr>
-              <a:t>Version 3: correct the odds first</a:t>
+              <a:t>Class imbalance: good for predictions, bad for odds</a:t>
             </a:r>
             <a:endParaRPr lang="en-US" sz="3200" dirty="0"/>
           </a:p>
         </p:txBody>
       </p:sp>
-      <p:graphicFrame>
-        <p:nvGraphicFramePr>
-          <p:cNvPr id="3" name="Chart 0" descr=""/>
-          <p:cNvGraphicFramePr/>
-          <p:nvPr/>
-        </p:nvGraphicFramePr>
-        <p:xfrm>
-          <a:off x="548640" y="1280160"/>
-          <a:ext cx="6766560" cy="4572000"/>
-        </p:xfrm>
-        <a:graphic xmlns:a="http://schemas.openxmlformats.org/drawingml/2006/main">
-          <a:graphicData uri="http://schemas.openxmlformats.org/drawingml/2006/chart">
-            <c:chart xmlns:c="http://schemas.openxmlformats.org/drawingml/2006/chart" r:id="rId1"/>
-          </a:graphicData>
-        </a:graphic>
-      </p:graphicFrame>
-      <p:sp>
-        <p:nvSpPr>
-          <p:cNvPr id="4" name="Shape 1"/>
+      <p:sp>
+        <p:nvSpPr>
+          <p:cNvPr id="3" name="Text 1"/>
+          <p:cNvSpPr txBox="1"/>
+          <p:nvPr/>
+        </p:nvSpPr>
+        <p:spPr>
+          <a:xfrm>
+            <a:off x="548640" y="1325880"/>
+            <a:ext cx="7589520" cy="347472"/>
+          </a:xfrm>
+          <a:prstGeom prst="rect">
+            <a:avLst/>
+          </a:prstGeom>
+          <a:noFill/>
+          <a:ln/>
+        </p:spPr>
+        <p:txBody>
+          <a:bodyPr wrap="square" lIns="0" tIns="0" rIns="0" bIns="0" rtlCol="0" anchor="t"/>
+          <a:lstStyle/>
+          <a:p>
+            <a:pPr indent="0" marL="0">
+              <a:buNone/>
+            </a:pPr>
+            <a:r>
+              <a:rPr lang="en-US" sz="1500" b="1" dirty="0">
+                <a:solidFill>
+                  <a:schemeClr val="tx1"/>
+                </a:solidFill>
+              </a:rPr>
+              <a:t>Real mix of weeks, 2010–2020</a:t>
+            </a:r>
+            <a:endParaRPr lang="en-US" sz="1500" dirty="0"/>
+          </a:p>
+        </p:txBody>
+      </p:sp>
+      <p:sp>
+        <p:nvSpPr>
+          <p:cNvPr id="4" name="Shape 2"/>
           <p:cNvSpPr/>
           <p:nvPr/>
         </p:nvSpPr>
         <p:spPr>
           <a:xfrm>
-            <a:off x="7589520" y="1371600"/>
-            <a:ext cx="4050792" cy="2011680"/>
+            <a:off x="548640" y="1709928"/>
+            <a:ext cx="1496507" cy="548640"/>
+          </a:xfrm>
+          <a:prstGeom prst="rect">
+            <a:avLst/>
+          </a:prstGeom>
+          <a:solidFill>
+            <a:schemeClr val="accent2"/>
+          </a:solidFill>
+          <a:ln w="12700">
+            <a:solidFill>
+              <a:schemeClr val="accent2"/>
+            </a:solidFill>
+            <a:prstDash val="solid"/>
+          </a:ln>
+        </p:spPr>
+      </p:sp>
+      <p:sp>
+        <p:nvSpPr>
+          <p:cNvPr id="5" name="Text 3"/>
+          <p:cNvSpPr txBox="1"/>
+          <p:nvPr/>
+        </p:nvSpPr>
+        <p:spPr>
+          <a:xfrm>
+            <a:off x="548640" y="1709928"/>
+            <a:ext cx="1496507" cy="548640"/>
+          </a:xfrm>
+          <a:prstGeom prst="rect">
+            <a:avLst/>
+          </a:prstGeom>
+          <a:noFill/>
+          <a:ln/>
+        </p:spPr>
+        <p:txBody>
+          <a:bodyPr wrap="square" lIns="0" tIns="0" rIns="0" bIns="0" rtlCol="0" anchor="ctr"/>
+          <a:lstStyle/>
+          <a:p>
+            <a:pPr algn="ctr" indent="0" marL="0">
+              <a:buNone/>
+            </a:pPr>
+            <a:r>
+              <a:rPr lang="en-US" sz="1500" b="1" dirty="0">
+                <a:solidFill>
+                  <a:schemeClr val="bg1"/>
+                </a:solidFill>
+              </a:rPr>
+              <a:t>Down 20%</a:t>
+            </a:r>
+            <a:endParaRPr lang="en-US" sz="1500" dirty="0"/>
+          </a:p>
+        </p:txBody>
+      </p:sp>
+      <p:sp>
+        <p:nvSpPr>
+          <p:cNvPr id="6" name="Shape 4"/>
+          <p:cNvSpPr/>
+          <p:nvPr/>
+        </p:nvSpPr>
+        <p:spPr>
+          <a:xfrm>
+            <a:off x="2081723" y="1709928"/>
+            <a:ext cx="3363529" cy="548640"/>
+          </a:xfrm>
+          <a:prstGeom prst="rect">
+            <a:avLst/>
+          </a:prstGeom>
+          <a:solidFill>
+            <a:schemeClr val="accent3"/>
+          </a:solidFill>
+          <a:ln w="12700">
+            <a:solidFill>
+              <a:schemeClr val="accent3"/>
+            </a:solidFill>
+            <a:prstDash val="solid"/>
+          </a:ln>
+        </p:spPr>
+      </p:sp>
+      <p:sp>
+        <p:nvSpPr>
+          <p:cNvPr id="7" name="Text 5"/>
+          <p:cNvSpPr txBox="1"/>
+          <p:nvPr/>
+        </p:nvSpPr>
+        <p:spPr>
+          <a:xfrm>
+            <a:off x="2081723" y="1709928"/>
+            <a:ext cx="3363529" cy="548640"/>
+          </a:xfrm>
+          <a:prstGeom prst="rect">
+            <a:avLst/>
+          </a:prstGeom>
+          <a:noFill/>
+          <a:ln/>
+        </p:spPr>
+        <p:txBody>
+          <a:bodyPr wrap="square" lIns="0" tIns="0" rIns="0" bIns="0" rtlCol="0" anchor="ctr"/>
+          <a:lstStyle/>
+          <a:p>
+            <a:pPr algn="ctr" indent="0" marL="0">
+              <a:buNone/>
+            </a:pPr>
+            <a:r>
+              <a:rPr lang="en-US" sz="1500" b="1" dirty="0">
+                <a:solidFill>
+                  <a:schemeClr val="bg1"/>
+                </a:solidFill>
+              </a:rPr>
+              <a:t>Flat 45%</a:t>
+            </a:r>
+            <a:endParaRPr lang="en-US" sz="1500" dirty="0"/>
+          </a:p>
+        </p:txBody>
+      </p:sp>
+      <p:sp>
+        <p:nvSpPr>
+          <p:cNvPr id="8" name="Shape 6"/>
+          <p:cNvSpPr/>
+          <p:nvPr/>
+        </p:nvSpPr>
+        <p:spPr>
+          <a:xfrm>
+            <a:off x="5481828" y="1709928"/>
+            <a:ext cx="2619756" cy="548640"/>
+          </a:xfrm>
+          <a:prstGeom prst="rect">
+            <a:avLst/>
+          </a:prstGeom>
+          <a:solidFill>
+            <a:schemeClr val="accent1"/>
+          </a:solidFill>
+          <a:ln w="12700">
+            <a:solidFill>
+              <a:schemeClr val="accent1"/>
+            </a:solidFill>
+            <a:prstDash val="solid"/>
+          </a:ln>
+        </p:spPr>
+      </p:sp>
+      <p:sp>
+        <p:nvSpPr>
+          <p:cNvPr id="9" name="Text 7"/>
+          <p:cNvSpPr txBox="1"/>
+          <p:nvPr/>
+        </p:nvSpPr>
+        <p:spPr>
+          <a:xfrm>
+            <a:off x="5481828" y="1709928"/>
+            <a:ext cx="2619756" cy="548640"/>
+          </a:xfrm>
+          <a:prstGeom prst="rect">
+            <a:avLst/>
+          </a:prstGeom>
+          <a:noFill/>
+          <a:ln/>
+        </p:spPr>
+        <p:txBody>
+          <a:bodyPr wrap="square" lIns="0" tIns="0" rIns="0" bIns="0" rtlCol="0" anchor="ctr"/>
+          <a:lstStyle/>
+          <a:p>
+            <a:pPr algn="ctr" indent="0" marL="0">
+              <a:buNone/>
+            </a:pPr>
+            <a:r>
+              <a:rPr lang="en-US" sz="1500" b="1" dirty="0">
+                <a:solidFill>
+                  <a:schemeClr val="bg1"/>
+                </a:solidFill>
+              </a:rPr>
+              <a:t>Up 35%</a:t>
+            </a:r>
+            <a:endParaRPr lang="en-US" sz="1500" dirty="0"/>
+          </a:p>
+        </p:txBody>
+      </p:sp>
+      <p:sp>
+        <p:nvSpPr>
+          <p:cNvPr id="10" name="Text 8"/>
+          <p:cNvSpPr txBox="1"/>
+          <p:nvPr/>
+        </p:nvSpPr>
+        <p:spPr>
+          <a:xfrm>
+            <a:off x="548640" y="2423160"/>
+            <a:ext cx="7589520" cy="347472"/>
+          </a:xfrm>
+          <a:prstGeom prst="rect">
+            <a:avLst/>
+          </a:prstGeom>
+          <a:noFill/>
+          <a:ln/>
+        </p:spPr>
+        <p:txBody>
+          <a:bodyPr wrap="square" lIns="0" tIns="0" rIns="0" bIns="0" rtlCol="0" anchor="t"/>
+          <a:lstStyle/>
+          <a:p>
+            <a:pPr indent="0" marL="0">
+              <a:buNone/>
+            </a:pPr>
+            <a:r>
+              <a:rPr lang="en-US" sz="1500" b="1" dirty="0">
+                <a:solidFill>
+                  <a:schemeClr val="tx1"/>
+                </a:solidFill>
+              </a:rPr>
+              <a:t>What the model is trained to treat as normal, after balancing</a:t>
+            </a:r>
+            <a:endParaRPr lang="en-US" sz="1500" dirty="0"/>
+          </a:p>
+        </p:txBody>
+      </p:sp>
+      <p:sp>
+        <p:nvSpPr>
+          <p:cNvPr id="11" name="Shape 9"/>
+          <p:cNvSpPr/>
+          <p:nvPr/>
+        </p:nvSpPr>
+        <p:spPr>
+          <a:xfrm>
+            <a:off x="548640" y="2807208"/>
+            <a:ext cx="2493264" cy="548640"/>
+          </a:xfrm>
+          <a:prstGeom prst="rect">
+            <a:avLst/>
+          </a:prstGeom>
+          <a:solidFill>
+            <a:schemeClr val="accent2"/>
+          </a:solidFill>
+          <a:ln w="12700">
+            <a:solidFill>
+              <a:schemeClr val="accent2"/>
+            </a:solidFill>
+            <a:prstDash val="solid"/>
+          </a:ln>
+        </p:spPr>
+      </p:sp>
+      <p:sp>
+        <p:nvSpPr>
+          <p:cNvPr id="12" name="Text 10"/>
+          <p:cNvSpPr txBox="1"/>
+          <p:nvPr/>
+        </p:nvSpPr>
+        <p:spPr>
+          <a:xfrm>
+            <a:off x="548640" y="2807208"/>
+            <a:ext cx="2493264" cy="548640"/>
+          </a:xfrm>
+          <a:prstGeom prst="rect">
+            <a:avLst/>
+          </a:prstGeom>
+          <a:noFill/>
+          <a:ln/>
+        </p:spPr>
+        <p:txBody>
+          <a:bodyPr wrap="square" lIns="0" tIns="0" rIns="0" bIns="0" rtlCol="0" anchor="ctr"/>
+          <a:lstStyle/>
+          <a:p>
+            <a:pPr algn="ctr" indent="0" marL="0">
+              <a:buNone/>
+            </a:pPr>
+            <a:r>
+              <a:rPr lang="en-US" sz="1500" b="1" dirty="0">
+                <a:solidFill>
+                  <a:schemeClr val="bg1"/>
+                </a:solidFill>
+              </a:rPr>
+              <a:t>Down 33%</a:t>
+            </a:r>
+            <a:endParaRPr lang="en-US" sz="1500" dirty="0"/>
+          </a:p>
+        </p:txBody>
+      </p:sp>
+      <p:sp>
+        <p:nvSpPr>
+          <p:cNvPr id="13" name="Shape 11"/>
+          <p:cNvSpPr/>
+          <p:nvPr/>
+        </p:nvSpPr>
+        <p:spPr>
+          <a:xfrm>
+            <a:off x="3078480" y="2807208"/>
+            <a:ext cx="2493264" cy="548640"/>
+          </a:xfrm>
+          <a:prstGeom prst="rect">
+            <a:avLst/>
+          </a:prstGeom>
+          <a:solidFill>
+            <a:schemeClr val="accent3"/>
+          </a:solidFill>
+          <a:ln w="12700">
+            <a:solidFill>
+              <a:schemeClr val="accent3"/>
+            </a:solidFill>
+            <a:prstDash val="solid"/>
+          </a:ln>
+        </p:spPr>
+      </p:sp>
+      <p:sp>
+        <p:nvSpPr>
+          <p:cNvPr id="14" name="Text 12"/>
+          <p:cNvSpPr txBox="1"/>
+          <p:nvPr/>
+        </p:nvSpPr>
+        <p:spPr>
+          <a:xfrm>
+            <a:off x="3078480" y="2807208"/>
+            <a:ext cx="2493264" cy="548640"/>
+          </a:xfrm>
+          <a:prstGeom prst="rect">
+            <a:avLst/>
+          </a:prstGeom>
+          <a:noFill/>
+          <a:ln/>
+        </p:spPr>
+        <p:txBody>
+          <a:bodyPr wrap="square" lIns="0" tIns="0" rIns="0" bIns="0" rtlCol="0" anchor="ctr"/>
+          <a:lstStyle/>
+          <a:p>
+            <a:pPr algn="ctr" indent="0" marL="0">
+              <a:buNone/>
+            </a:pPr>
+            <a:r>
+              <a:rPr lang="en-US" sz="1500" b="1" dirty="0">
+                <a:solidFill>
+                  <a:schemeClr val="bg1"/>
+                </a:solidFill>
+              </a:rPr>
+              <a:t>Flat 33%</a:t>
+            </a:r>
+            <a:endParaRPr lang="en-US" sz="1500" dirty="0"/>
+          </a:p>
+        </p:txBody>
+      </p:sp>
+      <p:sp>
+        <p:nvSpPr>
+          <p:cNvPr id="15" name="Shape 13"/>
+          <p:cNvSpPr/>
+          <p:nvPr/>
+        </p:nvSpPr>
+        <p:spPr>
+          <a:xfrm>
+            <a:off x="5608320" y="2807208"/>
+            <a:ext cx="2493264" cy="548640"/>
+          </a:xfrm>
+          <a:prstGeom prst="rect">
+            <a:avLst/>
+          </a:prstGeom>
+          <a:solidFill>
+            <a:schemeClr val="accent1"/>
+          </a:solidFill>
+          <a:ln w="12700">
+            <a:solidFill>
+              <a:schemeClr val="accent1"/>
+            </a:solidFill>
+            <a:prstDash val="solid"/>
+          </a:ln>
+        </p:spPr>
+      </p:sp>
+      <p:sp>
+        <p:nvSpPr>
+          <p:cNvPr id="16" name="Text 14"/>
+          <p:cNvSpPr txBox="1"/>
+          <p:nvPr/>
+        </p:nvSpPr>
+        <p:spPr>
+          <a:xfrm>
+            <a:off x="5608320" y="2807208"/>
+            <a:ext cx="2493264" cy="548640"/>
+          </a:xfrm>
+          <a:prstGeom prst="rect">
+            <a:avLst/>
+          </a:prstGeom>
+          <a:noFill/>
+          <a:ln/>
+        </p:spPr>
+        <p:txBody>
+          <a:bodyPr wrap="square" lIns="0" tIns="0" rIns="0" bIns="0" rtlCol="0" anchor="ctr"/>
+          <a:lstStyle/>
+          <a:p>
+            <a:pPr algn="ctr" indent="0" marL="0">
+              <a:buNone/>
+            </a:pPr>
+            <a:r>
+              <a:rPr lang="en-US" sz="1500" b="1" dirty="0">
+                <a:solidFill>
+                  <a:schemeClr val="bg1"/>
+                </a:solidFill>
+              </a:rPr>
+              <a:t>Up 33%</a:t>
+            </a:r>
+            <a:endParaRPr lang="en-US" sz="1500" dirty="0"/>
+          </a:p>
+        </p:txBody>
+      </p:sp>
+      <p:sp>
+        <p:nvSpPr>
+          <p:cNvPr id="17" name="Shape 15"/>
+          <p:cNvSpPr/>
+          <p:nvPr/>
+        </p:nvSpPr>
+        <p:spPr>
+          <a:xfrm>
+            <a:off x="8412480" y="1325880"/>
+            <a:ext cx="3227832" cy="2057400"/>
           </a:xfrm>
           <a:prstGeom prst="roundRect">
             <a:avLst>
-              <a:gd name="adj" fmla="val 5455"/>
+              <a:gd name="adj" fmla="val 5333"/>
             </a:avLst>
           </a:prstGeom>
           <a:solidFill>
@@ -15558,14 +16070,14 @@
       </p:sp>
       <p:sp>
         <p:nvSpPr>
-          <p:cNvPr id="5" name="Text 2"/>
+          <p:cNvPr id="18" name="Text 16"/>
           <p:cNvSpPr txBox="1"/>
           <p:nvPr/>
         </p:nvSpPr>
         <p:spPr>
           <a:xfrm>
-            <a:off x="7818120" y="1600200"/>
-            <a:ext cx="3593592" cy="438912"/>
+            <a:off x="8641080" y="1554480"/>
+            <a:ext cx="2770632" cy="563880"/>
           </a:xfrm>
           <a:prstGeom prst="rect">
             <a:avLst/>
@@ -15581,7 +16093,7 @@
               <a:buNone/>
             </a:pPr>
             <a:r>
-              <a:rPr lang="en-US" sz="1800" b="1" dirty="0">
+              <a:rPr lang="en-US" sz="1700" b="1" dirty="0">
                 <a:solidFill>
                   <a:schemeClr val="tx1"/>
                 </a:solidFill>
@@ -15589,22 +16101,22 @@
                 <a:ea typeface="Cambria" pitchFamily="34" charset="-122"/>
                 <a:cs typeface="Cambria" pitchFamily="34" charset="-120"/>
               </a:rPr>
-              <a:t>On average: fixed</a:t>
-            </a:r>
-            <a:endParaRPr lang="en-US" sz="1800" dirty="0"/>
-          </a:p>
-        </p:txBody>
-      </p:sp>
-      <p:sp>
-        <p:nvSpPr>
-          <p:cNvPr id="6" name="Text 3"/>
+              <a:t>Good for predictions, bad for odds</a:t>
+            </a:r>
+            <a:endParaRPr lang="en-US" sz="1700" dirty="0"/>
+          </a:p>
+        </p:txBody>
+      </p:sp>
+      <p:sp>
+        <p:nvSpPr>
+          <p:cNvPr id="19" name="Text 17"/>
           <p:cNvSpPr txBox="1"/>
           <p:nvPr/>
         </p:nvSpPr>
         <p:spPr>
           <a:xfrm>
-            <a:off x="7818120" y="2148840"/>
-            <a:ext cx="3593592" cy="1051560"/>
+            <a:off x="8641080" y="2228088"/>
+            <a:ext cx="2770632" cy="972312"/>
           </a:xfrm>
           <a:prstGeom prst="rect">
             <a:avLst/>
@@ -15620,31 +16132,31 @@
               <a:buNone/>
             </a:pPr>
             <a:r>
-              <a:rPr lang="en-US" sz="1500" dirty="0">
+              <a:rPr lang="en-US" sz="1400" dirty="0">
                 <a:solidFill>
                   <a:schemeClr val="tx2"/>
                 </a:solidFill>
               </a:rPr>
-              <a:t>Two simple corrections bring the predicted chance of a down week from 30% to about 21–22%, close to the real 21%.</a:t>
-            </a:r>
-            <a:endParaRPr lang="en-US" sz="1500" dirty="0"/>
-          </a:p>
-        </p:txBody>
-      </p:sp>
-      <p:sp>
-        <p:nvSpPr>
-          <p:cNvPr id="7" name="Shape 4"/>
+              <a:t>The model stops ignoring rare down weeks, but its odds of one come out inflated: 30% predicted vs 21% real.</a:t>
+            </a:r>
+            <a:endParaRPr lang="en-US" sz="1400" dirty="0"/>
+          </a:p>
+        </p:txBody>
+      </p:sp>
+      <p:sp>
+        <p:nvSpPr>
+          <p:cNvPr id="20" name="Shape 18"/>
           <p:cNvSpPr/>
           <p:nvPr/>
         </p:nvSpPr>
         <p:spPr>
           <a:xfrm>
-            <a:off x="7589520" y="3566160"/>
-            <a:ext cx="4050792" cy="2331720"/>
+            <a:off x="548640" y="3657600"/>
+            <a:ext cx="2636444" cy="2240280"/>
           </a:xfrm>
           <a:prstGeom prst="roundRect">
             <a:avLst>
-              <a:gd name="adj" fmla="val 4706"/>
+              <a:gd name="adj" fmla="val 4898"/>
             </a:avLst>
           </a:prstGeom>
           <a:solidFill>
@@ -15660,14 +16172,39 @@
       </p:sp>
       <p:sp>
         <p:nvSpPr>
-          <p:cNvPr id="8" name="Text 5"/>
+          <p:cNvPr id="21" name="Shape 19"/>
+          <p:cNvSpPr/>
+          <p:nvPr/>
+        </p:nvSpPr>
+        <p:spPr>
+          <a:xfrm>
+            <a:off x="777240" y="3886200"/>
+            <a:ext cx="438912" cy="438912"/>
+          </a:xfrm>
+          <a:prstGeom prst="ellipse">
+            <a:avLst/>
+          </a:prstGeom>
+          <a:solidFill>
+            <a:schemeClr val="accent1"/>
+          </a:solidFill>
+          <a:ln w="12700">
+            <a:solidFill>
+              <a:schemeClr val="accent1"/>
+            </a:solidFill>
+            <a:prstDash val="solid"/>
+          </a:ln>
+        </p:spPr>
+      </p:sp>
+      <p:sp>
+        <p:nvSpPr>
+          <p:cNvPr id="22" name="Text 20"/>
           <p:cNvSpPr txBox="1"/>
           <p:nvPr/>
         </p:nvSpPr>
         <p:spPr>
           <a:xfrm>
-            <a:off x="7818120" y="3794760"/>
-            <a:ext cx="3593592" cy="438912"/>
+            <a:off x="777240" y="3886200"/>
+            <a:ext cx="438912" cy="438912"/>
           </a:xfrm>
           <a:prstGeom prst="rect">
             <a:avLst/>
@@ -15679,11 +16216,47 @@
           <a:bodyPr wrap="square" lIns="0" tIns="0" rIns="0" bIns="0" rtlCol="0" anchor="ctr"/>
           <a:lstStyle/>
           <a:p>
+            <a:pPr algn="ctr" indent="0" marL="0">
+              <a:buNone/>
+            </a:pPr>
+            <a:r>
+              <a:rPr lang="en-US" sz="1600" b="1" dirty="0">
+                <a:solidFill>
+                  <a:schemeClr val="bg1"/>
+                </a:solidFill>
+              </a:rPr>
+              <a:t>1</a:t>
+            </a:r>
+            <a:endParaRPr lang="en-US" sz="1600" dirty="0"/>
+          </a:p>
+        </p:txBody>
+      </p:sp>
+      <p:sp>
+        <p:nvSpPr>
+          <p:cNvPr id="23" name="Text 21"/>
+          <p:cNvSpPr txBox="1"/>
+          <p:nvPr/>
+        </p:nvSpPr>
+        <p:spPr>
+          <a:xfrm>
+            <a:off x="1371600" y="3886200"/>
+            <a:ext cx="1584884" cy="438912"/>
+          </a:xfrm>
+          <a:prstGeom prst="rect">
+            <a:avLst/>
+          </a:prstGeom>
+          <a:noFill/>
+          <a:ln/>
+        </p:spPr>
+        <p:txBody>
+          <a:bodyPr wrap="square" lIns="0" tIns="0" rIns="0" bIns="0" rtlCol="0" anchor="ctr"/>
+          <a:lstStyle/>
+          <a:p>
             <a:pPr indent="0" marL="0">
               <a:buNone/>
             </a:pPr>
             <a:r>
-              <a:rPr lang="en-US" sz="1800" b="1" dirty="0">
+              <a:rPr lang="en-US" sz="1700" b="1" dirty="0">
                 <a:solidFill>
                   <a:schemeClr val="tx1"/>
                 </a:solidFill>
@@ -15691,22 +16264,22 @@
                 <a:ea typeface="Cambria" pitchFamily="34" charset="-122"/>
                 <a:cs typeface="Cambria" pitchFamily="34" charset="-120"/>
               </a:rPr>
-              <a:t>Year by year: not fixed</a:t>
-            </a:r>
-            <a:endParaRPr lang="en-US" sz="1800" dirty="0"/>
-          </a:p>
-        </p:txBody>
-      </p:sp>
-      <p:sp>
-        <p:nvSpPr>
-          <p:cNvPr id="9" name="Text 6"/>
+              <a:t>The brief</a:t>
+            </a:r>
+            <a:endParaRPr lang="en-US" sz="1700" dirty="0"/>
+          </a:p>
+        </p:txBody>
+      </p:sp>
+      <p:sp>
+        <p:nvSpPr>
+          <p:cNvPr id="24" name="Text 22"/>
           <p:cNvSpPr txBox="1"/>
           <p:nvPr/>
         </p:nvSpPr>
         <p:spPr>
           <a:xfrm>
-            <a:off x="7818120" y="4343400"/>
-            <a:ext cx="3593592" cy="1371600"/>
+            <a:off x="777240" y="4434840"/>
+            <a:ext cx="2179244" cy="1280160"/>
           </a:xfrm>
           <a:prstGeom prst="rect">
             <a:avLst/>
@@ -15722,14 +16295,503 @@
               <a:buNone/>
             </a:pPr>
             <a:r>
-              <a:rPr lang="en-US" sz="1500" dirty="0">
+              <a:rPr lang="en-US" sz="1400" dirty="0">
                 <a:solidFill>
                   <a:schemeClr val="tx2"/>
                 </a:solidFill>
               </a:rPr>
-              <a:t>The real share of down weeks swings (few in 2017, many in 2022). No correction stayed within 3 points in more than 4 of 10 years; our rule, set in advance, needed 8. So v3 failed its own calibration test.</a:t>
-            </a:r>
-            <a:endParaRPr lang="en-US" sz="1500" dirty="0"/>
+              <a:t>Requires handling imbalance: SMOTE, class weights or thresholds.</a:t>
+            </a:r>
+            <a:endParaRPr lang="en-US" sz="1400" dirty="0"/>
+          </a:p>
+        </p:txBody>
+      </p:sp>
+      <p:sp>
+        <p:nvSpPr>
+          <p:cNvPr id="25" name="Shape 23"/>
+          <p:cNvSpPr/>
+          <p:nvPr/>
+        </p:nvSpPr>
+        <p:spPr>
+          <a:xfrm>
+            <a:off x="3367964" y="3657600"/>
+            <a:ext cx="2636444" cy="2240280"/>
+          </a:xfrm>
+          <a:prstGeom prst="roundRect">
+            <a:avLst>
+              <a:gd name="adj" fmla="val 4898"/>
+            </a:avLst>
+          </a:prstGeom>
+          <a:solidFill>
+            <a:schemeClr val="bg2"/>
+          </a:solidFill>
+          <a:ln w="12700">
+            <a:solidFill>
+              <a:schemeClr val="bg2"/>
+            </a:solidFill>
+            <a:prstDash val="solid"/>
+          </a:ln>
+        </p:spPr>
+      </p:sp>
+      <p:sp>
+        <p:nvSpPr>
+          <p:cNvPr id="26" name="Shape 24"/>
+          <p:cNvSpPr/>
+          <p:nvPr/>
+        </p:nvSpPr>
+        <p:spPr>
+          <a:xfrm>
+            <a:off x="3596564" y="3886200"/>
+            <a:ext cx="438912" cy="438912"/>
+          </a:xfrm>
+          <a:prstGeom prst="ellipse">
+            <a:avLst/>
+          </a:prstGeom>
+          <a:solidFill>
+            <a:schemeClr val="accent1"/>
+          </a:solidFill>
+          <a:ln w="12700">
+            <a:solidFill>
+              <a:schemeClr val="accent1"/>
+            </a:solidFill>
+            <a:prstDash val="solid"/>
+          </a:ln>
+        </p:spPr>
+      </p:sp>
+      <p:sp>
+        <p:nvSpPr>
+          <p:cNvPr id="27" name="Text 25"/>
+          <p:cNvSpPr txBox="1"/>
+          <p:nvPr/>
+        </p:nvSpPr>
+        <p:spPr>
+          <a:xfrm>
+            <a:off x="3596564" y="3886200"/>
+            <a:ext cx="438912" cy="438912"/>
+          </a:xfrm>
+          <a:prstGeom prst="rect">
+            <a:avLst/>
+          </a:prstGeom>
+          <a:noFill/>
+          <a:ln/>
+        </p:spPr>
+        <p:txBody>
+          <a:bodyPr wrap="square" lIns="0" tIns="0" rIns="0" bIns="0" rtlCol="0" anchor="ctr"/>
+          <a:lstStyle/>
+          <a:p>
+            <a:pPr algn="ctr" indent="0" marL="0">
+              <a:buNone/>
+            </a:pPr>
+            <a:r>
+              <a:rPr lang="en-US" sz="1600" b="1" dirty="0">
+                <a:solidFill>
+                  <a:schemeClr val="bg1"/>
+                </a:solidFill>
+              </a:rPr>
+              <a:t>2</a:t>
+            </a:r>
+            <a:endParaRPr lang="en-US" sz="1600" dirty="0"/>
+          </a:p>
+        </p:txBody>
+      </p:sp>
+      <p:sp>
+        <p:nvSpPr>
+          <p:cNvPr id="28" name="Text 26"/>
+          <p:cNvSpPr txBox="1"/>
+          <p:nvPr/>
+        </p:nvSpPr>
+        <p:spPr>
+          <a:xfrm>
+            <a:off x="4190924" y="3886200"/>
+            <a:ext cx="1584884" cy="438912"/>
+          </a:xfrm>
+          <a:prstGeom prst="rect">
+            <a:avLst/>
+          </a:prstGeom>
+          <a:noFill/>
+          <a:ln/>
+        </p:spPr>
+        <p:txBody>
+          <a:bodyPr wrap="square" lIns="0" tIns="0" rIns="0" bIns="0" rtlCol="0" anchor="ctr"/>
+          <a:lstStyle/>
+          <a:p>
+            <a:pPr indent="0" marL="0">
+              <a:buNone/>
+            </a:pPr>
+            <a:r>
+              <a:rPr lang="en-US" sz="1700" b="1" dirty="0">
+                <a:solidFill>
+                  <a:schemeClr val="tx1"/>
+                </a:solidFill>
+                <a:latin typeface="Cambria" pitchFamily="34" charset="0"/>
+                <a:ea typeface="Cambria" pitchFamily="34" charset="-122"/>
+                <a:cs typeface="Cambria" pitchFamily="34" charset="-120"/>
+              </a:rPr>
+              <a:t>Version 1</a:t>
+            </a:r>
+            <a:endParaRPr lang="en-US" sz="1700" dirty="0"/>
+          </a:p>
+        </p:txBody>
+      </p:sp>
+      <p:sp>
+        <p:nvSpPr>
+          <p:cNvPr id="29" name="Text 27"/>
+          <p:cNvSpPr txBox="1"/>
+          <p:nvPr/>
+        </p:nvSpPr>
+        <p:spPr>
+          <a:xfrm>
+            <a:off x="3596564" y="4434840"/>
+            <a:ext cx="2179244" cy="1280160"/>
+          </a:xfrm>
+          <a:prstGeom prst="rect">
+            <a:avLst/>
+          </a:prstGeom>
+          <a:noFill/>
+          <a:ln/>
+        </p:spPr>
+        <p:txBody>
+          <a:bodyPr wrap="square" lIns="0" tIns="0" rIns="0" bIns="0" rtlCol="0" anchor="t"/>
+          <a:lstStyle/>
+          <a:p>
+            <a:pPr indent="0" marL="0">
+              <a:buNone/>
+            </a:pPr>
+            <a:r>
+              <a:rPr lang="en-US" sz="1400" dirty="0">
+                <a:solidFill>
+                  <a:schemeClr val="tx2"/>
+                </a:solidFill>
+              </a:rPr>
+              <a:t>Class weights. SMOTE and no weighting were tested; weights scored best.</a:t>
+            </a:r>
+            <a:endParaRPr lang="en-US" sz="1400" dirty="0"/>
+          </a:p>
+        </p:txBody>
+      </p:sp>
+      <p:sp>
+        <p:nvSpPr>
+          <p:cNvPr id="30" name="Shape 28"/>
+          <p:cNvSpPr/>
+          <p:nvPr/>
+        </p:nvSpPr>
+        <p:spPr>
+          <a:xfrm>
+            <a:off x="6187288" y="3657600"/>
+            <a:ext cx="2636444" cy="2240280"/>
+          </a:xfrm>
+          <a:prstGeom prst="roundRect">
+            <a:avLst>
+              <a:gd name="adj" fmla="val 4898"/>
+            </a:avLst>
+          </a:prstGeom>
+          <a:solidFill>
+            <a:schemeClr val="bg2"/>
+          </a:solidFill>
+          <a:ln w="12700">
+            <a:solidFill>
+              <a:schemeClr val="bg2"/>
+            </a:solidFill>
+            <a:prstDash val="solid"/>
+          </a:ln>
+        </p:spPr>
+      </p:sp>
+      <p:sp>
+        <p:nvSpPr>
+          <p:cNvPr id="31" name="Shape 29"/>
+          <p:cNvSpPr/>
+          <p:nvPr/>
+        </p:nvSpPr>
+        <p:spPr>
+          <a:xfrm>
+            <a:off x="6415888" y="3886200"/>
+            <a:ext cx="438912" cy="438912"/>
+          </a:xfrm>
+          <a:prstGeom prst="ellipse">
+            <a:avLst/>
+          </a:prstGeom>
+          <a:solidFill>
+            <a:schemeClr val="accent1"/>
+          </a:solidFill>
+          <a:ln w="12700">
+            <a:solidFill>
+              <a:schemeClr val="accent1"/>
+            </a:solidFill>
+            <a:prstDash val="solid"/>
+          </a:ln>
+        </p:spPr>
+      </p:sp>
+      <p:sp>
+        <p:nvSpPr>
+          <p:cNvPr id="32" name="Text 30"/>
+          <p:cNvSpPr txBox="1"/>
+          <p:nvPr/>
+        </p:nvSpPr>
+        <p:spPr>
+          <a:xfrm>
+            <a:off x="6415888" y="3886200"/>
+            <a:ext cx="438912" cy="438912"/>
+          </a:xfrm>
+          <a:prstGeom prst="rect">
+            <a:avLst/>
+          </a:prstGeom>
+          <a:noFill/>
+          <a:ln/>
+        </p:spPr>
+        <p:txBody>
+          <a:bodyPr wrap="square" lIns="0" tIns="0" rIns="0" bIns="0" rtlCol="0" anchor="ctr"/>
+          <a:lstStyle/>
+          <a:p>
+            <a:pPr algn="ctr" indent="0" marL="0">
+              <a:buNone/>
+            </a:pPr>
+            <a:r>
+              <a:rPr lang="en-US" sz="1600" b="1" dirty="0">
+                <a:solidFill>
+                  <a:schemeClr val="bg1"/>
+                </a:solidFill>
+              </a:rPr>
+              <a:t>3</a:t>
+            </a:r>
+            <a:endParaRPr lang="en-US" sz="1600" dirty="0"/>
+          </a:p>
+        </p:txBody>
+      </p:sp>
+      <p:sp>
+        <p:nvSpPr>
+          <p:cNvPr id="33" name="Text 31"/>
+          <p:cNvSpPr txBox="1"/>
+          <p:nvPr/>
+        </p:nvSpPr>
+        <p:spPr>
+          <a:xfrm>
+            <a:off x="7010248" y="3886200"/>
+            <a:ext cx="1584884" cy="438912"/>
+          </a:xfrm>
+          <a:prstGeom prst="rect">
+            <a:avLst/>
+          </a:prstGeom>
+          <a:noFill/>
+          <a:ln/>
+        </p:spPr>
+        <p:txBody>
+          <a:bodyPr wrap="square" lIns="0" tIns="0" rIns="0" bIns="0" rtlCol="0" anchor="ctr"/>
+          <a:lstStyle/>
+          <a:p>
+            <a:pPr indent="0" marL="0">
+              <a:buNone/>
+            </a:pPr>
+            <a:r>
+              <a:rPr lang="en-US" sz="1700" b="1" dirty="0">
+                <a:solidFill>
+                  <a:schemeClr val="tx1"/>
+                </a:solidFill>
+                <a:latin typeface="Cambria" pitchFamily="34" charset="0"/>
+                <a:ea typeface="Cambria" pitchFamily="34" charset="-122"/>
+                <a:cs typeface="Cambria" pitchFamily="34" charset="-120"/>
+              </a:rPr>
+              <a:t>Version 2</a:t>
+            </a:r>
+            <a:endParaRPr lang="en-US" sz="1700" dirty="0"/>
+          </a:p>
+        </p:txBody>
+      </p:sp>
+      <p:sp>
+        <p:nvSpPr>
+          <p:cNvPr id="34" name="Text 32"/>
+          <p:cNvSpPr txBox="1"/>
+          <p:nvPr/>
+        </p:nvSpPr>
+        <p:spPr>
+          <a:xfrm>
+            <a:off x="6415888" y="4434840"/>
+            <a:ext cx="2179244" cy="1280160"/>
+          </a:xfrm>
+          <a:prstGeom prst="rect">
+            <a:avLst/>
+          </a:prstGeom>
+          <a:noFill/>
+          <a:ln/>
+        </p:spPr>
+        <p:txBody>
+          <a:bodyPr wrap="square" lIns="0" tIns="0" rIns="0" bIns="0" rtlCol="0" anchor="t"/>
+          <a:lstStyle/>
+          <a:p>
+            <a:pPr indent="0" marL="0">
+              <a:buNone/>
+            </a:pPr>
+            <a:r>
+              <a:rPr lang="en-US" sz="1400" dirty="0">
+                <a:solidFill>
+                  <a:schemeClr val="tx2"/>
+                </a:solidFill>
+              </a:rPr>
+              <a:t>Used the odds directly, so the inflated down-week odds kept it selling.</a:t>
+            </a:r>
+            <a:endParaRPr lang="en-US" sz="1400" dirty="0"/>
+          </a:p>
+        </p:txBody>
+      </p:sp>
+      <p:sp>
+        <p:nvSpPr>
+          <p:cNvPr id="35" name="Shape 33"/>
+          <p:cNvSpPr/>
+          <p:nvPr/>
+        </p:nvSpPr>
+        <p:spPr>
+          <a:xfrm>
+            <a:off x="9006611" y="3657600"/>
+            <a:ext cx="2636444" cy="2240280"/>
+          </a:xfrm>
+          <a:prstGeom prst="roundRect">
+            <a:avLst>
+              <a:gd name="adj" fmla="val 4898"/>
+            </a:avLst>
+          </a:prstGeom>
+          <a:solidFill>
+            <a:schemeClr val="bg2"/>
+          </a:solidFill>
+          <a:ln w="12700">
+            <a:solidFill>
+              <a:schemeClr val="bg2"/>
+            </a:solidFill>
+            <a:prstDash val="solid"/>
+          </a:ln>
+        </p:spPr>
+      </p:sp>
+      <p:sp>
+        <p:nvSpPr>
+          <p:cNvPr id="36" name="Shape 34"/>
+          <p:cNvSpPr/>
+          <p:nvPr/>
+        </p:nvSpPr>
+        <p:spPr>
+          <a:xfrm>
+            <a:off x="9235211" y="3886200"/>
+            <a:ext cx="438912" cy="438912"/>
+          </a:xfrm>
+          <a:prstGeom prst="ellipse">
+            <a:avLst/>
+          </a:prstGeom>
+          <a:solidFill>
+            <a:schemeClr val="accent1"/>
+          </a:solidFill>
+          <a:ln w="12700">
+            <a:solidFill>
+              <a:schemeClr val="accent1"/>
+            </a:solidFill>
+            <a:prstDash val="solid"/>
+          </a:ln>
+        </p:spPr>
+      </p:sp>
+      <p:sp>
+        <p:nvSpPr>
+          <p:cNvPr id="37" name="Text 35"/>
+          <p:cNvSpPr txBox="1"/>
+          <p:nvPr/>
+        </p:nvSpPr>
+        <p:spPr>
+          <a:xfrm>
+            <a:off x="9235211" y="3886200"/>
+            <a:ext cx="438912" cy="438912"/>
+          </a:xfrm>
+          <a:prstGeom prst="rect">
+            <a:avLst/>
+          </a:prstGeom>
+          <a:noFill/>
+          <a:ln/>
+        </p:spPr>
+        <p:txBody>
+          <a:bodyPr wrap="square" lIns="0" tIns="0" rIns="0" bIns="0" rtlCol="0" anchor="ctr"/>
+          <a:lstStyle/>
+          <a:p>
+            <a:pPr algn="ctr" indent="0" marL="0">
+              <a:buNone/>
+            </a:pPr>
+            <a:r>
+              <a:rPr lang="en-US" sz="1600" b="1" dirty="0">
+                <a:solidFill>
+                  <a:schemeClr val="bg1"/>
+                </a:solidFill>
+              </a:rPr>
+              <a:t>4</a:t>
+            </a:r>
+            <a:endParaRPr lang="en-US" sz="1600" dirty="0"/>
+          </a:p>
+        </p:txBody>
+      </p:sp>
+      <p:sp>
+        <p:nvSpPr>
+          <p:cNvPr id="38" name="Text 36"/>
+          <p:cNvSpPr txBox="1"/>
+          <p:nvPr/>
+        </p:nvSpPr>
+        <p:spPr>
+          <a:xfrm>
+            <a:off x="9829571" y="3886200"/>
+            <a:ext cx="1584884" cy="438912"/>
+          </a:xfrm>
+          <a:prstGeom prst="rect">
+            <a:avLst/>
+          </a:prstGeom>
+          <a:noFill/>
+          <a:ln/>
+        </p:spPr>
+        <p:txBody>
+          <a:bodyPr wrap="square" lIns="0" tIns="0" rIns="0" bIns="0" rtlCol="0" anchor="ctr"/>
+          <a:lstStyle/>
+          <a:p>
+            <a:pPr indent="0" marL="0">
+              <a:buNone/>
+            </a:pPr>
+            <a:r>
+              <a:rPr lang="en-US" sz="1700" b="1" dirty="0">
+                <a:solidFill>
+                  <a:schemeClr val="tx1"/>
+                </a:solidFill>
+                <a:latin typeface="Cambria" pitchFamily="34" charset="0"/>
+                <a:ea typeface="Cambria" pitchFamily="34" charset="-122"/>
+                <a:cs typeface="Cambria" pitchFamily="34" charset="-120"/>
+              </a:rPr>
+              <a:t>Version 3</a:t>
+            </a:r>
+            <a:endParaRPr lang="en-US" sz="1700" dirty="0"/>
+          </a:p>
+        </p:txBody>
+      </p:sp>
+      <p:sp>
+        <p:nvSpPr>
+          <p:cNvPr id="39" name="Text 37"/>
+          <p:cNvSpPr txBox="1"/>
+          <p:nvPr/>
+        </p:nvSpPr>
+        <p:spPr>
+          <a:xfrm>
+            <a:off x="9235211" y="4434840"/>
+            <a:ext cx="2179244" cy="1280160"/>
+          </a:xfrm>
+          <a:prstGeom prst="rect">
+            <a:avLst/>
+          </a:prstGeom>
+          <a:noFill/>
+          <a:ln/>
+        </p:spPr>
+        <p:txBody>
+          <a:bodyPr wrap="square" lIns="0" tIns="0" rIns="0" bIns="0" rtlCol="0" anchor="t"/>
+          <a:lstStyle/>
+          <a:p>
+            <a:pPr indent="0" marL="0">
+              <a:buNone/>
+            </a:pPr>
+            <a:r>
+              <a:rPr lang="en-US" sz="1400" dirty="0">
+                <a:solidFill>
+                  <a:schemeClr val="tx2"/>
+                </a:solidFill>
+              </a:rPr>
+              <a:t>Keep the weights for training, then correct the odds before trading.</a:t>
+            </a:r>
+            <a:endParaRPr lang="en-US" sz="1400" dirty="0"/>
           </a:p>
         </p:txBody>
       </p:sp>
@@ -15838,7 +16900,7 @@
                 <a:ea typeface="Cambria" pitchFamily="34" charset="-122"/>
                 <a:cs typeface="Cambria" pitchFamily="34" charset="-120"/>
               </a:rPr>
-              <a:t>With honest odds, the best rule is: don’t trade</a:t>
+              <a:t>Version 3: correct the odds first</a:t>
             </a:r>
             <a:endParaRPr lang="en-US" sz="3200" dirty="0"/>
           </a:p>
@@ -15852,7 +16914,7 @@
         </p:nvGraphicFramePr>
         <p:xfrm>
           <a:off x="548640" y="1280160"/>
-          <a:ext cx="7223760" cy="4572000"/>
+          <a:ext cx="6766560" cy="4572000"/>
         </p:xfrm>
         <a:graphic xmlns:a="http://schemas.openxmlformats.org/drawingml/2006/main">
           <a:graphicData uri="http://schemas.openxmlformats.org/drawingml/2006/chart">
@@ -15868,12 +16930,12 @@
         </p:nvSpPr>
         <p:spPr>
           <a:xfrm>
-            <a:off x="8046720" y="1371600"/>
-            <a:ext cx="3593592" cy="2286000"/>
+            <a:off x="7589520" y="1371600"/>
+            <a:ext cx="4050792" cy="2011680"/>
           </a:xfrm>
           <a:prstGeom prst="roundRect">
             <a:avLst>
-              <a:gd name="adj" fmla="val 4800"/>
+              <a:gd name="adj" fmla="val 5455"/>
             </a:avLst>
           </a:prstGeom>
           <a:solidFill>
@@ -15895,8 +16957,8 @@
         </p:nvSpPr>
         <p:spPr>
           <a:xfrm>
-            <a:off x="8275320" y="1600200"/>
-            <a:ext cx="3136392" cy="438912"/>
+            <a:off x="7818120" y="1600200"/>
+            <a:ext cx="3593592" cy="438912"/>
           </a:xfrm>
           <a:prstGeom prst="rect">
             <a:avLst/>
@@ -15920,7 +16982,7 @@
                 <a:ea typeface="Cambria" pitchFamily="34" charset="-122"/>
                 <a:cs typeface="Cambria" pitchFamily="34" charset="-120"/>
               </a:rPr>
-              <a:t>The pick never sold</a:t>
+              <a:t>On average: fixed</a:t>
             </a:r>
             <a:endParaRPr lang="en-US" sz="1800" dirty="0"/>
           </a:p>
@@ -15934,8 +16996,8 @@
         </p:nvSpPr>
         <p:spPr>
           <a:xfrm>
-            <a:off x="8275320" y="2148840"/>
-            <a:ext cx="3136392" cy="1325880"/>
+            <a:off x="7818120" y="2148840"/>
+            <a:ext cx="3593592" cy="1051560"/>
           </a:xfrm>
           <a:prstGeom prst="rect">
             <a:avLst/>
@@ -15956,7 +17018,7 @@
                   <a:schemeClr val="tx2"/>
                 </a:solidFill>
               </a:rPr>
-              <a:t>Chosen by a rule fixed in advance. In ten years it never stepped out of the market: it is Buy &amp; Hold, and it ties Buy &amp; Hold.</a:t>
+              <a:t>Two simple corrections bring the predicted chance of a down week from 30% to about 21–22%, close to the real 21%.</a:t>
             </a:r>
             <a:endParaRPr lang="en-US" sz="1500" dirty="0"/>
           </a:p>
@@ -15970,12 +17032,12 @@
         </p:nvSpPr>
         <p:spPr>
           <a:xfrm>
-            <a:off x="8046720" y="3840480"/>
-            <a:ext cx="3593592" cy="2057400"/>
+            <a:off x="7589520" y="3566160"/>
+            <a:ext cx="4050792" cy="2331720"/>
           </a:xfrm>
           <a:prstGeom prst="roundRect">
             <a:avLst>
-              <a:gd name="adj" fmla="val 5333"/>
+              <a:gd name="adj" fmla="val 4706"/>
             </a:avLst>
           </a:prstGeom>
           <a:solidFill>
@@ -15997,8 +17059,8 @@
         </p:nvSpPr>
         <p:spPr>
           <a:xfrm>
-            <a:off x="8275320" y="4069080"/>
-            <a:ext cx="3136392" cy="594360"/>
+            <a:off x="7818120" y="3794760"/>
+            <a:ext cx="3593592" cy="438912"/>
           </a:xfrm>
           <a:prstGeom prst="rect">
             <a:avLst/>
@@ -16022,7 +17084,7 @@
                 <a:ea typeface="Cambria" pitchFamily="34" charset="-122"/>
                 <a:cs typeface="Cambria" pitchFamily="34" charset="-120"/>
               </a:rPr>
-              <a:t>Every version that traded did worse</a:t>
+              <a:t>Year by year: not fixed</a:t>
             </a:r>
             <a:endParaRPr lang="en-US" sz="1800" dirty="0"/>
           </a:p>
@@ -16036,8 +17098,8 @@
         </p:nvSpPr>
         <p:spPr>
           <a:xfrm>
-            <a:off x="8275320" y="4773168"/>
-            <a:ext cx="3136392" cy="941832"/>
+            <a:off x="7818120" y="4343400"/>
+            <a:ext cx="3593592" cy="1371600"/>
           </a:xfrm>
           <a:prstGeom prst="rect">
             <a:avLst/>
@@ -16058,45 +17120,9 @@
                   <a:schemeClr val="tx2"/>
                 </a:solidFill>
               </a:rPr>
-              <a:t>Even the ones invested 95% of the time ended about $70,000 behind.</a:t>
+              <a:t>The real share of down weeks swings (few in 2017, many in 2022). No correction stayed within 3 points in more than 4 of 10 years; our rule, set in advance, needed 8. So v3 failed its own calibration test.</a:t>
             </a:r>
             <a:endParaRPr lang="en-US" sz="1500" dirty="0"/>
-          </a:p>
-        </p:txBody>
-      </p:sp>
-      <p:sp>
-        <p:nvSpPr>
-          <p:cNvPr id="10" name="Text 7"/>
-          <p:cNvSpPr txBox="1"/>
-          <p:nvPr/>
-        </p:nvSpPr>
-        <p:spPr>
-          <a:xfrm>
-            <a:off x="548640" y="5943600"/>
-            <a:ext cx="11094415" cy="320040"/>
-          </a:xfrm>
-          <a:prstGeom prst="rect">
-            <a:avLst/>
-          </a:prstGeom>
-          <a:noFill/>
-          <a:ln/>
-        </p:spPr>
-        <p:txBody>
-          <a:bodyPr wrap="square" lIns="0" tIns="0" rIns="0" bIns="0" rtlCol="0" anchor="t"/>
-          <a:lstStyle/>
-          <a:p>
-            <a:pPr indent="0" marL="0">
-              <a:buNone/>
-            </a:pPr>
-            <a:r>
-              <a:rPr lang="en-US" sz="1300" i="1" dirty="0">
-                <a:solidFill>
-                  <a:schemeClr val="accent3"/>
-                </a:solidFill>
-              </a:rPr>
-              <a:t>Still to come: the frozen pick on 2025–26 data and a live paper-trade from 13 Oct 2026.</a:t>
-            </a:r>
-            <a:endParaRPr lang="en-US" sz="1300" dirty="0"/>
           </a:p>
         </p:txBody>
       </p:sp>
@@ -16205,26 +17231,144 @@
                 <a:ea typeface="Cambria" pitchFamily="34" charset="-122"/>
                 <a:cs typeface="Cambria" pitchFamily="34" charset="-120"/>
               </a:rPr>
-              <a:t>How we kept the test honest</a:t>
+              <a:t>With honest odds, the best rule is: don’t trade</a:t>
             </a:r>
             <a:endParaRPr lang="en-US" sz="3200" dirty="0"/>
           </a:p>
         </p:txBody>
       </p:sp>
-      <p:sp>
-        <p:nvSpPr>
-          <p:cNvPr id="3" name="Shape 1"/>
+      <p:graphicFrame>
+        <p:nvGraphicFramePr>
+          <p:cNvPr id="3" name="Chart 0" descr=""/>
+          <p:cNvGraphicFramePr/>
+          <p:nvPr/>
+        </p:nvGraphicFramePr>
+        <p:xfrm>
+          <a:off x="548640" y="1280160"/>
+          <a:ext cx="7223760" cy="4572000"/>
+        </p:xfrm>
+        <a:graphic xmlns:a="http://schemas.openxmlformats.org/drawingml/2006/main">
+          <a:graphicData uri="http://schemas.openxmlformats.org/drawingml/2006/chart">
+            <c:chart xmlns:c="http://schemas.openxmlformats.org/drawingml/2006/chart" r:id="rId1"/>
+          </a:graphicData>
+        </a:graphic>
+      </p:graphicFrame>
+      <p:sp>
+        <p:nvSpPr>
+          <p:cNvPr id="4" name="Shape 1"/>
           <p:cNvSpPr/>
           <p:nvPr/>
         </p:nvSpPr>
         <p:spPr>
           <a:xfrm>
-            <a:off x="548640" y="1417320"/>
-            <a:ext cx="5468112" cy="2103120"/>
+            <a:off x="8046720" y="1371600"/>
+            <a:ext cx="3593592" cy="2286000"/>
           </a:xfrm>
           <a:prstGeom prst="roundRect">
             <a:avLst>
-              <a:gd name="adj" fmla="val 5217"/>
+              <a:gd name="adj" fmla="val 4800"/>
+            </a:avLst>
+          </a:prstGeom>
+          <a:solidFill>
+            <a:srgbClr val="FBEDE4"/>
+          </a:solidFill>
+          <a:ln w="12700">
+            <a:solidFill>
+              <a:srgbClr val="FBEDE4"/>
+            </a:solidFill>
+            <a:prstDash val="solid"/>
+          </a:ln>
+        </p:spPr>
+      </p:sp>
+      <p:sp>
+        <p:nvSpPr>
+          <p:cNvPr id="5" name="Text 2"/>
+          <p:cNvSpPr txBox="1"/>
+          <p:nvPr/>
+        </p:nvSpPr>
+        <p:spPr>
+          <a:xfrm>
+            <a:off x="8275320" y="1600200"/>
+            <a:ext cx="3136392" cy="438912"/>
+          </a:xfrm>
+          <a:prstGeom prst="rect">
+            <a:avLst/>
+          </a:prstGeom>
+          <a:noFill/>
+          <a:ln/>
+        </p:spPr>
+        <p:txBody>
+          <a:bodyPr wrap="square" lIns="0" tIns="0" rIns="0" bIns="0" rtlCol="0" anchor="ctr"/>
+          <a:lstStyle/>
+          <a:p>
+            <a:pPr indent="0" marL="0">
+              <a:buNone/>
+            </a:pPr>
+            <a:r>
+              <a:rPr lang="en-US" sz="1800" b="1" dirty="0">
+                <a:solidFill>
+                  <a:schemeClr val="tx1"/>
+                </a:solidFill>
+                <a:latin typeface="Cambria" pitchFamily="34" charset="0"/>
+                <a:ea typeface="Cambria" pitchFamily="34" charset="-122"/>
+                <a:cs typeface="Cambria" pitchFamily="34" charset="-120"/>
+              </a:rPr>
+              <a:t>The pick never sold</a:t>
+            </a:r>
+            <a:endParaRPr lang="en-US" sz="1800" dirty="0"/>
+          </a:p>
+        </p:txBody>
+      </p:sp>
+      <p:sp>
+        <p:nvSpPr>
+          <p:cNvPr id="6" name="Text 3"/>
+          <p:cNvSpPr txBox="1"/>
+          <p:nvPr/>
+        </p:nvSpPr>
+        <p:spPr>
+          <a:xfrm>
+            <a:off x="8275320" y="2148840"/>
+            <a:ext cx="3136392" cy="1325880"/>
+          </a:xfrm>
+          <a:prstGeom prst="rect">
+            <a:avLst/>
+          </a:prstGeom>
+          <a:noFill/>
+          <a:ln/>
+        </p:spPr>
+        <p:txBody>
+          <a:bodyPr wrap="square" lIns="0" tIns="0" rIns="0" bIns="0" rtlCol="0" anchor="t"/>
+          <a:lstStyle/>
+          <a:p>
+            <a:pPr indent="0" marL="0">
+              <a:buNone/>
+            </a:pPr>
+            <a:r>
+              <a:rPr lang="en-US" sz="1500" dirty="0">
+                <a:solidFill>
+                  <a:schemeClr val="tx2"/>
+                </a:solidFill>
+              </a:rPr>
+              <a:t>Chosen by a rule fixed in advance. In ten years it never stepped out of the market: it is Buy &amp; Hold, and it ties Buy &amp; Hold.</a:t>
+            </a:r>
+            <a:endParaRPr lang="en-US" sz="1500" dirty="0"/>
+          </a:p>
+        </p:txBody>
+      </p:sp>
+      <p:sp>
+        <p:nvSpPr>
+          <p:cNvPr id="7" name="Shape 4"/>
+          <p:cNvSpPr/>
+          <p:nvPr/>
+        </p:nvSpPr>
+        <p:spPr>
+          <a:xfrm>
+            <a:off x="8046720" y="3840480"/>
+            <a:ext cx="3593592" cy="2057400"/>
+          </a:xfrm>
+          <a:prstGeom prst="roundRect">
+            <a:avLst>
+              <a:gd name="adj" fmla="val 5333"/>
             </a:avLst>
           </a:prstGeom>
           <a:solidFill>
@@ -16240,75 +17384,14 @@
       </p:sp>
       <p:sp>
         <p:nvSpPr>
-          <p:cNvPr id="4" name="Shape 2"/>
-          <p:cNvSpPr/>
-          <p:nvPr/>
-        </p:nvSpPr>
-        <p:spPr>
-          <a:xfrm>
-            <a:off x="777240" y="1645920"/>
-            <a:ext cx="438912" cy="438912"/>
-          </a:xfrm>
-          <a:prstGeom prst="ellipse">
-            <a:avLst/>
-          </a:prstGeom>
-          <a:solidFill>
-            <a:schemeClr val="accent1"/>
-          </a:solidFill>
-          <a:ln w="12700">
-            <a:solidFill>
-              <a:schemeClr val="accent1"/>
-            </a:solidFill>
-            <a:prstDash val="solid"/>
-          </a:ln>
-        </p:spPr>
-      </p:sp>
-      <p:sp>
-        <p:nvSpPr>
-          <p:cNvPr id="5" name="Text 3"/>
+          <p:cNvPr id="8" name="Text 5"/>
           <p:cNvSpPr txBox="1"/>
           <p:nvPr/>
         </p:nvSpPr>
         <p:spPr>
           <a:xfrm>
-            <a:off x="777240" y="1645920"/>
-            <a:ext cx="438912" cy="438912"/>
-          </a:xfrm>
-          <a:prstGeom prst="rect">
-            <a:avLst/>
-          </a:prstGeom>
-          <a:noFill/>
-          <a:ln/>
-        </p:spPr>
-        <p:txBody>
-          <a:bodyPr wrap="square" lIns="0" tIns="0" rIns="0" bIns="0" rtlCol="0" anchor="ctr"/>
-          <a:lstStyle/>
-          <a:p>
-            <a:pPr algn="ctr" indent="0" marL="0">
-              <a:buNone/>
-            </a:pPr>
-            <a:r>
-              <a:rPr lang="en-US" sz="1600" b="1" dirty="0">
-                <a:solidFill>
-                  <a:schemeClr val="bg1"/>
-                </a:solidFill>
-              </a:rPr>
-              <a:t>1</a:t>
-            </a:r>
-            <a:endParaRPr lang="en-US" sz="1600" dirty="0"/>
-          </a:p>
-        </p:txBody>
-      </p:sp>
-      <p:sp>
-        <p:nvSpPr>
-          <p:cNvPr id="6" name="Text 4"/>
-          <p:cNvSpPr txBox="1"/>
-          <p:nvPr/>
-        </p:nvSpPr>
-        <p:spPr>
-          <a:xfrm>
-            <a:off x="1371600" y="1645920"/>
-            <a:ext cx="4416552" cy="438912"/>
+            <a:off x="8275320" y="4069080"/>
+            <a:ext cx="3136392" cy="594360"/>
           </a:xfrm>
           <a:prstGeom prst="rect">
             <a:avLst/>
@@ -16332,7 +17415,7 @@
                 <a:ea typeface="Cambria" pitchFamily="34" charset="-122"/>
                 <a:cs typeface="Cambria" pitchFamily="34" charset="-120"/>
               </a:rPr>
-              <a:t>Plans written before code</a:t>
+              <a:t>Every version that traded did worse</a:t>
             </a:r>
             <a:endParaRPr lang="en-US" sz="1800" dirty="0"/>
           </a:p>
@@ -16340,14 +17423,14 @@
       </p:sp>
       <p:sp>
         <p:nvSpPr>
-          <p:cNvPr id="7" name="Text 5"/>
+          <p:cNvPr id="9" name="Text 6"/>
           <p:cNvSpPr txBox="1"/>
           <p:nvPr/>
         </p:nvSpPr>
         <p:spPr>
           <a:xfrm>
-            <a:off x="777240" y="2194560"/>
-            <a:ext cx="5010912" cy="1143000"/>
+            <a:off x="8275320" y="4773168"/>
+            <a:ext cx="3136392" cy="941832"/>
           </a:xfrm>
           <a:prstGeom prst="rect">
             <a:avLst/>
@@ -16368,7 +17451,7 @@
                   <a:schemeClr val="tx2"/>
                 </a:solidFill>
               </a:rPr>
-              <a:t>Each version’s design was committed before any code or result existed, with a digital fingerprint (SHA-256) so later edits would show.</a:t>
+              <a:t>Even the ones invested 95% of the time ended about $70,000 behind.</a:t>
             </a:r>
             <a:endParaRPr lang="en-US" sz="1500" dirty="0"/>
           </a:p>
@@ -16376,490 +17459,37 @@
       </p:sp>
       <p:sp>
         <p:nvSpPr>
-          <p:cNvPr id="8" name="Shape 6"/>
-          <p:cNvSpPr/>
-          <p:nvPr/>
-        </p:nvSpPr>
-        <p:spPr>
-          <a:xfrm>
-            <a:off x="6172200" y="1417320"/>
-            <a:ext cx="5468112" cy="2103120"/>
-          </a:xfrm>
-          <a:prstGeom prst="roundRect">
-            <a:avLst>
-              <a:gd name="adj" fmla="val 5217"/>
-            </a:avLst>
-          </a:prstGeom>
-          <a:solidFill>
-            <a:schemeClr val="bg2"/>
-          </a:solidFill>
-          <a:ln w="12700">
-            <a:solidFill>
-              <a:schemeClr val="bg2"/>
-            </a:solidFill>
-            <a:prstDash val="solid"/>
-          </a:ln>
-        </p:spPr>
-      </p:sp>
-      <p:sp>
-        <p:nvSpPr>
-          <p:cNvPr id="9" name="Shape 7"/>
-          <p:cNvSpPr/>
-          <p:nvPr/>
-        </p:nvSpPr>
-        <p:spPr>
-          <a:xfrm>
-            <a:off x="6400800" y="1645920"/>
-            <a:ext cx="438912" cy="438912"/>
-          </a:xfrm>
-          <a:prstGeom prst="ellipse">
-            <a:avLst/>
-          </a:prstGeom>
-          <a:solidFill>
-            <a:schemeClr val="accent1"/>
-          </a:solidFill>
-          <a:ln w="12700">
-            <a:solidFill>
-              <a:schemeClr val="accent1"/>
-            </a:solidFill>
-            <a:prstDash val="solid"/>
-          </a:ln>
-        </p:spPr>
-      </p:sp>
-      <p:sp>
-        <p:nvSpPr>
-          <p:cNvPr id="10" name="Text 8"/>
+          <p:cNvPr id="10" name="Text 7"/>
           <p:cNvSpPr txBox="1"/>
           <p:nvPr/>
         </p:nvSpPr>
         <p:spPr>
           <a:xfrm>
-            <a:off x="6400800" y="1645920"/>
-            <a:ext cx="438912" cy="438912"/>
-          </a:xfrm>
-          <a:prstGeom prst="rect">
-            <a:avLst/>
-          </a:prstGeom>
-          <a:noFill/>
-          <a:ln/>
-        </p:spPr>
-        <p:txBody>
-          <a:bodyPr wrap="square" lIns="0" tIns="0" rIns="0" bIns="0" rtlCol="0" anchor="ctr"/>
-          <a:lstStyle/>
-          <a:p>
-            <a:pPr algn="ctr" indent="0" marL="0">
-              <a:buNone/>
-            </a:pPr>
-            <a:r>
-              <a:rPr lang="en-US" sz="1600" b="1" dirty="0">
-                <a:solidFill>
-                  <a:schemeClr val="bg1"/>
-                </a:solidFill>
-              </a:rPr>
-              <a:t>2</a:t>
-            </a:r>
-            <a:endParaRPr lang="en-US" sz="1600" dirty="0"/>
-          </a:p>
-        </p:txBody>
-      </p:sp>
-      <p:sp>
-        <p:nvSpPr>
-          <p:cNvPr id="11" name="Text 9"/>
-          <p:cNvSpPr txBox="1"/>
-          <p:nvPr/>
-        </p:nvSpPr>
-        <p:spPr>
-          <a:xfrm>
-            <a:off x="6995160" y="1645920"/>
-            <a:ext cx="4416552" cy="438912"/>
-          </a:xfrm>
-          <a:prstGeom prst="rect">
-            <a:avLst/>
-          </a:prstGeom>
-          <a:noFill/>
-          <a:ln/>
-        </p:spPr>
-        <p:txBody>
-          <a:bodyPr wrap="square" lIns="0" tIns="0" rIns="0" bIns="0" rtlCol="0" anchor="ctr"/>
+            <a:off x="548640" y="5943600"/>
+            <a:ext cx="11094415" cy="320040"/>
+          </a:xfrm>
+          <a:prstGeom prst="rect">
+            <a:avLst/>
+          </a:prstGeom>
+          <a:noFill/>
+          <a:ln/>
+        </p:spPr>
+        <p:txBody>
+          <a:bodyPr wrap="square" lIns="0" tIns="0" rIns="0" bIns="0" rtlCol="0" anchor="t"/>
           <a:lstStyle/>
           <a:p>
             <a:pPr indent="0" marL="0">
               <a:buNone/>
             </a:pPr>
             <a:r>
-              <a:rPr lang="en-US" sz="1800" b="1" dirty="0">
-                <a:solidFill>
-                  <a:schemeClr val="tx1"/>
-                </a:solidFill>
-                <a:latin typeface="Cambria" pitchFamily="34" charset="0"/>
-                <a:ea typeface="Cambria" pitchFamily="34" charset="-122"/>
-                <a:cs typeface="Cambria" pitchFamily="34" charset="-120"/>
-              </a:rPr>
-              <a:t>Final exam opened once</a:t>
-            </a:r>
-            <a:endParaRPr lang="en-US" sz="1800" dirty="0"/>
-          </a:p>
-        </p:txBody>
-      </p:sp>
-      <p:sp>
-        <p:nvSpPr>
-          <p:cNvPr id="12" name="Text 10"/>
-          <p:cNvSpPr txBox="1"/>
-          <p:nvPr/>
-        </p:nvSpPr>
-        <p:spPr>
-          <a:xfrm>
-            <a:off x="6400800" y="2194560"/>
-            <a:ext cx="5010912" cy="1143000"/>
-          </a:xfrm>
-          <a:prstGeom prst="rect">
-            <a:avLst/>
-          </a:prstGeom>
-          <a:noFill/>
-          <a:ln/>
-        </p:spPr>
-        <p:txBody>
-          <a:bodyPr wrap="square" lIns="0" tIns="0" rIns="0" bIns="0" rtlCol="0" anchor="t"/>
-          <a:lstStyle/>
-          <a:p>
-            <a:pPr indent="0" marL="0">
-              <a:buNone/>
-            </a:pPr>
-            <a:r>
-              <a:rPr lang="en-US" sz="1500" dirty="0">
-                <a:solidFill>
-                  <a:schemeClr val="tx2"/>
-                </a:solidFill>
-              </a:rPr>
-              <a:t>Each version picked its model on earlier data, locked it, and only then saw the test years.</a:t>
-            </a:r>
-            <a:endParaRPr lang="en-US" sz="1500" dirty="0"/>
-          </a:p>
-        </p:txBody>
-      </p:sp>
-      <p:sp>
-        <p:nvSpPr>
-          <p:cNvPr id="13" name="Shape 11"/>
-          <p:cNvSpPr/>
-          <p:nvPr/>
-        </p:nvSpPr>
-        <p:spPr>
-          <a:xfrm>
-            <a:off x="548640" y="3703320"/>
-            <a:ext cx="5468112" cy="2103120"/>
-          </a:xfrm>
-          <a:prstGeom prst="roundRect">
-            <a:avLst>
-              <a:gd name="adj" fmla="val 5217"/>
-            </a:avLst>
-          </a:prstGeom>
-          <a:solidFill>
-            <a:schemeClr val="bg2"/>
-          </a:solidFill>
-          <a:ln w="12700">
-            <a:solidFill>
-              <a:schemeClr val="bg2"/>
-            </a:solidFill>
-            <a:prstDash val="solid"/>
-          </a:ln>
-        </p:spPr>
-      </p:sp>
-      <p:sp>
-        <p:nvSpPr>
-          <p:cNvPr id="14" name="Shape 12"/>
-          <p:cNvSpPr/>
-          <p:nvPr/>
-        </p:nvSpPr>
-        <p:spPr>
-          <a:xfrm>
-            <a:off x="777240" y="3931920"/>
-            <a:ext cx="438912" cy="438912"/>
-          </a:xfrm>
-          <a:prstGeom prst="ellipse">
-            <a:avLst/>
-          </a:prstGeom>
-          <a:solidFill>
-            <a:schemeClr val="accent1"/>
-          </a:solidFill>
-          <a:ln w="12700">
-            <a:solidFill>
-              <a:schemeClr val="accent1"/>
-            </a:solidFill>
-            <a:prstDash val="solid"/>
-          </a:ln>
-        </p:spPr>
-      </p:sp>
-      <p:sp>
-        <p:nvSpPr>
-          <p:cNvPr id="15" name="Text 13"/>
-          <p:cNvSpPr txBox="1"/>
-          <p:nvPr/>
-        </p:nvSpPr>
-        <p:spPr>
-          <a:xfrm>
-            <a:off x="777240" y="3931920"/>
-            <a:ext cx="438912" cy="438912"/>
-          </a:xfrm>
-          <a:prstGeom prst="rect">
-            <a:avLst/>
-          </a:prstGeom>
-          <a:noFill/>
-          <a:ln/>
-        </p:spPr>
-        <p:txBody>
-          <a:bodyPr wrap="square" lIns="0" tIns="0" rIns="0" bIns="0" rtlCol="0" anchor="ctr"/>
-          <a:lstStyle/>
-          <a:p>
-            <a:pPr algn="ctr" indent="0" marL="0">
-              <a:buNone/>
-            </a:pPr>
-            <a:r>
-              <a:rPr lang="en-US" sz="1600" b="1" dirty="0">
-                <a:solidFill>
-                  <a:schemeClr val="bg1"/>
-                </a:solidFill>
-              </a:rPr>
-              <a:t>3</a:t>
-            </a:r>
-            <a:endParaRPr lang="en-US" sz="1600" dirty="0"/>
-          </a:p>
-        </p:txBody>
-      </p:sp>
-      <p:sp>
-        <p:nvSpPr>
-          <p:cNvPr id="16" name="Text 14"/>
-          <p:cNvSpPr txBox="1"/>
-          <p:nvPr/>
-        </p:nvSpPr>
-        <p:spPr>
-          <a:xfrm>
-            <a:off x="1371600" y="3931920"/>
-            <a:ext cx="4416552" cy="438912"/>
-          </a:xfrm>
-          <a:prstGeom prst="rect">
-            <a:avLst/>
-          </a:prstGeom>
-          <a:noFill/>
-          <a:ln/>
-        </p:spPr>
-        <p:txBody>
-          <a:bodyPr wrap="square" lIns="0" tIns="0" rIns="0" bIns="0" rtlCol="0" anchor="ctr"/>
-          <a:lstStyle/>
-          <a:p>
-            <a:pPr indent="0" marL="0">
-              <a:buNone/>
-            </a:pPr>
-            <a:r>
-              <a:rPr lang="en-US" sz="1800" b="1" dirty="0">
-                <a:solidFill>
-                  <a:schemeClr val="tx1"/>
-                </a:solidFill>
-                <a:latin typeface="Cambria" pitchFamily="34" charset="0"/>
-                <a:ea typeface="Cambria" pitchFamily="34" charset="-122"/>
-                <a:cs typeface="Cambria" pitchFamily="34" charset="-120"/>
-              </a:rPr>
-              <a:t>46 automated tests</a:t>
-            </a:r>
-            <a:endParaRPr lang="en-US" sz="1800" dirty="0"/>
-          </a:p>
-        </p:txBody>
-      </p:sp>
-      <p:sp>
-        <p:nvSpPr>
-          <p:cNvPr id="17" name="Text 15"/>
-          <p:cNvSpPr txBox="1"/>
-          <p:nvPr/>
-        </p:nvSpPr>
-        <p:spPr>
-          <a:xfrm>
-            <a:off x="777240" y="4480560"/>
-            <a:ext cx="5010912" cy="1143000"/>
-          </a:xfrm>
-          <a:prstGeom prst="rect">
-            <a:avLst/>
-          </a:prstGeom>
-          <a:noFill/>
-          <a:ln/>
-        </p:spPr>
-        <p:txBody>
-          <a:bodyPr wrap="square" lIns="0" tIns="0" rIns="0" bIns="0" rtlCol="0" anchor="t"/>
-          <a:lstStyle/>
-          <a:p>
-            <a:pPr indent="0" marL="0">
-              <a:buNone/>
-            </a:pPr>
-            <a:r>
-              <a:rPr lang="en-US" sz="1500" dirty="0">
-                <a:solidFill>
-                  <a:schemeClr val="tx2"/>
-                </a:solidFill>
-              </a:rPr>
-              <a:t>They check the model never sees the future, e.g. scrambling future data must not change any prediction.</a:t>
-            </a:r>
-            <a:endParaRPr lang="en-US" sz="1500" dirty="0"/>
-          </a:p>
-        </p:txBody>
-      </p:sp>
-      <p:sp>
-        <p:nvSpPr>
-          <p:cNvPr id="18" name="Shape 16"/>
-          <p:cNvSpPr/>
-          <p:nvPr/>
-        </p:nvSpPr>
-        <p:spPr>
-          <a:xfrm>
-            <a:off x="6172200" y="3703320"/>
-            <a:ext cx="5468112" cy="2103120"/>
-          </a:xfrm>
-          <a:prstGeom prst="roundRect">
-            <a:avLst>
-              <a:gd name="adj" fmla="val 5217"/>
-            </a:avLst>
-          </a:prstGeom>
-          <a:solidFill>
-            <a:schemeClr val="bg2"/>
-          </a:solidFill>
-          <a:ln w="12700">
-            <a:solidFill>
-              <a:schemeClr val="bg2"/>
-            </a:solidFill>
-            <a:prstDash val="solid"/>
-          </a:ln>
-        </p:spPr>
-      </p:sp>
-      <p:sp>
-        <p:nvSpPr>
-          <p:cNvPr id="19" name="Shape 17"/>
-          <p:cNvSpPr/>
-          <p:nvPr/>
-        </p:nvSpPr>
-        <p:spPr>
-          <a:xfrm>
-            <a:off x="6400800" y="3931920"/>
-            <a:ext cx="438912" cy="438912"/>
-          </a:xfrm>
-          <a:prstGeom prst="ellipse">
-            <a:avLst/>
-          </a:prstGeom>
-          <a:solidFill>
-            <a:schemeClr val="accent1"/>
-          </a:solidFill>
-          <a:ln w="12700">
-            <a:solidFill>
-              <a:schemeClr val="accent1"/>
-            </a:solidFill>
-            <a:prstDash val="solid"/>
-          </a:ln>
-        </p:spPr>
-      </p:sp>
-      <p:sp>
-        <p:nvSpPr>
-          <p:cNvPr id="20" name="Text 18"/>
-          <p:cNvSpPr txBox="1"/>
-          <p:nvPr/>
-        </p:nvSpPr>
-        <p:spPr>
-          <a:xfrm>
-            <a:off x="6400800" y="3931920"/>
-            <a:ext cx="438912" cy="438912"/>
-          </a:xfrm>
-          <a:prstGeom prst="rect">
-            <a:avLst/>
-          </a:prstGeom>
-          <a:noFill/>
-          <a:ln/>
-        </p:spPr>
-        <p:txBody>
-          <a:bodyPr wrap="square" lIns="0" tIns="0" rIns="0" bIns="0" rtlCol="0" anchor="ctr"/>
-          <a:lstStyle/>
-          <a:p>
-            <a:pPr algn="ctr" indent="0" marL="0">
-              <a:buNone/>
-            </a:pPr>
-            <a:r>
-              <a:rPr lang="en-US" sz="1600" b="1" dirty="0">
-                <a:solidFill>
-                  <a:schemeClr val="bg1"/>
-                </a:solidFill>
-              </a:rPr>
-              <a:t>4</a:t>
-            </a:r>
-            <a:endParaRPr lang="en-US" sz="1600" dirty="0"/>
-          </a:p>
-        </p:txBody>
-      </p:sp>
-      <p:sp>
-        <p:nvSpPr>
-          <p:cNvPr id="21" name="Text 19"/>
-          <p:cNvSpPr txBox="1"/>
-          <p:nvPr/>
-        </p:nvSpPr>
-        <p:spPr>
-          <a:xfrm>
-            <a:off x="6995160" y="3931920"/>
-            <a:ext cx="4416552" cy="438912"/>
-          </a:xfrm>
-          <a:prstGeom prst="rect">
-            <a:avLst/>
-          </a:prstGeom>
-          <a:noFill/>
-          <a:ln/>
-        </p:spPr>
-        <p:txBody>
-          <a:bodyPr wrap="square" lIns="0" tIns="0" rIns="0" bIns="0" rtlCol="0" anchor="ctr"/>
-          <a:lstStyle/>
-          <a:p>
-            <a:pPr indent="0" marL="0">
-              <a:buNone/>
-            </a:pPr>
-            <a:r>
-              <a:rPr lang="en-US" sz="1800" b="1" dirty="0">
-                <a:solidFill>
-                  <a:schemeClr val="tx1"/>
-                </a:solidFill>
-                <a:latin typeface="Cambria" pitchFamily="34" charset="0"/>
-                <a:ea typeface="Cambria" pitchFamily="34" charset="-122"/>
-                <a:cs typeface="Cambria" pitchFamily="34" charset="-120"/>
-              </a:rPr>
-              <a:t>Failures reported, not hidden</a:t>
-            </a:r>
-            <a:endParaRPr lang="en-US" sz="1800" dirty="0"/>
-          </a:p>
-        </p:txBody>
-      </p:sp>
-      <p:sp>
-        <p:nvSpPr>
-          <p:cNvPr id="22" name="Text 20"/>
-          <p:cNvSpPr txBox="1"/>
-          <p:nvPr/>
-        </p:nvSpPr>
-        <p:spPr>
-          <a:xfrm>
-            <a:off x="6400800" y="4480560"/>
-            <a:ext cx="5010912" cy="1143000"/>
-          </a:xfrm>
-          <a:prstGeom prst="rect">
-            <a:avLst/>
-          </a:prstGeom>
-          <a:noFill/>
-          <a:ln/>
-        </p:spPr>
-        <p:txBody>
-          <a:bodyPr wrap="square" lIns="0" tIns="0" rIns="0" bIns="0" rtlCol="0" anchor="t"/>
-          <a:lstStyle/>
-          <a:p>
-            <a:pPr indent="0" marL="0">
-              <a:buNone/>
-            </a:pPr>
-            <a:r>
-              <a:rPr lang="en-US" sz="1500" dirty="0">
-                <a:solidFill>
-                  <a:schemeClr val="tx2"/>
-                </a:solidFill>
-              </a:rPr>
-              <a:t>Every change after results is logged, including a one-day overlap we found in v1’s work and v3 failing its own calibration test.</a:t>
-            </a:r>
-            <a:endParaRPr lang="en-US" sz="1500" dirty="0"/>
+              <a:rPr lang="en-US" sz="1300" i="1" dirty="0">
+                <a:solidFill>
+                  <a:schemeClr val="accent3"/>
+                </a:solidFill>
+              </a:rPr>
+              <a:t>Still to come: the frozen pick on 2025–26 data and a live paper-trade from 13 Oct 2026.</a:t>
+            </a:r>
+            <a:endParaRPr lang="en-US" sz="1300" dirty="0"/>
           </a:p>
         </p:txBody>
       </p:sp>
@@ -16968,7 +17598,7 @@
                 <a:ea typeface="Cambria" pitchFamily="34" charset="-122"/>
                 <a:cs typeface="Cambria" pitchFamily="34" charset="-120"/>
               </a:rPr>
-              <a:t>A flaw of machine learning, or of the question?</a:t>
+              <a:t>How we kept the test honest</a:t>
             </a:r>
             <a:endParaRPr lang="en-US" sz="3200" dirty="0"/>
           </a:p>
@@ -16982,114 +17612,12 @@
         </p:nvSpPr>
         <p:spPr>
           <a:xfrm>
-            <a:off x="548640" y="1371600"/>
-            <a:ext cx="11094415" cy="1024128"/>
+            <a:off x="548640" y="1417320"/>
+            <a:ext cx="5468112" cy="2103120"/>
           </a:xfrm>
           <a:prstGeom prst="roundRect">
             <a:avLst>
-              <a:gd name="adj" fmla="val 8929"/>
-            </a:avLst>
-          </a:prstGeom>
-          <a:solidFill>
-            <a:srgbClr val="FBEDE4"/>
-          </a:solidFill>
-          <a:ln w="12700">
-            <a:solidFill>
-              <a:srgbClr val="FBEDE4"/>
-            </a:solidFill>
-            <a:prstDash val="solid"/>
-          </a:ln>
-        </p:spPr>
-      </p:sp>
-      <p:sp>
-        <p:nvSpPr>
-          <p:cNvPr id="4" name="Text 2"/>
-          <p:cNvSpPr txBox="1"/>
-          <p:nvPr/>
-        </p:nvSpPr>
-        <p:spPr>
-          <a:xfrm>
-            <a:off x="822960" y="1371600"/>
-            <a:ext cx="3291840" cy="1024128"/>
-          </a:xfrm>
-          <a:prstGeom prst="rect">
-            <a:avLst/>
-          </a:prstGeom>
-          <a:noFill/>
-          <a:ln/>
-        </p:spPr>
-        <p:txBody>
-          <a:bodyPr wrap="square" lIns="0" tIns="0" rIns="0" bIns="0" rtlCol="0" anchor="ctr"/>
-          <a:lstStyle/>
-          <a:p>
-            <a:pPr indent="0" marL="0">
-              <a:buNone/>
-            </a:pPr>
-            <a:r>
-              <a:rPr lang="en-US" sz="1900" b="1" dirty="0">
-                <a:solidFill>
-                  <a:schemeClr val="tx1"/>
-                </a:solidFill>
-                <a:latin typeface="Cambria" pitchFamily="34" charset="0"/>
-                <a:ea typeface="Cambria" pitchFamily="34" charset="-122"/>
-                <a:cs typeface="Cambria" pitchFamily="34" charset="-120"/>
-              </a:rPr>
-              <a:t>Mostly the question</a:t>
-            </a:r>
-            <a:endParaRPr lang="en-US" sz="1900" dirty="0"/>
-          </a:p>
-        </p:txBody>
-      </p:sp>
-      <p:sp>
-        <p:nvSpPr>
-          <p:cNvPr id="5" name="Text 3"/>
-          <p:cNvSpPr txBox="1"/>
-          <p:nvPr/>
-        </p:nvSpPr>
-        <p:spPr>
-          <a:xfrm>
-            <a:off x="4297680" y="1371600"/>
-            <a:ext cx="7116775" cy="1024128"/>
-          </a:xfrm>
-          <a:prstGeom prst="rect">
-            <a:avLst/>
-          </a:prstGeom>
-          <a:noFill/>
-          <a:ln/>
-        </p:spPr>
-        <p:txBody>
-          <a:bodyPr wrap="square" lIns="0" tIns="0" rIns="0" bIns="0" rtlCol="0" anchor="ctr"/>
-          <a:lstStyle/>
-          <a:p>
-            <a:pPr indent="0" marL="0">
-              <a:buNone/>
-            </a:pPr>
-            <a:r>
-              <a:rPr lang="en-US" sz="1600" dirty="0">
-                <a:solidFill>
-                  <a:schemeClr val="tx2"/>
-                </a:solidFill>
-              </a:rPr>
-              <a:t>We asked for next week’s direction of the world’s most-watched fund, using only its own public price history. Simple patterns there get traded away, and no algorithm can find information that isn’t in the data.</a:t>
-            </a:r>
-            <a:endParaRPr lang="en-US" sz="1600" dirty="0"/>
-          </a:p>
-        </p:txBody>
-      </p:sp>
-      <p:sp>
-        <p:nvSpPr>
-          <p:cNvPr id="6" name="Shape 4"/>
-          <p:cNvSpPr/>
-          <p:nvPr/>
-        </p:nvSpPr>
-        <p:spPr>
-          <a:xfrm>
-            <a:off x="548640" y="2514600"/>
-            <a:ext cx="11094415" cy="1024128"/>
-          </a:xfrm>
-          <a:prstGeom prst="roundRect">
-            <a:avLst>
-              <a:gd name="adj" fmla="val 8929"/>
+              <a:gd name="adj" fmla="val 5217"/>
             </a:avLst>
           </a:prstGeom>
           <a:solidFill>
@@ -17105,14 +17633,39 @@
       </p:sp>
       <p:sp>
         <p:nvSpPr>
-          <p:cNvPr id="7" name="Text 5"/>
+          <p:cNvPr id="4" name="Shape 2"/>
+          <p:cNvSpPr/>
+          <p:nvPr/>
+        </p:nvSpPr>
+        <p:spPr>
+          <a:xfrm>
+            <a:off x="777240" y="1645920"/>
+            <a:ext cx="438912" cy="438912"/>
+          </a:xfrm>
+          <a:prstGeom prst="ellipse">
+            <a:avLst/>
+          </a:prstGeom>
+          <a:solidFill>
+            <a:schemeClr val="accent1"/>
+          </a:solidFill>
+          <a:ln w="12700">
+            <a:solidFill>
+              <a:schemeClr val="accent1"/>
+            </a:solidFill>
+            <a:prstDash val="solid"/>
+          </a:ln>
+        </p:spPr>
+      </p:sp>
+      <p:sp>
+        <p:nvSpPr>
+          <p:cNvPr id="5" name="Text 3"/>
           <p:cNvSpPr txBox="1"/>
           <p:nvPr/>
         </p:nvSpPr>
         <p:spPr>
           <a:xfrm>
-            <a:off x="822960" y="2514600"/>
-            <a:ext cx="3291840" cy="1024128"/>
+            <a:off x="777240" y="1645920"/>
+            <a:ext cx="438912" cy="438912"/>
           </a:xfrm>
           <a:prstGeom prst="rect">
             <a:avLst/>
@@ -17124,11 +17677,47 @@
           <a:bodyPr wrap="square" lIns="0" tIns="0" rIns="0" bIns="0" rtlCol="0" anchor="ctr"/>
           <a:lstStyle/>
           <a:p>
+            <a:pPr algn="ctr" indent="0" marL="0">
+              <a:buNone/>
+            </a:pPr>
+            <a:r>
+              <a:rPr lang="en-US" sz="1600" b="1" dirty="0">
+                <a:solidFill>
+                  <a:schemeClr val="bg1"/>
+                </a:solidFill>
+              </a:rPr>
+              <a:t>1</a:t>
+            </a:r>
+            <a:endParaRPr lang="en-US" sz="1600" dirty="0"/>
+          </a:p>
+        </p:txBody>
+      </p:sp>
+      <p:sp>
+        <p:nvSpPr>
+          <p:cNvPr id="6" name="Text 4"/>
+          <p:cNvSpPr txBox="1"/>
+          <p:nvPr/>
+        </p:nvSpPr>
+        <p:spPr>
+          <a:xfrm>
+            <a:off x="1371600" y="1645920"/>
+            <a:ext cx="4416552" cy="438912"/>
+          </a:xfrm>
+          <a:prstGeom prst="rect">
+            <a:avLst/>
+          </a:prstGeom>
+          <a:noFill/>
+          <a:ln/>
+        </p:spPr>
+        <p:txBody>
+          <a:bodyPr wrap="square" lIns="0" tIns="0" rIns="0" bIns="0" rtlCol="0" anchor="ctr"/>
+          <a:lstStyle/>
+          <a:p>
             <a:pPr indent="0" marL="0">
               <a:buNone/>
             </a:pPr>
             <a:r>
-              <a:rPr lang="en-US" sz="1900" b="1" dirty="0">
+              <a:rPr lang="en-US" sz="1800" b="1" dirty="0">
                 <a:solidFill>
                   <a:schemeClr val="tx1"/>
                 </a:solidFill>
@@ -17136,62 +17725,62 @@
                 <a:ea typeface="Cambria" pitchFamily="34" charset="-122"/>
                 <a:cs typeface="Cambria" pitchFamily="34" charset="-120"/>
               </a:rPr>
-              <a:t>Partly our own limits</a:t>
-            </a:r>
-            <a:endParaRPr lang="en-US" sz="1900" dirty="0"/>
-          </a:p>
-        </p:txBody>
-      </p:sp>
-      <p:sp>
-        <p:nvSpPr>
-          <p:cNvPr id="8" name="Text 6"/>
+              <a:t>Plans written before code</a:t>
+            </a:r>
+            <a:endParaRPr lang="en-US" sz="1800" dirty="0"/>
+          </a:p>
+        </p:txBody>
+      </p:sp>
+      <p:sp>
+        <p:nvSpPr>
+          <p:cNvPr id="7" name="Text 5"/>
           <p:cNvSpPr txBox="1"/>
           <p:nvPr/>
         </p:nvSpPr>
         <p:spPr>
           <a:xfrm>
-            <a:off x="4297680" y="2514600"/>
-            <a:ext cx="7116775" cy="1024128"/>
-          </a:xfrm>
-          <a:prstGeom prst="rect">
-            <a:avLst/>
-          </a:prstGeom>
-          <a:noFill/>
-          <a:ln/>
-        </p:spPr>
-        <p:txBody>
-          <a:bodyPr wrap="square" lIns="0" tIns="0" rIns="0" bIns="0" rtlCol="0" anchor="ctr"/>
+            <a:off x="777240" y="2194560"/>
+            <a:ext cx="5010912" cy="1143000"/>
+          </a:xfrm>
+          <a:prstGeom prst="rect">
+            <a:avLst/>
+          </a:prstGeom>
+          <a:noFill/>
+          <a:ln/>
+        </p:spPr>
+        <p:txBody>
+          <a:bodyPr wrap="square" lIns="0" tIns="0" rIns="0" bIns="0" rtlCol="0" anchor="t"/>
           <a:lstStyle/>
           <a:p>
             <a:pPr indent="0" marL="0">
               <a:buNone/>
             </a:pPr>
             <a:r>
-              <a:rPr lang="en-US" sz="1600" dirty="0">
+              <a:rPr lang="en-US" sz="1500" dirty="0">
                 <a:solidFill>
                   <a:schemeClr val="tx2"/>
                 </a:solidFill>
               </a:rPr>
-              <a:t>One fund, all in or all out, price data only, a one-week horizon. Lifting these makes the task easier, but wouldn’t flip the result: even with zero fees, v1 still lost.</a:t>
-            </a:r>
-            <a:endParaRPr lang="en-US" sz="1600" dirty="0"/>
-          </a:p>
-        </p:txBody>
-      </p:sp>
-      <p:sp>
-        <p:nvSpPr>
-          <p:cNvPr id="9" name="Shape 7"/>
+              <a:t>Each version’s design was committed before any code or result existed, with a digital fingerprint (SHA-256) so later edits would show.</a:t>
+            </a:r>
+            <a:endParaRPr lang="en-US" sz="1500" dirty="0"/>
+          </a:p>
+        </p:txBody>
+      </p:sp>
+      <p:sp>
+        <p:nvSpPr>
+          <p:cNvPr id="8" name="Shape 6"/>
           <p:cNvSpPr/>
           <p:nvPr/>
         </p:nvSpPr>
         <p:spPr>
           <a:xfrm>
-            <a:off x="548640" y="3657600"/>
-            <a:ext cx="11094415" cy="1024128"/>
+            <a:off x="6172200" y="1417320"/>
+            <a:ext cx="5468112" cy="2103120"/>
           </a:xfrm>
           <a:prstGeom prst="roundRect">
             <a:avLst>
-              <a:gd name="adj" fmla="val 8929"/>
+              <a:gd name="adj" fmla="val 5217"/>
             </a:avLst>
           </a:prstGeom>
           <a:solidFill>
@@ -17207,14 +17796,39 @@
       </p:sp>
       <p:sp>
         <p:nvSpPr>
+          <p:cNvPr id="9" name="Shape 7"/>
+          <p:cNvSpPr/>
+          <p:nvPr/>
+        </p:nvSpPr>
+        <p:spPr>
+          <a:xfrm>
+            <a:off x="6400800" y="1645920"/>
+            <a:ext cx="438912" cy="438912"/>
+          </a:xfrm>
+          <a:prstGeom prst="ellipse">
+            <a:avLst/>
+          </a:prstGeom>
+          <a:solidFill>
+            <a:schemeClr val="accent1"/>
+          </a:solidFill>
+          <a:ln w="12700">
+            <a:solidFill>
+              <a:schemeClr val="accent1"/>
+            </a:solidFill>
+            <a:prstDash val="solid"/>
+          </a:ln>
+        </p:spPr>
+      </p:sp>
+      <p:sp>
+        <p:nvSpPr>
           <p:cNvPr id="10" name="Text 8"/>
           <p:cNvSpPr txBox="1"/>
           <p:nvPr/>
         </p:nvSpPr>
         <p:spPr>
           <a:xfrm>
-            <a:off x="822960" y="3657600"/>
-            <a:ext cx="3291840" cy="1024128"/>
+            <a:off x="6400800" y="1645920"/>
+            <a:ext cx="438912" cy="438912"/>
           </a:xfrm>
           <a:prstGeom prst="rect">
             <a:avLst/>
@@ -17226,11 +17840,47 @@
           <a:bodyPr wrap="square" lIns="0" tIns="0" rIns="0" bIns="0" rtlCol="0" anchor="ctr"/>
           <a:lstStyle/>
           <a:p>
+            <a:pPr algn="ctr" indent="0" marL="0">
+              <a:buNone/>
+            </a:pPr>
+            <a:r>
+              <a:rPr lang="en-US" sz="1600" b="1" dirty="0">
+                <a:solidFill>
+                  <a:schemeClr val="bg1"/>
+                </a:solidFill>
+              </a:rPr>
+              <a:t>2</a:t>
+            </a:r>
+            <a:endParaRPr lang="en-US" sz="1600" dirty="0"/>
+          </a:p>
+        </p:txBody>
+      </p:sp>
+      <p:sp>
+        <p:nvSpPr>
+          <p:cNvPr id="11" name="Text 9"/>
+          <p:cNvSpPr txBox="1"/>
+          <p:nvPr/>
+        </p:nvSpPr>
+        <p:spPr>
+          <a:xfrm>
+            <a:off x="6995160" y="1645920"/>
+            <a:ext cx="4416552" cy="438912"/>
+          </a:xfrm>
+          <a:prstGeom prst="rect">
+            <a:avLst/>
+          </a:prstGeom>
+          <a:noFill/>
+          <a:ln/>
+        </p:spPr>
+        <p:txBody>
+          <a:bodyPr wrap="square" lIns="0" tIns="0" rIns="0" bIns="0" rtlCol="0" anchor="ctr"/>
+          <a:lstStyle/>
+          <a:p>
             <a:pPr indent="0" marL="0">
               <a:buNone/>
             </a:pPr>
             <a:r>
-              <a:rPr lang="en-US" sz="1900" b="1" dirty="0">
+              <a:rPr lang="en-US" sz="1800" b="1" dirty="0">
                 <a:solidFill>
                   <a:schemeClr val="tx1"/>
                 </a:solidFill>
@@ -17238,62 +17888,62 @@
                 <a:ea typeface="Cambria" pitchFamily="34" charset="-122"/>
                 <a:cs typeface="Cambria" pitchFamily="34" charset="-120"/>
               </a:rPr>
-              <a:t>Where machine learning does help</a:t>
-            </a:r>
-            <a:endParaRPr lang="en-US" sz="1900" dirty="0"/>
-          </a:p>
-        </p:txBody>
-      </p:sp>
-      <p:sp>
-        <p:nvSpPr>
-          <p:cNvPr id="11" name="Text 9"/>
+              <a:t>Final exam opened once</a:t>
+            </a:r>
+            <a:endParaRPr lang="en-US" sz="1800" dirty="0"/>
+          </a:p>
+        </p:txBody>
+      </p:sp>
+      <p:sp>
+        <p:nvSpPr>
+          <p:cNvPr id="12" name="Text 10"/>
           <p:cNvSpPr txBox="1"/>
           <p:nvPr/>
         </p:nvSpPr>
         <p:spPr>
           <a:xfrm>
-            <a:off x="4297680" y="3657600"/>
-            <a:ext cx="7116775" cy="1024128"/>
-          </a:xfrm>
-          <a:prstGeom prst="rect">
-            <a:avLst/>
-          </a:prstGeom>
-          <a:noFill/>
-          <a:ln/>
-        </p:spPr>
-        <p:txBody>
-          <a:bodyPr wrap="square" lIns="0" tIns="0" rIns="0" bIns="0" rtlCol="0" anchor="ctr"/>
+            <a:off x="6400800" y="2194560"/>
+            <a:ext cx="5010912" cy="1143000"/>
+          </a:xfrm>
+          <a:prstGeom prst="rect">
+            <a:avLst/>
+          </a:prstGeom>
+          <a:noFill/>
+          <a:ln/>
+        </p:spPr>
+        <p:txBody>
+          <a:bodyPr wrap="square" lIns="0" tIns="0" rIns="0" bIns="0" rtlCol="0" anchor="t"/>
           <a:lstStyle/>
           <a:p>
             <a:pPr indent="0" marL="0">
               <a:buNone/>
             </a:pPr>
             <a:r>
-              <a:rPr lang="en-US" sz="1600" dirty="0">
+              <a:rPr lang="en-US" sz="1500" dirty="0">
                 <a:solidFill>
                   <a:schemeClr val="tx2"/>
                 </a:solidFill>
               </a:rPr>
-              <a:t>Ranking many assets against each other, forecasting risk to size positions, and using data most people don’t have. Even there the edges are usually small and shrink after costs.</a:t>
-            </a:r>
-            <a:endParaRPr lang="en-US" sz="1600" dirty="0"/>
-          </a:p>
-        </p:txBody>
-      </p:sp>
-      <p:sp>
-        <p:nvSpPr>
-          <p:cNvPr id="12" name="Shape 10"/>
+              <a:t>Each version picked its model on earlier data, locked it, and only then saw the test years.</a:t>
+            </a:r>
+            <a:endParaRPr lang="en-US" sz="1500" dirty="0"/>
+          </a:p>
+        </p:txBody>
+      </p:sp>
+      <p:sp>
+        <p:nvSpPr>
+          <p:cNvPr id="13" name="Shape 11"/>
           <p:cNvSpPr/>
           <p:nvPr/>
         </p:nvSpPr>
         <p:spPr>
           <a:xfrm>
-            <a:off x="548640" y="4800600"/>
-            <a:ext cx="11094415" cy="1024128"/>
+            <a:off x="548640" y="3703320"/>
+            <a:ext cx="5468112" cy="2103120"/>
           </a:xfrm>
           <a:prstGeom prst="roundRect">
             <a:avLst>
-              <a:gd name="adj" fmla="val 8929"/>
+              <a:gd name="adj" fmla="val 5217"/>
             </a:avLst>
           </a:prstGeom>
           <a:solidFill>
@@ -17309,14 +17959,39 @@
       </p:sp>
       <p:sp>
         <p:nvSpPr>
-          <p:cNvPr id="13" name="Text 11"/>
+          <p:cNvPr id="14" name="Shape 12"/>
+          <p:cNvSpPr/>
+          <p:nvPr/>
+        </p:nvSpPr>
+        <p:spPr>
+          <a:xfrm>
+            <a:off x="777240" y="3931920"/>
+            <a:ext cx="438912" cy="438912"/>
+          </a:xfrm>
+          <a:prstGeom prst="ellipse">
+            <a:avLst/>
+          </a:prstGeom>
+          <a:solidFill>
+            <a:schemeClr val="accent1"/>
+          </a:solidFill>
+          <a:ln w="12700">
+            <a:solidFill>
+              <a:schemeClr val="accent1"/>
+            </a:solidFill>
+            <a:prstDash val="solid"/>
+          </a:ln>
+        </p:spPr>
+      </p:sp>
+      <p:sp>
+        <p:nvSpPr>
+          <p:cNvPr id="15" name="Text 13"/>
           <p:cNvSpPr txBox="1"/>
           <p:nvPr/>
         </p:nvSpPr>
         <p:spPr>
           <a:xfrm>
-            <a:off x="822960" y="4800600"/>
-            <a:ext cx="3291840" cy="1024128"/>
+            <a:off x="777240" y="3931920"/>
+            <a:ext cx="438912" cy="438912"/>
           </a:xfrm>
           <a:prstGeom prst="rect">
             <a:avLst/>
@@ -17328,11 +18003,47 @@
           <a:bodyPr wrap="square" lIns="0" tIns="0" rIns="0" bIns="0" rtlCol="0" anchor="ctr"/>
           <a:lstStyle/>
           <a:p>
+            <a:pPr algn="ctr" indent="0" marL="0">
+              <a:buNone/>
+            </a:pPr>
+            <a:r>
+              <a:rPr lang="en-US" sz="1600" b="1" dirty="0">
+                <a:solidFill>
+                  <a:schemeClr val="bg1"/>
+                </a:solidFill>
+              </a:rPr>
+              <a:t>3</a:t>
+            </a:r>
+            <a:endParaRPr lang="en-US" sz="1600" dirty="0"/>
+          </a:p>
+        </p:txBody>
+      </p:sp>
+      <p:sp>
+        <p:nvSpPr>
+          <p:cNvPr id="16" name="Text 14"/>
+          <p:cNvSpPr txBox="1"/>
+          <p:nvPr/>
+        </p:nvSpPr>
+        <p:spPr>
+          <a:xfrm>
+            <a:off x="1371600" y="3931920"/>
+            <a:ext cx="4416552" cy="438912"/>
+          </a:xfrm>
+          <a:prstGeom prst="rect">
+            <a:avLst/>
+          </a:prstGeom>
+          <a:noFill/>
+          <a:ln/>
+        </p:spPr>
+        <p:txBody>
+          <a:bodyPr wrap="square" lIns="0" tIns="0" rIns="0" bIns="0" rtlCol="0" anchor="ctr"/>
+          <a:lstStyle/>
+          <a:p>
             <a:pPr indent="0" marL="0">
               <a:buNone/>
             </a:pPr>
             <a:r>
-              <a:rPr lang="en-US" sz="1900" b="1" dirty="0">
+              <a:rPr lang="en-US" sz="1800" b="1" dirty="0">
                 <a:solidFill>
                   <a:schemeClr val="tx1"/>
                 </a:solidFill>
@@ -17340,22 +18051,110 @@
                 <a:ea typeface="Cambria" pitchFamily="34" charset="-122"/>
                 <a:cs typeface="Cambria" pitchFamily="34" charset="-120"/>
               </a:rPr>
-              <a:t>The fair bar</a:t>
-            </a:r>
-            <a:endParaRPr lang="en-US" sz="1900" dirty="0"/>
-          </a:p>
-        </p:txBody>
-      </p:sp>
-      <p:sp>
-        <p:nvSpPr>
-          <p:cNvPr id="14" name="Text 12"/>
+              <a:t>46 automated tests</a:t>
+            </a:r>
+            <a:endParaRPr lang="en-US" sz="1800" dirty="0"/>
+          </a:p>
+        </p:txBody>
+      </p:sp>
+      <p:sp>
+        <p:nvSpPr>
+          <p:cNvPr id="17" name="Text 15"/>
           <p:cNvSpPr txBox="1"/>
           <p:nvPr/>
         </p:nvSpPr>
         <p:spPr>
           <a:xfrm>
-            <a:off x="4297680" y="4800600"/>
-            <a:ext cx="7116775" cy="1024128"/>
+            <a:off x="777240" y="4480560"/>
+            <a:ext cx="5010912" cy="1143000"/>
+          </a:xfrm>
+          <a:prstGeom prst="rect">
+            <a:avLst/>
+          </a:prstGeom>
+          <a:noFill/>
+          <a:ln/>
+        </p:spPr>
+        <p:txBody>
+          <a:bodyPr wrap="square" lIns="0" tIns="0" rIns="0" bIns="0" rtlCol="0" anchor="t"/>
+          <a:lstStyle/>
+          <a:p>
+            <a:pPr indent="0" marL="0">
+              <a:buNone/>
+            </a:pPr>
+            <a:r>
+              <a:rPr lang="en-US" sz="1500" dirty="0">
+                <a:solidFill>
+                  <a:schemeClr val="tx2"/>
+                </a:solidFill>
+              </a:rPr>
+              <a:t>They check the model never sees the future, e.g. scrambling future data must not change any prediction.</a:t>
+            </a:r>
+            <a:endParaRPr lang="en-US" sz="1500" dirty="0"/>
+          </a:p>
+        </p:txBody>
+      </p:sp>
+      <p:sp>
+        <p:nvSpPr>
+          <p:cNvPr id="18" name="Shape 16"/>
+          <p:cNvSpPr/>
+          <p:nvPr/>
+        </p:nvSpPr>
+        <p:spPr>
+          <a:xfrm>
+            <a:off x="6172200" y="3703320"/>
+            <a:ext cx="5468112" cy="2103120"/>
+          </a:xfrm>
+          <a:prstGeom prst="roundRect">
+            <a:avLst>
+              <a:gd name="adj" fmla="val 5217"/>
+            </a:avLst>
+          </a:prstGeom>
+          <a:solidFill>
+            <a:schemeClr val="bg2"/>
+          </a:solidFill>
+          <a:ln w="12700">
+            <a:solidFill>
+              <a:schemeClr val="bg2"/>
+            </a:solidFill>
+            <a:prstDash val="solid"/>
+          </a:ln>
+        </p:spPr>
+      </p:sp>
+      <p:sp>
+        <p:nvSpPr>
+          <p:cNvPr id="19" name="Shape 17"/>
+          <p:cNvSpPr/>
+          <p:nvPr/>
+        </p:nvSpPr>
+        <p:spPr>
+          <a:xfrm>
+            <a:off x="6400800" y="3931920"/>
+            <a:ext cx="438912" cy="438912"/>
+          </a:xfrm>
+          <a:prstGeom prst="ellipse">
+            <a:avLst/>
+          </a:prstGeom>
+          <a:solidFill>
+            <a:schemeClr val="accent1"/>
+          </a:solidFill>
+          <a:ln w="12700">
+            <a:solidFill>
+              <a:schemeClr val="accent1"/>
+            </a:solidFill>
+            <a:prstDash val="solid"/>
+          </a:ln>
+        </p:spPr>
+      </p:sp>
+      <p:sp>
+        <p:nvSpPr>
+          <p:cNvPr id="20" name="Text 18"/>
+          <p:cNvSpPr txBox="1"/>
+          <p:nvPr/>
+        </p:nvSpPr>
+        <p:spPr>
+          <a:xfrm>
+            <a:off x="6400800" y="3931920"/>
+            <a:ext cx="438912" cy="438912"/>
           </a:xfrm>
           <a:prstGeom prst="rect">
             <a:avLst/>
@@ -17367,18 +18166,93 @@
           <a:bodyPr wrap="square" lIns="0" tIns="0" rIns="0" bIns="0" rtlCol="0" anchor="ctr"/>
           <a:lstStyle/>
           <a:p>
+            <a:pPr algn="ctr" indent="0" marL="0">
+              <a:buNone/>
+            </a:pPr>
+            <a:r>
+              <a:rPr lang="en-US" sz="1600" b="1" dirty="0">
+                <a:solidFill>
+                  <a:schemeClr val="bg1"/>
+                </a:solidFill>
+              </a:rPr>
+              <a:t>4</a:t>
+            </a:r>
+            <a:endParaRPr lang="en-US" sz="1600" dirty="0"/>
+          </a:p>
+        </p:txBody>
+      </p:sp>
+      <p:sp>
+        <p:nvSpPr>
+          <p:cNvPr id="21" name="Text 19"/>
+          <p:cNvSpPr txBox="1"/>
+          <p:nvPr/>
+        </p:nvSpPr>
+        <p:spPr>
+          <a:xfrm>
+            <a:off x="6995160" y="3931920"/>
+            <a:ext cx="4416552" cy="438912"/>
+          </a:xfrm>
+          <a:prstGeom prst="rect">
+            <a:avLst/>
+          </a:prstGeom>
+          <a:noFill/>
+          <a:ln/>
+        </p:spPr>
+        <p:txBody>
+          <a:bodyPr wrap="square" lIns="0" tIns="0" rIns="0" bIns="0" rtlCol="0" anchor="ctr"/>
+          <a:lstStyle/>
+          <a:p>
             <a:pPr indent="0" marL="0">
               <a:buNone/>
             </a:pPr>
             <a:r>
-              <a:rPr lang="en-US" sz="1600" dirty="0">
+              <a:rPr lang="en-US" sz="1800" b="1" dirty="0">
+                <a:solidFill>
+                  <a:schemeClr val="tx1"/>
+                </a:solidFill>
+                <a:latin typeface="Cambria" pitchFamily="34" charset="0"/>
+                <a:ea typeface="Cambria" pitchFamily="34" charset="-122"/>
+                <a:cs typeface="Cambria" pitchFamily="34" charset="-120"/>
+              </a:rPr>
+              <a:t>Failures reported, not hidden</a:t>
+            </a:r>
+            <a:endParaRPr lang="en-US" sz="1800" dirty="0"/>
+          </a:p>
+        </p:txBody>
+      </p:sp>
+      <p:sp>
+        <p:nvSpPr>
+          <p:cNvPr id="22" name="Text 20"/>
+          <p:cNvSpPr txBox="1"/>
+          <p:nvPr/>
+        </p:nvSpPr>
+        <p:spPr>
+          <a:xfrm>
+            <a:off x="6400800" y="4480560"/>
+            <a:ext cx="5010912" cy="1143000"/>
+          </a:xfrm>
+          <a:prstGeom prst="rect">
+            <a:avLst/>
+          </a:prstGeom>
+          <a:noFill/>
+          <a:ln/>
+        </p:spPr>
+        <p:txBody>
+          <a:bodyPr wrap="square" lIns="0" tIns="0" rIns="0" bIns="0" rtlCol="0" anchor="t"/>
+          <a:lstStyle/>
+          <a:p>
+            <a:pPr indent="0" marL="0">
+              <a:buNone/>
+            </a:pPr>
+            <a:r>
+              <a:rPr lang="en-US" sz="1500" dirty="0">
                 <a:solidFill>
                   <a:schemeClr val="tx2"/>
                 </a:solidFill>
               </a:rPr>
-              <a:t>Return for the risk taken, and beating random timing — not simply “more money than Buy &amp; Hold”. That is how we judged every version.</a:t>
-            </a:r>
-            <a:endParaRPr lang="en-US" sz="1600" dirty="0"/>
+              <a:t>Every change after results is logged, including a one-day overlap we found in v1’s work and v3 failing its own calibration test.</a:t>
+            </a:r>
+            <a:endParaRPr lang="en-US" sz="1500" dirty="0"/>
           </a:p>
         </p:txBody>
       </p:sp>
@@ -17487,7 +18361,7 @@
                 <a:ea typeface="Cambria" pitchFamily="34" charset="-122"/>
                 <a:cs typeface="Cambria" pitchFamily="34" charset="-120"/>
               </a:rPr>
-              <a:t>What we learned</a:t>
+              <a:t>A flaw of machine learning, or of the question?</a:t>
             </a:r>
             <a:endParaRPr lang="en-US" sz="3200" dirty="0"/>
           </a:p>
@@ -17501,12 +18375,114 @@
         </p:nvSpPr>
         <p:spPr>
           <a:xfrm>
-            <a:off x="548640" y="1417320"/>
-            <a:ext cx="5468112" cy="2103120"/>
+            <a:off x="548640" y="1371600"/>
+            <a:ext cx="11094415" cy="1024128"/>
           </a:xfrm>
           <a:prstGeom prst="roundRect">
             <a:avLst>
-              <a:gd name="adj" fmla="val 5217"/>
+              <a:gd name="adj" fmla="val 8929"/>
+            </a:avLst>
+          </a:prstGeom>
+          <a:solidFill>
+            <a:srgbClr val="FBEDE4"/>
+          </a:solidFill>
+          <a:ln w="12700">
+            <a:solidFill>
+              <a:srgbClr val="FBEDE4"/>
+            </a:solidFill>
+            <a:prstDash val="solid"/>
+          </a:ln>
+        </p:spPr>
+      </p:sp>
+      <p:sp>
+        <p:nvSpPr>
+          <p:cNvPr id="4" name="Text 2"/>
+          <p:cNvSpPr txBox="1"/>
+          <p:nvPr/>
+        </p:nvSpPr>
+        <p:spPr>
+          <a:xfrm>
+            <a:off x="822960" y="1371600"/>
+            <a:ext cx="3291840" cy="1024128"/>
+          </a:xfrm>
+          <a:prstGeom prst="rect">
+            <a:avLst/>
+          </a:prstGeom>
+          <a:noFill/>
+          <a:ln/>
+        </p:spPr>
+        <p:txBody>
+          <a:bodyPr wrap="square" lIns="0" tIns="0" rIns="0" bIns="0" rtlCol="0" anchor="ctr"/>
+          <a:lstStyle/>
+          <a:p>
+            <a:pPr indent="0" marL="0">
+              <a:buNone/>
+            </a:pPr>
+            <a:r>
+              <a:rPr lang="en-US" sz="1900" b="1" dirty="0">
+                <a:solidFill>
+                  <a:schemeClr val="tx1"/>
+                </a:solidFill>
+                <a:latin typeface="Cambria" pitchFamily="34" charset="0"/>
+                <a:ea typeface="Cambria" pitchFamily="34" charset="-122"/>
+                <a:cs typeface="Cambria" pitchFamily="34" charset="-120"/>
+              </a:rPr>
+              <a:t>Mostly the question</a:t>
+            </a:r>
+            <a:endParaRPr lang="en-US" sz="1900" dirty="0"/>
+          </a:p>
+        </p:txBody>
+      </p:sp>
+      <p:sp>
+        <p:nvSpPr>
+          <p:cNvPr id="5" name="Text 3"/>
+          <p:cNvSpPr txBox="1"/>
+          <p:nvPr/>
+        </p:nvSpPr>
+        <p:spPr>
+          <a:xfrm>
+            <a:off x="4297680" y="1371600"/>
+            <a:ext cx="7116775" cy="1024128"/>
+          </a:xfrm>
+          <a:prstGeom prst="rect">
+            <a:avLst/>
+          </a:prstGeom>
+          <a:noFill/>
+          <a:ln/>
+        </p:spPr>
+        <p:txBody>
+          <a:bodyPr wrap="square" lIns="0" tIns="0" rIns="0" bIns="0" rtlCol="0" anchor="ctr"/>
+          <a:lstStyle/>
+          <a:p>
+            <a:pPr indent="0" marL="0">
+              <a:buNone/>
+            </a:pPr>
+            <a:r>
+              <a:rPr lang="en-US" sz="1600" dirty="0">
+                <a:solidFill>
+                  <a:schemeClr val="tx2"/>
+                </a:solidFill>
+              </a:rPr>
+              <a:t>We asked for next week’s direction of the world’s most-watched fund, using only its own public price history. Simple patterns there get traded away, and no algorithm can find information that isn’t in the data.</a:t>
+            </a:r>
+            <a:endParaRPr lang="en-US" sz="1600" dirty="0"/>
+          </a:p>
+        </p:txBody>
+      </p:sp>
+      <p:sp>
+        <p:nvSpPr>
+          <p:cNvPr id="6" name="Shape 4"/>
+          <p:cNvSpPr/>
+          <p:nvPr/>
+        </p:nvSpPr>
+        <p:spPr>
+          <a:xfrm>
+            <a:off x="548640" y="2514600"/>
+            <a:ext cx="11094415" cy="1024128"/>
+          </a:xfrm>
+          <a:prstGeom prst="roundRect">
+            <a:avLst>
+              <a:gd name="adj" fmla="val 8929"/>
             </a:avLst>
           </a:prstGeom>
           <a:solidFill>
@@ -17522,39 +18498,14 @@
       </p:sp>
       <p:sp>
         <p:nvSpPr>
-          <p:cNvPr id="4" name="Shape 2"/>
-          <p:cNvSpPr/>
-          <p:nvPr/>
-        </p:nvSpPr>
-        <p:spPr>
-          <a:xfrm>
-            <a:off x="777240" y="1645920"/>
-            <a:ext cx="438912" cy="438912"/>
-          </a:xfrm>
-          <a:prstGeom prst="ellipse">
-            <a:avLst/>
-          </a:prstGeom>
-          <a:solidFill>
-            <a:schemeClr val="accent1"/>
-          </a:solidFill>
-          <a:ln w="12700">
-            <a:solidFill>
-              <a:schemeClr val="accent1"/>
-            </a:solidFill>
-            <a:prstDash val="solid"/>
-          </a:ln>
-        </p:spPr>
-      </p:sp>
-      <p:sp>
-        <p:nvSpPr>
-          <p:cNvPr id="5" name="Text 3"/>
+          <p:cNvPr id="7" name="Text 5"/>
           <p:cNvSpPr txBox="1"/>
           <p:nvPr/>
         </p:nvSpPr>
         <p:spPr>
           <a:xfrm>
-            <a:off x="777240" y="1645920"/>
-            <a:ext cx="438912" cy="438912"/>
+            <a:off x="822960" y="2514600"/>
+            <a:ext cx="3291840" cy="1024128"/>
           </a:xfrm>
           <a:prstGeom prst="rect">
             <a:avLst/>
@@ -17566,47 +18517,11 @@
           <a:bodyPr wrap="square" lIns="0" tIns="0" rIns="0" bIns="0" rtlCol="0" anchor="ctr"/>
           <a:lstStyle/>
           <a:p>
-            <a:pPr algn="ctr" indent="0" marL="0">
-              <a:buNone/>
-            </a:pPr>
-            <a:r>
-              <a:rPr lang="en-US" sz="1600" b="1" dirty="0">
-                <a:solidFill>
-                  <a:schemeClr val="bg1"/>
-                </a:solidFill>
-              </a:rPr>
-              <a:t>1</a:t>
-            </a:r>
-            <a:endParaRPr lang="en-US" sz="1600" dirty="0"/>
-          </a:p>
-        </p:txBody>
-      </p:sp>
-      <p:sp>
-        <p:nvSpPr>
-          <p:cNvPr id="6" name="Text 4"/>
-          <p:cNvSpPr txBox="1"/>
-          <p:nvPr/>
-        </p:nvSpPr>
-        <p:spPr>
-          <a:xfrm>
-            <a:off x="1371600" y="1645920"/>
-            <a:ext cx="4416552" cy="594360"/>
-          </a:xfrm>
-          <a:prstGeom prst="rect">
-            <a:avLst/>
-          </a:prstGeom>
-          <a:noFill/>
-          <a:ln/>
-        </p:spPr>
-        <p:txBody>
-          <a:bodyPr wrap="square" lIns="0" tIns="0" rIns="0" bIns="0" rtlCol="0" anchor="ctr"/>
-          <a:lstStyle/>
-          <a:p>
             <a:pPr indent="0" marL="0">
               <a:buNone/>
             </a:pPr>
             <a:r>
-              <a:rPr lang="en-US" sz="1800" b="1" dirty="0">
+              <a:rPr lang="en-US" sz="1900" b="1" dirty="0">
                 <a:solidFill>
                   <a:schemeClr val="tx1"/>
                 </a:solidFill>
@@ -17614,31 +18529,31 @@
                 <a:ea typeface="Cambria" pitchFamily="34" charset="-122"/>
                 <a:cs typeface="Cambria" pitchFamily="34" charset="-120"/>
               </a:rPr>
-              <a:t>Size is predictable; direction isn’t</a:t>
-            </a:r>
-            <a:endParaRPr lang="en-US" sz="1800" dirty="0"/>
-          </a:p>
-        </p:txBody>
-      </p:sp>
-      <p:sp>
-        <p:nvSpPr>
-          <p:cNvPr id="7" name="Text 5"/>
+              <a:t>Partly our own limits</a:t>
+            </a:r>
+            <a:endParaRPr lang="en-US" sz="1900" dirty="0"/>
+          </a:p>
+        </p:txBody>
+      </p:sp>
+      <p:sp>
+        <p:nvSpPr>
+          <p:cNvPr id="8" name="Text 6"/>
           <p:cNvSpPr txBox="1"/>
           <p:nvPr/>
         </p:nvSpPr>
         <p:spPr>
           <a:xfrm>
-            <a:off x="777240" y="2350008"/>
-            <a:ext cx="5010912" cy="987552"/>
-          </a:xfrm>
-          <a:prstGeom prst="rect">
-            <a:avLst/>
-          </a:prstGeom>
-          <a:noFill/>
-          <a:ln/>
-        </p:spPr>
-        <p:txBody>
-          <a:bodyPr wrap="square" lIns="0" tIns="0" rIns="0" bIns="0" rtlCol="0" anchor="t"/>
+            <a:off x="4297680" y="2514600"/>
+            <a:ext cx="7116775" cy="1024128"/>
+          </a:xfrm>
+          <a:prstGeom prst="rect">
+            <a:avLst/>
+          </a:prstGeom>
+          <a:noFill/>
+          <a:ln/>
+        </p:spPr>
+        <p:txBody>
+          <a:bodyPr wrap="square" lIns="0" tIns="0" rIns="0" bIns="0" rtlCol="0" anchor="ctr"/>
           <a:lstStyle/>
           <a:p>
             <a:pPr indent="0" marL="0">
@@ -17650,7 +18565,7 @@
                   <a:schemeClr val="tx2"/>
                 </a:solidFill>
               </a:rPr>
-              <a:t>Big-move weeks cluster together, so the model can see them coming. Which way they go is close to a coin flip.</a:t>
+              <a:t>One fund, all in or all out, price data only, a one-week horizon. Lifting these makes the task easier, but wouldn’t flip the result: even with zero fees, v1 still lost.</a:t>
             </a:r>
             <a:endParaRPr lang="en-US" sz="1600" dirty="0"/>
           </a:p>
@@ -17658,18 +18573,18 @@
       </p:sp>
       <p:sp>
         <p:nvSpPr>
-          <p:cNvPr id="8" name="Shape 6"/>
+          <p:cNvPr id="9" name="Shape 7"/>
           <p:cNvSpPr/>
           <p:nvPr/>
         </p:nvSpPr>
         <p:spPr>
           <a:xfrm>
-            <a:off x="6172200" y="1417320"/>
-            <a:ext cx="5468112" cy="2103120"/>
+            <a:off x="548640" y="3657600"/>
+            <a:ext cx="11094415" cy="1024128"/>
           </a:xfrm>
           <a:prstGeom prst="roundRect">
             <a:avLst>
-              <a:gd name="adj" fmla="val 5217"/>
+              <a:gd name="adj" fmla="val 8929"/>
             </a:avLst>
           </a:prstGeom>
           <a:solidFill>
@@ -17685,39 +18600,14 @@
       </p:sp>
       <p:sp>
         <p:nvSpPr>
-          <p:cNvPr id="9" name="Shape 7"/>
-          <p:cNvSpPr/>
-          <p:nvPr/>
-        </p:nvSpPr>
-        <p:spPr>
-          <a:xfrm>
-            <a:off x="6400800" y="1645920"/>
-            <a:ext cx="438912" cy="438912"/>
-          </a:xfrm>
-          <a:prstGeom prst="ellipse">
-            <a:avLst/>
-          </a:prstGeom>
-          <a:solidFill>
-            <a:schemeClr val="accent1"/>
-          </a:solidFill>
-          <a:ln w="12700">
-            <a:solidFill>
-              <a:schemeClr val="accent1"/>
-            </a:solidFill>
-            <a:prstDash val="solid"/>
-          </a:ln>
-        </p:spPr>
-      </p:sp>
-      <p:sp>
-        <p:nvSpPr>
           <p:cNvPr id="10" name="Text 8"/>
           <p:cNvSpPr txBox="1"/>
           <p:nvPr/>
         </p:nvSpPr>
         <p:spPr>
           <a:xfrm>
-            <a:off x="6400800" y="1645920"/>
-            <a:ext cx="438912" cy="438912"/>
+            <a:off x="822960" y="3657600"/>
+            <a:ext cx="3291840" cy="1024128"/>
           </a:xfrm>
           <a:prstGeom prst="rect">
             <a:avLst/>
@@ -17729,47 +18619,11 @@
           <a:bodyPr wrap="square" lIns="0" tIns="0" rIns="0" bIns="0" rtlCol="0" anchor="ctr"/>
           <a:lstStyle/>
           <a:p>
-            <a:pPr algn="ctr" indent="0" marL="0">
-              <a:buNone/>
-            </a:pPr>
-            <a:r>
-              <a:rPr lang="en-US" sz="1600" b="1" dirty="0">
-                <a:solidFill>
-                  <a:schemeClr val="bg1"/>
-                </a:solidFill>
-              </a:rPr>
-              <a:t>2</a:t>
-            </a:r>
-            <a:endParaRPr lang="en-US" sz="1600" dirty="0"/>
-          </a:p>
-        </p:txBody>
-      </p:sp>
-      <p:sp>
-        <p:nvSpPr>
-          <p:cNvPr id="11" name="Text 9"/>
-          <p:cNvSpPr txBox="1"/>
-          <p:nvPr/>
-        </p:nvSpPr>
-        <p:spPr>
-          <a:xfrm>
-            <a:off x="6995160" y="1645920"/>
-            <a:ext cx="4416552" cy="438912"/>
-          </a:xfrm>
-          <a:prstGeom prst="rect">
-            <a:avLst/>
-          </a:prstGeom>
-          <a:noFill/>
-          <a:ln/>
-        </p:spPr>
-        <p:txBody>
-          <a:bodyPr wrap="square" lIns="0" tIns="0" rIns="0" bIns="0" rtlCol="0" anchor="ctr"/>
-          <a:lstStyle/>
-          <a:p>
             <a:pPr indent="0" marL="0">
               <a:buNone/>
             </a:pPr>
             <a:r>
-              <a:rPr lang="en-US" sz="1800" b="1" dirty="0">
+              <a:rPr lang="en-US" sz="1900" b="1" dirty="0">
                 <a:solidFill>
                   <a:schemeClr val="tx1"/>
                 </a:solidFill>
@@ -17777,31 +18631,31 @@
                 <a:ea typeface="Cambria" pitchFamily="34" charset="-122"/>
                 <a:cs typeface="Cambria" pitchFamily="34" charset="-120"/>
               </a:rPr>
-              <a:t>Sitting in cash has a cost</a:t>
-            </a:r>
-            <a:endParaRPr lang="en-US" sz="1800" dirty="0"/>
-          </a:p>
-        </p:txBody>
-      </p:sp>
-      <p:sp>
-        <p:nvSpPr>
-          <p:cNvPr id="12" name="Text 10"/>
+              <a:t>Where machine learning does help</a:t>
+            </a:r>
+            <a:endParaRPr lang="en-US" sz="1900" dirty="0"/>
+          </a:p>
+        </p:txBody>
+      </p:sp>
+      <p:sp>
+        <p:nvSpPr>
+          <p:cNvPr id="11" name="Text 9"/>
           <p:cNvSpPr txBox="1"/>
           <p:nvPr/>
         </p:nvSpPr>
         <p:spPr>
           <a:xfrm>
-            <a:off x="6400800" y="2194560"/>
-            <a:ext cx="5010912" cy="1143000"/>
-          </a:xfrm>
-          <a:prstGeom prst="rect">
-            <a:avLst/>
-          </a:prstGeom>
-          <a:noFill/>
-          <a:ln/>
-        </p:spPr>
-        <p:txBody>
-          <a:bodyPr wrap="square" lIns="0" tIns="0" rIns="0" bIns="0" rtlCol="0" anchor="t"/>
+            <a:off x="4297680" y="3657600"/>
+            <a:ext cx="7116775" cy="1024128"/>
+          </a:xfrm>
+          <a:prstGeom prst="rect">
+            <a:avLst/>
+          </a:prstGeom>
+          <a:noFill/>
+          <a:ln/>
+        </p:spPr>
+        <p:txBody>
+          <a:bodyPr wrap="square" lIns="0" tIns="0" rIns="0" bIns="0" rtlCol="0" anchor="ctr"/>
           <a:lstStyle/>
           <a:p>
             <a:pPr indent="0" marL="0">
@@ -17813,7 +18667,7 @@
                   <a:schemeClr val="tx2"/>
                 </a:solidFill>
               </a:rPr>
-              <a:t>The market mostly goes up. Without real timing skill, every day out of the market loses money on average.</a:t>
+              <a:t>Ranking many assets against each other, forecasting risk to size positions, and using data most people don’t have. Even there the edges are usually small and shrink after costs.</a:t>
             </a:r>
             <a:endParaRPr lang="en-US" sz="1600" dirty="0"/>
           </a:p>
@@ -17821,18 +18675,18 @@
       </p:sp>
       <p:sp>
         <p:nvSpPr>
-          <p:cNvPr id="13" name="Shape 11"/>
+          <p:cNvPr id="12" name="Shape 10"/>
           <p:cNvSpPr/>
           <p:nvPr/>
         </p:nvSpPr>
         <p:spPr>
           <a:xfrm>
-            <a:off x="548640" y="3703320"/>
-            <a:ext cx="5468112" cy="2103120"/>
+            <a:off x="548640" y="4800600"/>
+            <a:ext cx="11094415" cy="1024128"/>
           </a:xfrm>
           <a:prstGeom prst="roundRect">
             <a:avLst>
-              <a:gd name="adj" fmla="val 5217"/>
+              <a:gd name="adj" fmla="val 8929"/>
             </a:avLst>
           </a:prstGeom>
           <a:solidFill>
@@ -17848,39 +18702,14 @@
       </p:sp>
       <p:sp>
         <p:nvSpPr>
-          <p:cNvPr id="14" name="Shape 12"/>
-          <p:cNvSpPr/>
-          <p:nvPr/>
-        </p:nvSpPr>
-        <p:spPr>
-          <a:xfrm>
-            <a:off x="777240" y="3931920"/>
-            <a:ext cx="438912" cy="438912"/>
-          </a:xfrm>
-          <a:prstGeom prst="ellipse">
-            <a:avLst/>
-          </a:prstGeom>
-          <a:solidFill>
-            <a:schemeClr val="accent1"/>
-          </a:solidFill>
-          <a:ln w="12700">
-            <a:solidFill>
-              <a:schemeClr val="accent1"/>
-            </a:solidFill>
-            <a:prstDash val="solid"/>
-          </a:ln>
-        </p:spPr>
-      </p:sp>
-      <p:sp>
-        <p:nvSpPr>
-          <p:cNvPr id="15" name="Text 13"/>
+          <p:cNvPr id="13" name="Text 11"/>
           <p:cNvSpPr txBox="1"/>
           <p:nvPr/>
         </p:nvSpPr>
         <p:spPr>
           <a:xfrm>
-            <a:off x="777240" y="3931920"/>
-            <a:ext cx="438912" cy="438912"/>
+            <a:off x="822960" y="4800600"/>
+            <a:ext cx="3291840" cy="1024128"/>
           </a:xfrm>
           <a:prstGeom prst="rect">
             <a:avLst/>
@@ -17892,47 +18721,11 @@
           <a:bodyPr wrap="square" lIns="0" tIns="0" rIns="0" bIns="0" rtlCol="0" anchor="ctr"/>
           <a:lstStyle/>
           <a:p>
-            <a:pPr algn="ctr" indent="0" marL="0">
-              <a:buNone/>
-            </a:pPr>
-            <a:r>
-              <a:rPr lang="en-US" sz="1600" b="1" dirty="0">
-                <a:solidFill>
-                  <a:schemeClr val="bg1"/>
-                </a:solidFill>
-              </a:rPr>
-              <a:t>3</a:t>
-            </a:r>
-            <a:endParaRPr lang="en-US" sz="1600" dirty="0"/>
-          </a:p>
-        </p:txBody>
-      </p:sp>
-      <p:sp>
-        <p:nvSpPr>
-          <p:cNvPr id="16" name="Text 14"/>
-          <p:cNvSpPr txBox="1"/>
-          <p:nvPr/>
-        </p:nvSpPr>
-        <p:spPr>
-          <a:xfrm>
-            <a:off x="1371600" y="3931920"/>
-            <a:ext cx="4416552" cy="438912"/>
-          </a:xfrm>
-          <a:prstGeom prst="rect">
-            <a:avLst/>
-          </a:prstGeom>
-          <a:noFill/>
-          <a:ln/>
-        </p:spPr>
-        <p:txBody>
-          <a:bodyPr wrap="square" lIns="0" tIns="0" rIns="0" bIns="0" rtlCol="0" anchor="ctr"/>
-          <a:lstStyle/>
-          <a:p>
             <a:pPr indent="0" marL="0">
               <a:buNone/>
             </a:pPr>
             <a:r>
-              <a:rPr lang="en-US" sz="1800" b="1" dirty="0">
+              <a:rPr lang="en-US" sz="1900" b="1" dirty="0">
                 <a:solidFill>
                   <a:schemeClr val="tx1"/>
                 </a:solidFill>
@@ -17940,31 +18733,31 @@
                 <a:ea typeface="Cambria" pitchFamily="34" charset="-122"/>
                 <a:cs typeface="Cambria" pitchFamily="34" charset="-120"/>
               </a:rPr>
-              <a:t>The past changes</a:t>
-            </a:r>
-            <a:endParaRPr lang="en-US" sz="1800" dirty="0"/>
-          </a:p>
-        </p:txBody>
-      </p:sp>
-      <p:sp>
-        <p:nvSpPr>
-          <p:cNvPr id="17" name="Text 15"/>
+              <a:t>The fair bar</a:t>
+            </a:r>
+            <a:endParaRPr lang="en-US" sz="1900" dirty="0"/>
+          </a:p>
+        </p:txBody>
+      </p:sp>
+      <p:sp>
+        <p:nvSpPr>
+          <p:cNvPr id="14" name="Text 12"/>
           <p:cNvSpPr txBox="1"/>
           <p:nvPr/>
         </p:nvSpPr>
         <p:spPr>
           <a:xfrm>
-            <a:off x="777240" y="4480560"/>
-            <a:ext cx="5010912" cy="1143000"/>
-          </a:xfrm>
-          <a:prstGeom prst="rect">
-            <a:avLst/>
-          </a:prstGeom>
-          <a:noFill/>
-          <a:ln/>
-        </p:spPr>
-        <p:txBody>
-          <a:bodyPr wrap="square" lIns="0" tIns="0" rIns="0" bIns="0" rtlCol="0" anchor="t"/>
+            <a:off x="4297680" y="4800600"/>
+            <a:ext cx="7116775" cy="1024128"/>
+          </a:xfrm>
+          <a:prstGeom prst="rect">
+            <a:avLst/>
+          </a:prstGeom>
+          <a:noFill/>
+          <a:ln/>
+        </p:spPr>
+        <p:txBody>
+          <a:bodyPr wrap="square" lIns="0" tIns="0" rIns="0" bIns="0" rtlCol="0" anchor="ctr"/>
           <a:lstStyle/>
           <a:p>
             <a:pPr indent="0" marL="0">
@@ -17976,170 +18769,7 @@
                   <a:schemeClr val="tx2"/>
                 </a:solidFill>
               </a:rPr>
-              <a:t>A signal that helped from 2010 to 2020 actually misled the model in 2022.</a:t>
-            </a:r>
-            <a:endParaRPr lang="en-US" sz="1600" dirty="0"/>
-          </a:p>
-        </p:txBody>
-      </p:sp>
-      <p:sp>
-        <p:nvSpPr>
-          <p:cNvPr id="18" name="Shape 16"/>
-          <p:cNvSpPr/>
-          <p:nvPr/>
-        </p:nvSpPr>
-        <p:spPr>
-          <a:xfrm>
-            <a:off x="6172200" y="3703320"/>
-            <a:ext cx="5468112" cy="2103120"/>
-          </a:xfrm>
-          <a:prstGeom prst="roundRect">
-            <a:avLst>
-              <a:gd name="adj" fmla="val 5217"/>
-            </a:avLst>
-          </a:prstGeom>
-          <a:solidFill>
-            <a:schemeClr val="bg2"/>
-          </a:solidFill>
-          <a:ln w="12700">
-            <a:solidFill>
-              <a:schemeClr val="bg2"/>
-            </a:solidFill>
-            <a:prstDash val="solid"/>
-          </a:ln>
-        </p:spPr>
-      </p:sp>
-      <p:sp>
-        <p:nvSpPr>
-          <p:cNvPr id="19" name="Shape 17"/>
-          <p:cNvSpPr/>
-          <p:nvPr/>
-        </p:nvSpPr>
-        <p:spPr>
-          <a:xfrm>
-            <a:off x="6400800" y="3931920"/>
-            <a:ext cx="438912" cy="438912"/>
-          </a:xfrm>
-          <a:prstGeom prst="ellipse">
-            <a:avLst/>
-          </a:prstGeom>
-          <a:solidFill>
-            <a:schemeClr val="accent1"/>
-          </a:solidFill>
-          <a:ln w="12700">
-            <a:solidFill>
-              <a:schemeClr val="accent1"/>
-            </a:solidFill>
-            <a:prstDash val="solid"/>
-          </a:ln>
-        </p:spPr>
-      </p:sp>
-      <p:sp>
-        <p:nvSpPr>
-          <p:cNvPr id="20" name="Text 18"/>
-          <p:cNvSpPr txBox="1"/>
-          <p:nvPr/>
-        </p:nvSpPr>
-        <p:spPr>
-          <a:xfrm>
-            <a:off x="6400800" y="3931920"/>
-            <a:ext cx="438912" cy="438912"/>
-          </a:xfrm>
-          <a:prstGeom prst="rect">
-            <a:avLst/>
-          </a:prstGeom>
-          <a:noFill/>
-          <a:ln/>
-        </p:spPr>
-        <p:txBody>
-          <a:bodyPr wrap="square" lIns="0" tIns="0" rIns="0" bIns="0" rtlCol="0" anchor="ctr"/>
-          <a:lstStyle/>
-          <a:p>
-            <a:pPr algn="ctr" indent="0" marL="0">
-              <a:buNone/>
-            </a:pPr>
-            <a:r>
-              <a:rPr lang="en-US" sz="1600" b="1" dirty="0">
-                <a:solidFill>
-                  <a:schemeClr val="bg1"/>
-                </a:solidFill>
-              </a:rPr>
-              <a:t>4</a:t>
-            </a:r>
-            <a:endParaRPr lang="en-US" sz="1600" dirty="0"/>
-          </a:p>
-        </p:txBody>
-      </p:sp>
-      <p:sp>
-        <p:nvSpPr>
-          <p:cNvPr id="21" name="Text 19"/>
-          <p:cNvSpPr txBox="1"/>
-          <p:nvPr/>
-        </p:nvSpPr>
-        <p:spPr>
-          <a:xfrm>
-            <a:off x="6995160" y="3931920"/>
-            <a:ext cx="4416552" cy="438912"/>
-          </a:xfrm>
-          <a:prstGeom prst="rect">
-            <a:avLst/>
-          </a:prstGeom>
-          <a:noFill/>
-          <a:ln/>
-        </p:spPr>
-        <p:txBody>
-          <a:bodyPr wrap="square" lIns="0" tIns="0" rIns="0" bIns="0" rtlCol="0" anchor="ctr"/>
-          <a:lstStyle/>
-          <a:p>
-            <a:pPr indent="0" marL="0">
-              <a:buNone/>
-            </a:pPr>
-            <a:r>
-              <a:rPr lang="en-US" sz="1800" b="1" dirty="0">
-                <a:solidFill>
-                  <a:schemeClr val="tx1"/>
-                </a:solidFill>
-                <a:latin typeface="Cambria" pitchFamily="34" charset="0"/>
-                <a:ea typeface="Cambria" pitchFamily="34" charset="-122"/>
-                <a:cs typeface="Cambria" pitchFamily="34" charset="-120"/>
-              </a:rPr>
-              <a:t>Good predictions ≠ good trades</a:t>
-            </a:r>
-            <a:endParaRPr lang="en-US" sz="1800" dirty="0"/>
-          </a:p>
-        </p:txBody>
-      </p:sp>
-      <p:sp>
-        <p:nvSpPr>
-          <p:cNvPr id="22" name="Text 20"/>
-          <p:cNvSpPr txBox="1"/>
-          <p:nvPr/>
-        </p:nvSpPr>
-        <p:spPr>
-          <a:xfrm>
-            <a:off x="6400800" y="4480560"/>
-            <a:ext cx="5010912" cy="1143000"/>
-          </a:xfrm>
-          <a:prstGeom prst="rect">
-            <a:avLst/>
-          </a:prstGeom>
-          <a:noFill/>
-          <a:ln/>
-        </p:spPr>
-        <p:txBody>
-          <a:bodyPr wrap="square" lIns="0" tIns="0" rIns="0" bIns="0" rtlCol="0" anchor="t"/>
-          <a:lstStyle/>
-          <a:p>
-            <a:pPr indent="0" marL="0">
-              <a:buNone/>
-            </a:pPr>
-            <a:r>
-              <a:rPr lang="en-US" sz="1600" dirty="0">
-                <a:solidFill>
-                  <a:schemeClr val="tx2"/>
-                </a:solidFill>
-              </a:rPr>
-              <a:t>Settings that improve the prediction score can distort the odds a trading rule relies on. With honest odds (v3), the best rule was not to trade.</a:t>
+              <a:t>Return for the risk taken, and beating random timing — not simply “more money than Buy &amp; Hold”. That is how we judged every version.</a:t>
             </a:r>
             <a:endParaRPr lang="en-US" sz="1600" dirty="0"/>
           </a:p>
@@ -18225,100 +18855,686 @@
         </p:nvSpPr>
         <p:spPr>
           <a:xfrm>
-            <a:off x="548640" y="1097280"/>
-            <a:ext cx="10789920" cy="2560320"/>
-          </a:xfrm>
-          <a:prstGeom prst="rect">
-            <a:avLst/>
-          </a:prstGeom>
-          <a:noFill/>
-          <a:ln/>
-        </p:spPr>
-        <p:txBody>
-          <a:bodyPr wrap="square" rtlCol="0" anchor="b"/>
+            <a:off x="548640" y="365760"/>
+            <a:ext cx="11094415" cy="822960"/>
+          </a:xfrm>
+          <a:prstGeom prst="rect">
+            <a:avLst/>
+          </a:prstGeom>
+          <a:noFill/>
+          <a:ln/>
+        </p:spPr>
+        <p:txBody>
+          <a:bodyPr wrap="square" rtlCol="0" anchor="ctr"/>
           <a:lstStyle/>
           <a:p>
             <a:pPr indent="0" marL="0">
               <a:buNone/>
             </a:pPr>
             <a:r>
-              <a:rPr lang="en-US" sz="4000" b="1" dirty="0">
-                <a:solidFill>
-                  <a:schemeClr val="bg1"/>
+              <a:rPr lang="en-US" sz="3200" b="1" dirty="0">
+                <a:solidFill>
+                  <a:schemeClr val="tx1"/>
                 </a:solidFill>
                 <a:latin typeface="Cambria" pitchFamily="34" charset="0"/>
                 <a:ea typeface="Cambria" pitchFamily="34" charset="-122"/>
                 <a:cs typeface="Cambria" pitchFamily="34" charset="-120"/>
               </a:rPr>
-              <a:t>Questions?</a:t>
-            </a:r>
-            <a:endParaRPr lang="en-US" sz="4000" dirty="0"/>
-          </a:p>
-        </p:txBody>
-      </p:sp>
-      <p:sp>
-        <p:nvSpPr>
-          <p:cNvPr id="3" name="Text 0"/>
+              <a:t>What we learned</a:t>
+            </a:r>
+            <a:endParaRPr lang="en-US" sz="3200" dirty="0"/>
+          </a:p>
+        </p:txBody>
+      </p:sp>
+      <p:sp>
+        <p:nvSpPr>
+          <p:cNvPr id="3" name="Shape 1"/>
           <p:cNvSpPr/>
-          <p:nvPr>
-            <p:ph idx="101" type="body" hasCustomPrompt="1"/>
-          </p:nvPr>
-        </p:nvSpPr>
-        <p:spPr>
-          <a:xfrm>
-            <a:off x="548640" y="3931920"/>
-            <a:ext cx="10424160" cy="2103120"/>
-          </a:xfrm>
-          <a:prstGeom prst="rect">
-            <a:avLst/>
-          </a:prstGeom>
-          <a:noFill/>
-          <a:ln/>
-        </p:spPr>
-        <p:txBody>
-          <a:bodyPr wrap="square" rtlCol="0" anchor="t"/>
+          <p:nvPr/>
+        </p:nvSpPr>
+        <p:spPr>
+          <a:xfrm>
+            <a:off x="548640" y="1417320"/>
+            <a:ext cx="5468112" cy="2103120"/>
+          </a:xfrm>
+          <a:prstGeom prst="roundRect">
+            <a:avLst>
+              <a:gd name="adj" fmla="val 5217"/>
+            </a:avLst>
+          </a:prstGeom>
+          <a:solidFill>
+            <a:schemeClr val="bg2"/>
+          </a:solidFill>
+          <a:ln w="12700">
+            <a:solidFill>
+              <a:schemeClr val="bg2"/>
+            </a:solidFill>
+            <a:prstDash val="solid"/>
+          </a:ln>
+        </p:spPr>
+      </p:sp>
+      <p:sp>
+        <p:nvSpPr>
+          <p:cNvPr id="4" name="Shape 2"/>
+          <p:cNvSpPr/>
+          <p:nvPr/>
+        </p:nvSpPr>
+        <p:spPr>
+          <a:xfrm>
+            <a:off x="777240" y="1645920"/>
+            <a:ext cx="438912" cy="438912"/>
+          </a:xfrm>
+          <a:prstGeom prst="ellipse">
+            <a:avLst/>
+          </a:prstGeom>
+          <a:solidFill>
+            <a:schemeClr val="accent1"/>
+          </a:solidFill>
+          <a:ln w="12700">
+            <a:solidFill>
+              <a:schemeClr val="accent1"/>
+            </a:solidFill>
+            <a:prstDash val="solid"/>
+          </a:ln>
+        </p:spPr>
+      </p:sp>
+      <p:sp>
+        <p:nvSpPr>
+          <p:cNvPr id="5" name="Text 3"/>
+          <p:cNvSpPr txBox="1"/>
+          <p:nvPr/>
+        </p:nvSpPr>
+        <p:spPr>
+          <a:xfrm>
+            <a:off x="777240" y="1645920"/>
+            <a:ext cx="438912" cy="438912"/>
+          </a:xfrm>
+          <a:prstGeom prst="rect">
+            <a:avLst/>
+          </a:prstGeom>
+          <a:noFill/>
+          <a:ln/>
+        </p:spPr>
+        <p:txBody>
+          <a:bodyPr wrap="square" lIns="0" tIns="0" rIns="0" bIns="0" rtlCol="0" anchor="ctr"/>
+          <a:lstStyle/>
+          <a:p>
+            <a:pPr algn="ctr" indent="0" marL="0">
+              <a:buNone/>
+            </a:pPr>
+            <a:r>
+              <a:rPr lang="en-US" sz="1600" b="1" dirty="0">
+                <a:solidFill>
+                  <a:schemeClr val="bg1"/>
+                </a:solidFill>
+              </a:rPr>
+              <a:t>1</a:t>
+            </a:r>
+            <a:endParaRPr lang="en-US" sz="1600" dirty="0"/>
+          </a:p>
+        </p:txBody>
+      </p:sp>
+      <p:sp>
+        <p:nvSpPr>
+          <p:cNvPr id="6" name="Text 4"/>
+          <p:cNvSpPr txBox="1"/>
+          <p:nvPr/>
+        </p:nvSpPr>
+        <p:spPr>
+          <a:xfrm>
+            <a:off x="1371600" y="1645920"/>
+            <a:ext cx="4416552" cy="594360"/>
+          </a:xfrm>
+          <a:prstGeom prst="rect">
+            <a:avLst/>
+          </a:prstGeom>
+          <a:noFill/>
+          <a:ln/>
+        </p:spPr>
+        <p:txBody>
+          <a:bodyPr wrap="square" lIns="0" tIns="0" rIns="0" bIns="0" rtlCol="0" anchor="ctr"/>
           <a:lstStyle/>
           <a:p>
             <a:pPr indent="0" marL="0">
               <a:buNone/>
             </a:pPr>
             <a:r>
-              <a:rPr lang="en-US" sz="2100" dirty="0">
-                <a:solidFill>
-                  <a:schemeClr val="bg2"/>
-                </a:solidFill>
-              </a:rPr>
-              <a:t>$100,000 in 2023–24 → $156,546 by waiting, $123,714 with v1, $121,812 with v2. With honest odds, v3’s best rule is not to trade.</a:t>
-            </a:r>
-            <a:endParaRPr lang="en-US" sz="2100" dirty="0"/>
-          </a:p>
+              <a:rPr lang="en-US" sz="1800" b="1" dirty="0">
+                <a:solidFill>
+                  <a:schemeClr val="tx1"/>
+                </a:solidFill>
+                <a:latin typeface="Cambria" pitchFamily="34" charset="0"/>
+                <a:ea typeface="Cambria" pitchFamily="34" charset="-122"/>
+                <a:cs typeface="Cambria" pitchFamily="34" charset="-120"/>
+              </a:rPr>
+              <a:t>Size is predictable; direction isn’t</a:t>
+            </a:r>
+            <a:endParaRPr lang="en-US" sz="1800" dirty="0"/>
+          </a:p>
+        </p:txBody>
+      </p:sp>
+      <p:sp>
+        <p:nvSpPr>
+          <p:cNvPr id="7" name="Text 5"/>
+          <p:cNvSpPr txBox="1"/>
+          <p:nvPr/>
+        </p:nvSpPr>
+        <p:spPr>
+          <a:xfrm>
+            <a:off x="777240" y="2350008"/>
+            <a:ext cx="5010912" cy="987552"/>
+          </a:xfrm>
+          <a:prstGeom prst="rect">
+            <a:avLst/>
+          </a:prstGeom>
+          <a:noFill/>
+          <a:ln/>
+        </p:spPr>
+        <p:txBody>
+          <a:bodyPr wrap="square" lIns="0" tIns="0" rIns="0" bIns="0" rtlCol="0" anchor="t"/>
+          <a:lstStyle/>
           <a:p>
             <a:pPr indent="0" marL="0">
               <a:buNone/>
             </a:pPr>
             <a:r>
-              <a:rPr lang="en-US" sz="2100" dirty="0">
-                <a:solidFill>
-                  <a:schemeClr val="bg2"/>
-                </a:solidFill>
-              </a:rPr>
-              <a:t> </a:t>
-            </a:r>
-            <a:endParaRPr lang="en-US" sz="2100" dirty="0"/>
-          </a:p>
+              <a:rPr lang="en-US" sz="1600" dirty="0">
+                <a:solidFill>
+                  <a:schemeClr val="tx2"/>
+                </a:solidFill>
+              </a:rPr>
+              <a:t>Big-move weeks cluster together, so the model can see them coming. Which way they go is close to a coin flip.</a:t>
+            </a:r>
+            <a:endParaRPr lang="en-US" sz="1600" dirty="0"/>
+          </a:p>
+        </p:txBody>
+      </p:sp>
+      <p:sp>
+        <p:nvSpPr>
+          <p:cNvPr id="8" name="Shape 6"/>
+          <p:cNvSpPr/>
+          <p:nvPr/>
+        </p:nvSpPr>
+        <p:spPr>
+          <a:xfrm>
+            <a:off x="6172200" y="1417320"/>
+            <a:ext cx="5468112" cy="2103120"/>
+          </a:xfrm>
+          <a:prstGeom prst="roundRect">
+            <a:avLst>
+              <a:gd name="adj" fmla="val 5217"/>
+            </a:avLst>
+          </a:prstGeom>
+          <a:solidFill>
+            <a:schemeClr val="bg2"/>
+          </a:solidFill>
+          <a:ln w="12700">
+            <a:solidFill>
+              <a:schemeClr val="bg2"/>
+            </a:solidFill>
+            <a:prstDash val="solid"/>
+          </a:ln>
+        </p:spPr>
+      </p:sp>
+      <p:sp>
+        <p:nvSpPr>
+          <p:cNvPr id="9" name="Shape 7"/>
+          <p:cNvSpPr/>
+          <p:nvPr/>
+        </p:nvSpPr>
+        <p:spPr>
+          <a:xfrm>
+            <a:off x="6400800" y="1645920"/>
+            <a:ext cx="438912" cy="438912"/>
+          </a:xfrm>
+          <a:prstGeom prst="ellipse">
+            <a:avLst/>
+          </a:prstGeom>
+          <a:solidFill>
+            <a:schemeClr val="accent1"/>
+          </a:solidFill>
+          <a:ln w="12700">
+            <a:solidFill>
+              <a:schemeClr val="accent1"/>
+            </a:solidFill>
+            <a:prstDash val="solid"/>
+          </a:ln>
+        </p:spPr>
+      </p:sp>
+      <p:sp>
+        <p:nvSpPr>
+          <p:cNvPr id="10" name="Text 8"/>
+          <p:cNvSpPr txBox="1"/>
+          <p:nvPr/>
+        </p:nvSpPr>
+        <p:spPr>
+          <a:xfrm>
+            <a:off x="6400800" y="1645920"/>
+            <a:ext cx="438912" cy="438912"/>
+          </a:xfrm>
+          <a:prstGeom prst="rect">
+            <a:avLst/>
+          </a:prstGeom>
+          <a:noFill/>
+          <a:ln/>
+        </p:spPr>
+        <p:txBody>
+          <a:bodyPr wrap="square" lIns="0" tIns="0" rIns="0" bIns="0" rtlCol="0" anchor="ctr"/>
+          <a:lstStyle/>
+          <a:p>
+            <a:pPr algn="ctr" indent="0" marL="0">
+              <a:buNone/>
+            </a:pPr>
+            <a:r>
+              <a:rPr lang="en-US" sz="1600" b="1" dirty="0">
+                <a:solidFill>
+                  <a:schemeClr val="bg1"/>
+                </a:solidFill>
+              </a:rPr>
+              <a:t>2</a:t>
+            </a:r>
+            <a:endParaRPr lang="en-US" sz="1600" dirty="0"/>
+          </a:p>
+        </p:txBody>
+      </p:sp>
+      <p:sp>
+        <p:nvSpPr>
+          <p:cNvPr id="11" name="Text 9"/>
+          <p:cNvSpPr txBox="1"/>
+          <p:nvPr/>
+        </p:nvSpPr>
+        <p:spPr>
+          <a:xfrm>
+            <a:off x="6995160" y="1645920"/>
+            <a:ext cx="4416552" cy="438912"/>
+          </a:xfrm>
+          <a:prstGeom prst="rect">
+            <a:avLst/>
+          </a:prstGeom>
+          <a:noFill/>
+          <a:ln/>
+        </p:spPr>
+        <p:txBody>
+          <a:bodyPr wrap="square" lIns="0" tIns="0" rIns="0" bIns="0" rtlCol="0" anchor="ctr"/>
+          <a:lstStyle/>
           <a:p>
             <a:pPr indent="0" marL="0">
               <a:buNone/>
             </a:pPr>
             <a:r>
-              <a:rPr lang="en-US" sz="1800" dirty="0">
-                <a:solidFill>
-                  <a:schemeClr val="accent4"/>
-                </a:solidFill>
-              </a:rPr>
-              <a:t>github.com/TKCH121/spy</a:t>
-            </a:r>
-            <a:endParaRPr lang="en-US" sz="2100" dirty="0"/>
+              <a:rPr lang="en-US" sz="1800" b="1" dirty="0">
+                <a:solidFill>
+                  <a:schemeClr val="tx1"/>
+                </a:solidFill>
+                <a:latin typeface="Cambria" pitchFamily="34" charset="0"/>
+                <a:ea typeface="Cambria" pitchFamily="34" charset="-122"/>
+                <a:cs typeface="Cambria" pitchFamily="34" charset="-120"/>
+              </a:rPr>
+              <a:t>Sitting in cash has a cost</a:t>
+            </a:r>
+            <a:endParaRPr lang="en-US" sz="1800" dirty="0"/>
+          </a:p>
+        </p:txBody>
+      </p:sp>
+      <p:sp>
+        <p:nvSpPr>
+          <p:cNvPr id="12" name="Text 10"/>
+          <p:cNvSpPr txBox="1"/>
+          <p:nvPr/>
+        </p:nvSpPr>
+        <p:spPr>
+          <a:xfrm>
+            <a:off x="6400800" y="2194560"/>
+            <a:ext cx="5010912" cy="1143000"/>
+          </a:xfrm>
+          <a:prstGeom prst="rect">
+            <a:avLst/>
+          </a:prstGeom>
+          <a:noFill/>
+          <a:ln/>
+        </p:spPr>
+        <p:txBody>
+          <a:bodyPr wrap="square" lIns="0" tIns="0" rIns="0" bIns="0" rtlCol="0" anchor="t"/>
+          <a:lstStyle/>
+          <a:p>
+            <a:pPr indent="0" marL="0">
+              <a:buNone/>
+            </a:pPr>
+            <a:r>
+              <a:rPr lang="en-US" sz="1600" dirty="0">
+                <a:solidFill>
+                  <a:schemeClr val="tx2"/>
+                </a:solidFill>
+              </a:rPr>
+              <a:t>The market mostly goes up. Without real timing skill, every day out of the market loses money on average.</a:t>
+            </a:r>
+            <a:endParaRPr lang="en-US" sz="1600" dirty="0"/>
+          </a:p>
+        </p:txBody>
+      </p:sp>
+      <p:sp>
+        <p:nvSpPr>
+          <p:cNvPr id="13" name="Shape 11"/>
+          <p:cNvSpPr/>
+          <p:nvPr/>
+        </p:nvSpPr>
+        <p:spPr>
+          <a:xfrm>
+            <a:off x="548640" y="3703320"/>
+            <a:ext cx="5468112" cy="2103120"/>
+          </a:xfrm>
+          <a:prstGeom prst="roundRect">
+            <a:avLst>
+              <a:gd name="adj" fmla="val 5217"/>
+            </a:avLst>
+          </a:prstGeom>
+          <a:solidFill>
+            <a:schemeClr val="bg2"/>
+          </a:solidFill>
+          <a:ln w="12700">
+            <a:solidFill>
+              <a:schemeClr val="bg2"/>
+            </a:solidFill>
+            <a:prstDash val="solid"/>
+          </a:ln>
+        </p:spPr>
+      </p:sp>
+      <p:sp>
+        <p:nvSpPr>
+          <p:cNvPr id="14" name="Shape 12"/>
+          <p:cNvSpPr/>
+          <p:nvPr/>
+        </p:nvSpPr>
+        <p:spPr>
+          <a:xfrm>
+            <a:off x="777240" y="3931920"/>
+            <a:ext cx="438912" cy="438912"/>
+          </a:xfrm>
+          <a:prstGeom prst="ellipse">
+            <a:avLst/>
+          </a:prstGeom>
+          <a:solidFill>
+            <a:schemeClr val="accent1"/>
+          </a:solidFill>
+          <a:ln w="12700">
+            <a:solidFill>
+              <a:schemeClr val="accent1"/>
+            </a:solidFill>
+            <a:prstDash val="solid"/>
+          </a:ln>
+        </p:spPr>
+      </p:sp>
+      <p:sp>
+        <p:nvSpPr>
+          <p:cNvPr id="15" name="Text 13"/>
+          <p:cNvSpPr txBox="1"/>
+          <p:nvPr/>
+        </p:nvSpPr>
+        <p:spPr>
+          <a:xfrm>
+            <a:off x="777240" y="3931920"/>
+            <a:ext cx="438912" cy="438912"/>
+          </a:xfrm>
+          <a:prstGeom prst="rect">
+            <a:avLst/>
+          </a:prstGeom>
+          <a:noFill/>
+          <a:ln/>
+        </p:spPr>
+        <p:txBody>
+          <a:bodyPr wrap="square" lIns="0" tIns="0" rIns="0" bIns="0" rtlCol="0" anchor="ctr"/>
+          <a:lstStyle/>
+          <a:p>
+            <a:pPr algn="ctr" indent="0" marL="0">
+              <a:buNone/>
+            </a:pPr>
+            <a:r>
+              <a:rPr lang="en-US" sz="1600" b="1" dirty="0">
+                <a:solidFill>
+                  <a:schemeClr val="bg1"/>
+                </a:solidFill>
+              </a:rPr>
+              <a:t>3</a:t>
+            </a:r>
+            <a:endParaRPr lang="en-US" sz="1600" dirty="0"/>
+          </a:p>
+        </p:txBody>
+      </p:sp>
+      <p:sp>
+        <p:nvSpPr>
+          <p:cNvPr id="16" name="Text 14"/>
+          <p:cNvSpPr txBox="1"/>
+          <p:nvPr/>
+        </p:nvSpPr>
+        <p:spPr>
+          <a:xfrm>
+            <a:off x="1371600" y="3931920"/>
+            <a:ext cx="4416552" cy="438912"/>
+          </a:xfrm>
+          <a:prstGeom prst="rect">
+            <a:avLst/>
+          </a:prstGeom>
+          <a:noFill/>
+          <a:ln/>
+        </p:spPr>
+        <p:txBody>
+          <a:bodyPr wrap="square" lIns="0" tIns="0" rIns="0" bIns="0" rtlCol="0" anchor="ctr"/>
+          <a:lstStyle/>
+          <a:p>
+            <a:pPr indent="0" marL="0">
+              <a:buNone/>
+            </a:pPr>
+            <a:r>
+              <a:rPr lang="en-US" sz="1800" b="1" dirty="0">
+                <a:solidFill>
+                  <a:schemeClr val="tx1"/>
+                </a:solidFill>
+                <a:latin typeface="Cambria" pitchFamily="34" charset="0"/>
+                <a:ea typeface="Cambria" pitchFamily="34" charset="-122"/>
+                <a:cs typeface="Cambria" pitchFamily="34" charset="-120"/>
+              </a:rPr>
+              <a:t>The past changes</a:t>
+            </a:r>
+            <a:endParaRPr lang="en-US" sz="1800" dirty="0"/>
+          </a:p>
+        </p:txBody>
+      </p:sp>
+      <p:sp>
+        <p:nvSpPr>
+          <p:cNvPr id="17" name="Text 15"/>
+          <p:cNvSpPr txBox="1"/>
+          <p:nvPr/>
+        </p:nvSpPr>
+        <p:spPr>
+          <a:xfrm>
+            <a:off x="777240" y="4480560"/>
+            <a:ext cx="5010912" cy="1143000"/>
+          </a:xfrm>
+          <a:prstGeom prst="rect">
+            <a:avLst/>
+          </a:prstGeom>
+          <a:noFill/>
+          <a:ln/>
+        </p:spPr>
+        <p:txBody>
+          <a:bodyPr wrap="square" lIns="0" tIns="0" rIns="0" bIns="0" rtlCol="0" anchor="t"/>
+          <a:lstStyle/>
+          <a:p>
+            <a:pPr indent="0" marL="0">
+              <a:buNone/>
+            </a:pPr>
+            <a:r>
+              <a:rPr lang="en-US" sz="1600" dirty="0">
+                <a:solidFill>
+                  <a:schemeClr val="tx2"/>
+                </a:solidFill>
+              </a:rPr>
+              <a:t>A signal that helped from 2010 to 2020 actually misled the model in 2022.</a:t>
+            </a:r>
+            <a:endParaRPr lang="en-US" sz="1600" dirty="0"/>
+          </a:p>
+        </p:txBody>
+      </p:sp>
+      <p:sp>
+        <p:nvSpPr>
+          <p:cNvPr id="18" name="Shape 16"/>
+          <p:cNvSpPr/>
+          <p:nvPr/>
+        </p:nvSpPr>
+        <p:spPr>
+          <a:xfrm>
+            <a:off x="6172200" y="3703320"/>
+            <a:ext cx="5468112" cy="2103120"/>
+          </a:xfrm>
+          <a:prstGeom prst="roundRect">
+            <a:avLst>
+              <a:gd name="adj" fmla="val 5217"/>
+            </a:avLst>
+          </a:prstGeom>
+          <a:solidFill>
+            <a:schemeClr val="bg2"/>
+          </a:solidFill>
+          <a:ln w="12700">
+            <a:solidFill>
+              <a:schemeClr val="bg2"/>
+            </a:solidFill>
+            <a:prstDash val="solid"/>
+          </a:ln>
+        </p:spPr>
+      </p:sp>
+      <p:sp>
+        <p:nvSpPr>
+          <p:cNvPr id="19" name="Shape 17"/>
+          <p:cNvSpPr/>
+          <p:nvPr/>
+        </p:nvSpPr>
+        <p:spPr>
+          <a:xfrm>
+            <a:off x="6400800" y="3931920"/>
+            <a:ext cx="438912" cy="438912"/>
+          </a:xfrm>
+          <a:prstGeom prst="ellipse">
+            <a:avLst/>
+          </a:prstGeom>
+          <a:solidFill>
+            <a:schemeClr val="accent1"/>
+          </a:solidFill>
+          <a:ln w="12700">
+            <a:solidFill>
+              <a:schemeClr val="accent1"/>
+            </a:solidFill>
+            <a:prstDash val="solid"/>
+          </a:ln>
+        </p:spPr>
+      </p:sp>
+      <p:sp>
+        <p:nvSpPr>
+          <p:cNvPr id="20" name="Text 18"/>
+          <p:cNvSpPr txBox="1"/>
+          <p:nvPr/>
+        </p:nvSpPr>
+        <p:spPr>
+          <a:xfrm>
+            <a:off x="6400800" y="3931920"/>
+            <a:ext cx="438912" cy="438912"/>
+          </a:xfrm>
+          <a:prstGeom prst="rect">
+            <a:avLst/>
+          </a:prstGeom>
+          <a:noFill/>
+          <a:ln/>
+        </p:spPr>
+        <p:txBody>
+          <a:bodyPr wrap="square" lIns="0" tIns="0" rIns="0" bIns="0" rtlCol="0" anchor="ctr"/>
+          <a:lstStyle/>
+          <a:p>
+            <a:pPr algn="ctr" indent="0" marL="0">
+              <a:buNone/>
+            </a:pPr>
+            <a:r>
+              <a:rPr lang="en-US" sz="1600" b="1" dirty="0">
+                <a:solidFill>
+                  <a:schemeClr val="bg1"/>
+                </a:solidFill>
+              </a:rPr>
+              <a:t>4</a:t>
+            </a:r>
+            <a:endParaRPr lang="en-US" sz="1600" dirty="0"/>
+          </a:p>
+        </p:txBody>
+      </p:sp>
+      <p:sp>
+        <p:nvSpPr>
+          <p:cNvPr id="21" name="Text 19"/>
+          <p:cNvSpPr txBox="1"/>
+          <p:nvPr/>
+        </p:nvSpPr>
+        <p:spPr>
+          <a:xfrm>
+            <a:off x="6995160" y="3931920"/>
+            <a:ext cx="4416552" cy="438912"/>
+          </a:xfrm>
+          <a:prstGeom prst="rect">
+            <a:avLst/>
+          </a:prstGeom>
+          <a:noFill/>
+          <a:ln/>
+        </p:spPr>
+        <p:txBody>
+          <a:bodyPr wrap="square" lIns="0" tIns="0" rIns="0" bIns="0" rtlCol="0" anchor="ctr"/>
+          <a:lstStyle/>
+          <a:p>
+            <a:pPr indent="0" marL="0">
+              <a:buNone/>
+            </a:pPr>
+            <a:r>
+              <a:rPr lang="en-US" sz="1800" b="1" dirty="0">
+                <a:solidFill>
+                  <a:schemeClr val="tx1"/>
+                </a:solidFill>
+                <a:latin typeface="Cambria" pitchFamily="34" charset="0"/>
+                <a:ea typeface="Cambria" pitchFamily="34" charset="-122"/>
+                <a:cs typeface="Cambria" pitchFamily="34" charset="-120"/>
+              </a:rPr>
+              <a:t>Good predictions ≠ good trades</a:t>
+            </a:r>
+            <a:endParaRPr lang="en-US" sz="1800" dirty="0"/>
+          </a:p>
+        </p:txBody>
+      </p:sp>
+      <p:sp>
+        <p:nvSpPr>
+          <p:cNvPr id="22" name="Text 20"/>
+          <p:cNvSpPr txBox="1"/>
+          <p:nvPr/>
+        </p:nvSpPr>
+        <p:spPr>
+          <a:xfrm>
+            <a:off x="6400800" y="4480560"/>
+            <a:ext cx="5010912" cy="1143000"/>
+          </a:xfrm>
+          <a:prstGeom prst="rect">
+            <a:avLst/>
+          </a:prstGeom>
+          <a:noFill/>
+          <a:ln/>
+        </p:spPr>
+        <p:txBody>
+          <a:bodyPr wrap="square" lIns="0" tIns="0" rIns="0" bIns="0" rtlCol="0" anchor="t"/>
+          <a:lstStyle/>
+          <a:p>
+            <a:pPr indent="0" marL="0">
+              <a:buNone/>
+            </a:pPr>
+            <a:r>
+              <a:rPr lang="en-US" sz="1600" dirty="0">
+                <a:solidFill>
+                  <a:schemeClr val="tx2"/>
+                </a:solidFill>
+              </a:rPr>
+              <a:t>Settings that improve the prediction score can distort the odds a trading rule relies on. With honest odds (v3), the best rule was not to trade.</a:t>
+            </a:r>
+            <a:endParaRPr lang="en-US" sz="1600" dirty="0"/>
           </a:p>
         </p:txBody>
       </p:sp>
@@ -18362,6 +19578,183 @@
             <a:fld id="{F7021451-1387-4CA6-816F-3879F97B5CBC}" type="slidenum">
               <a:rPr b="0" lang="en-US"/>
               <a:t>26</a:t>
+            </a:fld>
+            <a:endParaRPr lang="en-US"/>
+          </a:p>
+        </p:txBody>
+      </p:sp>
+    </p:spTree>
+  </p:cSld>
+  <p:clrMapOvr>
+    <a:masterClrMapping/>
+  </p:clrMapOvr>
+</p:sld>
+</file>
+
+<file path=ppt/slides/slide27.xml><?xml version="1.0" encoding="utf-8"?>
+<p:sld xmlns:a="http://schemas.openxmlformats.org/drawingml/2006/main" xmlns:r="http://schemas.openxmlformats.org/officeDocument/2006/relationships" xmlns:p="http://schemas.openxmlformats.org/presentationml/2006/main">
+  <p:cSld name="Slide 27">
+    <p:spTree>
+      <p:nvGrpSpPr>
+        <p:cNvPr id="1" name=""/>
+        <p:cNvGrpSpPr/>
+        <p:nvPr/>
+      </p:nvGrpSpPr>
+      <p:grpSpPr>
+        <a:xfrm>
+          <a:off x="0" y="0"/>
+          <a:ext cx="0" cy="0"/>
+          <a:chOff x="0" y="0"/>
+          <a:chExt cx="0" cy="0"/>
+        </a:xfrm>
+      </p:grpSpPr>
+      <p:sp>
+        <p:nvSpPr>
+          <p:cNvPr id="2" name="Text 0"/>
+          <p:cNvSpPr/>
+          <p:nvPr>
+            <p:ph idx="100" type="title" hasCustomPrompt="1"/>
+          </p:nvPr>
+        </p:nvSpPr>
+        <p:spPr>
+          <a:xfrm>
+            <a:off x="548640" y="1097280"/>
+            <a:ext cx="10789920" cy="2560320"/>
+          </a:xfrm>
+          <a:prstGeom prst="rect">
+            <a:avLst/>
+          </a:prstGeom>
+          <a:noFill/>
+          <a:ln/>
+        </p:spPr>
+        <p:txBody>
+          <a:bodyPr wrap="square" rtlCol="0" anchor="b"/>
+          <a:lstStyle/>
+          <a:p>
+            <a:pPr indent="0" marL="0">
+              <a:buNone/>
+            </a:pPr>
+            <a:r>
+              <a:rPr lang="en-US" sz="4000" b="1" dirty="0">
+                <a:solidFill>
+                  <a:schemeClr val="bg1"/>
+                </a:solidFill>
+                <a:latin typeface="Cambria" pitchFamily="34" charset="0"/>
+                <a:ea typeface="Cambria" pitchFamily="34" charset="-122"/>
+                <a:cs typeface="Cambria" pitchFamily="34" charset="-120"/>
+              </a:rPr>
+              <a:t>Questions?</a:t>
+            </a:r>
+            <a:endParaRPr lang="en-US" sz="4000" dirty="0"/>
+          </a:p>
+        </p:txBody>
+      </p:sp>
+      <p:sp>
+        <p:nvSpPr>
+          <p:cNvPr id="3" name="Text 0"/>
+          <p:cNvSpPr/>
+          <p:nvPr>
+            <p:ph idx="101" type="body" hasCustomPrompt="1"/>
+          </p:nvPr>
+        </p:nvSpPr>
+        <p:spPr>
+          <a:xfrm>
+            <a:off x="548640" y="3931920"/>
+            <a:ext cx="10424160" cy="2103120"/>
+          </a:xfrm>
+          <a:prstGeom prst="rect">
+            <a:avLst/>
+          </a:prstGeom>
+          <a:noFill/>
+          <a:ln/>
+        </p:spPr>
+        <p:txBody>
+          <a:bodyPr wrap="square" rtlCol="0" anchor="t"/>
+          <a:lstStyle/>
+          <a:p>
+            <a:pPr indent="0" marL="0">
+              <a:buNone/>
+            </a:pPr>
+            <a:r>
+              <a:rPr lang="en-US" sz="2100" dirty="0">
+                <a:solidFill>
+                  <a:schemeClr val="bg2"/>
+                </a:solidFill>
+              </a:rPr>
+              <a:t>$100,000 in 2023–24 → $156,546 by waiting, $123,714 with v1, $121,812 with v2. With honest odds, v3’s best rule is not to trade.</a:t>
+            </a:r>
+            <a:endParaRPr lang="en-US" sz="2100" dirty="0"/>
+          </a:p>
+          <a:p>
+            <a:pPr indent="0" marL="0">
+              <a:buNone/>
+            </a:pPr>
+            <a:r>
+              <a:rPr lang="en-US" sz="2100" dirty="0">
+                <a:solidFill>
+                  <a:schemeClr val="bg2"/>
+                </a:solidFill>
+              </a:rPr>
+              <a:t> </a:t>
+            </a:r>
+            <a:endParaRPr lang="en-US" sz="2100" dirty="0"/>
+          </a:p>
+          <a:p>
+            <a:pPr indent="0" marL="0">
+              <a:buNone/>
+            </a:pPr>
+            <a:r>
+              <a:rPr lang="en-US" sz="1800" dirty="0">
+                <a:solidFill>
+                  <a:schemeClr val="accent4"/>
+                </a:solidFill>
+              </a:rPr>
+              <a:t>github.com/TKCH121/spy</a:t>
+            </a:r>
+            <a:endParaRPr lang="en-US" sz="2100" dirty="0"/>
+          </a:p>
+        </p:txBody>
+      </p:sp>
+      <p:sp>
+        <p:nvSpPr>
+          <p:cNvPr id="25" name="Slide Number Placeholder 0"/>
+          <p:cNvSpPr>
+            <a:spLocks noGrp="1"/>
+          </p:cNvSpPr>
+          <p:nvPr>
+            <p:ph type="sldNum" sz="quarter" idx="4294967295"/>
+          </p:nvPr>
+        </p:nvSpPr>
+        <p:spPr>
+          <a:xfrm>
+            <a:off x="11155680" y="6355080"/>
+            <a:ext cx="548640" cy="320040"/>
+          </a:xfrm>
+          <a:prstGeom prst="rect">
+            <a:avLst/>
+          </a:prstGeom>
+          <a:extLst>
+            <a:ext uri="{C572A759-6A51-4108-AA02-DFA0A04FC94B}">
+              <ma14:wrappingTextBoxFlag xmlns:ma14="http://schemas.microsoft.com/office/mac/drawingml/2011/main" val="0"/>
+            </a:ext>
+          </a:extLst>
+        </p:spPr>
+        <p:txBody>
+          <a:bodyPr/>
+          <a:lstStyle>
+            <a:lvl1pPr>
+              <a:defRPr sz="1200">
+                <a:solidFill>
+                  <a:schemeClr val="accent3"/>
+                </a:solidFill>
+              </a:defRPr>
+            </a:lvl1pPr>
+          </a:lstStyle>
+          <a:p>
+            <a:pPr algn="r"/>
+            <a:fld id="{F7021451-1387-4CA6-816F-3879F97B5CBC}" type="slidenum">
+              <a:rPr b="0" lang="en-US"/>
+              <a:t>27</a:t>
             </a:fld>
             <a:endParaRPr lang="en-US"/>
           </a:p>

</xml_diff>

<commit_message>
Docs: assessor-facing README, cross-version SUMMARY, model-and-accuracy slide
- README rewritten as a 'Start here' page: answer, versions table, where each brief
  deliverable is, guardrails, repo map, full reproduce loop, credits.
- outputs/SUMMARY.md: lessons learned across v1-v3 with links to detailed reports.
- Deck: new 'Which model, and how accurate?' slide (25); v3 slides show the holdout
  result; script updated (~10 minutes).

Co-Authored-By: Claude Opus 5.5 <noreply@anthropic.com>
</commit_message>
<xml_diff>
--- a/presentation/SPY_Model_Presentation.pptx
+++ b/presentation/SPY_Model_Presentation.pptx
@@ -33,9 +33,10 @@
     <p:sldId id="281" r:id="rId27"/>
     <p:sldId id="282" r:id="rId28"/>
     <p:sldId id="283" r:id="rId29"/>
+    <p:sldId id="284" r:id="rId30"/>
   </p:sldIdLst>
   <p:notesMasterIdLst>
-    <p:notesMasterId r:id="rId30"/>
+    <p:notesMasterId r:id="rId31"/>
   </p:notesMasterIdLst>
   <p:sldSz cx="12192000" cy="6858000"/>
   <p:notesSz cx="6858000" cy="12192000"/>
@@ -134,7 +135,7 @@
   <p:extLst>
     <p:ext uri="{521415D9-36F7-43E2-AB2F-B90AF26B5E84}">
       <p14:sectionLst xmlns:p14="http://schemas.microsoft.com/office/powerpoint/2010/main">
-        <p14:section name="The question" id="{d78dd8d1-52fb-56fa-97b8-933938c1a918}">
+        <p14:section name="The question" id="{9ce59636-46d4-dbae-f74a-d77ee1f25c77}">
           <p14:sldIdLst>
             <p14:sldId id="256"/>
             <p14:sldId id="257"/>
@@ -144,7 +145,7 @@
             <p14:sldId id="261"/>
           </p14:sldIdLst>
         </p14:section>
-        <p14:section name="How the model works" id="{94a233eb-b2a2-8c94-b7ea-6641816dc4c5}">
+        <p14:section name="How the model works" id="{22591102-ca6c-e4d3-6cfa-407aed3205a9}">
           <p14:sldIdLst>
             <p14:sldId id="262"/>
             <p14:sldId id="263"/>
@@ -154,7 +155,7 @@
             <p14:sldId id="267"/>
           </p14:sldIdLst>
         </p14:section>
-        <p14:section name="What happened" id="{609151fb-10ec-34be-46c9-c4f70be05380}">
+        <p14:section name="What happened" id="{7868a3f9-0056-ee5c-e562-f328e66a3def}">
           <p14:sldIdLst>
             <p14:sldId id="268"/>
             <p14:sldId id="269"/>
@@ -162,7 +163,7 @@
             <p14:sldId id="271"/>
           </p14:sldIdLst>
         </p14:section>
-        <p14:section name="Version 2" id="{a35609ea-4c00-ae3b-c46d-bebf17c85f3b}">
+        <p14:section name="Version 2" id="{8aa8a8a7-c03a-6c0f-d037-133550b7715e}">
           <p14:sldIdLst>
             <p14:sldId id="272"/>
             <p14:sldId id="273"/>
@@ -172,18 +173,19 @@
             <p14:sldId id="277"/>
           </p14:sldIdLst>
         </p14:section>
-        <p14:section name="Version 3" id="{ffaab827-805a-c5e4-9fcf-875b12bd1325}">
+        <p14:section name="Version 3" id="{c2ff4141-5a3c-4503-3ac6-d0690f39df70}">
           <p14:sldIdLst>
             <p14:sldId id="278"/>
             <p14:sldId id="279"/>
             <p14:sldId id="280"/>
+            <p14:sldId id="281"/>
           </p14:sldIdLst>
         </p14:section>
-        <p14:section name="Wrap-up" id="{c6204ca2-49c1-1014-be9d-1d748f777bc3}">
+        <p14:section name="Wrap-up" id="{d808f77e-3d5c-bf9c-123d-e34be173be0b}">
           <p14:sldIdLst>
-            <p14:sldId id="281"/>
             <p14:sldId id="282"/>
             <p14:sldId id="283"/>
+            <p14:sldId id="284"/>
           </p14:sldIdLst>
         </p14:section>
       </p14:sectionLst>
@@ -5760,6 +5762,94 @@
 </p:notes>
 </file>
 
+<file path=ppt/notesSlides/notesSlide29.xml><?xml version="1.0" encoding="utf-8"?>
+<p:notes xmlns:a="http://schemas.openxmlformats.org/drawingml/2006/main" xmlns:r="http://schemas.openxmlformats.org/officeDocument/2006/relationships" xmlns:p="http://schemas.openxmlformats.org/presentationml/2006/main">
+  <p:cSld>
+    <p:spTree>
+      <p:nvGrpSpPr>
+        <p:cNvPr id="1" name=""/>
+        <p:cNvGrpSpPr/>
+        <p:nvPr/>
+      </p:nvGrpSpPr>
+      <p:grpSpPr>
+        <a:xfrm>
+          <a:off x="0" y="0"/>
+          <a:ext cx="0" cy="0"/>
+          <a:chOff x="0" y="0"/>
+          <a:chExt cx="0" cy="0"/>
+        </a:xfrm>
+      </p:grpSpPr>
+      <p:sp>
+        <p:nvSpPr>
+          <p:cNvPr id="2" name="Slide Image Placeholder 1"/>
+          <p:cNvSpPr>
+            <a:spLocks noGrp="1" noRot="1" noChangeAspect="1"/>
+          </p:cNvSpPr>
+          <p:nvPr>
+            <p:ph type="sldImg"/>
+          </p:nvPr>
+        </p:nvSpPr>
+        <p:spPr/>
+      </p:sp>
+      <p:sp>
+        <p:nvSpPr>
+          <p:cNvPr id="3" name="Notes Placeholder 2"/>
+          <p:cNvSpPr>
+            <a:spLocks noGrp="1"/>
+          </p:cNvSpPr>
+          <p:nvPr>
+            <p:ph type="body" idx="1"/>
+          </p:nvPr>
+        </p:nvSpPr>
+        <p:spPr/>
+        <p:txBody>
+          <a:bodyPr/>
+          <a:lstStyle/>
+          <a:p>
+            <a:r>
+              <a:rPr lang="en-US" dirty="0"/>
+              <a:t/>
+            </a:r>
+            <a:endParaRPr lang="en-US" dirty="0"/>
+          </a:p>
+        </p:txBody>
+      </p:sp>
+      <p:sp>
+        <p:nvSpPr>
+          <p:cNvPr id="4" name="Slide Number Placeholder 3"/>
+          <p:cNvSpPr>
+            <a:spLocks noGrp="1"/>
+          </p:cNvSpPr>
+          <p:nvPr>
+            <p:ph type="sldNum" sz="quarter" idx="10"/>
+          </p:nvPr>
+        </p:nvSpPr>
+        <p:spPr/>
+        <p:txBody>
+          <a:bodyPr/>
+          <a:lstStyle/>
+          <a:p>
+            <a:fld id="{F7021451-1387-4CA6-816F-3879F97B5CBC}" type="slidenum">
+              <a:rPr lang="en-US"/>
+              <a:t>29</a:t>
+            </a:fld>
+            <a:endParaRPr lang="en-US"/>
+          </a:p>
+        </p:txBody>
+      </p:sp>
+    </p:spTree>
+    <p:extLst>
+      <p:ext uri="{BB962C8B-B14F-4D97-AF65-F5344CB8AC3E}">
+        <p14:creationId xmlns:p14="http://schemas.microsoft.com/office/powerpoint/2010/main" val="1024086991"/>
+      </p:ext>
+    </p:extLst>
+  </p:cSld>
+  <p:clrMapOvr>
+    <a:masterClrMapping/>
+  </p:clrMapOvr>
+</p:notes>
+</file>
+
 <file path=ppt/notesSlides/notesSlide3.xml><?xml version="1.0" encoding="utf-8"?>
 <p:notes xmlns:a="http://schemas.openxmlformats.org/drawingml/2006/main" xmlns:r="http://schemas.openxmlformats.org/officeDocument/2006/relationships" xmlns:p="http://schemas.openxmlformats.org/presentationml/2006/main">
   <p:cSld>
@@ -16018,7 +16108,7 @@
                             <a:schemeClr val="tx2"/>
                           </a:solidFill>
                         </a:rPr>
-                        <a:t>outputs/report.md</a:t>
+                        <a:t>outputs/report.md, SUMMARY.md</a:t>
                       </a:r>
                       <a:endParaRPr lang="en-US" sz="1600" dirty="0"/>
                     </a:p>
@@ -19102,14 +19192,14 @@
               <a:buNone/>
             </a:pPr>
             <a:r>
-              <a:rPr lang="en-US" sz="1500" dirty="0">
+              <a:rPr lang="en-US" sz="1400" dirty="0">
                 <a:solidFill>
                   <a:schemeClr val="tx2"/>
                 </a:solidFill>
               </a:rPr>
-              <a:t>Chosen by a rule fixed in advance. In ten years it never stepped out of the market: it is Buy &amp; Hold, and it ties Buy &amp; Hold.</a:t>
-            </a:r>
-            <a:endParaRPr lang="en-US" sz="1500" dirty="0"/>
+              <a:t>Chosen by a rule fixed in advance. It never stepped out of the market: not in 2013–22, not in 2023–24 ($156,546), not on the 2025–26 holdout ($134,410). It is Buy &amp; Hold.</a:t>
+            </a:r>
+            <a:endParaRPr lang="en-US" sz="1400" dirty="0"/>
           </a:p>
         </p:txBody>
       </p:sp>
@@ -19209,7 +19299,7 @@
                   <a:schemeClr val="tx2"/>
                 </a:solidFill>
               </a:rPr>
-              <a:t>Even the ones invested 95% of the time ended about $70,000 behind.</a:t>
+              <a:t>Even the ones invested 95% of the time ended about $70,000 behind over 2013–22.</a:t>
             </a:r>
             <a:endParaRPr lang="en-US" sz="1500" dirty="0"/>
           </a:p>
@@ -19245,7 +19335,7 @@
                   <a:schemeClr val="accent3"/>
                 </a:solidFill>
               </a:rPr>
-              <a:t>Still to come: the frozen pick on 2025–26 data and a live paper-trade from 13 Oct 2026.</a:t>
+              <a:t>A live paper-trade of the frozen rule runs from 13 Oct 2026.</a:t>
             </a:r>
             <a:endParaRPr lang="en-US" sz="1300" dirty="0"/>
           </a:p>
@@ -19356,26 +19446,1478 @@
                 <a:ea typeface="Cambria" pitchFamily="34" charset="-122"/>
                 <a:cs typeface="Cambria" pitchFamily="34" charset="-120"/>
               </a:rPr>
-              <a:t>How we kept the test honest</a:t>
+              <a:t>Which model, and how accurate?</a:t>
             </a:r>
             <a:endParaRPr lang="en-US" sz="3200" dirty="0"/>
           </a:p>
         </p:txBody>
       </p:sp>
-      <p:sp>
-        <p:nvSpPr>
-          <p:cNvPr id="3" name="Shape 1"/>
+      <p:graphicFrame>
+        <p:nvGraphicFramePr>
+          <p:cNvPr id="26" name="Table 0"/>
+          <p:cNvGraphicFramePr>
+            <a:graphicFrameLocks noGrp="1"/>
+          </p:cNvGraphicFramePr>
+          <p:nvPr>
+            <p:extLst>
+              <p:ext uri="{D42A27DB-BD31-4B8C-83A1-F6EECF244321}">
+                <p14:modId xmlns:p14="http://schemas.microsoft.com/office/powerpoint/2010/main" val="1579011935"/>
+              </p:ext>
+            </p:extLst>
+          </p:nvPr>
+        </p:nvGraphicFramePr>
+        <p:xfrm>
+          <a:off x="548640" y="1371600"/>
+          <a:ext cx="11094415" cy="914400"/>
+        </p:xfrm>
+        <a:graphic>
+          <a:graphicData uri="http://schemas.openxmlformats.org/drawingml/2006/table">
+            <a:tbl>
+              <a:tblPr/>
+              <a:tblGrid>
+                <a:gridCol w="1005840"/>
+                <a:gridCol w="2834640"/>
+                <a:gridCol w="2514600"/>
+                <a:gridCol w="1234440"/>
+                <a:gridCol w="1234440"/>
+                <a:gridCol w="2267712"/>
+              </a:tblGrid>
+              <a:tr h="566928">
+                <a:tc>
+                  <a:txBody>
+                    <a:bodyPr/>
+                    <a:lstStyle/>
+                    <a:p>
+                      <a:pPr indent="0" marL="0">
+                        <a:buNone/>
+                      </a:pPr>
+                      <a:r>
+                        <a:rPr lang="en-US" sz="1500" b="1" dirty="0">
+                          <a:solidFill>
+                            <a:schemeClr val="bg1"/>
+                          </a:solidFill>
+                        </a:rPr>
+                        <a:t>Version</a:t>
+                      </a:r>
+                      <a:endParaRPr lang="en-US" sz="1500" dirty="0"/>
+                    </a:p>
+                  </a:txBody>
+                  <a:tcPr marL="91440" marR="91440" marT="54864" marB="54864" anchor="ctr">
+                    <a:lnL w="9525" cap="flat" cmpd="sng" algn="ctr">
+                      <a:solidFill>
+                        <a:srgbClr val="D5DAE3"/>
+                      </a:solidFill>
+                      <a:prstDash val="solid"/>
+                      <a:round/>
+                      <a:headEnd type="none" w="med" len="med"/>
+                      <a:tailEnd type="none" w="med" len="med"/>
+                    </a:lnL>
+                    <a:lnR w="9525" cap="flat" cmpd="sng" algn="ctr">
+                      <a:solidFill>
+                        <a:srgbClr val="D5DAE3"/>
+                      </a:solidFill>
+                      <a:prstDash val="solid"/>
+                      <a:round/>
+                      <a:headEnd type="none" w="med" len="med"/>
+                      <a:tailEnd type="none" w="med" len="med"/>
+                    </a:lnR>
+                    <a:lnT w="9525" cap="flat" cmpd="sng" algn="ctr">
+                      <a:solidFill>
+                        <a:srgbClr val="D5DAE3"/>
+                      </a:solidFill>
+                      <a:prstDash val="solid"/>
+                      <a:round/>
+                      <a:headEnd type="none" w="med" len="med"/>
+                      <a:tailEnd type="none" w="med" len="med"/>
+                    </a:lnT>
+                    <a:lnB w="9525" cap="flat" cmpd="sng" algn="ctr">
+                      <a:solidFill>
+                        <a:srgbClr val="D5DAE3"/>
+                      </a:solidFill>
+                      <a:prstDash val="solid"/>
+                      <a:round/>
+                      <a:headEnd type="none" w="med" len="med"/>
+                      <a:tailEnd type="none" w="med" len="med"/>
+                    </a:lnB>
+                    <a:solidFill>
+                      <a:schemeClr val="tx1"/>
+                    </a:solidFill>
+                  </a:tcPr>
+                </a:tc>
+                <a:tc>
+                  <a:txBody>
+                    <a:bodyPr/>
+                    <a:lstStyle/>
+                    <a:p>
+                      <a:pPr indent="0" marL="0">
+                        <a:buNone/>
+                      </a:pPr>
+                      <a:r>
+                        <a:rPr lang="en-US" sz="1500" b="1" dirty="0">
+                          <a:solidFill>
+                            <a:schemeClr val="bg1"/>
+                          </a:solidFill>
+                        </a:rPr>
+                        <a:t>Model</a:t>
+                      </a:r>
+                      <a:endParaRPr lang="en-US" sz="1500" dirty="0"/>
+                    </a:p>
+                  </a:txBody>
+                  <a:tcPr marL="91440" marR="91440" marT="54864" marB="54864" anchor="ctr">
+                    <a:lnL w="9525" cap="flat" cmpd="sng" algn="ctr">
+                      <a:solidFill>
+                        <a:srgbClr val="D5DAE3"/>
+                      </a:solidFill>
+                      <a:prstDash val="solid"/>
+                      <a:round/>
+                      <a:headEnd type="none" w="med" len="med"/>
+                      <a:tailEnd type="none" w="med" len="med"/>
+                    </a:lnL>
+                    <a:lnR w="9525" cap="flat" cmpd="sng" algn="ctr">
+                      <a:solidFill>
+                        <a:srgbClr val="D5DAE3"/>
+                      </a:solidFill>
+                      <a:prstDash val="solid"/>
+                      <a:round/>
+                      <a:headEnd type="none" w="med" len="med"/>
+                      <a:tailEnd type="none" w="med" len="med"/>
+                    </a:lnR>
+                    <a:lnT w="9525" cap="flat" cmpd="sng" algn="ctr">
+                      <a:solidFill>
+                        <a:srgbClr val="D5DAE3"/>
+                      </a:solidFill>
+                      <a:prstDash val="solid"/>
+                      <a:round/>
+                      <a:headEnd type="none" w="med" len="med"/>
+                      <a:tailEnd type="none" w="med" len="med"/>
+                    </a:lnT>
+                    <a:lnB w="9525" cap="flat" cmpd="sng" algn="ctr">
+                      <a:solidFill>
+                        <a:srgbClr val="D5DAE3"/>
+                      </a:solidFill>
+                      <a:prstDash val="solid"/>
+                      <a:round/>
+                      <a:headEnd type="none" w="med" len="med"/>
+                      <a:tailEnd type="none" w="med" len="med"/>
+                    </a:lnB>
+                    <a:solidFill>
+                      <a:schemeClr val="tx1"/>
+                    </a:solidFill>
+                  </a:tcPr>
+                </a:tc>
+                <a:tc>
+                  <a:txBody>
+                    <a:bodyPr/>
+                    <a:lstStyle/>
+                    <a:p>
+                      <a:pPr indent="0" marL="0">
+                        <a:buNone/>
+                      </a:pPr>
+                      <a:r>
+                        <a:rPr lang="en-US" sz="1500" b="1" dirty="0">
+                          <a:solidFill>
+                            <a:schemeClr val="bg1"/>
+                          </a:solidFill>
+                        </a:rPr>
+                        <a:t>Chosen by</a:t>
+                      </a:r>
+                      <a:endParaRPr lang="en-US" sz="1500" dirty="0"/>
+                    </a:p>
+                  </a:txBody>
+                  <a:tcPr marL="91440" marR="91440" marT="54864" marB="54864" anchor="ctr">
+                    <a:lnL w="9525" cap="flat" cmpd="sng" algn="ctr">
+                      <a:solidFill>
+                        <a:srgbClr val="D5DAE3"/>
+                      </a:solidFill>
+                      <a:prstDash val="solid"/>
+                      <a:round/>
+                      <a:headEnd type="none" w="med" len="med"/>
+                      <a:tailEnd type="none" w="med" len="med"/>
+                    </a:lnL>
+                    <a:lnR w="9525" cap="flat" cmpd="sng" algn="ctr">
+                      <a:solidFill>
+                        <a:srgbClr val="D5DAE3"/>
+                      </a:solidFill>
+                      <a:prstDash val="solid"/>
+                      <a:round/>
+                      <a:headEnd type="none" w="med" len="med"/>
+                      <a:tailEnd type="none" w="med" len="med"/>
+                    </a:lnR>
+                    <a:lnT w="9525" cap="flat" cmpd="sng" algn="ctr">
+                      <a:solidFill>
+                        <a:srgbClr val="D5DAE3"/>
+                      </a:solidFill>
+                      <a:prstDash val="solid"/>
+                      <a:round/>
+                      <a:headEnd type="none" w="med" len="med"/>
+                      <a:tailEnd type="none" w="med" len="med"/>
+                    </a:lnT>
+                    <a:lnB w="9525" cap="flat" cmpd="sng" algn="ctr">
+                      <a:solidFill>
+                        <a:srgbClr val="D5DAE3"/>
+                      </a:solidFill>
+                      <a:prstDash val="solid"/>
+                      <a:round/>
+                      <a:headEnd type="none" w="med" len="med"/>
+                      <a:tailEnd type="none" w="med" len="med"/>
+                    </a:lnB>
+                    <a:solidFill>
+                      <a:schemeClr val="tx1"/>
+                    </a:solidFill>
+                  </a:tcPr>
+                </a:tc>
+                <a:tc>
+                  <a:txBody>
+                    <a:bodyPr/>
+                    <a:lstStyle/>
+                    <a:p>
+                      <a:pPr indent="0" marL="0">
+                        <a:buNone/>
+                      </a:pPr>
+                      <a:r>
+                        <a:rPr lang="en-US" sz="1500" b="1" dirty="0">
+                          <a:solidFill>
+                            <a:schemeClr val="bg1"/>
+                          </a:solidFill>
+                        </a:rPr>
+                        <a:t>Accuracy</a:t>
+                      </a:r>
+                      <a:endParaRPr lang="en-US" sz="1500" dirty="0"/>
+                    </a:p>
+                  </a:txBody>
+                  <a:tcPr marL="91440" marR="91440" marT="54864" marB="54864" anchor="ctr">
+                    <a:lnL w="9525" cap="flat" cmpd="sng" algn="ctr">
+                      <a:solidFill>
+                        <a:srgbClr val="D5DAE3"/>
+                      </a:solidFill>
+                      <a:prstDash val="solid"/>
+                      <a:round/>
+                      <a:headEnd type="none" w="med" len="med"/>
+                      <a:tailEnd type="none" w="med" len="med"/>
+                    </a:lnL>
+                    <a:lnR w="9525" cap="flat" cmpd="sng" algn="ctr">
+                      <a:solidFill>
+                        <a:srgbClr val="D5DAE3"/>
+                      </a:solidFill>
+                      <a:prstDash val="solid"/>
+                      <a:round/>
+                      <a:headEnd type="none" w="med" len="med"/>
+                      <a:tailEnd type="none" w="med" len="med"/>
+                    </a:lnR>
+                    <a:lnT w="9525" cap="flat" cmpd="sng" algn="ctr">
+                      <a:solidFill>
+                        <a:srgbClr val="D5DAE3"/>
+                      </a:solidFill>
+                      <a:prstDash val="solid"/>
+                      <a:round/>
+                      <a:headEnd type="none" w="med" len="med"/>
+                      <a:tailEnd type="none" w="med" len="med"/>
+                    </a:lnT>
+                    <a:lnB w="9525" cap="flat" cmpd="sng" algn="ctr">
+                      <a:solidFill>
+                        <a:srgbClr val="D5DAE3"/>
+                      </a:solidFill>
+                      <a:prstDash val="solid"/>
+                      <a:round/>
+                      <a:headEnd type="none" w="med" len="med"/>
+                      <a:tailEnd type="none" w="med" len="med"/>
+                    </a:lnB>
+                    <a:solidFill>
+                      <a:schemeClr val="tx1"/>
+                    </a:solidFill>
+                  </a:tcPr>
+                </a:tc>
+                <a:tc>
+                  <a:txBody>
+                    <a:bodyPr/>
+                    <a:lstStyle/>
+                    <a:p>
+                      <a:pPr indent="0" marL="0">
+                        <a:buNone/>
+                      </a:pPr>
+                      <a:r>
+                        <a:rPr lang="en-US" sz="1500" b="1" dirty="0">
+                          <a:solidFill>
+                            <a:schemeClr val="bg1"/>
+                          </a:solidFill>
+                        </a:rPr>
+                        <a:t>Macro-F1</a:t>
+                      </a:r>
+                      <a:endParaRPr lang="en-US" sz="1500" dirty="0"/>
+                    </a:p>
+                  </a:txBody>
+                  <a:tcPr marL="91440" marR="91440" marT="54864" marB="54864" anchor="ctr">
+                    <a:lnL w="9525" cap="flat" cmpd="sng" algn="ctr">
+                      <a:solidFill>
+                        <a:srgbClr val="D5DAE3"/>
+                      </a:solidFill>
+                      <a:prstDash val="solid"/>
+                      <a:round/>
+                      <a:headEnd type="none" w="med" len="med"/>
+                      <a:tailEnd type="none" w="med" len="med"/>
+                    </a:lnL>
+                    <a:lnR w="9525" cap="flat" cmpd="sng" algn="ctr">
+                      <a:solidFill>
+                        <a:srgbClr val="D5DAE3"/>
+                      </a:solidFill>
+                      <a:prstDash val="solid"/>
+                      <a:round/>
+                      <a:headEnd type="none" w="med" len="med"/>
+                      <a:tailEnd type="none" w="med" len="med"/>
+                    </a:lnR>
+                    <a:lnT w="9525" cap="flat" cmpd="sng" algn="ctr">
+                      <a:solidFill>
+                        <a:srgbClr val="D5DAE3"/>
+                      </a:solidFill>
+                      <a:prstDash val="solid"/>
+                      <a:round/>
+                      <a:headEnd type="none" w="med" len="med"/>
+                      <a:tailEnd type="none" w="med" len="med"/>
+                    </a:lnT>
+                    <a:lnB w="9525" cap="flat" cmpd="sng" algn="ctr">
+                      <a:solidFill>
+                        <a:srgbClr val="D5DAE3"/>
+                      </a:solidFill>
+                      <a:prstDash val="solid"/>
+                      <a:round/>
+                      <a:headEnd type="none" w="med" len="med"/>
+                      <a:tailEnd type="none" w="med" len="med"/>
+                    </a:lnB>
+                    <a:solidFill>
+                      <a:schemeClr val="tx1"/>
+                    </a:solidFill>
+                  </a:tcPr>
+                </a:tc>
+                <a:tc>
+                  <a:txBody>
+                    <a:bodyPr/>
+                    <a:lstStyle/>
+                    <a:p>
+                      <a:pPr indent="0" marL="0">
+                        <a:buNone/>
+                      </a:pPr>
+                      <a:r>
+                        <a:rPr lang="en-US" sz="1500" b="1" dirty="0">
+                          <a:solidFill>
+                            <a:schemeClr val="bg1"/>
+                          </a:solidFill>
+                        </a:rPr>
+                        <a:t>$100,000 on 2023–24</a:t>
+                      </a:r>
+                      <a:endParaRPr lang="en-US" sz="1500" dirty="0"/>
+                    </a:p>
+                  </a:txBody>
+                  <a:tcPr marL="91440" marR="91440" marT="54864" marB="54864" anchor="ctr">
+                    <a:lnL w="9525" cap="flat" cmpd="sng" algn="ctr">
+                      <a:solidFill>
+                        <a:srgbClr val="D5DAE3"/>
+                      </a:solidFill>
+                      <a:prstDash val="solid"/>
+                      <a:round/>
+                      <a:headEnd type="none" w="med" len="med"/>
+                      <a:tailEnd type="none" w="med" len="med"/>
+                    </a:lnL>
+                    <a:lnR w="9525" cap="flat" cmpd="sng" algn="ctr">
+                      <a:solidFill>
+                        <a:srgbClr val="D5DAE3"/>
+                      </a:solidFill>
+                      <a:prstDash val="solid"/>
+                      <a:round/>
+                      <a:headEnd type="none" w="med" len="med"/>
+                      <a:tailEnd type="none" w="med" len="med"/>
+                    </a:lnR>
+                    <a:lnT w="9525" cap="flat" cmpd="sng" algn="ctr">
+                      <a:solidFill>
+                        <a:srgbClr val="D5DAE3"/>
+                      </a:solidFill>
+                      <a:prstDash val="solid"/>
+                      <a:round/>
+                      <a:headEnd type="none" w="med" len="med"/>
+                      <a:tailEnd type="none" w="med" len="med"/>
+                    </a:lnT>
+                    <a:lnB w="9525" cap="flat" cmpd="sng" algn="ctr">
+                      <a:solidFill>
+                        <a:srgbClr val="D5DAE3"/>
+                      </a:solidFill>
+                      <a:prstDash val="solid"/>
+                      <a:round/>
+                      <a:headEnd type="none" w="med" len="med"/>
+                      <a:tailEnd type="none" w="med" len="med"/>
+                    </a:lnB>
+                    <a:solidFill>
+                      <a:schemeClr val="tx1"/>
+                    </a:solidFill>
+                  </a:tcPr>
+                </a:tc>
+              </a:tr>
+              <a:tr h="566928">
+                <a:tc>
+                  <a:txBody>
+                    <a:bodyPr/>
+                    <a:lstStyle/>
+                    <a:p>
+                      <a:pPr indent="0" marL="0">
+                        <a:buNone/>
+                      </a:pPr>
+                      <a:r>
+                        <a:rPr lang="en-US" sz="1500" dirty="0">
+                          <a:solidFill>
+                            <a:schemeClr val="tx2"/>
+                          </a:solidFill>
+                        </a:rPr>
+                        <a:t>v1</a:t>
+                      </a:r>
+                      <a:endParaRPr lang="en-US" sz="1500" dirty="0"/>
+                    </a:p>
+                  </a:txBody>
+                  <a:tcPr marL="91440" marR="91440" marT="54864" marB="54864" anchor="ctr">
+                    <a:lnL w="9525" cap="flat" cmpd="sng" algn="ctr">
+                      <a:solidFill>
+                        <a:srgbClr val="D5DAE3"/>
+                      </a:solidFill>
+                      <a:prstDash val="solid"/>
+                      <a:round/>
+                      <a:headEnd type="none" w="med" len="med"/>
+                      <a:tailEnd type="none" w="med" len="med"/>
+                    </a:lnL>
+                    <a:lnR w="9525" cap="flat" cmpd="sng" algn="ctr">
+                      <a:solidFill>
+                        <a:srgbClr val="D5DAE3"/>
+                      </a:solidFill>
+                      <a:prstDash val="solid"/>
+                      <a:round/>
+                      <a:headEnd type="none" w="med" len="med"/>
+                      <a:tailEnd type="none" w="med" len="med"/>
+                    </a:lnR>
+                    <a:lnT w="9525" cap="flat" cmpd="sng" algn="ctr">
+                      <a:solidFill>
+                        <a:srgbClr val="D5DAE3"/>
+                      </a:solidFill>
+                      <a:prstDash val="solid"/>
+                      <a:round/>
+                      <a:headEnd type="none" w="med" len="med"/>
+                      <a:tailEnd type="none" w="med" len="med"/>
+                    </a:lnT>
+                    <a:lnB w="9525" cap="flat" cmpd="sng" algn="ctr">
+                      <a:solidFill>
+                        <a:srgbClr val="D5DAE3"/>
+                      </a:solidFill>
+                      <a:prstDash val="solid"/>
+                      <a:round/>
+                      <a:headEnd type="none" w="med" len="med"/>
+                      <a:tailEnd type="none" w="med" len="med"/>
+                    </a:lnB>
+                  </a:tcPr>
+                </a:tc>
+                <a:tc>
+                  <a:txBody>
+                    <a:bodyPr/>
+                    <a:lstStyle/>
+                    <a:p>
+                      <a:pPr indent="0" marL="0">
+                        <a:buNone/>
+                      </a:pPr>
+                      <a:r>
+                        <a:rPr lang="en-US" sz="1500" dirty="0">
+                          <a:solidFill>
+                            <a:schemeClr val="tx2"/>
+                          </a:solidFill>
+                        </a:rPr>
+                        <a:t>Random forest</a:t>
+                      </a:r>
+                      <a:endParaRPr lang="en-US" sz="1500" dirty="0"/>
+                    </a:p>
+                  </a:txBody>
+                  <a:tcPr marL="91440" marR="91440" marT="54864" marB="54864" anchor="ctr">
+                    <a:lnL w="9525" cap="flat" cmpd="sng" algn="ctr">
+                      <a:solidFill>
+                        <a:srgbClr val="D5DAE3"/>
+                      </a:solidFill>
+                      <a:prstDash val="solid"/>
+                      <a:round/>
+                      <a:headEnd type="none" w="med" len="med"/>
+                      <a:tailEnd type="none" w="med" len="med"/>
+                    </a:lnL>
+                    <a:lnR w="9525" cap="flat" cmpd="sng" algn="ctr">
+                      <a:solidFill>
+                        <a:srgbClr val="D5DAE3"/>
+                      </a:solidFill>
+                      <a:prstDash val="solid"/>
+                      <a:round/>
+                      <a:headEnd type="none" w="med" len="med"/>
+                      <a:tailEnd type="none" w="med" len="med"/>
+                    </a:lnR>
+                    <a:lnT w="9525" cap="flat" cmpd="sng" algn="ctr">
+                      <a:solidFill>
+                        <a:srgbClr val="D5DAE3"/>
+                      </a:solidFill>
+                      <a:prstDash val="solid"/>
+                      <a:round/>
+                      <a:headEnd type="none" w="med" len="med"/>
+                      <a:tailEnd type="none" w="med" len="med"/>
+                    </a:lnT>
+                    <a:lnB w="9525" cap="flat" cmpd="sng" algn="ctr">
+                      <a:solidFill>
+                        <a:srgbClr val="D5DAE3"/>
+                      </a:solidFill>
+                      <a:prstDash val="solid"/>
+                      <a:round/>
+                      <a:headEnd type="none" w="med" len="med"/>
+                      <a:tailEnd type="none" w="med" len="med"/>
+                    </a:lnB>
+                  </a:tcPr>
+                </a:tc>
+                <a:tc>
+                  <a:txBody>
+                    <a:bodyPr/>
+                    <a:lstStyle/>
+                    <a:p>
+                      <a:pPr indent="0" marL="0">
+                        <a:buNone/>
+                      </a:pPr>
+                      <a:r>
+                        <a:rPr lang="en-US" sz="1500" dirty="0">
+                          <a:solidFill>
+                            <a:schemeClr val="tx2"/>
+                          </a:solidFill>
+                        </a:rPr>
+                        <a:t>Best prediction score</a:t>
+                      </a:r>
+                      <a:endParaRPr lang="en-US" sz="1500" dirty="0"/>
+                    </a:p>
+                  </a:txBody>
+                  <a:tcPr marL="91440" marR="91440" marT="54864" marB="54864" anchor="ctr">
+                    <a:lnL w="9525" cap="flat" cmpd="sng" algn="ctr">
+                      <a:solidFill>
+                        <a:srgbClr val="D5DAE3"/>
+                      </a:solidFill>
+                      <a:prstDash val="solid"/>
+                      <a:round/>
+                      <a:headEnd type="none" w="med" len="med"/>
+                      <a:tailEnd type="none" w="med" len="med"/>
+                    </a:lnL>
+                    <a:lnR w="9525" cap="flat" cmpd="sng" algn="ctr">
+                      <a:solidFill>
+                        <a:srgbClr val="D5DAE3"/>
+                      </a:solidFill>
+                      <a:prstDash val="solid"/>
+                      <a:round/>
+                      <a:headEnd type="none" w="med" len="med"/>
+                      <a:tailEnd type="none" w="med" len="med"/>
+                    </a:lnR>
+                    <a:lnT w="9525" cap="flat" cmpd="sng" algn="ctr">
+                      <a:solidFill>
+                        <a:srgbClr val="D5DAE3"/>
+                      </a:solidFill>
+                      <a:prstDash val="solid"/>
+                      <a:round/>
+                      <a:headEnd type="none" w="med" len="med"/>
+                      <a:tailEnd type="none" w="med" len="med"/>
+                    </a:lnT>
+                    <a:lnB w="9525" cap="flat" cmpd="sng" algn="ctr">
+                      <a:solidFill>
+                        <a:srgbClr val="D5DAE3"/>
+                      </a:solidFill>
+                      <a:prstDash val="solid"/>
+                      <a:round/>
+                      <a:headEnd type="none" w="med" len="med"/>
+                      <a:tailEnd type="none" w="med" len="med"/>
+                    </a:lnB>
+                  </a:tcPr>
+                </a:tc>
+                <a:tc>
+                  <a:txBody>
+                    <a:bodyPr/>
+                    <a:lstStyle/>
+                    <a:p>
+                      <a:pPr indent="0" marL="0">
+                        <a:buNone/>
+                      </a:pPr>
+                      <a:r>
+                        <a:rPr lang="en-US" sz="1500" dirty="0">
+                          <a:solidFill>
+                            <a:schemeClr val="tx2"/>
+                          </a:solidFill>
+                        </a:rPr>
+                        <a:t>44.9%</a:t>
+                      </a:r>
+                      <a:endParaRPr lang="en-US" sz="1500" dirty="0"/>
+                    </a:p>
+                  </a:txBody>
+                  <a:tcPr marL="91440" marR="91440" marT="54864" marB="54864" anchor="ctr">
+                    <a:lnL w="9525" cap="flat" cmpd="sng" algn="ctr">
+                      <a:solidFill>
+                        <a:srgbClr val="D5DAE3"/>
+                      </a:solidFill>
+                      <a:prstDash val="solid"/>
+                      <a:round/>
+                      <a:headEnd type="none" w="med" len="med"/>
+                      <a:tailEnd type="none" w="med" len="med"/>
+                    </a:lnL>
+                    <a:lnR w="9525" cap="flat" cmpd="sng" algn="ctr">
+                      <a:solidFill>
+                        <a:srgbClr val="D5DAE3"/>
+                      </a:solidFill>
+                      <a:prstDash val="solid"/>
+                      <a:round/>
+                      <a:headEnd type="none" w="med" len="med"/>
+                      <a:tailEnd type="none" w="med" len="med"/>
+                    </a:lnR>
+                    <a:lnT w="9525" cap="flat" cmpd="sng" algn="ctr">
+                      <a:solidFill>
+                        <a:srgbClr val="D5DAE3"/>
+                      </a:solidFill>
+                      <a:prstDash val="solid"/>
+                      <a:round/>
+                      <a:headEnd type="none" w="med" len="med"/>
+                      <a:tailEnd type="none" w="med" len="med"/>
+                    </a:lnT>
+                    <a:lnB w="9525" cap="flat" cmpd="sng" algn="ctr">
+                      <a:solidFill>
+                        <a:srgbClr val="D5DAE3"/>
+                      </a:solidFill>
+                      <a:prstDash val="solid"/>
+                      <a:round/>
+                      <a:headEnd type="none" w="med" len="med"/>
+                      <a:tailEnd type="none" w="med" len="med"/>
+                    </a:lnB>
+                  </a:tcPr>
+                </a:tc>
+                <a:tc>
+                  <a:txBody>
+                    <a:bodyPr/>
+                    <a:lstStyle/>
+                    <a:p>
+                      <a:pPr indent="0" marL="0">
+                        <a:buNone/>
+                      </a:pPr>
+                      <a:r>
+                        <a:rPr lang="en-US" sz="1500" dirty="0">
+                          <a:solidFill>
+                            <a:schemeClr val="tx2"/>
+                          </a:solidFill>
+                        </a:rPr>
+                        <a:t>0.41</a:t>
+                      </a:r>
+                      <a:endParaRPr lang="en-US" sz="1500" dirty="0"/>
+                    </a:p>
+                  </a:txBody>
+                  <a:tcPr marL="91440" marR="91440" marT="54864" marB="54864" anchor="ctr">
+                    <a:lnL w="9525" cap="flat" cmpd="sng" algn="ctr">
+                      <a:solidFill>
+                        <a:srgbClr val="D5DAE3"/>
+                      </a:solidFill>
+                      <a:prstDash val="solid"/>
+                      <a:round/>
+                      <a:headEnd type="none" w="med" len="med"/>
+                      <a:tailEnd type="none" w="med" len="med"/>
+                    </a:lnL>
+                    <a:lnR w="9525" cap="flat" cmpd="sng" algn="ctr">
+                      <a:solidFill>
+                        <a:srgbClr val="D5DAE3"/>
+                      </a:solidFill>
+                      <a:prstDash val="solid"/>
+                      <a:round/>
+                      <a:headEnd type="none" w="med" len="med"/>
+                      <a:tailEnd type="none" w="med" len="med"/>
+                    </a:lnR>
+                    <a:lnT w="9525" cap="flat" cmpd="sng" algn="ctr">
+                      <a:solidFill>
+                        <a:srgbClr val="D5DAE3"/>
+                      </a:solidFill>
+                      <a:prstDash val="solid"/>
+                      <a:round/>
+                      <a:headEnd type="none" w="med" len="med"/>
+                      <a:tailEnd type="none" w="med" len="med"/>
+                    </a:lnT>
+                    <a:lnB w="9525" cap="flat" cmpd="sng" algn="ctr">
+                      <a:solidFill>
+                        <a:srgbClr val="D5DAE3"/>
+                      </a:solidFill>
+                      <a:prstDash val="solid"/>
+                      <a:round/>
+                      <a:headEnd type="none" w="med" len="med"/>
+                      <a:tailEnd type="none" w="med" len="med"/>
+                    </a:lnB>
+                  </a:tcPr>
+                </a:tc>
+                <a:tc>
+                  <a:txBody>
+                    <a:bodyPr/>
+                    <a:lstStyle/>
+                    <a:p>
+                      <a:pPr indent="0" marL="0">
+                        <a:buNone/>
+                      </a:pPr>
+                      <a:r>
+                        <a:rPr lang="en-US" sz="1500" dirty="0">
+                          <a:solidFill>
+                            <a:schemeClr val="tx2"/>
+                          </a:solidFill>
+                        </a:rPr>
+                        <a:t>$123,714</a:t>
+                      </a:r>
+                      <a:endParaRPr lang="en-US" sz="1500" dirty="0"/>
+                    </a:p>
+                  </a:txBody>
+                  <a:tcPr marL="91440" marR="91440" marT="54864" marB="54864" anchor="ctr">
+                    <a:lnL w="9525" cap="flat" cmpd="sng" algn="ctr">
+                      <a:solidFill>
+                        <a:srgbClr val="D5DAE3"/>
+                      </a:solidFill>
+                      <a:prstDash val="solid"/>
+                      <a:round/>
+                      <a:headEnd type="none" w="med" len="med"/>
+                      <a:tailEnd type="none" w="med" len="med"/>
+                    </a:lnL>
+                    <a:lnR w="9525" cap="flat" cmpd="sng" algn="ctr">
+                      <a:solidFill>
+                        <a:srgbClr val="D5DAE3"/>
+                      </a:solidFill>
+                      <a:prstDash val="solid"/>
+                      <a:round/>
+                      <a:headEnd type="none" w="med" len="med"/>
+                      <a:tailEnd type="none" w="med" len="med"/>
+                    </a:lnR>
+                    <a:lnT w="9525" cap="flat" cmpd="sng" algn="ctr">
+                      <a:solidFill>
+                        <a:srgbClr val="D5DAE3"/>
+                      </a:solidFill>
+                      <a:prstDash val="solid"/>
+                      <a:round/>
+                      <a:headEnd type="none" w="med" len="med"/>
+                      <a:tailEnd type="none" w="med" len="med"/>
+                    </a:lnT>
+                    <a:lnB w="9525" cap="flat" cmpd="sng" algn="ctr">
+                      <a:solidFill>
+                        <a:srgbClr val="D5DAE3"/>
+                      </a:solidFill>
+                      <a:prstDash val="solid"/>
+                      <a:round/>
+                      <a:headEnd type="none" w="med" len="med"/>
+                      <a:tailEnd type="none" w="med" len="med"/>
+                    </a:lnB>
+                  </a:tcPr>
+                </a:tc>
+              </a:tr>
+              <a:tr h="566928">
+                <a:tc>
+                  <a:txBody>
+                    <a:bodyPr/>
+                    <a:lstStyle/>
+                    <a:p>
+                      <a:pPr indent="0" marL="0">
+                        <a:buNone/>
+                      </a:pPr>
+                      <a:r>
+                        <a:rPr lang="en-US" sz="1500" dirty="0">
+                          <a:solidFill>
+                            <a:schemeClr val="tx2"/>
+                          </a:solidFill>
+                        </a:rPr>
+                        <a:t>v2</a:t>
+                      </a:r>
+                      <a:endParaRPr lang="en-US" sz="1500" dirty="0"/>
+                    </a:p>
+                  </a:txBody>
+                  <a:tcPr marL="91440" marR="91440" marT="54864" marB="54864" anchor="ctr">
+                    <a:lnL w="9525" cap="flat" cmpd="sng" algn="ctr">
+                      <a:solidFill>
+                        <a:srgbClr val="D5DAE3"/>
+                      </a:solidFill>
+                      <a:prstDash val="solid"/>
+                      <a:round/>
+                      <a:headEnd type="none" w="med" len="med"/>
+                      <a:tailEnd type="none" w="med" len="med"/>
+                    </a:lnL>
+                    <a:lnR w="9525" cap="flat" cmpd="sng" algn="ctr">
+                      <a:solidFill>
+                        <a:srgbClr val="D5DAE3"/>
+                      </a:solidFill>
+                      <a:prstDash val="solid"/>
+                      <a:round/>
+                      <a:headEnd type="none" w="med" len="med"/>
+                      <a:tailEnd type="none" w="med" len="med"/>
+                    </a:lnR>
+                    <a:lnT w="9525" cap="flat" cmpd="sng" algn="ctr">
+                      <a:solidFill>
+                        <a:srgbClr val="D5DAE3"/>
+                      </a:solidFill>
+                      <a:prstDash val="solid"/>
+                      <a:round/>
+                      <a:headEnd type="none" w="med" len="med"/>
+                      <a:tailEnd type="none" w="med" len="med"/>
+                    </a:lnT>
+                    <a:lnB w="9525" cap="flat" cmpd="sng" algn="ctr">
+                      <a:solidFill>
+                        <a:srgbClr val="D5DAE3"/>
+                      </a:solidFill>
+                      <a:prstDash val="solid"/>
+                      <a:round/>
+                      <a:headEnd type="none" w="med" len="med"/>
+                      <a:tailEnd type="none" w="med" len="med"/>
+                    </a:lnB>
+                  </a:tcPr>
+                </a:tc>
+                <a:tc>
+                  <a:txBody>
+                    <a:bodyPr/>
+                    <a:lstStyle/>
+                    <a:p>
+                      <a:pPr indent="0" marL="0">
+                        <a:buNone/>
+                      </a:pPr>
+                      <a:r>
+                        <a:rPr lang="en-US" sz="1500" dirty="0">
+                          <a:solidFill>
+                            <a:schemeClr val="tx2"/>
+                          </a:solidFill>
+                        </a:rPr>
+                        <a:t>Gradient boosting</a:t>
+                      </a:r>
+                      <a:endParaRPr lang="en-US" sz="1500" dirty="0"/>
+                    </a:p>
+                  </a:txBody>
+                  <a:tcPr marL="91440" marR="91440" marT="54864" marB="54864" anchor="ctr">
+                    <a:lnL w="9525" cap="flat" cmpd="sng" algn="ctr">
+                      <a:solidFill>
+                        <a:srgbClr val="D5DAE3"/>
+                      </a:solidFill>
+                      <a:prstDash val="solid"/>
+                      <a:round/>
+                      <a:headEnd type="none" w="med" len="med"/>
+                      <a:tailEnd type="none" w="med" len="med"/>
+                    </a:lnL>
+                    <a:lnR w="9525" cap="flat" cmpd="sng" algn="ctr">
+                      <a:solidFill>
+                        <a:srgbClr val="D5DAE3"/>
+                      </a:solidFill>
+                      <a:prstDash val="solid"/>
+                      <a:round/>
+                      <a:headEnd type="none" w="med" len="med"/>
+                      <a:tailEnd type="none" w="med" len="med"/>
+                    </a:lnR>
+                    <a:lnT w="9525" cap="flat" cmpd="sng" algn="ctr">
+                      <a:solidFill>
+                        <a:srgbClr val="D5DAE3"/>
+                      </a:solidFill>
+                      <a:prstDash val="solid"/>
+                      <a:round/>
+                      <a:headEnd type="none" w="med" len="med"/>
+                      <a:tailEnd type="none" w="med" len="med"/>
+                    </a:lnT>
+                    <a:lnB w="9525" cap="flat" cmpd="sng" algn="ctr">
+                      <a:solidFill>
+                        <a:srgbClr val="D5DAE3"/>
+                      </a:solidFill>
+                      <a:prstDash val="solid"/>
+                      <a:round/>
+                      <a:headEnd type="none" w="med" len="med"/>
+                      <a:tailEnd type="none" w="med" len="med"/>
+                    </a:lnB>
+                  </a:tcPr>
+                </a:tc>
+                <a:tc>
+                  <a:txBody>
+                    <a:bodyPr/>
+                    <a:lstStyle/>
+                    <a:p>
+                      <a:pPr indent="0" marL="0">
+                        <a:buNone/>
+                      </a:pPr>
+                      <a:r>
+                        <a:rPr lang="en-US" sz="1500" dirty="0">
+                          <a:solidFill>
+                            <a:schemeClr val="tx2"/>
+                          </a:solidFill>
+                        </a:rPr>
+                        <a:t>Most money on the practice exam</a:t>
+                      </a:r>
+                      <a:endParaRPr lang="en-US" sz="1500" dirty="0"/>
+                    </a:p>
+                  </a:txBody>
+                  <a:tcPr marL="91440" marR="91440" marT="54864" marB="54864" anchor="ctr">
+                    <a:lnL w="9525" cap="flat" cmpd="sng" algn="ctr">
+                      <a:solidFill>
+                        <a:srgbClr val="D5DAE3"/>
+                      </a:solidFill>
+                      <a:prstDash val="solid"/>
+                      <a:round/>
+                      <a:headEnd type="none" w="med" len="med"/>
+                      <a:tailEnd type="none" w="med" len="med"/>
+                    </a:lnL>
+                    <a:lnR w="9525" cap="flat" cmpd="sng" algn="ctr">
+                      <a:solidFill>
+                        <a:srgbClr val="D5DAE3"/>
+                      </a:solidFill>
+                      <a:prstDash val="solid"/>
+                      <a:round/>
+                      <a:headEnd type="none" w="med" len="med"/>
+                      <a:tailEnd type="none" w="med" len="med"/>
+                    </a:lnR>
+                    <a:lnT w="9525" cap="flat" cmpd="sng" algn="ctr">
+                      <a:solidFill>
+                        <a:srgbClr val="D5DAE3"/>
+                      </a:solidFill>
+                      <a:prstDash val="solid"/>
+                      <a:round/>
+                      <a:headEnd type="none" w="med" len="med"/>
+                      <a:tailEnd type="none" w="med" len="med"/>
+                    </a:lnT>
+                    <a:lnB w="9525" cap="flat" cmpd="sng" algn="ctr">
+                      <a:solidFill>
+                        <a:srgbClr val="D5DAE3"/>
+                      </a:solidFill>
+                      <a:prstDash val="solid"/>
+                      <a:round/>
+                      <a:headEnd type="none" w="med" len="med"/>
+                      <a:tailEnd type="none" w="med" len="med"/>
+                    </a:lnB>
+                  </a:tcPr>
+                </a:tc>
+                <a:tc>
+                  <a:txBody>
+                    <a:bodyPr/>
+                    <a:lstStyle/>
+                    <a:p>
+                      <a:pPr indent="0" marL="0">
+                        <a:buNone/>
+                      </a:pPr>
+                      <a:r>
+                        <a:rPr lang="en-US" sz="1500" dirty="0">
+                          <a:solidFill>
+                            <a:schemeClr val="tx2"/>
+                          </a:solidFill>
+                        </a:rPr>
+                        <a:t>40.9%</a:t>
+                      </a:r>
+                      <a:endParaRPr lang="en-US" sz="1500" dirty="0"/>
+                    </a:p>
+                  </a:txBody>
+                  <a:tcPr marL="91440" marR="91440" marT="54864" marB="54864" anchor="ctr">
+                    <a:lnL w="9525" cap="flat" cmpd="sng" algn="ctr">
+                      <a:solidFill>
+                        <a:srgbClr val="D5DAE3"/>
+                      </a:solidFill>
+                      <a:prstDash val="solid"/>
+                      <a:round/>
+                      <a:headEnd type="none" w="med" len="med"/>
+                      <a:tailEnd type="none" w="med" len="med"/>
+                    </a:lnL>
+                    <a:lnR w="9525" cap="flat" cmpd="sng" algn="ctr">
+                      <a:solidFill>
+                        <a:srgbClr val="D5DAE3"/>
+                      </a:solidFill>
+                      <a:prstDash val="solid"/>
+                      <a:round/>
+                      <a:headEnd type="none" w="med" len="med"/>
+                      <a:tailEnd type="none" w="med" len="med"/>
+                    </a:lnR>
+                    <a:lnT w="9525" cap="flat" cmpd="sng" algn="ctr">
+                      <a:solidFill>
+                        <a:srgbClr val="D5DAE3"/>
+                      </a:solidFill>
+                      <a:prstDash val="solid"/>
+                      <a:round/>
+                      <a:headEnd type="none" w="med" len="med"/>
+                      <a:tailEnd type="none" w="med" len="med"/>
+                    </a:lnT>
+                    <a:lnB w="9525" cap="flat" cmpd="sng" algn="ctr">
+                      <a:solidFill>
+                        <a:srgbClr val="D5DAE3"/>
+                      </a:solidFill>
+                      <a:prstDash val="solid"/>
+                      <a:round/>
+                      <a:headEnd type="none" w="med" len="med"/>
+                      <a:tailEnd type="none" w="med" len="med"/>
+                    </a:lnB>
+                  </a:tcPr>
+                </a:tc>
+                <a:tc>
+                  <a:txBody>
+                    <a:bodyPr/>
+                    <a:lstStyle/>
+                    <a:p>
+                      <a:pPr indent="0" marL="0">
+                        <a:buNone/>
+                      </a:pPr>
+                      <a:r>
+                        <a:rPr lang="en-US" sz="1500" dirty="0">
+                          <a:solidFill>
+                            <a:schemeClr val="tx2"/>
+                          </a:solidFill>
+                        </a:rPr>
+                        <a:t>0.38</a:t>
+                      </a:r>
+                      <a:endParaRPr lang="en-US" sz="1500" dirty="0"/>
+                    </a:p>
+                  </a:txBody>
+                  <a:tcPr marL="91440" marR="91440" marT="54864" marB="54864" anchor="ctr">
+                    <a:lnL w="9525" cap="flat" cmpd="sng" algn="ctr">
+                      <a:solidFill>
+                        <a:srgbClr val="D5DAE3"/>
+                      </a:solidFill>
+                      <a:prstDash val="solid"/>
+                      <a:round/>
+                      <a:headEnd type="none" w="med" len="med"/>
+                      <a:tailEnd type="none" w="med" len="med"/>
+                    </a:lnL>
+                    <a:lnR w="9525" cap="flat" cmpd="sng" algn="ctr">
+                      <a:solidFill>
+                        <a:srgbClr val="D5DAE3"/>
+                      </a:solidFill>
+                      <a:prstDash val="solid"/>
+                      <a:round/>
+                      <a:headEnd type="none" w="med" len="med"/>
+                      <a:tailEnd type="none" w="med" len="med"/>
+                    </a:lnR>
+                    <a:lnT w="9525" cap="flat" cmpd="sng" algn="ctr">
+                      <a:solidFill>
+                        <a:srgbClr val="D5DAE3"/>
+                      </a:solidFill>
+                      <a:prstDash val="solid"/>
+                      <a:round/>
+                      <a:headEnd type="none" w="med" len="med"/>
+                      <a:tailEnd type="none" w="med" len="med"/>
+                    </a:lnT>
+                    <a:lnB w="9525" cap="flat" cmpd="sng" algn="ctr">
+                      <a:solidFill>
+                        <a:srgbClr val="D5DAE3"/>
+                      </a:solidFill>
+                      <a:prstDash val="solid"/>
+                      <a:round/>
+                      <a:headEnd type="none" w="med" len="med"/>
+                      <a:tailEnd type="none" w="med" len="med"/>
+                    </a:lnB>
+                  </a:tcPr>
+                </a:tc>
+                <a:tc>
+                  <a:txBody>
+                    <a:bodyPr/>
+                    <a:lstStyle/>
+                    <a:p>
+                      <a:pPr indent="0" marL="0">
+                        <a:buNone/>
+                      </a:pPr>
+                      <a:r>
+                        <a:rPr lang="en-US" sz="1500" dirty="0">
+                          <a:solidFill>
+                            <a:schemeClr val="tx2"/>
+                          </a:solidFill>
+                        </a:rPr>
+                        <a:t>$121,812</a:t>
+                      </a:r>
+                      <a:endParaRPr lang="en-US" sz="1500" dirty="0"/>
+                    </a:p>
+                  </a:txBody>
+                  <a:tcPr marL="91440" marR="91440" marT="54864" marB="54864" anchor="ctr">
+                    <a:lnL w="9525" cap="flat" cmpd="sng" algn="ctr">
+                      <a:solidFill>
+                        <a:srgbClr val="D5DAE3"/>
+                      </a:solidFill>
+                      <a:prstDash val="solid"/>
+                      <a:round/>
+                      <a:headEnd type="none" w="med" len="med"/>
+                      <a:tailEnd type="none" w="med" len="med"/>
+                    </a:lnL>
+                    <a:lnR w="9525" cap="flat" cmpd="sng" algn="ctr">
+                      <a:solidFill>
+                        <a:srgbClr val="D5DAE3"/>
+                      </a:solidFill>
+                      <a:prstDash val="solid"/>
+                      <a:round/>
+                      <a:headEnd type="none" w="med" len="med"/>
+                      <a:tailEnd type="none" w="med" len="med"/>
+                    </a:lnR>
+                    <a:lnT w="9525" cap="flat" cmpd="sng" algn="ctr">
+                      <a:solidFill>
+                        <a:srgbClr val="D5DAE3"/>
+                      </a:solidFill>
+                      <a:prstDash val="solid"/>
+                      <a:round/>
+                      <a:headEnd type="none" w="med" len="med"/>
+                      <a:tailEnd type="none" w="med" len="med"/>
+                    </a:lnT>
+                    <a:lnB w="9525" cap="flat" cmpd="sng" algn="ctr">
+                      <a:solidFill>
+                        <a:srgbClr val="D5DAE3"/>
+                      </a:solidFill>
+                      <a:prstDash val="solid"/>
+                      <a:round/>
+                      <a:headEnd type="none" w="med" len="med"/>
+                      <a:tailEnd type="none" w="med" len="med"/>
+                    </a:lnB>
+                  </a:tcPr>
+                </a:tc>
+              </a:tr>
+              <a:tr h="566928">
+                <a:tc>
+                  <a:txBody>
+                    <a:bodyPr/>
+                    <a:lstStyle/>
+                    <a:p>
+                      <a:pPr indent="0" marL="0">
+                        <a:buNone/>
+                      </a:pPr>
+                      <a:r>
+                        <a:rPr lang="en-US" sz="1500" dirty="0">
+                          <a:solidFill>
+                            <a:schemeClr val="tx2"/>
+                          </a:solidFill>
+                        </a:rPr>
+                        <a:t>v3</a:t>
+                      </a:r>
+                      <a:endParaRPr lang="en-US" sz="1500" dirty="0"/>
+                    </a:p>
+                  </a:txBody>
+                  <a:tcPr marL="91440" marR="91440" marT="54864" marB="54864" anchor="ctr">
+                    <a:lnL w="9525" cap="flat" cmpd="sng" algn="ctr">
+                      <a:solidFill>
+                        <a:srgbClr val="D5DAE3"/>
+                      </a:solidFill>
+                      <a:prstDash val="solid"/>
+                      <a:round/>
+                      <a:headEnd type="none" w="med" len="med"/>
+                      <a:tailEnd type="none" w="med" len="med"/>
+                    </a:lnL>
+                    <a:lnR w="9525" cap="flat" cmpd="sng" algn="ctr">
+                      <a:solidFill>
+                        <a:srgbClr val="D5DAE3"/>
+                      </a:solidFill>
+                      <a:prstDash val="solid"/>
+                      <a:round/>
+                      <a:headEnd type="none" w="med" len="med"/>
+                      <a:tailEnd type="none" w="med" len="med"/>
+                    </a:lnR>
+                    <a:lnT w="9525" cap="flat" cmpd="sng" algn="ctr">
+                      <a:solidFill>
+                        <a:srgbClr val="D5DAE3"/>
+                      </a:solidFill>
+                      <a:prstDash val="solid"/>
+                      <a:round/>
+                      <a:headEnd type="none" w="med" len="med"/>
+                      <a:tailEnd type="none" w="med" len="med"/>
+                    </a:lnT>
+                    <a:lnB w="9525" cap="flat" cmpd="sng" algn="ctr">
+                      <a:solidFill>
+                        <a:srgbClr val="D5DAE3"/>
+                      </a:solidFill>
+                      <a:prstDash val="solid"/>
+                      <a:round/>
+                      <a:headEnd type="none" w="med" len="med"/>
+                      <a:tailEnd type="none" w="med" len="med"/>
+                    </a:lnB>
+                  </a:tcPr>
+                </a:tc>
+                <a:tc>
+                  <a:txBody>
+                    <a:bodyPr/>
+                    <a:lstStyle/>
+                    <a:p>
+                      <a:pPr indent="0" marL="0">
+                        <a:buNone/>
+                      </a:pPr>
+                      <a:r>
+                        <a:rPr lang="en-US" sz="1500" dirty="0">
+                          <a:solidFill>
+                            <a:schemeClr val="tx2"/>
+                          </a:solidFill>
+                        </a:rPr>
+                        <a:t>Gradient boosting + corrected odds</a:t>
+                      </a:r>
+                      <a:endParaRPr lang="en-US" sz="1500" dirty="0"/>
+                    </a:p>
+                  </a:txBody>
+                  <a:tcPr marL="91440" marR="91440" marT="54864" marB="54864" anchor="ctr">
+                    <a:lnL w="9525" cap="flat" cmpd="sng" algn="ctr">
+                      <a:solidFill>
+                        <a:srgbClr val="D5DAE3"/>
+                      </a:solidFill>
+                      <a:prstDash val="solid"/>
+                      <a:round/>
+                      <a:headEnd type="none" w="med" len="med"/>
+                      <a:tailEnd type="none" w="med" len="med"/>
+                    </a:lnL>
+                    <a:lnR w="9525" cap="flat" cmpd="sng" algn="ctr">
+                      <a:solidFill>
+                        <a:srgbClr val="D5DAE3"/>
+                      </a:solidFill>
+                      <a:prstDash val="solid"/>
+                      <a:round/>
+                      <a:headEnd type="none" w="med" len="med"/>
+                      <a:tailEnd type="none" w="med" len="med"/>
+                    </a:lnR>
+                    <a:lnT w="9525" cap="flat" cmpd="sng" algn="ctr">
+                      <a:solidFill>
+                        <a:srgbClr val="D5DAE3"/>
+                      </a:solidFill>
+                      <a:prstDash val="solid"/>
+                      <a:round/>
+                      <a:headEnd type="none" w="med" len="med"/>
+                      <a:tailEnd type="none" w="med" len="med"/>
+                    </a:lnT>
+                    <a:lnB w="9525" cap="flat" cmpd="sng" algn="ctr">
+                      <a:solidFill>
+                        <a:srgbClr val="D5DAE3"/>
+                      </a:solidFill>
+                      <a:prstDash val="solid"/>
+                      <a:round/>
+                      <a:headEnd type="none" w="med" len="med"/>
+                      <a:tailEnd type="none" w="med" len="med"/>
+                    </a:lnB>
+                  </a:tcPr>
+                </a:tc>
+                <a:tc>
+                  <a:txBody>
+                    <a:bodyPr/>
+                    <a:lstStyle/>
+                    <a:p>
+                      <a:pPr indent="0" marL="0">
+                        <a:buNone/>
+                      </a:pPr>
+                      <a:r>
+                        <a:rPr lang="en-US" sz="1500" dirty="0">
+                          <a:solidFill>
+                            <a:schemeClr val="tx2"/>
+                          </a:solidFill>
+                        </a:rPr>
+                        <a:t>Pre-set rule, 2013–2022</a:t>
+                      </a:r>
+                      <a:endParaRPr lang="en-US" sz="1500" dirty="0"/>
+                    </a:p>
+                  </a:txBody>
+                  <a:tcPr marL="91440" marR="91440" marT="54864" marB="54864" anchor="ctr">
+                    <a:lnL w="9525" cap="flat" cmpd="sng" algn="ctr">
+                      <a:solidFill>
+                        <a:srgbClr val="D5DAE3"/>
+                      </a:solidFill>
+                      <a:prstDash val="solid"/>
+                      <a:round/>
+                      <a:headEnd type="none" w="med" len="med"/>
+                      <a:tailEnd type="none" w="med" len="med"/>
+                    </a:lnL>
+                    <a:lnR w="9525" cap="flat" cmpd="sng" algn="ctr">
+                      <a:solidFill>
+                        <a:srgbClr val="D5DAE3"/>
+                      </a:solidFill>
+                      <a:prstDash val="solid"/>
+                      <a:round/>
+                      <a:headEnd type="none" w="med" len="med"/>
+                      <a:tailEnd type="none" w="med" len="med"/>
+                    </a:lnR>
+                    <a:lnT w="9525" cap="flat" cmpd="sng" algn="ctr">
+                      <a:solidFill>
+                        <a:srgbClr val="D5DAE3"/>
+                      </a:solidFill>
+                      <a:prstDash val="solid"/>
+                      <a:round/>
+                      <a:headEnd type="none" w="med" len="med"/>
+                      <a:tailEnd type="none" w="med" len="med"/>
+                    </a:lnT>
+                    <a:lnB w="9525" cap="flat" cmpd="sng" algn="ctr">
+                      <a:solidFill>
+                        <a:srgbClr val="D5DAE3"/>
+                      </a:solidFill>
+                      <a:prstDash val="solid"/>
+                      <a:round/>
+                      <a:headEnd type="none" w="med" len="med"/>
+                      <a:tailEnd type="none" w="med" len="med"/>
+                    </a:lnB>
+                  </a:tcPr>
+                </a:tc>
+                <a:tc>
+                  <a:txBody>
+                    <a:bodyPr/>
+                    <a:lstStyle/>
+                    <a:p>
+                      <a:pPr indent="0" marL="0">
+                        <a:buNone/>
+                      </a:pPr>
+                      <a:r>
+                        <a:rPr lang="en-US" sz="1500" dirty="0">
+                          <a:solidFill>
+                            <a:schemeClr val="tx2"/>
+                          </a:solidFill>
+                        </a:rPr>
+                        <a:t>48.4%</a:t>
+                      </a:r>
+                      <a:endParaRPr lang="en-US" sz="1500" dirty="0"/>
+                    </a:p>
+                  </a:txBody>
+                  <a:tcPr marL="91440" marR="91440" marT="54864" marB="54864" anchor="ctr">
+                    <a:lnL w="9525" cap="flat" cmpd="sng" algn="ctr">
+                      <a:solidFill>
+                        <a:srgbClr val="D5DAE3"/>
+                      </a:solidFill>
+                      <a:prstDash val="solid"/>
+                      <a:round/>
+                      <a:headEnd type="none" w="med" len="med"/>
+                      <a:tailEnd type="none" w="med" len="med"/>
+                    </a:lnL>
+                    <a:lnR w="9525" cap="flat" cmpd="sng" algn="ctr">
+                      <a:solidFill>
+                        <a:srgbClr val="D5DAE3"/>
+                      </a:solidFill>
+                      <a:prstDash val="solid"/>
+                      <a:round/>
+                      <a:headEnd type="none" w="med" len="med"/>
+                      <a:tailEnd type="none" w="med" len="med"/>
+                    </a:lnR>
+                    <a:lnT w="9525" cap="flat" cmpd="sng" algn="ctr">
+                      <a:solidFill>
+                        <a:srgbClr val="D5DAE3"/>
+                      </a:solidFill>
+                      <a:prstDash val="solid"/>
+                      <a:round/>
+                      <a:headEnd type="none" w="med" len="med"/>
+                      <a:tailEnd type="none" w="med" len="med"/>
+                    </a:lnT>
+                    <a:lnB w="9525" cap="flat" cmpd="sng" algn="ctr">
+                      <a:solidFill>
+                        <a:srgbClr val="D5DAE3"/>
+                      </a:solidFill>
+                      <a:prstDash val="solid"/>
+                      <a:round/>
+                      <a:headEnd type="none" w="med" len="med"/>
+                      <a:tailEnd type="none" w="med" len="med"/>
+                    </a:lnB>
+                  </a:tcPr>
+                </a:tc>
+                <a:tc>
+                  <a:txBody>
+                    <a:bodyPr/>
+                    <a:lstStyle/>
+                    <a:p>
+                      <a:pPr indent="0" marL="0">
+                        <a:buNone/>
+                      </a:pPr>
+                      <a:r>
+                        <a:rPr lang="en-US" sz="1500" dirty="0">
+                          <a:solidFill>
+                            <a:schemeClr val="tx2"/>
+                          </a:solidFill>
+                        </a:rPr>
+                        <a:t>0.35</a:t>
+                      </a:r>
+                      <a:endParaRPr lang="en-US" sz="1500" dirty="0"/>
+                    </a:p>
+                  </a:txBody>
+                  <a:tcPr marL="91440" marR="91440" marT="54864" marB="54864" anchor="ctr">
+                    <a:lnL w="9525" cap="flat" cmpd="sng" algn="ctr">
+                      <a:solidFill>
+                        <a:srgbClr val="D5DAE3"/>
+                      </a:solidFill>
+                      <a:prstDash val="solid"/>
+                      <a:round/>
+                      <a:headEnd type="none" w="med" len="med"/>
+                      <a:tailEnd type="none" w="med" len="med"/>
+                    </a:lnL>
+                    <a:lnR w="9525" cap="flat" cmpd="sng" algn="ctr">
+                      <a:solidFill>
+                        <a:srgbClr val="D5DAE3"/>
+                      </a:solidFill>
+                      <a:prstDash val="solid"/>
+                      <a:round/>
+                      <a:headEnd type="none" w="med" len="med"/>
+                      <a:tailEnd type="none" w="med" len="med"/>
+                    </a:lnR>
+                    <a:lnT w="9525" cap="flat" cmpd="sng" algn="ctr">
+                      <a:solidFill>
+                        <a:srgbClr val="D5DAE3"/>
+                      </a:solidFill>
+                      <a:prstDash val="solid"/>
+                      <a:round/>
+                      <a:headEnd type="none" w="med" len="med"/>
+                      <a:tailEnd type="none" w="med" len="med"/>
+                    </a:lnT>
+                    <a:lnB w="9525" cap="flat" cmpd="sng" algn="ctr">
+                      <a:solidFill>
+                        <a:srgbClr val="D5DAE3"/>
+                      </a:solidFill>
+                      <a:prstDash val="solid"/>
+                      <a:round/>
+                      <a:headEnd type="none" w="med" len="med"/>
+                      <a:tailEnd type="none" w="med" len="med"/>
+                    </a:lnB>
+                  </a:tcPr>
+                </a:tc>
+                <a:tc>
+                  <a:txBody>
+                    <a:bodyPr/>
+                    <a:lstStyle/>
+                    <a:p>
+                      <a:pPr indent="0" marL="0">
+                        <a:buNone/>
+                      </a:pPr>
+                      <a:r>
+                        <a:rPr lang="en-US" sz="1500" dirty="0">
+                          <a:solidFill>
+                            <a:schemeClr val="tx2"/>
+                          </a:solidFill>
+                        </a:rPr>
+                        <a:t>$156,546 (never trades)</a:t>
+                      </a:r>
+                      <a:endParaRPr lang="en-US" sz="1500" dirty="0"/>
+                    </a:p>
+                  </a:txBody>
+                  <a:tcPr marL="91440" marR="91440" marT="54864" marB="54864" anchor="ctr">
+                    <a:lnL w="9525" cap="flat" cmpd="sng" algn="ctr">
+                      <a:solidFill>
+                        <a:srgbClr val="D5DAE3"/>
+                      </a:solidFill>
+                      <a:prstDash val="solid"/>
+                      <a:round/>
+                      <a:headEnd type="none" w="med" len="med"/>
+                      <a:tailEnd type="none" w="med" len="med"/>
+                    </a:lnL>
+                    <a:lnR w="9525" cap="flat" cmpd="sng" algn="ctr">
+                      <a:solidFill>
+                        <a:srgbClr val="D5DAE3"/>
+                      </a:solidFill>
+                      <a:prstDash val="solid"/>
+                      <a:round/>
+                      <a:headEnd type="none" w="med" len="med"/>
+                      <a:tailEnd type="none" w="med" len="med"/>
+                    </a:lnR>
+                    <a:lnT w="9525" cap="flat" cmpd="sng" algn="ctr">
+                      <a:solidFill>
+                        <a:srgbClr val="D5DAE3"/>
+                      </a:solidFill>
+                      <a:prstDash val="solid"/>
+                      <a:round/>
+                      <a:headEnd type="none" w="med" len="med"/>
+                      <a:tailEnd type="none" w="med" len="med"/>
+                    </a:lnT>
+                    <a:lnB w="9525" cap="flat" cmpd="sng" algn="ctr">
+                      <a:solidFill>
+                        <a:srgbClr val="D5DAE3"/>
+                      </a:solidFill>
+                      <a:prstDash val="solid"/>
+                      <a:round/>
+                      <a:headEnd type="none" w="med" len="med"/>
+                      <a:tailEnd type="none" w="med" len="med"/>
+                    </a:lnB>
+                  </a:tcPr>
+                </a:tc>
+              </a:tr>
+            </a:tbl>
+          </a:graphicData>
+        </a:graphic>
+      </p:graphicFrame>
+      <p:sp>
+        <p:nvSpPr>
+          <p:cNvPr id="4" name="Shape 1"/>
           <p:cNvSpPr/>
           <p:nvPr/>
         </p:nvSpPr>
         <p:spPr>
           <a:xfrm>
-            <a:off x="548640" y="1417320"/>
-            <a:ext cx="5468112" cy="2103120"/>
+            <a:off x="548640" y="3886200"/>
+            <a:ext cx="3593592" cy="2011680"/>
           </a:xfrm>
           <a:prstGeom prst="roundRect">
             <a:avLst>
-              <a:gd name="adj" fmla="val 5217"/>
+              <a:gd name="adj" fmla="val 5455"/>
             </a:avLst>
           </a:prstGeom>
           <a:solidFill>
@@ -19391,24 +20933,101 @@
       </p:sp>
       <p:sp>
         <p:nvSpPr>
-          <p:cNvPr id="4" name="Shape 2"/>
+          <p:cNvPr id="5" name="Text 2"/>
+          <p:cNvSpPr txBox="1"/>
+          <p:nvPr/>
+        </p:nvSpPr>
+        <p:spPr>
+          <a:xfrm>
+            <a:off x="777240" y="4114800"/>
+            <a:ext cx="3136392" cy="438912"/>
+          </a:xfrm>
+          <a:prstGeom prst="rect">
+            <a:avLst/>
+          </a:prstGeom>
+          <a:noFill/>
+          <a:ln/>
+        </p:spPr>
+        <p:txBody>
+          <a:bodyPr wrap="square" lIns="0" tIns="0" rIns="0" bIns="0" rtlCol="0" anchor="ctr"/>
+          <a:lstStyle/>
+          <a:p>
+            <a:pPr indent="0" marL="0">
+              <a:buNone/>
+            </a:pPr>
+            <a:r>
+              <a:rPr lang="en-US" sz="1700" b="1" dirty="0">
+                <a:solidFill>
+                  <a:schemeClr val="tx1"/>
+                </a:solidFill>
+                <a:latin typeface="Cambria" pitchFamily="34" charset="0"/>
+                <a:ea typeface="Cambria" pitchFamily="34" charset="-122"/>
+                <a:cs typeface="Cambria" pitchFamily="34" charset="-120"/>
+              </a:rPr>
+              <a:t>Why the model changed</a:t>
+            </a:r>
+            <a:endParaRPr lang="en-US" sz="1700" dirty="0"/>
+          </a:p>
+        </p:txBody>
+      </p:sp>
+      <p:sp>
+        <p:nvSpPr>
+          <p:cNvPr id="6" name="Text 3"/>
+          <p:cNvSpPr txBox="1"/>
+          <p:nvPr/>
+        </p:nvSpPr>
+        <p:spPr>
+          <a:xfrm>
+            <a:off x="777240" y="4663440"/>
+            <a:ext cx="3136392" cy="1051560"/>
+          </a:xfrm>
+          <a:prstGeom prst="rect">
+            <a:avLst/>
+          </a:prstGeom>
+          <a:noFill/>
+          <a:ln/>
+        </p:spPr>
+        <p:txBody>
+          <a:bodyPr wrap="square" lIns="0" tIns="0" rIns="0" bIns="0" rtlCol="0" anchor="t"/>
+          <a:lstStyle/>
+          <a:p>
+            <a:pPr indent="0" marL="0">
+              <a:buNone/>
+            </a:pPr>
+            <a:r>
+              <a:rPr lang="en-US" sz="1400" dirty="0">
+                <a:solidFill>
+                  <a:schemeClr val="tx2"/>
+                </a:solidFill>
+              </a:rPr>
+              <a:t>v2 picked the model by money made, not prediction score, so gradient boosting replaced the random forest.</a:t>
+            </a:r>
+            <a:endParaRPr lang="en-US" sz="1400" dirty="0"/>
+          </a:p>
+        </p:txBody>
+      </p:sp>
+      <p:sp>
+        <p:nvSpPr>
+          <p:cNvPr id="7" name="Shape 4"/>
           <p:cNvSpPr/>
           <p:nvPr/>
         </p:nvSpPr>
         <p:spPr>
           <a:xfrm>
-            <a:off x="777240" y="1645920"/>
-            <a:ext cx="438912" cy="438912"/>
-          </a:xfrm>
-          <a:prstGeom prst="ellipse">
-            <a:avLst/>
+            <a:off x="4297680" y="3886200"/>
+            <a:ext cx="3593592" cy="2011680"/>
+          </a:xfrm>
+          <a:prstGeom prst="roundRect">
+            <a:avLst>
+              <a:gd name="adj" fmla="val 5455"/>
+            </a:avLst>
           </a:prstGeom>
           <a:solidFill>
-            <a:schemeClr val="accent1"/>
+            <a:srgbClr val="FBEDE4"/>
           </a:solidFill>
           <a:ln w="12700">
             <a:solidFill>
-              <a:schemeClr val="accent1"/>
+              <a:srgbClr val="FBEDE4"/>
             </a:solidFill>
             <a:prstDash val="solid"/>
           </a:ln>
@@ -19416,14 +21035,14 @@
       </p:sp>
       <p:sp>
         <p:nvSpPr>
-          <p:cNvPr id="5" name="Text 3"/>
+          <p:cNvPr id="8" name="Text 5"/>
           <p:cNvSpPr txBox="1"/>
           <p:nvPr/>
         </p:nvSpPr>
         <p:spPr>
           <a:xfrm>
-            <a:off x="777240" y="1645920"/>
-            <a:ext cx="438912" cy="438912"/>
+            <a:off x="4526280" y="4114800"/>
+            <a:ext cx="3136392" cy="438912"/>
           </a:xfrm>
           <a:prstGeom prst="rect">
             <a:avLst/>
@@ -19435,47 +21054,11 @@
           <a:bodyPr wrap="square" lIns="0" tIns="0" rIns="0" bIns="0" rtlCol="0" anchor="ctr"/>
           <a:lstStyle/>
           <a:p>
-            <a:pPr algn="ctr" indent="0" marL="0">
-              <a:buNone/>
-            </a:pPr>
-            <a:r>
-              <a:rPr lang="en-US" sz="1600" b="1" dirty="0">
-                <a:solidFill>
-                  <a:schemeClr val="bg1"/>
-                </a:solidFill>
-              </a:rPr>
-              <a:t>1</a:t>
-            </a:r>
-            <a:endParaRPr lang="en-US" sz="1600" dirty="0"/>
-          </a:p>
-        </p:txBody>
-      </p:sp>
-      <p:sp>
-        <p:nvSpPr>
-          <p:cNvPr id="6" name="Text 4"/>
-          <p:cNvSpPr txBox="1"/>
-          <p:nvPr/>
-        </p:nvSpPr>
-        <p:spPr>
-          <a:xfrm>
-            <a:off x="1371600" y="1645920"/>
-            <a:ext cx="4416552" cy="438912"/>
-          </a:xfrm>
-          <a:prstGeom prst="rect">
-            <a:avLst/>
-          </a:prstGeom>
-          <a:noFill/>
-          <a:ln/>
-        </p:spPr>
-        <p:txBody>
-          <a:bodyPr wrap="square" lIns="0" tIns="0" rIns="0" bIns="0" rtlCol="0" anchor="ctr"/>
-          <a:lstStyle/>
-          <a:p>
             <a:pPr indent="0" marL="0">
               <a:buNone/>
             </a:pPr>
             <a:r>
-              <a:rPr lang="en-US" sz="1800" b="1" dirty="0">
+              <a:rPr lang="en-US" sz="1700" b="1" dirty="0">
                 <a:solidFill>
                   <a:schemeClr val="tx1"/>
                 </a:solidFill>
@@ -19483,22 +21066,22 @@
                 <a:ea typeface="Cambria" pitchFamily="34" charset="-122"/>
                 <a:cs typeface="Cambria" pitchFamily="34" charset="-120"/>
               </a:rPr>
-              <a:t>Plans written before code</a:t>
-            </a:r>
-            <a:endParaRPr lang="en-US" sz="1800" dirty="0"/>
-          </a:p>
-        </p:txBody>
-      </p:sp>
-      <p:sp>
-        <p:nvSpPr>
-          <p:cNvPr id="7" name="Text 5"/>
+              <a:t>Highest accuracy ≠ best</a:t>
+            </a:r>
+            <a:endParaRPr lang="en-US" sz="1700" dirty="0"/>
+          </a:p>
+        </p:txBody>
+      </p:sp>
+      <p:sp>
+        <p:nvSpPr>
+          <p:cNvPr id="9" name="Text 6"/>
           <p:cNvSpPr txBox="1"/>
           <p:nvPr/>
         </p:nvSpPr>
         <p:spPr>
           <a:xfrm>
-            <a:off x="777240" y="2194560"/>
-            <a:ext cx="5010912" cy="1143000"/>
+            <a:off x="4526280" y="4663440"/>
+            <a:ext cx="3136392" cy="1051560"/>
           </a:xfrm>
           <a:prstGeom prst="rect">
             <a:avLst/>
@@ -19514,31 +21097,31 @@
               <a:buNone/>
             </a:pPr>
             <a:r>
-              <a:rPr lang="en-US" sz="1500" dirty="0">
+              <a:rPr lang="en-US" sz="1400" dirty="0">
                 <a:solidFill>
                   <a:schemeClr val="tx2"/>
                 </a:solidFill>
               </a:rPr>
-              <a:t>Each version’s design was committed before any code or result existed, with a digital fingerprint (SHA-256) so later edits would show.</a:t>
-            </a:r>
-            <a:endParaRPr lang="en-US" sz="1500" dirty="0"/>
-          </a:p>
-        </p:txBody>
-      </p:sp>
-      <p:sp>
-        <p:nvSpPr>
-          <p:cNvPr id="8" name="Shape 6"/>
+              <a:t>v3’s corrected odds call the common flat weeks more often: accuracy up, macro-F1 down.</a:t>
+            </a:r>
+            <a:endParaRPr lang="en-US" sz="1400" dirty="0"/>
+          </a:p>
+        </p:txBody>
+      </p:sp>
+      <p:sp>
+        <p:nvSpPr>
+          <p:cNvPr id="10" name="Shape 7"/>
           <p:cNvSpPr/>
           <p:nvPr/>
         </p:nvSpPr>
         <p:spPr>
           <a:xfrm>
-            <a:off x="6172200" y="1417320"/>
-            <a:ext cx="5468112" cy="2103120"/>
+            <a:off x="8046720" y="3886200"/>
+            <a:ext cx="3593592" cy="2011680"/>
           </a:xfrm>
           <a:prstGeom prst="roundRect">
             <a:avLst>
-              <a:gd name="adj" fmla="val 5217"/>
+              <a:gd name="adj" fmla="val 5455"/>
             </a:avLst>
           </a:prstGeom>
           <a:solidFill>
@@ -19554,39 +21137,14 @@
       </p:sp>
       <p:sp>
         <p:nvSpPr>
-          <p:cNvPr id="9" name="Shape 7"/>
-          <p:cNvSpPr/>
-          <p:nvPr/>
-        </p:nvSpPr>
-        <p:spPr>
-          <a:xfrm>
-            <a:off x="6400800" y="1645920"/>
-            <a:ext cx="438912" cy="438912"/>
-          </a:xfrm>
-          <a:prstGeom prst="ellipse">
-            <a:avLst/>
-          </a:prstGeom>
-          <a:solidFill>
-            <a:schemeClr val="accent1"/>
-          </a:solidFill>
-          <a:ln w="12700">
-            <a:solidFill>
-              <a:schemeClr val="accent1"/>
-            </a:solidFill>
-            <a:prstDash val="solid"/>
-          </a:ln>
-        </p:spPr>
-      </p:sp>
-      <p:sp>
-        <p:nvSpPr>
-          <p:cNvPr id="10" name="Text 8"/>
+          <p:cNvPr id="11" name="Text 8"/>
           <p:cNvSpPr txBox="1"/>
           <p:nvPr/>
         </p:nvSpPr>
         <p:spPr>
           <a:xfrm>
-            <a:off x="6400800" y="1645920"/>
-            <a:ext cx="438912" cy="438912"/>
+            <a:off x="8275320" y="4114800"/>
+            <a:ext cx="3136392" cy="438912"/>
           </a:xfrm>
           <a:prstGeom prst="rect">
             <a:avLst/>
@@ -19598,47 +21156,11 @@
           <a:bodyPr wrap="square" lIns="0" tIns="0" rIns="0" bIns="0" rtlCol="0" anchor="ctr"/>
           <a:lstStyle/>
           <a:p>
-            <a:pPr algn="ctr" indent="0" marL="0">
-              <a:buNone/>
-            </a:pPr>
-            <a:r>
-              <a:rPr lang="en-US" sz="1600" b="1" dirty="0">
-                <a:solidFill>
-                  <a:schemeClr val="bg1"/>
-                </a:solidFill>
-              </a:rPr>
-              <a:t>2</a:t>
-            </a:r>
-            <a:endParaRPr lang="en-US" sz="1600" dirty="0"/>
-          </a:p>
-        </p:txBody>
-      </p:sp>
-      <p:sp>
-        <p:nvSpPr>
-          <p:cNvPr id="11" name="Text 9"/>
-          <p:cNvSpPr txBox="1"/>
-          <p:nvPr/>
-        </p:nvSpPr>
-        <p:spPr>
-          <a:xfrm>
-            <a:off x="6995160" y="1645920"/>
-            <a:ext cx="4416552" cy="438912"/>
-          </a:xfrm>
-          <a:prstGeom prst="rect">
-            <a:avLst/>
-          </a:prstGeom>
-          <a:noFill/>
-          <a:ln/>
-        </p:spPr>
-        <p:txBody>
-          <a:bodyPr wrap="square" lIns="0" tIns="0" rIns="0" bIns="0" rtlCol="0" anchor="ctr"/>
-          <a:lstStyle/>
-          <a:p>
             <a:pPr indent="0" marL="0">
               <a:buNone/>
             </a:pPr>
             <a:r>
-              <a:rPr lang="en-US" sz="1800" b="1" dirty="0">
+              <a:rPr lang="en-US" sz="1700" b="1" dirty="0">
                 <a:solidFill>
                   <a:schemeClr val="tx1"/>
                 </a:solidFill>
@@ -19646,22 +21168,22 @@
                 <a:ea typeface="Cambria" pitchFamily="34" charset="-122"/>
                 <a:cs typeface="Cambria" pitchFamily="34" charset="-120"/>
               </a:rPr>
-              <a:t>Final exam opened once</a:t>
-            </a:r>
-            <a:endParaRPr lang="en-US" sz="1800" dirty="0"/>
-          </a:p>
-        </p:txBody>
-      </p:sp>
-      <p:sp>
-        <p:nvSpPr>
-          <p:cNvPr id="12" name="Text 10"/>
+              <a:t>No sign of a leak</a:t>
+            </a:r>
+            <a:endParaRPr lang="en-US" sz="1700" dirty="0"/>
+          </a:p>
+        </p:txBody>
+      </p:sp>
+      <p:sp>
+        <p:nvSpPr>
+          <p:cNvPr id="12" name="Text 9"/>
           <p:cNvSpPr txBox="1"/>
           <p:nvPr/>
         </p:nvSpPr>
         <p:spPr>
           <a:xfrm>
-            <a:off x="6400800" y="2194560"/>
-            <a:ext cx="5010912" cy="1143000"/>
+            <a:off x="8275320" y="4663440"/>
+            <a:ext cx="3136392" cy="1051560"/>
           </a:xfrm>
           <a:prstGeom prst="rect">
             <a:avLst/>
@@ -19677,340 +21199,14 @@
               <a:buNone/>
             </a:pPr>
             <a:r>
-              <a:rPr lang="en-US" sz="1500" dirty="0">
+              <a:rPr lang="en-US" sz="1400" dirty="0">
                 <a:solidFill>
                   <a:schemeClr val="tx2"/>
                 </a:solidFill>
               </a:rPr>
-              <a:t>Each version picked its model on earlier data, locked it, and only then saw the test years.</a:t>
-            </a:r>
-            <a:endParaRPr lang="en-US" sz="1500" dirty="0"/>
-          </a:p>
-        </p:txBody>
-      </p:sp>
-      <p:sp>
-        <p:nvSpPr>
-          <p:cNvPr id="13" name="Shape 11"/>
-          <p:cNvSpPr/>
-          <p:nvPr/>
-        </p:nvSpPr>
-        <p:spPr>
-          <a:xfrm>
-            <a:off x="548640" y="3703320"/>
-            <a:ext cx="5468112" cy="2103120"/>
-          </a:xfrm>
-          <a:prstGeom prst="roundRect">
-            <a:avLst>
-              <a:gd name="adj" fmla="val 5217"/>
-            </a:avLst>
-          </a:prstGeom>
-          <a:solidFill>
-            <a:schemeClr val="bg2"/>
-          </a:solidFill>
-          <a:ln w="12700">
-            <a:solidFill>
-              <a:schemeClr val="bg2"/>
-            </a:solidFill>
-            <a:prstDash val="solid"/>
-          </a:ln>
-        </p:spPr>
-      </p:sp>
-      <p:sp>
-        <p:nvSpPr>
-          <p:cNvPr id="14" name="Shape 12"/>
-          <p:cNvSpPr/>
-          <p:nvPr/>
-        </p:nvSpPr>
-        <p:spPr>
-          <a:xfrm>
-            <a:off x="777240" y="3931920"/>
-            <a:ext cx="438912" cy="438912"/>
-          </a:xfrm>
-          <a:prstGeom prst="ellipse">
-            <a:avLst/>
-          </a:prstGeom>
-          <a:solidFill>
-            <a:schemeClr val="accent1"/>
-          </a:solidFill>
-          <a:ln w="12700">
-            <a:solidFill>
-              <a:schemeClr val="accent1"/>
-            </a:solidFill>
-            <a:prstDash val="solid"/>
-          </a:ln>
-        </p:spPr>
-      </p:sp>
-      <p:sp>
-        <p:nvSpPr>
-          <p:cNvPr id="15" name="Text 13"/>
-          <p:cNvSpPr txBox="1"/>
-          <p:nvPr/>
-        </p:nvSpPr>
-        <p:spPr>
-          <a:xfrm>
-            <a:off x="777240" y="3931920"/>
-            <a:ext cx="438912" cy="438912"/>
-          </a:xfrm>
-          <a:prstGeom prst="rect">
-            <a:avLst/>
-          </a:prstGeom>
-          <a:noFill/>
-          <a:ln/>
-        </p:spPr>
-        <p:txBody>
-          <a:bodyPr wrap="square" lIns="0" tIns="0" rIns="0" bIns="0" rtlCol="0" anchor="ctr"/>
-          <a:lstStyle/>
-          <a:p>
-            <a:pPr algn="ctr" indent="0" marL="0">
-              <a:buNone/>
-            </a:pPr>
-            <a:r>
-              <a:rPr lang="en-US" sz="1600" b="1" dirty="0">
-                <a:solidFill>
-                  <a:schemeClr val="bg1"/>
-                </a:solidFill>
-              </a:rPr>
-              <a:t>3</a:t>
-            </a:r>
-            <a:endParaRPr lang="en-US" sz="1600" dirty="0"/>
-          </a:p>
-        </p:txBody>
-      </p:sp>
-      <p:sp>
-        <p:nvSpPr>
-          <p:cNvPr id="16" name="Text 14"/>
-          <p:cNvSpPr txBox="1"/>
-          <p:nvPr/>
-        </p:nvSpPr>
-        <p:spPr>
-          <a:xfrm>
-            <a:off x="1371600" y="3931920"/>
-            <a:ext cx="4416552" cy="438912"/>
-          </a:xfrm>
-          <a:prstGeom prst="rect">
-            <a:avLst/>
-          </a:prstGeom>
-          <a:noFill/>
-          <a:ln/>
-        </p:spPr>
-        <p:txBody>
-          <a:bodyPr wrap="square" lIns="0" tIns="0" rIns="0" bIns="0" rtlCol="0" anchor="ctr"/>
-          <a:lstStyle/>
-          <a:p>
-            <a:pPr indent="0" marL="0">
-              <a:buNone/>
-            </a:pPr>
-            <a:r>
-              <a:rPr lang="en-US" sz="1800" b="1" dirty="0">
-                <a:solidFill>
-                  <a:schemeClr val="tx1"/>
-                </a:solidFill>
-                <a:latin typeface="Cambria" pitchFamily="34" charset="0"/>
-                <a:ea typeface="Cambria" pitchFamily="34" charset="-122"/>
-                <a:cs typeface="Cambria" pitchFamily="34" charset="-120"/>
-              </a:rPr>
-              <a:t>46 automated tests</a:t>
-            </a:r>
-            <a:endParaRPr lang="en-US" sz="1800" dirty="0"/>
-          </a:p>
-        </p:txBody>
-      </p:sp>
-      <p:sp>
-        <p:nvSpPr>
-          <p:cNvPr id="17" name="Text 15"/>
-          <p:cNvSpPr txBox="1"/>
-          <p:nvPr/>
-        </p:nvSpPr>
-        <p:spPr>
-          <a:xfrm>
-            <a:off x="777240" y="4480560"/>
-            <a:ext cx="5010912" cy="1143000"/>
-          </a:xfrm>
-          <a:prstGeom prst="rect">
-            <a:avLst/>
-          </a:prstGeom>
-          <a:noFill/>
-          <a:ln/>
-        </p:spPr>
-        <p:txBody>
-          <a:bodyPr wrap="square" lIns="0" tIns="0" rIns="0" bIns="0" rtlCol="0" anchor="t"/>
-          <a:lstStyle/>
-          <a:p>
-            <a:pPr indent="0" marL="0">
-              <a:buNone/>
-            </a:pPr>
-            <a:r>
-              <a:rPr lang="en-US" sz="1500" dirty="0">
-                <a:solidFill>
-                  <a:schemeClr val="tx2"/>
-                </a:solidFill>
-              </a:rPr>
-              <a:t>They check the model never sees the future, e.g. scrambling future data must not change any prediction.</a:t>
-            </a:r>
-            <a:endParaRPr lang="en-US" sz="1500" dirty="0"/>
-          </a:p>
-        </p:txBody>
-      </p:sp>
-      <p:sp>
-        <p:nvSpPr>
-          <p:cNvPr id="18" name="Shape 16"/>
-          <p:cNvSpPr/>
-          <p:nvPr/>
-        </p:nvSpPr>
-        <p:spPr>
-          <a:xfrm>
-            <a:off x="6172200" y="3703320"/>
-            <a:ext cx="5468112" cy="2103120"/>
-          </a:xfrm>
-          <a:prstGeom prst="roundRect">
-            <a:avLst>
-              <a:gd name="adj" fmla="val 5217"/>
-            </a:avLst>
-          </a:prstGeom>
-          <a:solidFill>
-            <a:schemeClr val="bg2"/>
-          </a:solidFill>
-          <a:ln w="12700">
-            <a:solidFill>
-              <a:schemeClr val="bg2"/>
-            </a:solidFill>
-            <a:prstDash val="solid"/>
-          </a:ln>
-        </p:spPr>
-      </p:sp>
-      <p:sp>
-        <p:nvSpPr>
-          <p:cNvPr id="19" name="Shape 17"/>
-          <p:cNvSpPr/>
-          <p:nvPr/>
-        </p:nvSpPr>
-        <p:spPr>
-          <a:xfrm>
-            <a:off x="6400800" y="3931920"/>
-            <a:ext cx="438912" cy="438912"/>
-          </a:xfrm>
-          <a:prstGeom prst="ellipse">
-            <a:avLst/>
-          </a:prstGeom>
-          <a:solidFill>
-            <a:schemeClr val="accent1"/>
-          </a:solidFill>
-          <a:ln w="12700">
-            <a:solidFill>
-              <a:schemeClr val="accent1"/>
-            </a:solidFill>
-            <a:prstDash val="solid"/>
-          </a:ln>
-        </p:spPr>
-      </p:sp>
-      <p:sp>
-        <p:nvSpPr>
-          <p:cNvPr id="20" name="Text 18"/>
-          <p:cNvSpPr txBox="1"/>
-          <p:nvPr/>
-        </p:nvSpPr>
-        <p:spPr>
-          <a:xfrm>
-            <a:off x="6400800" y="3931920"/>
-            <a:ext cx="438912" cy="438912"/>
-          </a:xfrm>
-          <a:prstGeom prst="rect">
-            <a:avLst/>
-          </a:prstGeom>
-          <a:noFill/>
-          <a:ln/>
-        </p:spPr>
-        <p:txBody>
-          <a:bodyPr wrap="square" lIns="0" tIns="0" rIns="0" bIns="0" rtlCol="0" anchor="ctr"/>
-          <a:lstStyle/>
-          <a:p>
-            <a:pPr algn="ctr" indent="0" marL="0">
-              <a:buNone/>
-            </a:pPr>
-            <a:r>
-              <a:rPr lang="en-US" sz="1600" b="1" dirty="0">
-                <a:solidFill>
-                  <a:schemeClr val="bg1"/>
-                </a:solidFill>
-              </a:rPr>
-              <a:t>4</a:t>
-            </a:r>
-            <a:endParaRPr lang="en-US" sz="1600" dirty="0"/>
-          </a:p>
-        </p:txBody>
-      </p:sp>
-      <p:sp>
-        <p:nvSpPr>
-          <p:cNvPr id="21" name="Text 19"/>
-          <p:cNvSpPr txBox="1"/>
-          <p:nvPr/>
-        </p:nvSpPr>
-        <p:spPr>
-          <a:xfrm>
-            <a:off x="6995160" y="3931920"/>
-            <a:ext cx="4416552" cy="438912"/>
-          </a:xfrm>
-          <a:prstGeom prst="rect">
-            <a:avLst/>
-          </a:prstGeom>
-          <a:noFill/>
-          <a:ln/>
-        </p:spPr>
-        <p:txBody>
-          <a:bodyPr wrap="square" lIns="0" tIns="0" rIns="0" bIns="0" rtlCol="0" anchor="ctr"/>
-          <a:lstStyle/>
-          <a:p>
-            <a:pPr indent="0" marL="0">
-              <a:buNone/>
-            </a:pPr>
-            <a:r>
-              <a:rPr lang="en-US" sz="1800" b="1" dirty="0">
-                <a:solidFill>
-                  <a:schemeClr val="tx1"/>
-                </a:solidFill>
-                <a:latin typeface="Cambria" pitchFamily="34" charset="0"/>
-                <a:ea typeface="Cambria" pitchFamily="34" charset="-122"/>
-                <a:cs typeface="Cambria" pitchFamily="34" charset="-120"/>
-              </a:rPr>
-              <a:t>Failures reported, not hidden</a:t>
-            </a:r>
-            <a:endParaRPr lang="en-US" sz="1800" dirty="0"/>
-          </a:p>
-        </p:txBody>
-      </p:sp>
-      <p:sp>
-        <p:nvSpPr>
-          <p:cNvPr id="22" name="Text 20"/>
-          <p:cNvSpPr txBox="1"/>
-          <p:nvPr/>
-        </p:nvSpPr>
-        <p:spPr>
-          <a:xfrm>
-            <a:off x="6400800" y="4480560"/>
-            <a:ext cx="5010912" cy="1143000"/>
-          </a:xfrm>
-          <a:prstGeom prst="rect">
-            <a:avLst/>
-          </a:prstGeom>
-          <a:noFill/>
-          <a:ln/>
-        </p:spPr>
-        <p:txBody>
-          <a:bodyPr wrap="square" lIns="0" tIns="0" rIns="0" bIns="0" rtlCol="0" anchor="t"/>
-          <a:lstStyle/>
-          <a:p>
-            <a:pPr indent="0" marL="0">
-              <a:buNone/>
-            </a:pPr>
-            <a:r>
-              <a:rPr lang="en-US" sz="1500" dirty="0">
-                <a:solidFill>
-                  <a:schemeClr val="tx2"/>
-                </a:solidFill>
-              </a:rPr>
-              <a:t>Every change after results is logged, including a one-day overlap we found in v1’s work and v3 failing its own calibration test.</a:t>
-            </a:r>
-            <a:endParaRPr lang="en-US" sz="1500" dirty="0"/>
+              <a:t>41–50% across three classes. The brief calls 35–40% normal and warns that 80% means a leak.</a:t>
+            </a:r>
+            <a:endParaRPr lang="en-US" sz="1400" dirty="0"/>
           </a:p>
         </p:txBody>
       </p:sp>
@@ -20119,7 +21315,7 @@
                 <a:ea typeface="Cambria" pitchFamily="34" charset="-122"/>
                 <a:cs typeface="Cambria" pitchFamily="34" charset="-120"/>
               </a:rPr>
-              <a:t>A flaw of machine learning, or of the question?</a:t>
+              <a:t>How we kept the test honest</a:t>
             </a:r>
             <a:endParaRPr lang="en-US" sz="3200" dirty="0"/>
           </a:p>
@@ -20133,114 +21329,12 @@
         </p:nvSpPr>
         <p:spPr>
           <a:xfrm>
-            <a:off x="548640" y="1371600"/>
-            <a:ext cx="11094415" cy="1024128"/>
+            <a:off x="548640" y="1417320"/>
+            <a:ext cx="5468112" cy="2103120"/>
           </a:xfrm>
           <a:prstGeom prst="roundRect">
             <a:avLst>
-              <a:gd name="adj" fmla="val 8929"/>
-            </a:avLst>
-          </a:prstGeom>
-          <a:solidFill>
-            <a:srgbClr val="FBEDE4"/>
-          </a:solidFill>
-          <a:ln w="12700">
-            <a:solidFill>
-              <a:srgbClr val="FBEDE4"/>
-            </a:solidFill>
-            <a:prstDash val="solid"/>
-          </a:ln>
-        </p:spPr>
-      </p:sp>
-      <p:sp>
-        <p:nvSpPr>
-          <p:cNvPr id="4" name="Text 2"/>
-          <p:cNvSpPr txBox="1"/>
-          <p:nvPr/>
-        </p:nvSpPr>
-        <p:spPr>
-          <a:xfrm>
-            <a:off x="822960" y="1371600"/>
-            <a:ext cx="3291840" cy="1024128"/>
-          </a:xfrm>
-          <a:prstGeom prst="rect">
-            <a:avLst/>
-          </a:prstGeom>
-          <a:noFill/>
-          <a:ln/>
-        </p:spPr>
-        <p:txBody>
-          <a:bodyPr wrap="square" lIns="0" tIns="0" rIns="0" bIns="0" rtlCol="0" anchor="ctr"/>
-          <a:lstStyle/>
-          <a:p>
-            <a:pPr indent="0" marL="0">
-              <a:buNone/>
-            </a:pPr>
-            <a:r>
-              <a:rPr lang="en-US" sz="1900" b="1" dirty="0">
-                <a:solidFill>
-                  <a:schemeClr val="tx1"/>
-                </a:solidFill>
-                <a:latin typeface="Cambria" pitchFamily="34" charset="0"/>
-                <a:ea typeface="Cambria" pitchFamily="34" charset="-122"/>
-                <a:cs typeface="Cambria" pitchFamily="34" charset="-120"/>
-              </a:rPr>
-              <a:t>Mostly the question</a:t>
-            </a:r>
-            <a:endParaRPr lang="en-US" sz="1900" dirty="0"/>
-          </a:p>
-        </p:txBody>
-      </p:sp>
-      <p:sp>
-        <p:nvSpPr>
-          <p:cNvPr id="5" name="Text 3"/>
-          <p:cNvSpPr txBox="1"/>
-          <p:nvPr/>
-        </p:nvSpPr>
-        <p:spPr>
-          <a:xfrm>
-            <a:off x="4297680" y="1371600"/>
-            <a:ext cx="7116775" cy="1024128"/>
-          </a:xfrm>
-          <a:prstGeom prst="rect">
-            <a:avLst/>
-          </a:prstGeom>
-          <a:noFill/>
-          <a:ln/>
-        </p:spPr>
-        <p:txBody>
-          <a:bodyPr wrap="square" lIns="0" tIns="0" rIns="0" bIns="0" rtlCol="0" anchor="ctr"/>
-          <a:lstStyle/>
-          <a:p>
-            <a:pPr indent="0" marL="0">
-              <a:buNone/>
-            </a:pPr>
-            <a:r>
-              <a:rPr lang="en-US" sz="1600" dirty="0">
-                <a:solidFill>
-                  <a:schemeClr val="tx2"/>
-                </a:solidFill>
-              </a:rPr>
-              <a:t>We asked for next week’s direction of the world’s most-watched fund, using only its own public price history. Simple patterns there get traded away, and no algorithm can find information that isn’t in the data.</a:t>
-            </a:r>
-            <a:endParaRPr lang="en-US" sz="1600" dirty="0"/>
-          </a:p>
-        </p:txBody>
-      </p:sp>
-      <p:sp>
-        <p:nvSpPr>
-          <p:cNvPr id="6" name="Shape 4"/>
-          <p:cNvSpPr/>
-          <p:nvPr/>
-        </p:nvSpPr>
-        <p:spPr>
-          <a:xfrm>
-            <a:off x="548640" y="2514600"/>
-            <a:ext cx="11094415" cy="1024128"/>
-          </a:xfrm>
-          <a:prstGeom prst="roundRect">
-            <a:avLst>
-              <a:gd name="adj" fmla="val 8929"/>
+              <a:gd name="adj" fmla="val 5217"/>
             </a:avLst>
           </a:prstGeom>
           <a:solidFill>
@@ -20256,14 +21350,39 @@
       </p:sp>
       <p:sp>
         <p:nvSpPr>
-          <p:cNvPr id="7" name="Text 5"/>
+          <p:cNvPr id="4" name="Shape 2"/>
+          <p:cNvSpPr/>
+          <p:nvPr/>
+        </p:nvSpPr>
+        <p:spPr>
+          <a:xfrm>
+            <a:off x="777240" y="1645920"/>
+            <a:ext cx="438912" cy="438912"/>
+          </a:xfrm>
+          <a:prstGeom prst="ellipse">
+            <a:avLst/>
+          </a:prstGeom>
+          <a:solidFill>
+            <a:schemeClr val="accent1"/>
+          </a:solidFill>
+          <a:ln w="12700">
+            <a:solidFill>
+              <a:schemeClr val="accent1"/>
+            </a:solidFill>
+            <a:prstDash val="solid"/>
+          </a:ln>
+        </p:spPr>
+      </p:sp>
+      <p:sp>
+        <p:nvSpPr>
+          <p:cNvPr id="5" name="Text 3"/>
           <p:cNvSpPr txBox="1"/>
           <p:nvPr/>
         </p:nvSpPr>
         <p:spPr>
           <a:xfrm>
-            <a:off x="822960" y="2514600"/>
-            <a:ext cx="3291840" cy="1024128"/>
+            <a:off x="777240" y="1645920"/>
+            <a:ext cx="438912" cy="438912"/>
           </a:xfrm>
           <a:prstGeom prst="rect">
             <a:avLst/>
@@ -20275,11 +21394,47 @@
           <a:bodyPr wrap="square" lIns="0" tIns="0" rIns="0" bIns="0" rtlCol="0" anchor="ctr"/>
           <a:lstStyle/>
           <a:p>
+            <a:pPr algn="ctr" indent="0" marL="0">
+              <a:buNone/>
+            </a:pPr>
+            <a:r>
+              <a:rPr lang="en-US" sz="1600" b="1" dirty="0">
+                <a:solidFill>
+                  <a:schemeClr val="bg1"/>
+                </a:solidFill>
+              </a:rPr>
+              <a:t>1</a:t>
+            </a:r>
+            <a:endParaRPr lang="en-US" sz="1600" dirty="0"/>
+          </a:p>
+        </p:txBody>
+      </p:sp>
+      <p:sp>
+        <p:nvSpPr>
+          <p:cNvPr id="6" name="Text 4"/>
+          <p:cNvSpPr txBox="1"/>
+          <p:nvPr/>
+        </p:nvSpPr>
+        <p:spPr>
+          <a:xfrm>
+            <a:off x="1371600" y="1645920"/>
+            <a:ext cx="4416552" cy="438912"/>
+          </a:xfrm>
+          <a:prstGeom prst="rect">
+            <a:avLst/>
+          </a:prstGeom>
+          <a:noFill/>
+          <a:ln/>
+        </p:spPr>
+        <p:txBody>
+          <a:bodyPr wrap="square" lIns="0" tIns="0" rIns="0" bIns="0" rtlCol="0" anchor="ctr"/>
+          <a:lstStyle/>
+          <a:p>
             <a:pPr indent="0" marL="0">
               <a:buNone/>
             </a:pPr>
             <a:r>
-              <a:rPr lang="en-US" sz="1900" b="1" dirty="0">
+              <a:rPr lang="en-US" sz="1800" b="1" dirty="0">
                 <a:solidFill>
                   <a:schemeClr val="tx1"/>
                 </a:solidFill>
@@ -20287,22 +21442,22 @@
                 <a:ea typeface="Cambria" pitchFamily="34" charset="-122"/>
                 <a:cs typeface="Cambria" pitchFamily="34" charset="-120"/>
               </a:rPr>
-              <a:t>Partly our own limits</a:t>
-            </a:r>
-            <a:endParaRPr lang="en-US" sz="1900" dirty="0"/>
-          </a:p>
-        </p:txBody>
-      </p:sp>
-      <p:sp>
-        <p:nvSpPr>
-          <p:cNvPr id="8" name="Text 6"/>
+              <a:t>Plans written before code</a:t>
+            </a:r>
+            <a:endParaRPr lang="en-US" sz="1800" dirty="0"/>
+          </a:p>
+        </p:txBody>
+      </p:sp>
+      <p:sp>
+        <p:nvSpPr>
+          <p:cNvPr id="7" name="Text 5"/>
           <p:cNvSpPr txBox="1"/>
           <p:nvPr/>
         </p:nvSpPr>
         <p:spPr>
           <a:xfrm>
-            <a:off x="4297680" y="2514600"/>
-            <a:ext cx="7116775" cy="1024128"/>
+            <a:off x="777240" y="2194560"/>
+            <a:ext cx="5010912" cy="1143000"/>
           </a:xfrm>
           <a:prstGeom prst="rect">
             <a:avLst/>
@@ -20311,38 +21466,38 @@
           <a:ln/>
         </p:spPr>
         <p:txBody>
-          <a:bodyPr wrap="square" lIns="0" tIns="0" rIns="0" bIns="0" rtlCol="0" anchor="ctr"/>
+          <a:bodyPr wrap="square" lIns="0" tIns="0" rIns="0" bIns="0" rtlCol="0" anchor="t"/>
           <a:lstStyle/>
           <a:p>
             <a:pPr indent="0" marL="0">
               <a:buNone/>
             </a:pPr>
             <a:r>
-              <a:rPr lang="en-US" sz="1600" dirty="0">
+              <a:rPr lang="en-US" sz="1500" dirty="0">
                 <a:solidFill>
                   <a:schemeClr val="tx2"/>
                 </a:solidFill>
               </a:rPr>
-              <a:t>One fund, all in or all out, price data only, a one-week horizon. Lifting these makes the task easier, but wouldn’t flip the result: even with zero fees, v1 still lost.</a:t>
-            </a:r>
-            <a:endParaRPr lang="en-US" sz="1600" dirty="0"/>
-          </a:p>
-        </p:txBody>
-      </p:sp>
-      <p:sp>
-        <p:nvSpPr>
-          <p:cNvPr id="9" name="Shape 7"/>
+              <a:t>Each version’s design was committed before any code or result existed, with a digital fingerprint (SHA-256) so later edits would show.</a:t>
+            </a:r>
+            <a:endParaRPr lang="en-US" sz="1500" dirty="0"/>
+          </a:p>
+        </p:txBody>
+      </p:sp>
+      <p:sp>
+        <p:nvSpPr>
+          <p:cNvPr id="8" name="Shape 6"/>
           <p:cNvSpPr/>
           <p:nvPr/>
         </p:nvSpPr>
         <p:spPr>
           <a:xfrm>
-            <a:off x="548640" y="3657600"/>
-            <a:ext cx="11094415" cy="1024128"/>
+            <a:off x="6172200" y="1417320"/>
+            <a:ext cx="5468112" cy="2103120"/>
           </a:xfrm>
           <a:prstGeom prst="roundRect">
             <a:avLst>
-              <a:gd name="adj" fmla="val 8929"/>
+              <a:gd name="adj" fmla="val 5217"/>
             </a:avLst>
           </a:prstGeom>
           <a:solidFill>
@@ -20358,14 +21513,39 @@
       </p:sp>
       <p:sp>
         <p:nvSpPr>
+          <p:cNvPr id="9" name="Shape 7"/>
+          <p:cNvSpPr/>
+          <p:nvPr/>
+        </p:nvSpPr>
+        <p:spPr>
+          <a:xfrm>
+            <a:off x="6400800" y="1645920"/>
+            <a:ext cx="438912" cy="438912"/>
+          </a:xfrm>
+          <a:prstGeom prst="ellipse">
+            <a:avLst/>
+          </a:prstGeom>
+          <a:solidFill>
+            <a:schemeClr val="accent1"/>
+          </a:solidFill>
+          <a:ln w="12700">
+            <a:solidFill>
+              <a:schemeClr val="accent1"/>
+            </a:solidFill>
+            <a:prstDash val="solid"/>
+          </a:ln>
+        </p:spPr>
+      </p:sp>
+      <p:sp>
+        <p:nvSpPr>
           <p:cNvPr id="10" name="Text 8"/>
           <p:cNvSpPr txBox="1"/>
           <p:nvPr/>
         </p:nvSpPr>
         <p:spPr>
           <a:xfrm>
-            <a:off x="822960" y="3657600"/>
-            <a:ext cx="3291840" cy="1024128"/>
+            <a:off x="6400800" y="1645920"/>
+            <a:ext cx="438912" cy="438912"/>
           </a:xfrm>
           <a:prstGeom prst="rect">
             <a:avLst/>
@@ -20377,11 +21557,47 @@
           <a:bodyPr wrap="square" lIns="0" tIns="0" rIns="0" bIns="0" rtlCol="0" anchor="ctr"/>
           <a:lstStyle/>
           <a:p>
+            <a:pPr algn="ctr" indent="0" marL="0">
+              <a:buNone/>
+            </a:pPr>
+            <a:r>
+              <a:rPr lang="en-US" sz="1600" b="1" dirty="0">
+                <a:solidFill>
+                  <a:schemeClr val="bg1"/>
+                </a:solidFill>
+              </a:rPr>
+              <a:t>2</a:t>
+            </a:r>
+            <a:endParaRPr lang="en-US" sz="1600" dirty="0"/>
+          </a:p>
+        </p:txBody>
+      </p:sp>
+      <p:sp>
+        <p:nvSpPr>
+          <p:cNvPr id="11" name="Text 9"/>
+          <p:cNvSpPr txBox="1"/>
+          <p:nvPr/>
+        </p:nvSpPr>
+        <p:spPr>
+          <a:xfrm>
+            <a:off x="6995160" y="1645920"/>
+            <a:ext cx="4416552" cy="438912"/>
+          </a:xfrm>
+          <a:prstGeom prst="rect">
+            <a:avLst/>
+          </a:prstGeom>
+          <a:noFill/>
+          <a:ln/>
+        </p:spPr>
+        <p:txBody>
+          <a:bodyPr wrap="square" lIns="0" tIns="0" rIns="0" bIns="0" rtlCol="0" anchor="ctr"/>
+          <a:lstStyle/>
+          <a:p>
             <a:pPr indent="0" marL="0">
               <a:buNone/>
             </a:pPr>
             <a:r>
-              <a:rPr lang="en-US" sz="1900" b="1" dirty="0">
+              <a:rPr lang="en-US" sz="1800" b="1" dirty="0">
                 <a:solidFill>
                   <a:schemeClr val="tx1"/>
                 </a:solidFill>
@@ -20389,22 +21605,22 @@
                 <a:ea typeface="Cambria" pitchFamily="34" charset="-122"/>
                 <a:cs typeface="Cambria" pitchFamily="34" charset="-120"/>
               </a:rPr>
-              <a:t>Where machine learning does help</a:t>
-            </a:r>
-            <a:endParaRPr lang="en-US" sz="1900" dirty="0"/>
-          </a:p>
-        </p:txBody>
-      </p:sp>
-      <p:sp>
-        <p:nvSpPr>
-          <p:cNvPr id="11" name="Text 9"/>
+              <a:t>Final exam opened once</a:t>
+            </a:r>
+            <a:endParaRPr lang="en-US" sz="1800" dirty="0"/>
+          </a:p>
+        </p:txBody>
+      </p:sp>
+      <p:sp>
+        <p:nvSpPr>
+          <p:cNvPr id="12" name="Text 10"/>
           <p:cNvSpPr txBox="1"/>
           <p:nvPr/>
         </p:nvSpPr>
         <p:spPr>
           <a:xfrm>
-            <a:off x="4297680" y="3657600"/>
-            <a:ext cx="7116775" cy="1024128"/>
+            <a:off x="6400800" y="2194560"/>
+            <a:ext cx="5010912" cy="1143000"/>
           </a:xfrm>
           <a:prstGeom prst="rect">
             <a:avLst/>
@@ -20413,38 +21629,38 @@
           <a:ln/>
         </p:spPr>
         <p:txBody>
-          <a:bodyPr wrap="square" lIns="0" tIns="0" rIns="0" bIns="0" rtlCol="0" anchor="ctr"/>
+          <a:bodyPr wrap="square" lIns="0" tIns="0" rIns="0" bIns="0" rtlCol="0" anchor="t"/>
           <a:lstStyle/>
           <a:p>
             <a:pPr indent="0" marL="0">
               <a:buNone/>
             </a:pPr>
             <a:r>
-              <a:rPr lang="en-US" sz="1600" dirty="0">
+              <a:rPr lang="en-US" sz="1500" dirty="0">
                 <a:solidFill>
                   <a:schemeClr val="tx2"/>
                 </a:solidFill>
               </a:rPr>
-              <a:t>Ranking many assets against each other, forecasting risk to size positions, and using data most people don’t have. Even there the edges are usually small and shrink after costs.</a:t>
-            </a:r>
-            <a:endParaRPr lang="en-US" sz="1600" dirty="0"/>
-          </a:p>
-        </p:txBody>
-      </p:sp>
-      <p:sp>
-        <p:nvSpPr>
-          <p:cNvPr id="12" name="Shape 10"/>
+              <a:t>Each version picked its model on earlier data, locked it, and only then saw the test years.</a:t>
+            </a:r>
+            <a:endParaRPr lang="en-US" sz="1500" dirty="0"/>
+          </a:p>
+        </p:txBody>
+      </p:sp>
+      <p:sp>
+        <p:nvSpPr>
+          <p:cNvPr id="13" name="Shape 11"/>
           <p:cNvSpPr/>
           <p:nvPr/>
         </p:nvSpPr>
         <p:spPr>
           <a:xfrm>
-            <a:off x="548640" y="4800600"/>
-            <a:ext cx="11094415" cy="1024128"/>
+            <a:off x="548640" y="3703320"/>
+            <a:ext cx="5468112" cy="2103120"/>
           </a:xfrm>
           <a:prstGeom prst="roundRect">
             <a:avLst>
-              <a:gd name="adj" fmla="val 8929"/>
+              <a:gd name="adj" fmla="val 5217"/>
             </a:avLst>
           </a:prstGeom>
           <a:solidFill>
@@ -20460,14 +21676,39 @@
       </p:sp>
       <p:sp>
         <p:nvSpPr>
-          <p:cNvPr id="13" name="Text 11"/>
+          <p:cNvPr id="14" name="Shape 12"/>
+          <p:cNvSpPr/>
+          <p:nvPr/>
+        </p:nvSpPr>
+        <p:spPr>
+          <a:xfrm>
+            <a:off x="777240" y="3931920"/>
+            <a:ext cx="438912" cy="438912"/>
+          </a:xfrm>
+          <a:prstGeom prst="ellipse">
+            <a:avLst/>
+          </a:prstGeom>
+          <a:solidFill>
+            <a:schemeClr val="accent1"/>
+          </a:solidFill>
+          <a:ln w="12700">
+            <a:solidFill>
+              <a:schemeClr val="accent1"/>
+            </a:solidFill>
+            <a:prstDash val="solid"/>
+          </a:ln>
+        </p:spPr>
+      </p:sp>
+      <p:sp>
+        <p:nvSpPr>
+          <p:cNvPr id="15" name="Text 13"/>
           <p:cNvSpPr txBox="1"/>
           <p:nvPr/>
         </p:nvSpPr>
         <p:spPr>
           <a:xfrm>
-            <a:off x="822960" y="4800600"/>
-            <a:ext cx="3291840" cy="1024128"/>
+            <a:off x="777240" y="3931920"/>
+            <a:ext cx="438912" cy="438912"/>
           </a:xfrm>
           <a:prstGeom prst="rect">
             <a:avLst/>
@@ -20479,11 +21720,47 @@
           <a:bodyPr wrap="square" lIns="0" tIns="0" rIns="0" bIns="0" rtlCol="0" anchor="ctr"/>
           <a:lstStyle/>
           <a:p>
+            <a:pPr algn="ctr" indent="0" marL="0">
+              <a:buNone/>
+            </a:pPr>
+            <a:r>
+              <a:rPr lang="en-US" sz="1600" b="1" dirty="0">
+                <a:solidFill>
+                  <a:schemeClr val="bg1"/>
+                </a:solidFill>
+              </a:rPr>
+              <a:t>3</a:t>
+            </a:r>
+            <a:endParaRPr lang="en-US" sz="1600" dirty="0"/>
+          </a:p>
+        </p:txBody>
+      </p:sp>
+      <p:sp>
+        <p:nvSpPr>
+          <p:cNvPr id="16" name="Text 14"/>
+          <p:cNvSpPr txBox="1"/>
+          <p:nvPr/>
+        </p:nvSpPr>
+        <p:spPr>
+          <a:xfrm>
+            <a:off x="1371600" y="3931920"/>
+            <a:ext cx="4416552" cy="438912"/>
+          </a:xfrm>
+          <a:prstGeom prst="rect">
+            <a:avLst/>
+          </a:prstGeom>
+          <a:noFill/>
+          <a:ln/>
+        </p:spPr>
+        <p:txBody>
+          <a:bodyPr wrap="square" lIns="0" tIns="0" rIns="0" bIns="0" rtlCol="0" anchor="ctr"/>
+          <a:lstStyle/>
+          <a:p>
             <a:pPr indent="0" marL="0">
               <a:buNone/>
             </a:pPr>
             <a:r>
-              <a:rPr lang="en-US" sz="1900" b="1" dirty="0">
+              <a:rPr lang="en-US" sz="1800" b="1" dirty="0">
                 <a:solidFill>
                   <a:schemeClr val="tx1"/>
                 </a:solidFill>
@@ -20491,22 +21768,22 @@
                 <a:ea typeface="Cambria" pitchFamily="34" charset="-122"/>
                 <a:cs typeface="Cambria" pitchFamily="34" charset="-120"/>
               </a:rPr>
-              <a:t>The fair bar</a:t>
-            </a:r>
-            <a:endParaRPr lang="en-US" sz="1900" dirty="0"/>
-          </a:p>
-        </p:txBody>
-      </p:sp>
-      <p:sp>
-        <p:nvSpPr>
-          <p:cNvPr id="14" name="Text 12"/>
+              <a:t>46 automated tests</a:t>
+            </a:r>
+            <a:endParaRPr lang="en-US" sz="1800" dirty="0"/>
+          </a:p>
+        </p:txBody>
+      </p:sp>
+      <p:sp>
+        <p:nvSpPr>
+          <p:cNvPr id="17" name="Text 15"/>
           <p:cNvSpPr txBox="1"/>
           <p:nvPr/>
         </p:nvSpPr>
         <p:spPr>
           <a:xfrm>
-            <a:off x="4297680" y="4800600"/>
-            <a:ext cx="7116775" cy="1024128"/>
+            <a:off x="777240" y="4480560"/>
+            <a:ext cx="5010912" cy="1143000"/>
           </a:xfrm>
           <a:prstGeom prst="rect">
             <a:avLst/>
@@ -20515,21 +21792,184 @@
           <a:ln/>
         </p:spPr>
         <p:txBody>
+          <a:bodyPr wrap="square" lIns="0" tIns="0" rIns="0" bIns="0" rtlCol="0" anchor="t"/>
+          <a:lstStyle/>
+          <a:p>
+            <a:pPr indent="0" marL="0">
+              <a:buNone/>
+            </a:pPr>
+            <a:r>
+              <a:rPr lang="en-US" sz="1500" dirty="0">
+                <a:solidFill>
+                  <a:schemeClr val="tx2"/>
+                </a:solidFill>
+              </a:rPr>
+              <a:t>They check the model never sees the future, e.g. scrambling future data must not change any prediction.</a:t>
+            </a:r>
+            <a:endParaRPr lang="en-US" sz="1500" dirty="0"/>
+          </a:p>
+        </p:txBody>
+      </p:sp>
+      <p:sp>
+        <p:nvSpPr>
+          <p:cNvPr id="18" name="Shape 16"/>
+          <p:cNvSpPr/>
+          <p:nvPr/>
+        </p:nvSpPr>
+        <p:spPr>
+          <a:xfrm>
+            <a:off x="6172200" y="3703320"/>
+            <a:ext cx="5468112" cy="2103120"/>
+          </a:xfrm>
+          <a:prstGeom prst="roundRect">
+            <a:avLst>
+              <a:gd name="adj" fmla="val 5217"/>
+            </a:avLst>
+          </a:prstGeom>
+          <a:solidFill>
+            <a:schemeClr val="bg2"/>
+          </a:solidFill>
+          <a:ln w="12700">
+            <a:solidFill>
+              <a:schemeClr val="bg2"/>
+            </a:solidFill>
+            <a:prstDash val="solid"/>
+          </a:ln>
+        </p:spPr>
+      </p:sp>
+      <p:sp>
+        <p:nvSpPr>
+          <p:cNvPr id="19" name="Shape 17"/>
+          <p:cNvSpPr/>
+          <p:nvPr/>
+        </p:nvSpPr>
+        <p:spPr>
+          <a:xfrm>
+            <a:off x="6400800" y="3931920"/>
+            <a:ext cx="438912" cy="438912"/>
+          </a:xfrm>
+          <a:prstGeom prst="ellipse">
+            <a:avLst/>
+          </a:prstGeom>
+          <a:solidFill>
+            <a:schemeClr val="accent1"/>
+          </a:solidFill>
+          <a:ln w="12700">
+            <a:solidFill>
+              <a:schemeClr val="accent1"/>
+            </a:solidFill>
+            <a:prstDash val="solid"/>
+          </a:ln>
+        </p:spPr>
+      </p:sp>
+      <p:sp>
+        <p:nvSpPr>
+          <p:cNvPr id="20" name="Text 18"/>
+          <p:cNvSpPr txBox="1"/>
+          <p:nvPr/>
+        </p:nvSpPr>
+        <p:spPr>
+          <a:xfrm>
+            <a:off x="6400800" y="3931920"/>
+            <a:ext cx="438912" cy="438912"/>
+          </a:xfrm>
+          <a:prstGeom prst="rect">
+            <a:avLst/>
+          </a:prstGeom>
+          <a:noFill/>
+          <a:ln/>
+        </p:spPr>
+        <p:txBody>
           <a:bodyPr wrap="square" lIns="0" tIns="0" rIns="0" bIns="0" rtlCol="0" anchor="ctr"/>
           <a:lstStyle/>
           <a:p>
+            <a:pPr algn="ctr" indent="0" marL="0">
+              <a:buNone/>
+            </a:pPr>
+            <a:r>
+              <a:rPr lang="en-US" sz="1600" b="1" dirty="0">
+                <a:solidFill>
+                  <a:schemeClr val="bg1"/>
+                </a:solidFill>
+              </a:rPr>
+              <a:t>4</a:t>
+            </a:r>
+            <a:endParaRPr lang="en-US" sz="1600" dirty="0"/>
+          </a:p>
+        </p:txBody>
+      </p:sp>
+      <p:sp>
+        <p:nvSpPr>
+          <p:cNvPr id="21" name="Text 19"/>
+          <p:cNvSpPr txBox="1"/>
+          <p:nvPr/>
+        </p:nvSpPr>
+        <p:spPr>
+          <a:xfrm>
+            <a:off x="6995160" y="3931920"/>
+            <a:ext cx="4416552" cy="438912"/>
+          </a:xfrm>
+          <a:prstGeom prst="rect">
+            <a:avLst/>
+          </a:prstGeom>
+          <a:noFill/>
+          <a:ln/>
+        </p:spPr>
+        <p:txBody>
+          <a:bodyPr wrap="square" lIns="0" tIns="0" rIns="0" bIns="0" rtlCol="0" anchor="ctr"/>
+          <a:lstStyle/>
+          <a:p>
             <a:pPr indent="0" marL="0">
               <a:buNone/>
             </a:pPr>
             <a:r>
-              <a:rPr lang="en-US" sz="1600" dirty="0">
+              <a:rPr lang="en-US" sz="1800" b="1" dirty="0">
+                <a:solidFill>
+                  <a:schemeClr val="tx1"/>
+                </a:solidFill>
+                <a:latin typeface="Cambria" pitchFamily="34" charset="0"/>
+                <a:ea typeface="Cambria" pitchFamily="34" charset="-122"/>
+                <a:cs typeface="Cambria" pitchFamily="34" charset="-120"/>
+              </a:rPr>
+              <a:t>Failures reported, not hidden</a:t>
+            </a:r>
+            <a:endParaRPr lang="en-US" sz="1800" dirty="0"/>
+          </a:p>
+        </p:txBody>
+      </p:sp>
+      <p:sp>
+        <p:nvSpPr>
+          <p:cNvPr id="22" name="Text 20"/>
+          <p:cNvSpPr txBox="1"/>
+          <p:nvPr/>
+        </p:nvSpPr>
+        <p:spPr>
+          <a:xfrm>
+            <a:off x="6400800" y="4480560"/>
+            <a:ext cx="5010912" cy="1143000"/>
+          </a:xfrm>
+          <a:prstGeom prst="rect">
+            <a:avLst/>
+          </a:prstGeom>
+          <a:noFill/>
+          <a:ln/>
+        </p:spPr>
+        <p:txBody>
+          <a:bodyPr wrap="square" lIns="0" tIns="0" rIns="0" bIns="0" rtlCol="0" anchor="t"/>
+          <a:lstStyle/>
+          <a:p>
+            <a:pPr indent="0" marL="0">
+              <a:buNone/>
+            </a:pPr>
+            <a:r>
+              <a:rPr lang="en-US" sz="1500" dirty="0">
                 <a:solidFill>
                   <a:schemeClr val="tx2"/>
                 </a:solidFill>
               </a:rPr>
-              <a:t>Return for the risk taken, and beating random timing — not simply “more money than Buy &amp; Hold”. That is how we judged every version.</a:t>
-            </a:r>
-            <a:endParaRPr lang="en-US" sz="1600" dirty="0"/>
+              <a:t>Every change after results is logged, including a one-day overlap we found in v1’s work and v3 failing its own calibration test.</a:t>
+            </a:r>
+            <a:endParaRPr lang="en-US" sz="1500" dirty="0"/>
           </a:p>
         </p:txBody>
       </p:sp>
@@ -20638,7 +22078,7 @@
                 <a:ea typeface="Cambria" pitchFamily="34" charset="-122"/>
                 <a:cs typeface="Cambria" pitchFamily="34" charset="-120"/>
               </a:rPr>
-              <a:t>What we learned</a:t>
+              <a:t>A flaw of machine learning, or of the question?</a:t>
             </a:r>
             <a:endParaRPr lang="en-US" sz="3200" dirty="0"/>
           </a:p>
@@ -20652,12 +22092,114 @@
         </p:nvSpPr>
         <p:spPr>
           <a:xfrm>
-            <a:off x="548640" y="1417320"/>
-            <a:ext cx="5468112" cy="2103120"/>
+            <a:off x="548640" y="1371600"/>
+            <a:ext cx="11094415" cy="1024128"/>
           </a:xfrm>
           <a:prstGeom prst="roundRect">
             <a:avLst>
-              <a:gd name="adj" fmla="val 5217"/>
+              <a:gd name="adj" fmla="val 8929"/>
+            </a:avLst>
+          </a:prstGeom>
+          <a:solidFill>
+            <a:srgbClr val="FBEDE4"/>
+          </a:solidFill>
+          <a:ln w="12700">
+            <a:solidFill>
+              <a:srgbClr val="FBEDE4"/>
+            </a:solidFill>
+            <a:prstDash val="solid"/>
+          </a:ln>
+        </p:spPr>
+      </p:sp>
+      <p:sp>
+        <p:nvSpPr>
+          <p:cNvPr id="4" name="Text 2"/>
+          <p:cNvSpPr txBox="1"/>
+          <p:nvPr/>
+        </p:nvSpPr>
+        <p:spPr>
+          <a:xfrm>
+            <a:off x="822960" y="1371600"/>
+            <a:ext cx="3291840" cy="1024128"/>
+          </a:xfrm>
+          <a:prstGeom prst="rect">
+            <a:avLst/>
+          </a:prstGeom>
+          <a:noFill/>
+          <a:ln/>
+        </p:spPr>
+        <p:txBody>
+          <a:bodyPr wrap="square" lIns="0" tIns="0" rIns="0" bIns="0" rtlCol="0" anchor="ctr"/>
+          <a:lstStyle/>
+          <a:p>
+            <a:pPr indent="0" marL="0">
+              <a:buNone/>
+            </a:pPr>
+            <a:r>
+              <a:rPr lang="en-US" sz="1900" b="1" dirty="0">
+                <a:solidFill>
+                  <a:schemeClr val="tx1"/>
+                </a:solidFill>
+                <a:latin typeface="Cambria" pitchFamily="34" charset="0"/>
+                <a:ea typeface="Cambria" pitchFamily="34" charset="-122"/>
+                <a:cs typeface="Cambria" pitchFamily="34" charset="-120"/>
+              </a:rPr>
+              <a:t>Mostly the question</a:t>
+            </a:r>
+            <a:endParaRPr lang="en-US" sz="1900" dirty="0"/>
+          </a:p>
+        </p:txBody>
+      </p:sp>
+      <p:sp>
+        <p:nvSpPr>
+          <p:cNvPr id="5" name="Text 3"/>
+          <p:cNvSpPr txBox="1"/>
+          <p:nvPr/>
+        </p:nvSpPr>
+        <p:spPr>
+          <a:xfrm>
+            <a:off x="4297680" y="1371600"/>
+            <a:ext cx="7116775" cy="1024128"/>
+          </a:xfrm>
+          <a:prstGeom prst="rect">
+            <a:avLst/>
+          </a:prstGeom>
+          <a:noFill/>
+          <a:ln/>
+        </p:spPr>
+        <p:txBody>
+          <a:bodyPr wrap="square" lIns="0" tIns="0" rIns="0" bIns="0" rtlCol="0" anchor="ctr"/>
+          <a:lstStyle/>
+          <a:p>
+            <a:pPr indent="0" marL="0">
+              <a:buNone/>
+            </a:pPr>
+            <a:r>
+              <a:rPr lang="en-US" sz="1600" dirty="0">
+                <a:solidFill>
+                  <a:schemeClr val="tx2"/>
+                </a:solidFill>
+              </a:rPr>
+              <a:t>We asked for next week’s direction of the world’s most-watched fund, using only its own public price history. Simple patterns there get traded away, and no algorithm can find information that isn’t in the data.</a:t>
+            </a:r>
+            <a:endParaRPr lang="en-US" sz="1600" dirty="0"/>
+          </a:p>
+        </p:txBody>
+      </p:sp>
+      <p:sp>
+        <p:nvSpPr>
+          <p:cNvPr id="6" name="Shape 4"/>
+          <p:cNvSpPr/>
+          <p:nvPr/>
+        </p:nvSpPr>
+        <p:spPr>
+          <a:xfrm>
+            <a:off x="548640" y="2514600"/>
+            <a:ext cx="11094415" cy="1024128"/>
+          </a:xfrm>
+          <a:prstGeom prst="roundRect">
+            <a:avLst>
+              <a:gd name="adj" fmla="val 8929"/>
             </a:avLst>
           </a:prstGeom>
           <a:solidFill>
@@ -20673,39 +22215,14 @@
       </p:sp>
       <p:sp>
         <p:nvSpPr>
-          <p:cNvPr id="4" name="Shape 2"/>
-          <p:cNvSpPr/>
-          <p:nvPr/>
-        </p:nvSpPr>
-        <p:spPr>
-          <a:xfrm>
-            <a:off x="777240" y="1645920"/>
-            <a:ext cx="438912" cy="438912"/>
-          </a:xfrm>
-          <a:prstGeom prst="ellipse">
-            <a:avLst/>
-          </a:prstGeom>
-          <a:solidFill>
-            <a:schemeClr val="accent1"/>
-          </a:solidFill>
-          <a:ln w="12700">
-            <a:solidFill>
-              <a:schemeClr val="accent1"/>
-            </a:solidFill>
-            <a:prstDash val="solid"/>
-          </a:ln>
-        </p:spPr>
-      </p:sp>
-      <p:sp>
-        <p:nvSpPr>
-          <p:cNvPr id="5" name="Text 3"/>
+          <p:cNvPr id="7" name="Text 5"/>
           <p:cNvSpPr txBox="1"/>
           <p:nvPr/>
         </p:nvSpPr>
         <p:spPr>
           <a:xfrm>
-            <a:off x="777240" y="1645920"/>
-            <a:ext cx="438912" cy="438912"/>
+            <a:off x="822960" y="2514600"/>
+            <a:ext cx="3291840" cy="1024128"/>
           </a:xfrm>
           <a:prstGeom prst="rect">
             <a:avLst/>
@@ -20717,47 +22234,11 @@
           <a:bodyPr wrap="square" lIns="0" tIns="0" rIns="0" bIns="0" rtlCol="0" anchor="ctr"/>
           <a:lstStyle/>
           <a:p>
-            <a:pPr algn="ctr" indent="0" marL="0">
-              <a:buNone/>
-            </a:pPr>
-            <a:r>
-              <a:rPr lang="en-US" sz="1600" b="1" dirty="0">
-                <a:solidFill>
-                  <a:schemeClr val="bg1"/>
-                </a:solidFill>
-              </a:rPr>
-              <a:t>1</a:t>
-            </a:r>
-            <a:endParaRPr lang="en-US" sz="1600" dirty="0"/>
-          </a:p>
-        </p:txBody>
-      </p:sp>
-      <p:sp>
-        <p:nvSpPr>
-          <p:cNvPr id="6" name="Text 4"/>
-          <p:cNvSpPr txBox="1"/>
-          <p:nvPr/>
-        </p:nvSpPr>
-        <p:spPr>
-          <a:xfrm>
-            <a:off x="1371600" y="1645920"/>
-            <a:ext cx="4416552" cy="594360"/>
-          </a:xfrm>
-          <a:prstGeom prst="rect">
-            <a:avLst/>
-          </a:prstGeom>
-          <a:noFill/>
-          <a:ln/>
-        </p:spPr>
-        <p:txBody>
-          <a:bodyPr wrap="square" lIns="0" tIns="0" rIns="0" bIns="0" rtlCol="0" anchor="ctr"/>
-          <a:lstStyle/>
-          <a:p>
             <a:pPr indent="0" marL="0">
               <a:buNone/>
             </a:pPr>
             <a:r>
-              <a:rPr lang="en-US" sz="1800" b="1" dirty="0">
+              <a:rPr lang="en-US" sz="1900" b="1" dirty="0">
                 <a:solidFill>
                   <a:schemeClr val="tx1"/>
                 </a:solidFill>
@@ -20765,22 +22246,22 @@
                 <a:ea typeface="Cambria" pitchFamily="34" charset="-122"/>
                 <a:cs typeface="Cambria" pitchFamily="34" charset="-120"/>
               </a:rPr>
-              <a:t>Size is predictable; direction isn’t</a:t>
-            </a:r>
-            <a:endParaRPr lang="en-US" sz="1800" dirty="0"/>
-          </a:p>
-        </p:txBody>
-      </p:sp>
-      <p:sp>
-        <p:nvSpPr>
-          <p:cNvPr id="7" name="Text 5"/>
+              <a:t>Partly our own limits</a:t>
+            </a:r>
+            <a:endParaRPr lang="en-US" sz="1900" dirty="0"/>
+          </a:p>
+        </p:txBody>
+      </p:sp>
+      <p:sp>
+        <p:nvSpPr>
+          <p:cNvPr id="8" name="Text 6"/>
           <p:cNvSpPr txBox="1"/>
           <p:nvPr/>
         </p:nvSpPr>
         <p:spPr>
           <a:xfrm>
-            <a:off x="777240" y="2350008"/>
-            <a:ext cx="5010912" cy="987552"/>
+            <a:off x="4297680" y="2514600"/>
+            <a:ext cx="7116775" cy="1024128"/>
           </a:xfrm>
           <a:prstGeom prst="rect">
             <a:avLst/>
@@ -20789,7 +22270,7 @@
           <a:ln/>
         </p:spPr>
         <p:txBody>
-          <a:bodyPr wrap="square" lIns="0" tIns="0" rIns="0" bIns="0" rtlCol="0" anchor="t"/>
+          <a:bodyPr wrap="square" lIns="0" tIns="0" rIns="0" bIns="0" rtlCol="0" anchor="ctr"/>
           <a:lstStyle/>
           <a:p>
             <a:pPr indent="0" marL="0">
@@ -20801,7 +22282,7 @@
                   <a:schemeClr val="tx2"/>
                 </a:solidFill>
               </a:rPr>
-              <a:t>Big-move weeks cluster together, so the model can see them coming. Which way they go is close to a coin flip.</a:t>
+              <a:t>One fund, all in or all out, price data only, a one-week horizon. Lifting these makes the task easier, but wouldn’t flip the result: even with zero fees, v1 still lost.</a:t>
             </a:r>
             <a:endParaRPr lang="en-US" sz="1600" dirty="0"/>
           </a:p>
@@ -20809,18 +22290,18 @@
       </p:sp>
       <p:sp>
         <p:nvSpPr>
-          <p:cNvPr id="8" name="Shape 6"/>
+          <p:cNvPr id="9" name="Shape 7"/>
           <p:cNvSpPr/>
           <p:nvPr/>
         </p:nvSpPr>
         <p:spPr>
           <a:xfrm>
-            <a:off x="6172200" y="1417320"/>
-            <a:ext cx="5468112" cy="2103120"/>
+            <a:off x="548640" y="3657600"/>
+            <a:ext cx="11094415" cy="1024128"/>
           </a:xfrm>
           <a:prstGeom prst="roundRect">
             <a:avLst>
-              <a:gd name="adj" fmla="val 5217"/>
+              <a:gd name="adj" fmla="val 8929"/>
             </a:avLst>
           </a:prstGeom>
           <a:solidFill>
@@ -20836,39 +22317,14 @@
       </p:sp>
       <p:sp>
         <p:nvSpPr>
-          <p:cNvPr id="9" name="Shape 7"/>
-          <p:cNvSpPr/>
-          <p:nvPr/>
-        </p:nvSpPr>
-        <p:spPr>
-          <a:xfrm>
-            <a:off x="6400800" y="1645920"/>
-            <a:ext cx="438912" cy="438912"/>
-          </a:xfrm>
-          <a:prstGeom prst="ellipse">
-            <a:avLst/>
-          </a:prstGeom>
-          <a:solidFill>
-            <a:schemeClr val="accent1"/>
-          </a:solidFill>
-          <a:ln w="12700">
-            <a:solidFill>
-              <a:schemeClr val="accent1"/>
-            </a:solidFill>
-            <a:prstDash val="solid"/>
-          </a:ln>
-        </p:spPr>
-      </p:sp>
-      <p:sp>
-        <p:nvSpPr>
           <p:cNvPr id="10" name="Text 8"/>
           <p:cNvSpPr txBox="1"/>
           <p:nvPr/>
         </p:nvSpPr>
         <p:spPr>
           <a:xfrm>
-            <a:off x="6400800" y="1645920"/>
-            <a:ext cx="438912" cy="438912"/>
+            <a:off x="822960" y="3657600"/>
+            <a:ext cx="3291840" cy="1024128"/>
           </a:xfrm>
           <a:prstGeom prst="rect">
             <a:avLst/>
@@ -20880,47 +22336,11 @@
           <a:bodyPr wrap="square" lIns="0" tIns="0" rIns="0" bIns="0" rtlCol="0" anchor="ctr"/>
           <a:lstStyle/>
           <a:p>
-            <a:pPr algn="ctr" indent="0" marL="0">
-              <a:buNone/>
-            </a:pPr>
-            <a:r>
-              <a:rPr lang="en-US" sz="1600" b="1" dirty="0">
-                <a:solidFill>
-                  <a:schemeClr val="bg1"/>
-                </a:solidFill>
-              </a:rPr>
-              <a:t>2</a:t>
-            </a:r>
-            <a:endParaRPr lang="en-US" sz="1600" dirty="0"/>
-          </a:p>
-        </p:txBody>
-      </p:sp>
-      <p:sp>
-        <p:nvSpPr>
-          <p:cNvPr id="11" name="Text 9"/>
-          <p:cNvSpPr txBox="1"/>
-          <p:nvPr/>
-        </p:nvSpPr>
-        <p:spPr>
-          <a:xfrm>
-            <a:off x="6995160" y="1645920"/>
-            <a:ext cx="4416552" cy="438912"/>
-          </a:xfrm>
-          <a:prstGeom prst="rect">
-            <a:avLst/>
-          </a:prstGeom>
-          <a:noFill/>
-          <a:ln/>
-        </p:spPr>
-        <p:txBody>
-          <a:bodyPr wrap="square" lIns="0" tIns="0" rIns="0" bIns="0" rtlCol="0" anchor="ctr"/>
-          <a:lstStyle/>
-          <a:p>
             <a:pPr indent="0" marL="0">
               <a:buNone/>
             </a:pPr>
             <a:r>
-              <a:rPr lang="en-US" sz="1800" b="1" dirty="0">
+              <a:rPr lang="en-US" sz="1900" b="1" dirty="0">
                 <a:solidFill>
                   <a:schemeClr val="tx1"/>
                 </a:solidFill>
@@ -20928,22 +22348,22 @@
                 <a:ea typeface="Cambria" pitchFamily="34" charset="-122"/>
                 <a:cs typeface="Cambria" pitchFamily="34" charset="-120"/>
               </a:rPr>
-              <a:t>Sitting in cash has a cost</a:t>
-            </a:r>
-            <a:endParaRPr lang="en-US" sz="1800" dirty="0"/>
-          </a:p>
-        </p:txBody>
-      </p:sp>
-      <p:sp>
-        <p:nvSpPr>
-          <p:cNvPr id="12" name="Text 10"/>
+              <a:t>Where machine learning does help</a:t>
+            </a:r>
+            <a:endParaRPr lang="en-US" sz="1900" dirty="0"/>
+          </a:p>
+        </p:txBody>
+      </p:sp>
+      <p:sp>
+        <p:nvSpPr>
+          <p:cNvPr id="11" name="Text 9"/>
           <p:cNvSpPr txBox="1"/>
           <p:nvPr/>
         </p:nvSpPr>
         <p:spPr>
           <a:xfrm>
-            <a:off x="6400800" y="2194560"/>
-            <a:ext cx="5010912" cy="1143000"/>
+            <a:off x="4297680" y="3657600"/>
+            <a:ext cx="7116775" cy="1024128"/>
           </a:xfrm>
           <a:prstGeom prst="rect">
             <a:avLst/>
@@ -20952,7 +22372,7 @@
           <a:ln/>
         </p:spPr>
         <p:txBody>
-          <a:bodyPr wrap="square" lIns="0" tIns="0" rIns="0" bIns="0" rtlCol="0" anchor="t"/>
+          <a:bodyPr wrap="square" lIns="0" tIns="0" rIns="0" bIns="0" rtlCol="0" anchor="ctr"/>
           <a:lstStyle/>
           <a:p>
             <a:pPr indent="0" marL="0">
@@ -20964,7 +22384,7 @@
                   <a:schemeClr val="tx2"/>
                 </a:solidFill>
               </a:rPr>
-              <a:t>The market mostly goes up. Without real timing skill, every day out of the market loses money on average.</a:t>
+              <a:t>Ranking many assets against each other, forecasting risk to size positions, and using data most people don’t have. Even there the edges are usually small and shrink after costs.</a:t>
             </a:r>
             <a:endParaRPr lang="en-US" sz="1600" dirty="0"/>
           </a:p>
@@ -20972,18 +22392,18 @@
       </p:sp>
       <p:sp>
         <p:nvSpPr>
-          <p:cNvPr id="13" name="Shape 11"/>
+          <p:cNvPr id="12" name="Shape 10"/>
           <p:cNvSpPr/>
           <p:nvPr/>
         </p:nvSpPr>
         <p:spPr>
           <a:xfrm>
-            <a:off x="548640" y="3703320"/>
-            <a:ext cx="5468112" cy="2103120"/>
+            <a:off x="548640" y="4800600"/>
+            <a:ext cx="11094415" cy="1024128"/>
           </a:xfrm>
           <a:prstGeom prst="roundRect">
             <a:avLst>
-              <a:gd name="adj" fmla="val 5217"/>
+              <a:gd name="adj" fmla="val 8929"/>
             </a:avLst>
           </a:prstGeom>
           <a:solidFill>
@@ -20999,39 +22419,14 @@
       </p:sp>
       <p:sp>
         <p:nvSpPr>
-          <p:cNvPr id="14" name="Shape 12"/>
-          <p:cNvSpPr/>
-          <p:nvPr/>
-        </p:nvSpPr>
-        <p:spPr>
-          <a:xfrm>
-            <a:off x="777240" y="3931920"/>
-            <a:ext cx="438912" cy="438912"/>
-          </a:xfrm>
-          <a:prstGeom prst="ellipse">
-            <a:avLst/>
-          </a:prstGeom>
-          <a:solidFill>
-            <a:schemeClr val="accent1"/>
-          </a:solidFill>
-          <a:ln w="12700">
-            <a:solidFill>
-              <a:schemeClr val="accent1"/>
-            </a:solidFill>
-            <a:prstDash val="solid"/>
-          </a:ln>
-        </p:spPr>
-      </p:sp>
-      <p:sp>
-        <p:nvSpPr>
-          <p:cNvPr id="15" name="Text 13"/>
+          <p:cNvPr id="13" name="Text 11"/>
           <p:cNvSpPr txBox="1"/>
           <p:nvPr/>
         </p:nvSpPr>
         <p:spPr>
           <a:xfrm>
-            <a:off x="777240" y="3931920"/>
-            <a:ext cx="438912" cy="438912"/>
+            <a:off x="822960" y="4800600"/>
+            <a:ext cx="3291840" cy="1024128"/>
           </a:xfrm>
           <a:prstGeom prst="rect">
             <a:avLst/>
@@ -21043,47 +22438,11 @@
           <a:bodyPr wrap="square" lIns="0" tIns="0" rIns="0" bIns="0" rtlCol="0" anchor="ctr"/>
           <a:lstStyle/>
           <a:p>
-            <a:pPr algn="ctr" indent="0" marL="0">
-              <a:buNone/>
-            </a:pPr>
-            <a:r>
-              <a:rPr lang="en-US" sz="1600" b="1" dirty="0">
-                <a:solidFill>
-                  <a:schemeClr val="bg1"/>
-                </a:solidFill>
-              </a:rPr>
-              <a:t>3</a:t>
-            </a:r>
-            <a:endParaRPr lang="en-US" sz="1600" dirty="0"/>
-          </a:p>
-        </p:txBody>
-      </p:sp>
-      <p:sp>
-        <p:nvSpPr>
-          <p:cNvPr id="16" name="Text 14"/>
-          <p:cNvSpPr txBox="1"/>
-          <p:nvPr/>
-        </p:nvSpPr>
-        <p:spPr>
-          <a:xfrm>
-            <a:off x="1371600" y="3931920"/>
-            <a:ext cx="4416552" cy="438912"/>
-          </a:xfrm>
-          <a:prstGeom prst="rect">
-            <a:avLst/>
-          </a:prstGeom>
-          <a:noFill/>
-          <a:ln/>
-        </p:spPr>
-        <p:txBody>
-          <a:bodyPr wrap="square" lIns="0" tIns="0" rIns="0" bIns="0" rtlCol="0" anchor="ctr"/>
-          <a:lstStyle/>
-          <a:p>
             <a:pPr indent="0" marL="0">
               <a:buNone/>
             </a:pPr>
             <a:r>
-              <a:rPr lang="en-US" sz="1800" b="1" dirty="0">
+              <a:rPr lang="en-US" sz="1900" b="1" dirty="0">
                 <a:solidFill>
                   <a:schemeClr val="tx1"/>
                 </a:solidFill>
@@ -21091,22 +22450,22 @@
                 <a:ea typeface="Cambria" pitchFamily="34" charset="-122"/>
                 <a:cs typeface="Cambria" pitchFamily="34" charset="-120"/>
               </a:rPr>
-              <a:t>The past changes</a:t>
-            </a:r>
-            <a:endParaRPr lang="en-US" sz="1800" dirty="0"/>
-          </a:p>
-        </p:txBody>
-      </p:sp>
-      <p:sp>
-        <p:nvSpPr>
-          <p:cNvPr id="17" name="Text 15"/>
+              <a:t>The fair bar</a:t>
+            </a:r>
+            <a:endParaRPr lang="en-US" sz="1900" dirty="0"/>
+          </a:p>
+        </p:txBody>
+      </p:sp>
+      <p:sp>
+        <p:nvSpPr>
+          <p:cNvPr id="14" name="Text 12"/>
           <p:cNvSpPr txBox="1"/>
           <p:nvPr/>
         </p:nvSpPr>
         <p:spPr>
           <a:xfrm>
-            <a:off x="777240" y="4480560"/>
-            <a:ext cx="5010912" cy="1143000"/>
+            <a:off x="4297680" y="4800600"/>
+            <a:ext cx="7116775" cy="1024128"/>
           </a:xfrm>
           <a:prstGeom prst="rect">
             <a:avLst/>
@@ -21115,7 +22474,7 @@
           <a:ln/>
         </p:spPr>
         <p:txBody>
-          <a:bodyPr wrap="square" lIns="0" tIns="0" rIns="0" bIns="0" rtlCol="0" anchor="t"/>
+          <a:bodyPr wrap="square" lIns="0" tIns="0" rIns="0" bIns="0" rtlCol="0" anchor="ctr"/>
           <a:lstStyle/>
           <a:p>
             <a:pPr indent="0" marL="0">
@@ -21127,170 +22486,7 @@
                   <a:schemeClr val="tx2"/>
                 </a:solidFill>
               </a:rPr>
-              <a:t>A signal that helped from 2010 to 2020 actually misled the model in 2022.</a:t>
-            </a:r>
-            <a:endParaRPr lang="en-US" sz="1600" dirty="0"/>
-          </a:p>
-        </p:txBody>
-      </p:sp>
-      <p:sp>
-        <p:nvSpPr>
-          <p:cNvPr id="18" name="Shape 16"/>
-          <p:cNvSpPr/>
-          <p:nvPr/>
-        </p:nvSpPr>
-        <p:spPr>
-          <a:xfrm>
-            <a:off x="6172200" y="3703320"/>
-            <a:ext cx="5468112" cy="2103120"/>
-          </a:xfrm>
-          <a:prstGeom prst="roundRect">
-            <a:avLst>
-              <a:gd name="adj" fmla="val 5217"/>
-            </a:avLst>
-          </a:prstGeom>
-          <a:solidFill>
-            <a:schemeClr val="bg2"/>
-          </a:solidFill>
-          <a:ln w="12700">
-            <a:solidFill>
-              <a:schemeClr val="bg2"/>
-            </a:solidFill>
-            <a:prstDash val="solid"/>
-          </a:ln>
-        </p:spPr>
-      </p:sp>
-      <p:sp>
-        <p:nvSpPr>
-          <p:cNvPr id="19" name="Shape 17"/>
-          <p:cNvSpPr/>
-          <p:nvPr/>
-        </p:nvSpPr>
-        <p:spPr>
-          <a:xfrm>
-            <a:off x="6400800" y="3931920"/>
-            <a:ext cx="438912" cy="438912"/>
-          </a:xfrm>
-          <a:prstGeom prst="ellipse">
-            <a:avLst/>
-          </a:prstGeom>
-          <a:solidFill>
-            <a:schemeClr val="accent1"/>
-          </a:solidFill>
-          <a:ln w="12700">
-            <a:solidFill>
-              <a:schemeClr val="accent1"/>
-            </a:solidFill>
-            <a:prstDash val="solid"/>
-          </a:ln>
-        </p:spPr>
-      </p:sp>
-      <p:sp>
-        <p:nvSpPr>
-          <p:cNvPr id="20" name="Text 18"/>
-          <p:cNvSpPr txBox="1"/>
-          <p:nvPr/>
-        </p:nvSpPr>
-        <p:spPr>
-          <a:xfrm>
-            <a:off x="6400800" y="3931920"/>
-            <a:ext cx="438912" cy="438912"/>
-          </a:xfrm>
-          <a:prstGeom prst="rect">
-            <a:avLst/>
-          </a:prstGeom>
-          <a:noFill/>
-          <a:ln/>
-        </p:spPr>
-        <p:txBody>
-          <a:bodyPr wrap="square" lIns="0" tIns="0" rIns="0" bIns="0" rtlCol="0" anchor="ctr"/>
-          <a:lstStyle/>
-          <a:p>
-            <a:pPr algn="ctr" indent="0" marL="0">
-              <a:buNone/>
-            </a:pPr>
-            <a:r>
-              <a:rPr lang="en-US" sz="1600" b="1" dirty="0">
-                <a:solidFill>
-                  <a:schemeClr val="bg1"/>
-                </a:solidFill>
-              </a:rPr>
-              <a:t>4</a:t>
-            </a:r>
-            <a:endParaRPr lang="en-US" sz="1600" dirty="0"/>
-          </a:p>
-        </p:txBody>
-      </p:sp>
-      <p:sp>
-        <p:nvSpPr>
-          <p:cNvPr id="21" name="Text 19"/>
-          <p:cNvSpPr txBox="1"/>
-          <p:nvPr/>
-        </p:nvSpPr>
-        <p:spPr>
-          <a:xfrm>
-            <a:off x="6995160" y="3931920"/>
-            <a:ext cx="4416552" cy="438912"/>
-          </a:xfrm>
-          <a:prstGeom prst="rect">
-            <a:avLst/>
-          </a:prstGeom>
-          <a:noFill/>
-          <a:ln/>
-        </p:spPr>
-        <p:txBody>
-          <a:bodyPr wrap="square" lIns="0" tIns="0" rIns="0" bIns="0" rtlCol="0" anchor="ctr"/>
-          <a:lstStyle/>
-          <a:p>
-            <a:pPr indent="0" marL="0">
-              <a:buNone/>
-            </a:pPr>
-            <a:r>
-              <a:rPr lang="en-US" sz="1800" b="1" dirty="0">
-                <a:solidFill>
-                  <a:schemeClr val="tx1"/>
-                </a:solidFill>
-                <a:latin typeface="Cambria" pitchFamily="34" charset="0"/>
-                <a:ea typeface="Cambria" pitchFamily="34" charset="-122"/>
-                <a:cs typeface="Cambria" pitchFamily="34" charset="-120"/>
-              </a:rPr>
-              <a:t>Good predictions ≠ good trades</a:t>
-            </a:r>
-            <a:endParaRPr lang="en-US" sz="1800" dirty="0"/>
-          </a:p>
-        </p:txBody>
-      </p:sp>
-      <p:sp>
-        <p:nvSpPr>
-          <p:cNvPr id="22" name="Text 20"/>
-          <p:cNvSpPr txBox="1"/>
-          <p:nvPr/>
-        </p:nvSpPr>
-        <p:spPr>
-          <a:xfrm>
-            <a:off x="6400800" y="4480560"/>
-            <a:ext cx="5010912" cy="1143000"/>
-          </a:xfrm>
-          <a:prstGeom prst="rect">
-            <a:avLst/>
-          </a:prstGeom>
-          <a:noFill/>
-          <a:ln/>
-        </p:spPr>
-        <p:txBody>
-          <a:bodyPr wrap="square" lIns="0" tIns="0" rIns="0" bIns="0" rtlCol="0" anchor="t"/>
-          <a:lstStyle/>
-          <a:p>
-            <a:pPr indent="0" marL="0">
-              <a:buNone/>
-            </a:pPr>
-            <a:r>
-              <a:rPr lang="en-US" sz="1600" dirty="0">
-                <a:solidFill>
-                  <a:schemeClr val="tx2"/>
-                </a:solidFill>
-              </a:rPr>
-              <a:t>Settings that improve the prediction score can distort the odds a trading rule relies on. With honest odds (v3), the best rule was not to trade.</a:t>
+              <a:t>Return for the risk taken, and beating random timing — not simply “more money than Buy &amp; Hold”. That is how we judged every version.</a:t>
             </a:r>
             <a:endParaRPr lang="en-US" sz="1600" dirty="0"/>
           </a:p>
@@ -21376,8 +22572,8 @@
         </p:nvSpPr>
         <p:spPr>
           <a:xfrm>
-            <a:off x="548640" y="1097280"/>
-            <a:ext cx="10789920" cy="2560320"/>
+            <a:off x="548640" y="365760"/>
+            <a:ext cx="11094415" cy="822960"/>
           </a:xfrm>
           <a:prstGeom prst="rect">
             <a:avLst/>
@@ -21386,39 +22582,89 @@
           <a:ln/>
         </p:spPr>
         <p:txBody>
-          <a:bodyPr wrap="square" rtlCol="0" anchor="b"/>
+          <a:bodyPr wrap="square" rtlCol="0" anchor="ctr"/>
           <a:lstStyle/>
           <a:p>
             <a:pPr indent="0" marL="0">
               <a:buNone/>
             </a:pPr>
             <a:r>
-              <a:rPr lang="en-US" sz="4000" b="1" dirty="0">
-                <a:solidFill>
-                  <a:schemeClr val="bg1"/>
+              <a:rPr lang="en-US" sz="3200" b="1" dirty="0">
+                <a:solidFill>
+                  <a:schemeClr val="tx1"/>
                 </a:solidFill>
                 <a:latin typeface="Cambria" pitchFamily="34" charset="0"/>
                 <a:ea typeface="Cambria" pitchFamily="34" charset="-122"/>
                 <a:cs typeface="Cambria" pitchFamily="34" charset="-120"/>
               </a:rPr>
-              <a:t>Questions?</a:t>
-            </a:r>
-            <a:endParaRPr lang="en-US" sz="4000" dirty="0"/>
-          </a:p>
-        </p:txBody>
-      </p:sp>
-      <p:sp>
-        <p:nvSpPr>
-          <p:cNvPr id="3" name="Text 0"/>
+              <a:t>What we learned</a:t>
+            </a:r>
+            <a:endParaRPr lang="en-US" sz="3200" dirty="0"/>
+          </a:p>
+        </p:txBody>
+      </p:sp>
+      <p:sp>
+        <p:nvSpPr>
+          <p:cNvPr id="3" name="Shape 1"/>
           <p:cNvSpPr/>
-          <p:nvPr>
-            <p:ph idx="101" type="body" hasCustomPrompt="1"/>
-          </p:nvPr>
-        </p:nvSpPr>
-        <p:spPr>
-          <a:xfrm>
-            <a:off x="548640" y="3931920"/>
-            <a:ext cx="10424160" cy="2103120"/>
+          <p:nvPr/>
+        </p:nvSpPr>
+        <p:spPr>
+          <a:xfrm>
+            <a:off x="548640" y="1417320"/>
+            <a:ext cx="5468112" cy="2103120"/>
+          </a:xfrm>
+          <a:prstGeom prst="roundRect">
+            <a:avLst>
+              <a:gd name="adj" fmla="val 5217"/>
+            </a:avLst>
+          </a:prstGeom>
+          <a:solidFill>
+            <a:schemeClr val="bg2"/>
+          </a:solidFill>
+          <a:ln w="12700">
+            <a:solidFill>
+              <a:schemeClr val="bg2"/>
+            </a:solidFill>
+            <a:prstDash val="solid"/>
+          </a:ln>
+        </p:spPr>
+      </p:sp>
+      <p:sp>
+        <p:nvSpPr>
+          <p:cNvPr id="4" name="Shape 2"/>
+          <p:cNvSpPr/>
+          <p:nvPr/>
+        </p:nvSpPr>
+        <p:spPr>
+          <a:xfrm>
+            <a:off x="777240" y="1645920"/>
+            <a:ext cx="438912" cy="438912"/>
+          </a:xfrm>
+          <a:prstGeom prst="ellipse">
+            <a:avLst/>
+          </a:prstGeom>
+          <a:solidFill>
+            <a:schemeClr val="accent1"/>
+          </a:solidFill>
+          <a:ln w="12700">
+            <a:solidFill>
+              <a:schemeClr val="accent1"/>
+            </a:solidFill>
+            <a:prstDash val="solid"/>
+          </a:ln>
+        </p:spPr>
+      </p:sp>
+      <p:sp>
+        <p:nvSpPr>
+          <p:cNvPr id="5" name="Text 3"/>
+          <p:cNvSpPr txBox="1"/>
+          <p:nvPr/>
+        </p:nvSpPr>
+        <p:spPr>
+          <a:xfrm>
+            <a:off x="777240" y="1645920"/>
+            <a:ext cx="438912" cy="438912"/>
           </a:xfrm>
           <a:prstGeom prst="rect">
             <a:avLst/>
@@ -21427,49 +22673,585 @@
           <a:ln/>
         </p:spPr>
         <p:txBody>
-          <a:bodyPr wrap="square" rtlCol="0" anchor="t"/>
+          <a:bodyPr wrap="square" lIns="0" tIns="0" rIns="0" bIns="0" rtlCol="0" anchor="ctr"/>
+          <a:lstStyle/>
+          <a:p>
+            <a:pPr algn="ctr" indent="0" marL="0">
+              <a:buNone/>
+            </a:pPr>
+            <a:r>
+              <a:rPr lang="en-US" sz="1600" b="1" dirty="0">
+                <a:solidFill>
+                  <a:schemeClr val="bg1"/>
+                </a:solidFill>
+              </a:rPr>
+              <a:t>1</a:t>
+            </a:r>
+            <a:endParaRPr lang="en-US" sz="1600" dirty="0"/>
+          </a:p>
+        </p:txBody>
+      </p:sp>
+      <p:sp>
+        <p:nvSpPr>
+          <p:cNvPr id="6" name="Text 4"/>
+          <p:cNvSpPr txBox="1"/>
+          <p:nvPr/>
+        </p:nvSpPr>
+        <p:spPr>
+          <a:xfrm>
+            <a:off x="1371600" y="1645920"/>
+            <a:ext cx="4416552" cy="594360"/>
+          </a:xfrm>
+          <a:prstGeom prst="rect">
+            <a:avLst/>
+          </a:prstGeom>
+          <a:noFill/>
+          <a:ln/>
+        </p:spPr>
+        <p:txBody>
+          <a:bodyPr wrap="square" lIns="0" tIns="0" rIns="0" bIns="0" rtlCol="0" anchor="ctr"/>
           <a:lstStyle/>
           <a:p>
             <a:pPr indent="0" marL="0">
               <a:buNone/>
             </a:pPr>
             <a:r>
-              <a:rPr lang="en-US" sz="2100" dirty="0">
-                <a:solidFill>
-                  <a:schemeClr val="bg2"/>
-                </a:solidFill>
-              </a:rPr>
-              <a:t>$100,000 in 2023–24 → $156,546 by waiting, $123,714 with v1, $121,812 with v2. With honest odds, v3’s best rule is not to trade.</a:t>
-            </a:r>
-            <a:endParaRPr lang="en-US" sz="2100" dirty="0"/>
-          </a:p>
+              <a:rPr lang="en-US" sz="1800" b="1" dirty="0">
+                <a:solidFill>
+                  <a:schemeClr val="tx1"/>
+                </a:solidFill>
+                <a:latin typeface="Cambria" pitchFamily="34" charset="0"/>
+                <a:ea typeface="Cambria" pitchFamily="34" charset="-122"/>
+                <a:cs typeface="Cambria" pitchFamily="34" charset="-120"/>
+              </a:rPr>
+              <a:t>Size is predictable; direction isn’t</a:t>
+            </a:r>
+            <a:endParaRPr lang="en-US" sz="1800" dirty="0"/>
+          </a:p>
+        </p:txBody>
+      </p:sp>
+      <p:sp>
+        <p:nvSpPr>
+          <p:cNvPr id="7" name="Text 5"/>
+          <p:cNvSpPr txBox="1"/>
+          <p:nvPr/>
+        </p:nvSpPr>
+        <p:spPr>
+          <a:xfrm>
+            <a:off x="777240" y="2350008"/>
+            <a:ext cx="5010912" cy="987552"/>
+          </a:xfrm>
+          <a:prstGeom prst="rect">
+            <a:avLst/>
+          </a:prstGeom>
+          <a:noFill/>
+          <a:ln/>
+        </p:spPr>
+        <p:txBody>
+          <a:bodyPr wrap="square" lIns="0" tIns="0" rIns="0" bIns="0" rtlCol="0" anchor="t"/>
+          <a:lstStyle/>
           <a:p>
             <a:pPr indent="0" marL="0">
               <a:buNone/>
             </a:pPr>
             <a:r>
-              <a:rPr lang="en-US" sz="2100" dirty="0">
-                <a:solidFill>
-                  <a:schemeClr val="bg2"/>
-                </a:solidFill>
-              </a:rPr>
-              <a:t> </a:t>
-            </a:r>
-            <a:endParaRPr lang="en-US" sz="2100" dirty="0"/>
-          </a:p>
+              <a:rPr lang="en-US" sz="1600" dirty="0">
+                <a:solidFill>
+                  <a:schemeClr val="tx2"/>
+                </a:solidFill>
+              </a:rPr>
+              <a:t>Big-move weeks cluster together, so the model can see them coming. Which way they go is close to a coin flip.</a:t>
+            </a:r>
+            <a:endParaRPr lang="en-US" sz="1600" dirty="0"/>
+          </a:p>
+        </p:txBody>
+      </p:sp>
+      <p:sp>
+        <p:nvSpPr>
+          <p:cNvPr id="8" name="Shape 6"/>
+          <p:cNvSpPr/>
+          <p:nvPr/>
+        </p:nvSpPr>
+        <p:spPr>
+          <a:xfrm>
+            <a:off x="6172200" y="1417320"/>
+            <a:ext cx="5468112" cy="2103120"/>
+          </a:xfrm>
+          <a:prstGeom prst="roundRect">
+            <a:avLst>
+              <a:gd name="adj" fmla="val 5217"/>
+            </a:avLst>
+          </a:prstGeom>
+          <a:solidFill>
+            <a:schemeClr val="bg2"/>
+          </a:solidFill>
+          <a:ln w="12700">
+            <a:solidFill>
+              <a:schemeClr val="bg2"/>
+            </a:solidFill>
+            <a:prstDash val="solid"/>
+          </a:ln>
+        </p:spPr>
+      </p:sp>
+      <p:sp>
+        <p:nvSpPr>
+          <p:cNvPr id="9" name="Shape 7"/>
+          <p:cNvSpPr/>
+          <p:nvPr/>
+        </p:nvSpPr>
+        <p:spPr>
+          <a:xfrm>
+            <a:off x="6400800" y="1645920"/>
+            <a:ext cx="438912" cy="438912"/>
+          </a:xfrm>
+          <a:prstGeom prst="ellipse">
+            <a:avLst/>
+          </a:prstGeom>
+          <a:solidFill>
+            <a:schemeClr val="accent1"/>
+          </a:solidFill>
+          <a:ln w="12700">
+            <a:solidFill>
+              <a:schemeClr val="accent1"/>
+            </a:solidFill>
+            <a:prstDash val="solid"/>
+          </a:ln>
+        </p:spPr>
+      </p:sp>
+      <p:sp>
+        <p:nvSpPr>
+          <p:cNvPr id="10" name="Text 8"/>
+          <p:cNvSpPr txBox="1"/>
+          <p:nvPr/>
+        </p:nvSpPr>
+        <p:spPr>
+          <a:xfrm>
+            <a:off x="6400800" y="1645920"/>
+            <a:ext cx="438912" cy="438912"/>
+          </a:xfrm>
+          <a:prstGeom prst="rect">
+            <a:avLst/>
+          </a:prstGeom>
+          <a:noFill/>
+          <a:ln/>
+        </p:spPr>
+        <p:txBody>
+          <a:bodyPr wrap="square" lIns="0" tIns="0" rIns="0" bIns="0" rtlCol="0" anchor="ctr"/>
+          <a:lstStyle/>
+          <a:p>
+            <a:pPr algn="ctr" indent="0" marL="0">
+              <a:buNone/>
+            </a:pPr>
+            <a:r>
+              <a:rPr lang="en-US" sz="1600" b="1" dirty="0">
+                <a:solidFill>
+                  <a:schemeClr val="bg1"/>
+                </a:solidFill>
+              </a:rPr>
+              <a:t>2</a:t>
+            </a:r>
+            <a:endParaRPr lang="en-US" sz="1600" dirty="0"/>
+          </a:p>
+        </p:txBody>
+      </p:sp>
+      <p:sp>
+        <p:nvSpPr>
+          <p:cNvPr id="11" name="Text 9"/>
+          <p:cNvSpPr txBox="1"/>
+          <p:nvPr/>
+        </p:nvSpPr>
+        <p:spPr>
+          <a:xfrm>
+            <a:off x="6995160" y="1645920"/>
+            <a:ext cx="4416552" cy="438912"/>
+          </a:xfrm>
+          <a:prstGeom prst="rect">
+            <a:avLst/>
+          </a:prstGeom>
+          <a:noFill/>
+          <a:ln/>
+        </p:spPr>
+        <p:txBody>
+          <a:bodyPr wrap="square" lIns="0" tIns="0" rIns="0" bIns="0" rtlCol="0" anchor="ctr"/>
+          <a:lstStyle/>
           <a:p>
             <a:pPr indent="0" marL="0">
               <a:buNone/>
             </a:pPr>
             <a:r>
-              <a:rPr lang="en-US" sz="1800" dirty="0">
-                <a:solidFill>
-                  <a:schemeClr val="accent4"/>
-                </a:solidFill>
-              </a:rPr>
-              <a:t>github.com/TKCH121/spy</a:t>
-            </a:r>
-            <a:endParaRPr lang="en-US" sz="2100" dirty="0"/>
+              <a:rPr lang="en-US" sz="1800" b="1" dirty="0">
+                <a:solidFill>
+                  <a:schemeClr val="tx1"/>
+                </a:solidFill>
+                <a:latin typeface="Cambria" pitchFamily="34" charset="0"/>
+                <a:ea typeface="Cambria" pitchFamily="34" charset="-122"/>
+                <a:cs typeface="Cambria" pitchFamily="34" charset="-120"/>
+              </a:rPr>
+              <a:t>Sitting in cash has a cost</a:t>
+            </a:r>
+            <a:endParaRPr lang="en-US" sz="1800" dirty="0"/>
+          </a:p>
+        </p:txBody>
+      </p:sp>
+      <p:sp>
+        <p:nvSpPr>
+          <p:cNvPr id="12" name="Text 10"/>
+          <p:cNvSpPr txBox="1"/>
+          <p:nvPr/>
+        </p:nvSpPr>
+        <p:spPr>
+          <a:xfrm>
+            <a:off x="6400800" y="2194560"/>
+            <a:ext cx="5010912" cy="1143000"/>
+          </a:xfrm>
+          <a:prstGeom prst="rect">
+            <a:avLst/>
+          </a:prstGeom>
+          <a:noFill/>
+          <a:ln/>
+        </p:spPr>
+        <p:txBody>
+          <a:bodyPr wrap="square" lIns="0" tIns="0" rIns="0" bIns="0" rtlCol="0" anchor="t"/>
+          <a:lstStyle/>
+          <a:p>
+            <a:pPr indent="0" marL="0">
+              <a:buNone/>
+            </a:pPr>
+            <a:r>
+              <a:rPr lang="en-US" sz="1600" dirty="0">
+                <a:solidFill>
+                  <a:schemeClr val="tx2"/>
+                </a:solidFill>
+              </a:rPr>
+              <a:t>The market mostly goes up. Without real timing skill, every day out of the market loses money on average.</a:t>
+            </a:r>
+            <a:endParaRPr lang="en-US" sz="1600" dirty="0"/>
+          </a:p>
+        </p:txBody>
+      </p:sp>
+      <p:sp>
+        <p:nvSpPr>
+          <p:cNvPr id="13" name="Shape 11"/>
+          <p:cNvSpPr/>
+          <p:nvPr/>
+        </p:nvSpPr>
+        <p:spPr>
+          <a:xfrm>
+            <a:off x="548640" y="3703320"/>
+            <a:ext cx="5468112" cy="2103120"/>
+          </a:xfrm>
+          <a:prstGeom prst="roundRect">
+            <a:avLst>
+              <a:gd name="adj" fmla="val 5217"/>
+            </a:avLst>
+          </a:prstGeom>
+          <a:solidFill>
+            <a:schemeClr val="bg2"/>
+          </a:solidFill>
+          <a:ln w="12700">
+            <a:solidFill>
+              <a:schemeClr val="bg2"/>
+            </a:solidFill>
+            <a:prstDash val="solid"/>
+          </a:ln>
+        </p:spPr>
+      </p:sp>
+      <p:sp>
+        <p:nvSpPr>
+          <p:cNvPr id="14" name="Shape 12"/>
+          <p:cNvSpPr/>
+          <p:nvPr/>
+        </p:nvSpPr>
+        <p:spPr>
+          <a:xfrm>
+            <a:off x="777240" y="3931920"/>
+            <a:ext cx="438912" cy="438912"/>
+          </a:xfrm>
+          <a:prstGeom prst="ellipse">
+            <a:avLst/>
+          </a:prstGeom>
+          <a:solidFill>
+            <a:schemeClr val="accent1"/>
+          </a:solidFill>
+          <a:ln w="12700">
+            <a:solidFill>
+              <a:schemeClr val="accent1"/>
+            </a:solidFill>
+            <a:prstDash val="solid"/>
+          </a:ln>
+        </p:spPr>
+      </p:sp>
+      <p:sp>
+        <p:nvSpPr>
+          <p:cNvPr id="15" name="Text 13"/>
+          <p:cNvSpPr txBox="1"/>
+          <p:nvPr/>
+        </p:nvSpPr>
+        <p:spPr>
+          <a:xfrm>
+            <a:off x="777240" y="3931920"/>
+            <a:ext cx="438912" cy="438912"/>
+          </a:xfrm>
+          <a:prstGeom prst="rect">
+            <a:avLst/>
+          </a:prstGeom>
+          <a:noFill/>
+          <a:ln/>
+        </p:spPr>
+        <p:txBody>
+          <a:bodyPr wrap="square" lIns="0" tIns="0" rIns="0" bIns="0" rtlCol="0" anchor="ctr"/>
+          <a:lstStyle/>
+          <a:p>
+            <a:pPr algn="ctr" indent="0" marL="0">
+              <a:buNone/>
+            </a:pPr>
+            <a:r>
+              <a:rPr lang="en-US" sz="1600" b="1" dirty="0">
+                <a:solidFill>
+                  <a:schemeClr val="bg1"/>
+                </a:solidFill>
+              </a:rPr>
+              <a:t>3</a:t>
+            </a:r>
+            <a:endParaRPr lang="en-US" sz="1600" dirty="0"/>
+          </a:p>
+        </p:txBody>
+      </p:sp>
+      <p:sp>
+        <p:nvSpPr>
+          <p:cNvPr id="16" name="Text 14"/>
+          <p:cNvSpPr txBox="1"/>
+          <p:nvPr/>
+        </p:nvSpPr>
+        <p:spPr>
+          <a:xfrm>
+            <a:off x="1371600" y="3931920"/>
+            <a:ext cx="4416552" cy="438912"/>
+          </a:xfrm>
+          <a:prstGeom prst="rect">
+            <a:avLst/>
+          </a:prstGeom>
+          <a:noFill/>
+          <a:ln/>
+        </p:spPr>
+        <p:txBody>
+          <a:bodyPr wrap="square" lIns="0" tIns="0" rIns="0" bIns="0" rtlCol="0" anchor="ctr"/>
+          <a:lstStyle/>
+          <a:p>
+            <a:pPr indent="0" marL="0">
+              <a:buNone/>
+            </a:pPr>
+            <a:r>
+              <a:rPr lang="en-US" sz="1800" b="1" dirty="0">
+                <a:solidFill>
+                  <a:schemeClr val="tx1"/>
+                </a:solidFill>
+                <a:latin typeface="Cambria" pitchFamily="34" charset="0"/>
+                <a:ea typeface="Cambria" pitchFamily="34" charset="-122"/>
+                <a:cs typeface="Cambria" pitchFamily="34" charset="-120"/>
+              </a:rPr>
+              <a:t>The past changes</a:t>
+            </a:r>
+            <a:endParaRPr lang="en-US" sz="1800" dirty="0"/>
+          </a:p>
+        </p:txBody>
+      </p:sp>
+      <p:sp>
+        <p:nvSpPr>
+          <p:cNvPr id="17" name="Text 15"/>
+          <p:cNvSpPr txBox="1"/>
+          <p:nvPr/>
+        </p:nvSpPr>
+        <p:spPr>
+          <a:xfrm>
+            <a:off x="777240" y="4480560"/>
+            <a:ext cx="5010912" cy="1143000"/>
+          </a:xfrm>
+          <a:prstGeom prst="rect">
+            <a:avLst/>
+          </a:prstGeom>
+          <a:noFill/>
+          <a:ln/>
+        </p:spPr>
+        <p:txBody>
+          <a:bodyPr wrap="square" lIns="0" tIns="0" rIns="0" bIns="0" rtlCol="0" anchor="t"/>
+          <a:lstStyle/>
+          <a:p>
+            <a:pPr indent="0" marL="0">
+              <a:buNone/>
+            </a:pPr>
+            <a:r>
+              <a:rPr lang="en-US" sz="1600" dirty="0">
+                <a:solidFill>
+                  <a:schemeClr val="tx2"/>
+                </a:solidFill>
+              </a:rPr>
+              <a:t>A signal that helped from 2010 to 2020 actually misled the model in 2022.</a:t>
+            </a:r>
+            <a:endParaRPr lang="en-US" sz="1600" dirty="0"/>
+          </a:p>
+        </p:txBody>
+      </p:sp>
+      <p:sp>
+        <p:nvSpPr>
+          <p:cNvPr id="18" name="Shape 16"/>
+          <p:cNvSpPr/>
+          <p:nvPr/>
+        </p:nvSpPr>
+        <p:spPr>
+          <a:xfrm>
+            <a:off x="6172200" y="3703320"/>
+            <a:ext cx="5468112" cy="2103120"/>
+          </a:xfrm>
+          <a:prstGeom prst="roundRect">
+            <a:avLst>
+              <a:gd name="adj" fmla="val 5217"/>
+            </a:avLst>
+          </a:prstGeom>
+          <a:solidFill>
+            <a:schemeClr val="bg2"/>
+          </a:solidFill>
+          <a:ln w="12700">
+            <a:solidFill>
+              <a:schemeClr val="bg2"/>
+            </a:solidFill>
+            <a:prstDash val="solid"/>
+          </a:ln>
+        </p:spPr>
+      </p:sp>
+      <p:sp>
+        <p:nvSpPr>
+          <p:cNvPr id="19" name="Shape 17"/>
+          <p:cNvSpPr/>
+          <p:nvPr/>
+        </p:nvSpPr>
+        <p:spPr>
+          <a:xfrm>
+            <a:off x="6400800" y="3931920"/>
+            <a:ext cx="438912" cy="438912"/>
+          </a:xfrm>
+          <a:prstGeom prst="ellipse">
+            <a:avLst/>
+          </a:prstGeom>
+          <a:solidFill>
+            <a:schemeClr val="accent1"/>
+          </a:solidFill>
+          <a:ln w="12700">
+            <a:solidFill>
+              <a:schemeClr val="accent1"/>
+            </a:solidFill>
+            <a:prstDash val="solid"/>
+          </a:ln>
+        </p:spPr>
+      </p:sp>
+      <p:sp>
+        <p:nvSpPr>
+          <p:cNvPr id="20" name="Text 18"/>
+          <p:cNvSpPr txBox="1"/>
+          <p:nvPr/>
+        </p:nvSpPr>
+        <p:spPr>
+          <a:xfrm>
+            <a:off x="6400800" y="3931920"/>
+            <a:ext cx="438912" cy="438912"/>
+          </a:xfrm>
+          <a:prstGeom prst="rect">
+            <a:avLst/>
+          </a:prstGeom>
+          <a:noFill/>
+          <a:ln/>
+        </p:spPr>
+        <p:txBody>
+          <a:bodyPr wrap="square" lIns="0" tIns="0" rIns="0" bIns="0" rtlCol="0" anchor="ctr"/>
+          <a:lstStyle/>
+          <a:p>
+            <a:pPr algn="ctr" indent="0" marL="0">
+              <a:buNone/>
+            </a:pPr>
+            <a:r>
+              <a:rPr lang="en-US" sz="1600" b="1" dirty="0">
+                <a:solidFill>
+                  <a:schemeClr val="bg1"/>
+                </a:solidFill>
+              </a:rPr>
+              <a:t>4</a:t>
+            </a:r>
+            <a:endParaRPr lang="en-US" sz="1600" dirty="0"/>
+          </a:p>
+        </p:txBody>
+      </p:sp>
+      <p:sp>
+        <p:nvSpPr>
+          <p:cNvPr id="21" name="Text 19"/>
+          <p:cNvSpPr txBox="1"/>
+          <p:nvPr/>
+        </p:nvSpPr>
+        <p:spPr>
+          <a:xfrm>
+            <a:off x="6995160" y="3931920"/>
+            <a:ext cx="4416552" cy="438912"/>
+          </a:xfrm>
+          <a:prstGeom prst="rect">
+            <a:avLst/>
+          </a:prstGeom>
+          <a:noFill/>
+          <a:ln/>
+        </p:spPr>
+        <p:txBody>
+          <a:bodyPr wrap="square" lIns="0" tIns="0" rIns="0" bIns="0" rtlCol="0" anchor="ctr"/>
+          <a:lstStyle/>
+          <a:p>
+            <a:pPr indent="0" marL="0">
+              <a:buNone/>
+            </a:pPr>
+            <a:r>
+              <a:rPr lang="en-US" sz="1800" b="1" dirty="0">
+                <a:solidFill>
+                  <a:schemeClr val="tx1"/>
+                </a:solidFill>
+                <a:latin typeface="Cambria" pitchFamily="34" charset="0"/>
+                <a:ea typeface="Cambria" pitchFamily="34" charset="-122"/>
+                <a:cs typeface="Cambria" pitchFamily="34" charset="-120"/>
+              </a:rPr>
+              <a:t>Good predictions ≠ good trades</a:t>
+            </a:r>
+            <a:endParaRPr lang="en-US" sz="1800" dirty="0"/>
+          </a:p>
+        </p:txBody>
+      </p:sp>
+      <p:sp>
+        <p:nvSpPr>
+          <p:cNvPr id="22" name="Text 20"/>
+          <p:cNvSpPr txBox="1"/>
+          <p:nvPr/>
+        </p:nvSpPr>
+        <p:spPr>
+          <a:xfrm>
+            <a:off x="6400800" y="4480560"/>
+            <a:ext cx="5010912" cy="1143000"/>
+          </a:xfrm>
+          <a:prstGeom prst="rect">
+            <a:avLst/>
+          </a:prstGeom>
+          <a:noFill/>
+          <a:ln/>
+        </p:spPr>
+        <p:txBody>
+          <a:bodyPr wrap="square" lIns="0" tIns="0" rIns="0" bIns="0" rtlCol="0" anchor="t"/>
+          <a:lstStyle/>
+          <a:p>
+            <a:pPr indent="0" marL="0">
+              <a:buNone/>
+            </a:pPr>
+            <a:r>
+              <a:rPr lang="en-US" sz="1600" dirty="0">
+                <a:solidFill>
+                  <a:schemeClr val="tx2"/>
+                </a:solidFill>
+              </a:rPr>
+              <a:t>Settings that improve the prediction score can distort the odds a trading rule relies on. With honest odds (v3), the best rule was not to trade.</a:t>
+            </a:r>
+            <a:endParaRPr lang="en-US" sz="1600" dirty="0"/>
           </a:p>
         </p:txBody>
       </p:sp>
@@ -21513,6 +23295,183 @@
             <a:fld id="{F7021451-1387-4CA6-816F-3879F97B5CBC}" type="slidenum">
               <a:rPr b="0" lang="en-US"/>
               <a:t>28</a:t>
+            </a:fld>
+            <a:endParaRPr lang="en-US"/>
+          </a:p>
+        </p:txBody>
+      </p:sp>
+    </p:spTree>
+  </p:cSld>
+  <p:clrMapOvr>
+    <a:masterClrMapping/>
+  </p:clrMapOvr>
+</p:sld>
+</file>
+
+<file path=ppt/slides/slide29.xml><?xml version="1.0" encoding="utf-8"?>
+<p:sld xmlns:a="http://schemas.openxmlformats.org/drawingml/2006/main" xmlns:r="http://schemas.openxmlformats.org/officeDocument/2006/relationships" xmlns:p="http://schemas.openxmlformats.org/presentationml/2006/main">
+  <p:cSld name="Slide 29">
+    <p:spTree>
+      <p:nvGrpSpPr>
+        <p:cNvPr id="1" name=""/>
+        <p:cNvGrpSpPr/>
+        <p:nvPr/>
+      </p:nvGrpSpPr>
+      <p:grpSpPr>
+        <a:xfrm>
+          <a:off x="0" y="0"/>
+          <a:ext cx="0" cy="0"/>
+          <a:chOff x="0" y="0"/>
+          <a:chExt cx="0" cy="0"/>
+        </a:xfrm>
+      </p:grpSpPr>
+      <p:sp>
+        <p:nvSpPr>
+          <p:cNvPr id="2" name="Text 0"/>
+          <p:cNvSpPr/>
+          <p:nvPr>
+            <p:ph idx="100" type="title" hasCustomPrompt="1"/>
+          </p:nvPr>
+        </p:nvSpPr>
+        <p:spPr>
+          <a:xfrm>
+            <a:off x="548640" y="1097280"/>
+            <a:ext cx="10789920" cy="2560320"/>
+          </a:xfrm>
+          <a:prstGeom prst="rect">
+            <a:avLst/>
+          </a:prstGeom>
+          <a:noFill/>
+          <a:ln/>
+        </p:spPr>
+        <p:txBody>
+          <a:bodyPr wrap="square" rtlCol="0" anchor="b"/>
+          <a:lstStyle/>
+          <a:p>
+            <a:pPr indent="0" marL="0">
+              <a:buNone/>
+            </a:pPr>
+            <a:r>
+              <a:rPr lang="en-US" sz="4000" b="1" dirty="0">
+                <a:solidFill>
+                  <a:schemeClr val="bg1"/>
+                </a:solidFill>
+                <a:latin typeface="Cambria" pitchFamily="34" charset="0"/>
+                <a:ea typeface="Cambria" pitchFamily="34" charset="-122"/>
+                <a:cs typeface="Cambria" pitchFamily="34" charset="-120"/>
+              </a:rPr>
+              <a:t>Questions?</a:t>
+            </a:r>
+            <a:endParaRPr lang="en-US" sz="4000" dirty="0"/>
+          </a:p>
+        </p:txBody>
+      </p:sp>
+      <p:sp>
+        <p:nvSpPr>
+          <p:cNvPr id="3" name="Text 0"/>
+          <p:cNvSpPr/>
+          <p:nvPr>
+            <p:ph idx="101" type="body" hasCustomPrompt="1"/>
+          </p:nvPr>
+        </p:nvSpPr>
+        <p:spPr>
+          <a:xfrm>
+            <a:off x="548640" y="3931920"/>
+            <a:ext cx="10424160" cy="2103120"/>
+          </a:xfrm>
+          <a:prstGeom prst="rect">
+            <a:avLst/>
+          </a:prstGeom>
+          <a:noFill/>
+          <a:ln/>
+        </p:spPr>
+        <p:txBody>
+          <a:bodyPr wrap="square" rtlCol="0" anchor="t"/>
+          <a:lstStyle/>
+          <a:p>
+            <a:pPr indent="0" marL="0">
+              <a:buNone/>
+            </a:pPr>
+            <a:r>
+              <a:rPr lang="en-US" sz="2100" dirty="0">
+                <a:solidFill>
+                  <a:schemeClr val="bg2"/>
+                </a:solidFill>
+              </a:rPr>
+              <a:t>$100,000 in 2023–24 → $156,546 by waiting, $123,714 with v1, $121,812 with v2. With honest odds, v3’s best rule is not to trade.</a:t>
+            </a:r>
+            <a:endParaRPr lang="en-US" sz="2100" dirty="0"/>
+          </a:p>
+          <a:p>
+            <a:pPr indent="0" marL="0">
+              <a:buNone/>
+            </a:pPr>
+            <a:r>
+              <a:rPr lang="en-US" sz="2100" dirty="0">
+                <a:solidFill>
+                  <a:schemeClr val="bg2"/>
+                </a:solidFill>
+              </a:rPr>
+              <a:t> </a:t>
+            </a:r>
+            <a:endParaRPr lang="en-US" sz="2100" dirty="0"/>
+          </a:p>
+          <a:p>
+            <a:pPr indent="0" marL="0">
+              <a:buNone/>
+            </a:pPr>
+            <a:r>
+              <a:rPr lang="en-US" sz="1800" dirty="0">
+                <a:solidFill>
+                  <a:schemeClr val="accent4"/>
+                </a:solidFill>
+              </a:rPr>
+              <a:t>github.com/TKCH121/spy</a:t>
+            </a:r>
+            <a:endParaRPr lang="en-US" sz="2100" dirty="0"/>
+          </a:p>
+        </p:txBody>
+      </p:sp>
+      <p:sp>
+        <p:nvSpPr>
+          <p:cNvPr id="25" name="Slide Number Placeholder 0"/>
+          <p:cNvSpPr>
+            <a:spLocks noGrp="1"/>
+          </p:cNvSpPr>
+          <p:nvPr>
+            <p:ph type="sldNum" sz="quarter" idx="4294967295"/>
+          </p:nvPr>
+        </p:nvSpPr>
+        <p:spPr>
+          <a:xfrm>
+            <a:off x="11155680" y="6355080"/>
+            <a:ext cx="548640" cy="320040"/>
+          </a:xfrm>
+          <a:prstGeom prst="rect">
+            <a:avLst/>
+          </a:prstGeom>
+          <a:extLst>
+            <a:ext uri="{C572A759-6A51-4108-AA02-DFA0A04FC94B}">
+              <ma14:wrappingTextBoxFlag xmlns:ma14="http://schemas.microsoft.com/office/mac/drawingml/2011/main" val="0"/>
+            </a:ext>
+          </a:extLst>
+        </p:spPr>
+        <p:txBody>
+          <a:bodyPr/>
+          <a:lstStyle>
+            <a:lvl1pPr>
+              <a:defRPr sz="1200">
+                <a:solidFill>
+                  <a:schemeClr val="accent3"/>
+                </a:solidFill>
+              </a:defRPr>
+            </a:lvl1pPr>
+          </a:lstStyle>
+          <a:p>
+            <a:pPr algn="r"/>
+            <a:fld id="{F7021451-1387-4CA6-816F-3879F97B5CBC}" type="slidenum">
+              <a:rPr b="0" lang="en-US"/>
+              <a:t>29</a:t>
             </a:fld>
             <a:endParaRPr lang="en-US"/>
           </a:p>

</xml_diff>

<commit_message>
Weekly decisions report; reword docs and deck around Buy/Hold/Sell for the next 5 days
- outputs/weekly/report.md; SUMMARY and README describe the model as the brief does
  (Buy/Hold/Sell over the next 5 trading days) and add the weekly check.
- Deck: cover, slides 3, 7 and 9 reworded; new slide 26 'One decision a week'; script updated.
- ruff format on the new weekly module and tests. 50 tests pass.

Co-Authored-By: Claude Opus 5.5 <noreply@anthropic.com>
</commit_message>
<xml_diff>
--- a/presentation/SPY_Model_Presentation.pptx
+++ b/presentation/SPY_Model_Presentation.pptx
@@ -34,9 +34,10 @@
     <p:sldId id="282" r:id="rId28"/>
     <p:sldId id="283" r:id="rId29"/>
     <p:sldId id="284" r:id="rId30"/>
+    <p:sldId id="285" r:id="rId31"/>
   </p:sldIdLst>
   <p:notesMasterIdLst>
-    <p:notesMasterId r:id="rId31"/>
+    <p:notesMasterId r:id="rId32"/>
   </p:notesMasterIdLst>
   <p:sldSz cx="12192000" cy="6858000"/>
   <p:notesSz cx="6858000" cy="12192000"/>
@@ -135,7 +136,7 @@
   <p:extLst>
     <p:ext uri="{521415D9-36F7-43E2-AB2F-B90AF26B5E84}">
       <p14:sectionLst xmlns:p14="http://schemas.microsoft.com/office/powerpoint/2010/main">
-        <p14:section name="The question" id="{9ce59636-46d4-dbae-f74a-d77ee1f25c77}">
+        <p14:section name="The question" id="{7926e54d-b7b5-9f39-52fe-afaefaaed1a7}">
           <p14:sldIdLst>
             <p14:sldId id="256"/>
             <p14:sldId id="257"/>
@@ -145,7 +146,7 @@
             <p14:sldId id="261"/>
           </p14:sldIdLst>
         </p14:section>
-        <p14:section name="How the model works" id="{22591102-ca6c-e4d3-6cfa-407aed3205a9}">
+        <p14:section name="How the model works" id="{573efc90-d4d6-aa97-9c41-73ec56ed59ca}">
           <p14:sldIdLst>
             <p14:sldId id="262"/>
             <p14:sldId id="263"/>
@@ -155,7 +156,7 @@
             <p14:sldId id="267"/>
           </p14:sldIdLst>
         </p14:section>
-        <p14:section name="What happened" id="{7868a3f9-0056-ee5c-e562-f328e66a3def}">
+        <p14:section name="What happened" id="{f6b10112-8e2e-e9ea-a239-c566157fba9a}">
           <p14:sldIdLst>
             <p14:sldId id="268"/>
             <p14:sldId id="269"/>
@@ -163,7 +164,7 @@
             <p14:sldId id="271"/>
           </p14:sldIdLst>
         </p14:section>
-        <p14:section name="Version 2" id="{8aa8a8a7-c03a-6c0f-d037-133550b7715e}">
+        <p14:section name="Version 2" id="{d2330aae-f162-be65-2586-8aca15d63e86}">
           <p14:sldIdLst>
             <p14:sldId id="272"/>
             <p14:sldId id="273"/>
@@ -173,19 +174,20 @@
             <p14:sldId id="277"/>
           </p14:sldIdLst>
         </p14:section>
-        <p14:section name="Version 3" id="{c2ff4141-5a3c-4503-3ac6-d0690f39df70}">
+        <p14:section name="Version 3" id="{43f40a15-f5d2-7d27-ebfb-cf32b0cd0fe5}">
           <p14:sldIdLst>
             <p14:sldId id="278"/>
             <p14:sldId id="279"/>
             <p14:sldId id="280"/>
             <p14:sldId id="281"/>
+            <p14:sldId id="282"/>
           </p14:sldIdLst>
         </p14:section>
-        <p14:section name="Wrap-up" id="{d808f77e-3d5c-bf9c-123d-e34be173be0b}">
+        <p14:section name="Wrap-up" id="{00dbf3a0-7ca6-7283-5b62-53083822df8a}">
           <p14:sldIdLst>
-            <p14:sldId id="282"/>
             <p14:sldId id="283"/>
             <p14:sldId id="284"/>
+            <p14:sldId id="285"/>
           </p14:sldIdLst>
         </p14:section>
       </p14:sectionLst>
@@ -5938,6 +5940,94 @@
 </p:notes>
 </file>
 
+<file path=ppt/notesSlides/notesSlide30.xml><?xml version="1.0" encoding="utf-8"?>
+<p:notes xmlns:a="http://schemas.openxmlformats.org/drawingml/2006/main" xmlns:r="http://schemas.openxmlformats.org/officeDocument/2006/relationships" xmlns:p="http://schemas.openxmlformats.org/presentationml/2006/main">
+  <p:cSld>
+    <p:spTree>
+      <p:nvGrpSpPr>
+        <p:cNvPr id="1" name=""/>
+        <p:cNvGrpSpPr/>
+        <p:nvPr/>
+      </p:nvGrpSpPr>
+      <p:grpSpPr>
+        <a:xfrm>
+          <a:off x="0" y="0"/>
+          <a:ext cx="0" cy="0"/>
+          <a:chOff x="0" y="0"/>
+          <a:chExt cx="0" cy="0"/>
+        </a:xfrm>
+      </p:grpSpPr>
+      <p:sp>
+        <p:nvSpPr>
+          <p:cNvPr id="2" name="Slide Image Placeholder 1"/>
+          <p:cNvSpPr>
+            <a:spLocks noGrp="1" noRot="1" noChangeAspect="1"/>
+          </p:cNvSpPr>
+          <p:nvPr>
+            <p:ph type="sldImg"/>
+          </p:nvPr>
+        </p:nvSpPr>
+        <p:spPr/>
+      </p:sp>
+      <p:sp>
+        <p:nvSpPr>
+          <p:cNvPr id="3" name="Notes Placeholder 2"/>
+          <p:cNvSpPr>
+            <a:spLocks noGrp="1"/>
+          </p:cNvSpPr>
+          <p:nvPr>
+            <p:ph type="body" idx="1"/>
+          </p:nvPr>
+        </p:nvSpPr>
+        <p:spPr/>
+        <p:txBody>
+          <a:bodyPr/>
+          <a:lstStyle/>
+          <a:p>
+            <a:r>
+              <a:rPr lang="en-US" dirty="0"/>
+              <a:t/>
+            </a:r>
+            <a:endParaRPr lang="en-US" dirty="0"/>
+          </a:p>
+        </p:txBody>
+      </p:sp>
+      <p:sp>
+        <p:nvSpPr>
+          <p:cNvPr id="4" name="Slide Number Placeholder 3"/>
+          <p:cNvSpPr>
+            <a:spLocks noGrp="1"/>
+          </p:cNvSpPr>
+          <p:nvPr>
+            <p:ph type="sldNum" sz="quarter" idx="10"/>
+          </p:nvPr>
+        </p:nvSpPr>
+        <p:spPr/>
+        <p:txBody>
+          <a:bodyPr/>
+          <a:lstStyle/>
+          <a:p>
+            <a:fld id="{F7021451-1387-4CA6-816F-3879F97B5CBC}" type="slidenum">
+              <a:rPr lang="en-US"/>
+              <a:t>30</a:t>
+            </a:fld>
+            <a:endParaRPr lang="en-US"/>
+          </a:p>
+        </p:txBody>
+      </p:sp>
+    </p:spTree>
+    <p:extLst>
+      <p:ext uri="{BB962C8B-B14F-4D97-AF65-F5344CB8AC3E}">
+        <p14:creationId xmlns:p14="http://schemas.microsoft.com/office/powerpoint/2010/main" val="1024086991"/>
+      </p:ext>
+    </p:extLst>
+  </p:cSld>
+  <p:clrMapOvr>
+    <a:masterClrMapping/>
+  </p:clrMapOvr>
+</p:notes>
+</file>
+
 <file path=ppt/notesSlides/notesSlide4.xml><?xml version="1.0" encoding="utf-8"?>
 <p:notes xmlns:a="http://schemas.openxmlformats.org/drawingml/2006/main" xmlns:r="http://schemas.openxmlformats.org/officeDocument/2006/relationships" xmlns:p="http://schemas.openxmlformats.org/presentationml/2006/main">
   <p:cSld>
@@ -7373,7 +7463,7 @@
                   <a:schemeClr val="bg2"/>
                 </a:solidFill>
               </a:rPr>
-              <a:t>Testing a machine-learning trading model on the US stock market with $100,000</a:t>
+              <a:t>A model that predicts Buy, Hold or Sell for the next 5 trading days, tested with $100,000</a:t>
             </a:r>
             <a:endParaRPr lang="en-US" sz="2200" dirty="0"/>
           </a:p>
@@ -16421,7 +16511,7 @@
                   <a:schemeClr val="accent1"/>
                 </a:solidFill>
               </a:rPr>
-              <a:t>Throughout: no look-ahead, checked by 46 automated tests. Code: github.com/TKCH121/spy</a:t>
+              <a:t>Throughout: no look-ahead, checked by 50 automated tests. Code: github.com/TKCH121/spy</a:t>
             </a:r>
             <a:endParaRPr lang="en-US" sz="1600" dirty="0"/>
           </a:p>
@@ -21315,26 +21405,1042 @@
                 <a:ea typeface="Cambria" pitchFamily="34" charset="-122"/>
                 <a:cs typeface="Cambria" pitchFamily="34" charset="-120"/>
               </a:rPr>
-              <a:t>How we kept the test honest</a:t>
+              <a:t>One decision a week: the brief’s literal reading</a:t>
             </a:r>
             <a:endParaRPr lang="en-US" sz="3200" dirty="0"/>
           </a:p>
         </p:txBody>
       </p:sp>
-      <p:sp>
-        <p:nvSpPr>
-          <p:cNvPr id="3" name="Shape 1"/>
+      <p:graphicFrame>
+        <p:nvGraphicFramePr>
+          <p:cNvPr id="27" name="Table 0"/>
+          <p:cNvGraphicFramePr>
+            <a:graphicFrameLocks noGrp="1"/>
+          </p:cNvGraphicFramePr>
+          <p:nvPr>
+            <p:extLst>
+              <p:ext uri="{D42A27DB-BD31-4B8C-83A1-F6EECF244321}">
+                <p14:modId xmlns:p14="http://schemas.microsoft.com/office/powerpoint/2010/main" val="1579011935"/>
+              </p:ext>
+            </p:extLst>
+          </p:nvPr>
+        </p:nvGraphicFramePr>
+        <p:xfrm>
+          <a:off x="548640" y="1371600"/>
+          <a:ext cx="11094415" cy="914400"/>
+        </p:xfrm>
+        <a:graphic>
+          <a:graphicData uri="http://schemas.openxmlformats.org/drawingml/2006/table">
+            <a:tbl>
+              <a:tblPr/>
+              <a:tblGrid>
+                <a:gridCol w="2377440"/>
+                <a:gridCol w="3291840"/>
+                <a:gridCol w="3291840"/>
+                <a:gridCol w="2130552"/>
+              </a:tblGrid>
+              <a:tr h="566928">
+                <a:tc>
+                  <a:txBody>
+                    <a:bodyPr/>
+                    <a:lstStyle/>
+                    <a:p>
+                      <a:pPr indent="0" marL="0">
+                        <a:buNone/>
+                      </a:pPr>
+                      <a:r>
+                        <a:rPr lang="en-US" sz="1600" b="1" dirty="0">
+                          <a:solidFill>
+                            <a:schemeClr val="bg1"/>
+                          </a:solidFill>
+                        </a:rPr>
+                        <a:t>$100,000, 2023–24</a:t>
+                      </a:r>
+                      <a:endParaRPr lang="en-US" sz="1600" dirty="0"/>
+                    </a:p>
+                  </a:txBody>
+                  <a:tcPr marL="109728" marR="109728" marT="54864" marB="54864" anchor="ctr">
+                    <a:lnL w="9525" cap="flat" cmpd="sng" algn="ctr">
+                      <a:solidFill>
+                        <a:srgbClr val="D5DAE3"/>
+                      </a:solidFill>
+                      <a:prstDash val="solid"/>
+                      <a:round/>
+                      <a:headEnd type="none" w="med" len="med"/>
+                      <a:tailEnd type="none" w="med" len="med"/>
+                    </a:lnL>
+                    <a:lnR w="9525" cap="flat" cmpd="sng" algn="ctr">
+                      <a:solidFill>
+                        <a:srgbClr val="D5DAE3"/>
+                      </a:solidFill>
+                      <a:prstDash val="solid"/>
+                      <a:round/>
+                      <a:headEnd type="none" w="med" len="med"/>
+                      <a:tailEnd type="none" w="med" len="med"/>
+                    </a:lnR>
+                    <a:lnT w="9525" cap="flat" cmpd="sng" algn="ctr">
+                      <a:solidFill>
+                        <a:srgbClr val="D5DAE3"/>
+                      </a:solidFill>
+                      <a:prstDash val="solid"/>
+                      <a:round/>
+                      <a:headEnd type="none" w="med" len="med"/>
+                      <a:tailEnd type="none" w="med" len="med"/>
+                    </a:lnT>
+                    <a:lnB w="9525" cap="flat" cmpd="sng" algn="ctr">
+                      <a:solidFill>
+                        <a:srgbClr val="D5DAE3"/>
+                      </a:solidFill>
+                      <a:prstDash val="solid"/>
+                      <a:round/>
+                      <a:headEnd type="none" w="med" len="med"/>
+                      <a:tailEnd type="none" w="med" len="med"/>
+                    </a:lnB>
+                    <a:solidFill>
+                      <a:schemeClr val="tx1"/>
+                    </a:solidFill>
+                  </a:tcPr>
+                </a:tc>
+                <a:tc>
+                  <a:txBody>
+                    <a:bodyPr/>
+                    <a:lstStyle/>
+                    <a:p>
+                      <a:pPr indent="0" marL="0">
+                        <a:buNone/>
+                      </a:pPr>
+                      <a:r>
+                        <a:rPr lang="en-US" sz="1600" b="1" dirty="0">
+                          <a:solidFill>
+                            <a:schemeClr val="bg1"/>
+                          </a:solidFill>
+                        </a:rPr>
+                        <a:t>Decides every day</a:t>
+                      </a:r>
+                      <a:endParaRPr lang="en-US" sz="1600" dirty="0"/>
+                    </a:p>
+                  </a:txBody>
+                  <a:tcPr marL="109728" marR="109728" marT="54864" marB="54864" anchor="ctr">
+                    <a:lnL w="9525" cap="flat" cmpd="sng" algn="ctr">
+                      <a:solidFill>
+                        <a:srgbClr val="D5DAE3"/>
+                      </a:solidFill>
+                      <a:prstDash val="solid"/>
+                      <a:round/>
+                      <a:headEnd type="none" w="med" len="med"/>
+                      <a:tailEnd type="none" w="med" len="med"/>
+                    </a:lnL>
+                    <a:lnR w="9525" cap="flat" cmpd="sng" algn="ctr">
+                      <a:solidFill>
+                        <a:srgbClr val="D5DAE3"/>
+                      </a:solidFill>
+                      <a:prstDash val="solid"/>
+                      <a:round/>
+                      <a:headEnd type="none" w="med" len="med"/>
+                      <a:tailEnd type="none" w="med" len="med"/>
+                    </a:lnR>
+                    <a:lnT w="9525" cap="flat" cmpd="sng" algn="ctr">
+                      <a:solidFill>
+                        <a:srgbClr val="D5DAE3"/>
+                      </a:solidFill>
+                      <a:prstDash val="solid"/>
+                      <a:round/>
+                      <a:headEnd type="none" w="med" len="med"/>
+                      <a:tailEnd type="none" w="med" len="med"/>
+                    </a:lnT>
+                    <a:lnB w="9525" cap="flat" cmpd="sng" algn="ctr">
+                      <a:solidFill>
+                        <a:srgbClr val="D5DAE3"/>
+                      </a:solidFill>
+                      <a:prstDash val="solid"/>
+                      <a:round/>
+                      <a:headEnd type="none" w="med" len="med"/>
+                      <a:tailEnd type="none" w="med" len="med"/>
+                    </a:lnB>
+                    <a:solidFill>
+                      <a:schemeClr val="tx1"/>
+                    </a:solidFill>
+                  </a:tcPr>
+                </a:tc>
+                <a:tc>
+                  <a:txBody>
+                    <a:bodyPr/>
+                    <a:lstStyle/>
+                    <a:p>
+                      <a:pPr indent="0" marL="0">
+                        <a:buNone/>
+                      </a:pPr>
+                      <a:r>
+                        <a:rPr lang="en-US" sz="1600" b="1" dirty="0">
+                          <a:solidFill>
+                            <a:schemeClr val="bg1"/>
+                          </a:solidFill>
+                        </a:rPr>
+                        <a:t>Decides each Friday</a:t>
+                      </a:r>
+                      <a:endParaRPr lang="en-US" sz="1600" dirty="0"/>
+                    </a:p>
+                  </a:txBody>
+                  <a:tcPr marL="109728" marR="109728" marT="54864" marB="54864" anchor="ctr">
+                    <a:lnL w="9525" cap="flat" cmpd="sng" algn="ctr">
+                      <a:solidFill>
+                        <a:srgbClr val="D5DAE3"/>
+                      </a:solidFill>
+                      <a:prstDash val="solid"/>
+                      <a:round/>
+                      <a:headEnd type="none" w="med" len="med"/>
+                      <a:tailEnd type="none" w="med" len="med"/>
+                    </a:lnL>
+                    <a:lnR w="9525" cap="flat" cmpd="sng" algn="ctr">
+                      <a:solidFill>
+                        <a:srgbClr val="D5DAE3"/>
+                      </a:solidFill>
+                      <a:prstDash val="solid"/>
+                      <a:round/>
+                      <a:headEnd type="none" w="med" len="med"/>
+                      <a:tailEnd type="none" w="med" len="med"/>
+                    </a:lnR>
+                    <a:lnT w="9525" cap="flat" cmpd="sng" algn="ctr">
+                      <a:solidFill>
+                        <a:srgbClr val="D5DAE3"/>
+                      </a:solidFill>
+                      <a:prstDash val="solid"/>
+                      <a:round/>
+                      <a:headEnd type="none" w="med" len="med"/>
+                      <a:tailEnd type="none" w="med" len="med"/>
+                    </a:lnT>
+                    <a:lnB w="9525" cap="flat" cmpd="sng" algn="ctr">
+                      <a:solidFill>
+                        <a:srgbClr val="D5DAE3"/>
+                      </a:solidFill>
+                      <a:prstDash val="solid"/>
+                      <a:round/>
+                      <a:headEnd type="none" w="med" len="med"/>
+                      <a:tailEnd type="none" w="med" len="med"/>
+                    </a:lnB>
+                    <a:solidFill>
+                      <a:schemeClr val="tx1"/>
+                    </a:solidFill>
+                  </a:tcPr>
+                </a:tc>
+                <a:tc>
+                  <a:txBody>
+                    <a:bodyPr/>
+                    <a:lstStyle/>
+                    <a:p>
+                      <a:pPr indent="0" marL="0">
+                        <a:buNone/>
+                      </a:pPr>
+                      <a:r>
+                        <a:rPr lang="en-US" sz="1600" b="1" dirty="0">
+                          <a:solidFill>
+                            <a:schemeClr val="bg1"/>
+                          </a:solidFill>
+                        </a:rPr>
+                        <a:t>Buy &amp; Hold</a:t>
+                      </a:r>
+                      <a:endParaRPr lang="en-US" sz="1600" dirty="0"/>
+                    </a:p>
+                  </a:txBody>
+                  <a:tcPr marL="109728" marR="109728" marT="54864" marB="54864" anchor="ctr">
+                    <a:lnL w="9525" cap="flat" cmpd="sng" algn="ctr">
+                      <a:solidFill>
+                        <a:srgbClr val="D5DAE3"/>
+                      </a:solidFill>
+                      <a:prstDash val="solid"/>
+                      <a:round/>
+                      <a:headEnd type="none" w="med" len="med"/>
+                      <a:tailEnd type="none" w="med" len="med"/>
+                    </a:lnL>
+                    <a:lnR w="9525" cap="flat" cmpd="sng" algn="ctr">
+                      <a:solidFill>
+                        <a:srgbClr val="D5DAE3"/>
+                      </a:solidFill>
+                      <a:prstDash val="solid"/>
+                      <a:round/>
+                      <a:headEnd type="none" w="med" len="med"/>
+                      <a:tailEnd type="none" w="med" len="med"/>
+                    </a:lnR>
+                    <a:lnT w="9525" cap="flat" cmpd="sng" algn="ctr">
+                      <a:solidFill>
+                        <a:srgbClr val="D5DAE3"/>
+                      </a:solidFill>
+                      <a:prstDash val="solid"/>
+                      <a:round/>
+                      <a:headEnd type="none" w="med" len="med"/>
+                      <a:tailEnd type="none" w="med" len="med"/>
+                    </a:lnT>
+                    <a:lnB w="9525" cap="flat" cmpd="sng" algn="ctr">
+                      <a:solidFill>
+                        <a:srgbClr val="D5DAE3"/>
+                      </a:solidFill>
+                      <a:prstDash val="solid"/>
+                      <a:round/>
+                      <a:headEnd type="none" w="med" len="med"/>
+                      <a:tailEnd type="none" w="med" len="med"/>
+                    </a:lnB>
+                    <a:solidFill>
+                      <a:schemeClr val="tx1"/>
+                    </a:solidFill>
+                  </a:tcPr>
+                </a:tc>
+              </a:tr>
+              <a:tr h="566928">
+                <a:tc>
+                  <a:txBody>
+                    <a:bodyPr/>
+                    <a:lstStyle/>
+                    <a:p>
+                      <a:pPr indent="0" marL="0">
+                        <a:buNone/>
+                      </a:pPr>
+                      <a:r>
+                        <a:rPr lang="en-US" sz="1600" dirty="0">
+                          <a:solidFill>
+                            <a:schemeClr val="tx2"/>
+                          </a:solidFill>
+                        </a:rPr>
+                        <a:t>Version 1</a:t>
+                      </a:r>
+                      <a:endParaRPr lang="en-US" sz="1600" dirty="0"/>
+                    </a:p>
+                  </a:txBody>
+                  <a:tcPr marL="109728" marR="109728" marT="54864" marB="54864" anchor="ctr">
+                    <a:lnL w="9525" cap="flat" cmpd="sng" algn="ctr">
+                      <a:solidFill>
+                        <a:srgbClr val="D5DAE3"/>
+                      </a:solidFill>
+                      <a:prstDash val="solid"/>
+                      <a:round/>
+                      <a:headEnd type="none" w="med" len="med"/>
+                      <a:tailEnd type="none" w="med" len="med"/>
+                    </a:lnL>
+                    <a:lnR w="9525" cap="flat" cmpd="sng" algn="ctr">
+                      <a:solidFill>
+                        <a:srgbClr val="D5DAE3"/>
+                      </a:solidFill>
+                      <a:prstDash val="solid"/>
+                      <a:round/>
+                      <a:headEnd type="none" w="med" len="med"/>
+                      <a:tailEnd type="none" w="med" len="med"/>
+                    </a:lnR>
+                    <a:lnT w="9525" cap="flat" cmpd="sng" algn="ctr">
+                      <a:solidFill>
+                        <a:srgbClr val="D5DAE3"/>
+                      </a:solidFill>
+                      <a:prstDash val="solid"/>
+                      <a:round/>
+                      <a:headEnd type="none" w="med" len="med"/>
+                      <a:tailEnd type="none" w="med" len="med"/>
+                    </a:lnT>
+                    <a:lnB w="9525" cap="flat" cmpd="sng" algn="ctr">
+                      <a:solidFill>
+                        <a:srgbClr val="D5DAE3"/>
+                      </a:solidFill>
+                      <a:prstDash val="solid"/>
+                      <a:round/>
+                      <a:headEnd type="none" w="med" len="med"/>
+                      <a:tailEnd type="none" w="med" len="med"/>
+                    </a:lnB>
+                  </a:tcPr>
+                </a:tc>
+                <a:tc>
+                  <a:txBody>
+                    <a:bodyPr/>
+                    <a:lstStyle/>
+                    <a:p>
+                      <a:pPr indent="0" marL="0">
+                        <a:buNone/>
+                      </a:pPr>
+                      <a:r>
+                        <a:rPr lang="en-US" sz="1600" dirty="0">
+                          <a:solidFill>
+                            <a:schemeClr val="tx2"/>
+                          </a:solidFill>
+                        </a:rPr>
+                        <a:t>$123,714 · 15 round trips</a:t>
+                      </a:r>
+                      <a:endParaRPr lang="en-US" sz="1600" dirty="0"/>
+                    </a:p>
+                  </a:txBody>
+                  <a:tcPr marL="109728" marR="109728" marT="54864" marB="54864" anchor="ctr">
+                    <a:lnL w="9525" cap="flat" cmpd="sng" algn="ctr">
+                      <a:solidFill>
+                        <a:srgbClr val="D5DAE3"/>
+                      </a:solidFill>
+                      <a:prstDash val="solid"/>
+                      <a:round/>
+                      <a:headEnd type="none" w="med" len="med"/>
+                      <a:tailEnd type="none" w="med" len="med"/>
+                    </a:lnL>
+                    <a:lnR w="9525" cap="flat" cmpd="sng" algn="ctr">
+                      <a:solidFill>
+                        <a:srgbClr val="D5DAE3"/>
+                      </a:solidFill>
+                      <a:prstDash val="solid"/>
+                      <a:round/>
+                      <a:headEnd type="none" w="med" len="med"/>
+                      <a:tailEnd type="none" w="med" len="med"/>
+                    </a:lnR>
+                    <a:lnT w="9525" cap="flat" cmpd="sng" algn="ctr">
+                      <a:solidFill>
+                        <a:srgbClr val="D5DAE3"/>
+                      </a:solidFill>
+                      <a:prstDash val="solid"/>
+                      <a:round/>
+                      <a:headEnd type="none" w="med" len="med"/>
+                      <a:tailEnd type="none" w="med" len="med"/>
+                    </a:lnT>
+                    <a:lnB w="9525" cap="flat" cmpd="sng" algn="ctr">
+                      <a:solidFill>
+                        <a:srgbClr val="D5DAE3"/>
+                      </a:solidFill>
+                      <a:prstDash val="solid"/>
+                      <a:round/>
+                      <a:headEnd type="none" w="med" len="med"/>
+                      <a:tailEnd type="none" w="med" len="med"/>
+                    </a:lnB>
+                  </a:tcPr>
+                </a:tc>
+                <a:tc>
+                  <a:txBody>
+                    <a:bodyPr/>
+                    <a:lstStyle/>
+                    <a:p>
+                      <a:pPr indent="0" marL="0">
+                        <a:buNone/>
+                      </a:pPr>
+                      <a:r>
+                        <a:rPr lang="en-US" sz="1600" dirty="0">
+                          <a:solidFill>
+                            <a:schemeClr val="tx2"/>
+                          </a:solidFill>
+                        </a:rPr>
+                        <a:t>$124,654 · 6 round trips</a:t>
+                      </a:r>
+                      <a:endParaRPr lang="en-US" sz="1600" dirty="0"/>
+                    </a:p>
+                  </a:txBody>
+                  <a:tcPr marL="109728" marR="109728" marT="54864" marB="54864" anchor="ctr">
+                    <a:lnL w="9525" cap="flat" cmpd="sng" algn="ctr">
+                      <a:solidFill>
+                        <a:srgbClr val="D5DAE3"/>
+                      </a:solidFill>
+                      <a:prstDash val="solid"/>
+                      <a:round/>
+                      <a:headEnd type="none" w="med" len="med"/>
+                      <a:tailEnd type="none" w="med" len="med"/>
+                    </a:lnL>
+                    <a:lnR w="9525" cap="flat" cmpd="sng" algn="ctr">
+                      <a:solidFill>
+                        <a:srgbClr val="D5DAE3"/>
+                      </a:solidFill>
+                      <a:prstDash val="solid"/>
+                      <a:round/>
+                      <a:headEnd type="none" w="med" len="med"/>
+                      <a:tailEnd type="none" w="med" len="med"/>
+                    </a:lnR>
+                    <a:lnT w="9525" cap="flat" cmpd="sng" algn="ctr">
+                      <a:solidFill>
+                        <a:srgbClr val="D5DAE3"/>
+                      </a:solidFill>
+                      <a:prstDash val="solid"/>
+                      <a:round/>
+                      <a:headEnd type="none" w="med" len="med"/>
+                      <a:tailEnd type="none" w="med" len="med"/>
+                    </a:lnT>
+                    <a:lnB w="9525" cap="flat" cmpd="sng" algn="ctr">
+                      <a:solidFill>
+                        <a:srgbClr val="D5DAE3"/>
+                      </a:solidFill>
+                      <a:prstDash val="solid"/>
+                      <a:round/>
+                      <a:headEnd type="none" w="med" len="med"/>
+                      <a:tailEnd type="none" w="med" len="med"/>
+                    </a:lnB>
+                  </a:tcPr>
+                </a:tc>
+                <a:tc>
+                  <a:txBody>
+                    <a:bodyPr/>
+                    <a:lstStyle/>
+                    <a:p>
+                      <a:pPr indent="0" marL="0">
+                        <a:buNone/>
+                      </a:pPr>
+                      <a:r>
+                        <a:rPr lang="en-US" sz="1600" dirty="0">
+                          <a:solidFill>
+                            <a:schemeClr val="tx2"/>
+                          </a:solidFill>
+                        </a:rPr>
+                        <a:t>$156,546</a:t>
+                      </a:r>
+                      <a:endParaRPr lang="en-US" sz="1600" dirty="0"/>
+                    </a:p>
+                  </a:txBody>
+                  <a:tcPr marL="109728" marR="109728" marT="54864" marB="54864" anchor="ctr">
+                    <a:lnL w="9525" cap="flat" cmpd="sng" algn="ctr">
+                      <a:solidFill>
+                        <a:srgbClr val="D5DAE3"/>
+                      </a:solidFill>
+                      <a:prstDash val="solid"/>
+                      <a:round/>
+                      <a:headEnd type="none" w="med" len="med"/>
+                      <a:tailEnd type="none" w="med" len="med"/>
+                    </a:lnL>
+                    <a:lnR w="9525" cap="flat" cmpd="sng" algn="ctr">
+                      <a:solidFill>
+                        <a:srgbClr val="D5DAE3"/>
+                      </a:solidFill>
+                      <a:prstDash val="solid"/>
+                      <a:round/>
+                      <a:headEnd type="none" w="med" len="med"/>
+                      <a:tailEnd type="none" w="med" len="med"/>
+                    </a:lnR>
+                    <a:lnT w="9525" cap="flat" cmpd="sng" algn="ctr">
+                      <a:solidFill>
+                        <a:srgbClr val="D5DAE3"/>
+                      </a:solidFill>
+                      <a:prstDash val="solid"/>
+                      <a:round/>
+                      <a:headEnd type="none" w="med" len="med"/>
+                      <a:tailEnd type="none" w="med" len="med"/>
+                    </a:lnT>
+                    <a:lnB w="9525" cap="flat" cmpd="sng" algn="ctr">
+                      <a:solidFill>
+                        <a:srgbClr val="D5DAE3"/>
+                      </a:solidFill>
+                      <a:prstDash val="solid"/>
+                      <a:round/>
+                      <a:headEnd type="none" w="med" len="med"/>
+                      <a:tailEnd type="none" w="med" len="med"/>
+                    </a:lnB>
+                  </a:tcPr>
+                </a:tc>
+              </a:tr>
+              <a:tr h="566928">
+                <a:tc>
+                  <a:txBody>
+                    <a:bodyPr/>
+                    <a:lstStyle/>
+                    <a:p>
+                      <a:pPr indent="0" marL="0">
+                        <a:buNone/>
+                      </a:pPr>
+                      <a:r>
+                        <a:rPr lang="en-US" sz="1600" dirty="0">
+                          <a:solidFill>
+                            <a:schemeClr val="tx2"/>
+                          </a:solidFill>
+                        </a:rPr>
+                        <a:t>Version 2</a:t>
+                      </a:r>
+                      <a:endParaRPr lang="en-US" sz="1600" dirty="0"/>
+                    </a:p>
+                  </a:txBody>
+                  <a:tcPr marL="109728" marR="109728" marT="54864" marB="54864" anchor="ctr">
+                    <a:lnL w="9525" cap="flat" cmpd="sng" algn="ctr">
+                      <a:solidFill>
+                        <a:srgbClr val="D5DAE3"/>
+                      </a:solidFill>
+                      <a:prstDash val="solid"/>
+                      <a:round/>
+                      <a:headEnd type="none" w="med" len="med"/>
+                      <a:tailEnd type="none" w="med" len="med"/>
+                    </a:lnL>
+                    <a:lnR w="9525" cap="flat" cmpd="sng" algn="ctr">
+                      <a:solidFill>
+                        <a:srgbClr val="D5DAE3"/>
+                      </a:solidFill>
+                      <a:prstDash val="solid"/>
+                      <a:round/>
+                      <a:headEnd type="none" w="med" len="med"/>
+                      <a:tailEnd type="none" w="med" len="med"/>
+                    </a:lnR>
+                    <a:lnT w="9525" cap="flat" cmpd="sng" algn="ctr">
+                      <a:solidFill>
+                        <a:srgbClr val="D5DAE3"/>
+                      </a:solidFill>
+                      <a:prstDash val="solid"/>
+                      <a:round/>
+                      <a:headEnd type="none" w="med" len="med"/>
+                      <a:tailEnd type="none" w="med" len="med"/>
+                    </a:lnT>
+                    <a:lnB w="9525" cap="flat" cmpd="sng" algn="ctr">
+                      <a:solidFill>
+                        <a:srgbClr val="D5DAE3"/>
+                      </a:solidFill>
+                      <a:prstDash val="solid"/>
+                      <a:round/>
+                      <a:headEnd type="none" w="med" len="med"/>
+                      <a:tailEnd type="none" w="med" len="med"/>
+                    </a:lnB>
+                  </a:tcPr>
+                </a:tc>
+                <a:tc>
+                  <a:txBody>
+                    <a:bodyPr/>
+                    <a:lstStyle/>
+                    <a:p>
+                      <a:pPr indent="0" marL="0">
+                        <a:buNone/>
+                      </a:pPr>
+                      <a:r>
+                        <a:rPr lang="en-US" sz="1600" dirty="0">
+                          <a:solidFill>
+                            <a:schemeClr val="tx2"/>
+                          </a:solidFill>
+                        </a:rPr>
+                        <a:t>$121,812 · 17 round trips</a:t>
+                      </a:r>
+                      <a:endParaRPr lang="en-US" sz="1600" dirty="0"/>
+                    </a:p>
+                  </a:txBody>
+                  <a:tcPr marL="109728" marR="109728" marT="54864" marB="54864" anchor="ctr">
+                    <a:lnL w="9525" cap="flat" cmpd="sng" algn="ctr">
+                      <a:solidFill>
+                        <a:srgbClr val="D5DAE3"/>
+                      </a:solidFill>
+                      <a:prstDash val="solid"/>
+                      <a:round/>
+                      <a:headEnd type="none" w="med" len="med"/>
+                      <a:tailEnd type="none" w="med" len="med"/>
+                    </a:lnL>
+                    <a:lnR w="9525" cap="flat" cmpd="sng" algn="ctr">
+                      <a:solidFill>
+                        <a:srgbClr val="D5DAE3"/>
+                      </a:solidFill>
+                      <a:prstDash val="solid"/>
+                      <a:round/>
+                      <a:headEnd type="none" w="med" len="med"/>
+                      <a:tailEnd type="none" w="med" len="med"/>
+                    </a:lnR>
+                    <a:lnT w="9525" cap="flat" cmpd="sng" algn="ctr">
+                      <a:solidFill>
+                        <a:srgbClr val="D5DAE3"/>
+                      </a:solidFill>
+                      <a:prstDash val="solid"/>
+                      <a:round/>
+                      <a:headEnd type="none" w="med" len="med"/>
+                      <a:tailEnd type="none" w="med" len="med"/>
+                    </a:lnT>
+                    <a:lnB w="9525" cap="flat" cmpd="sng" algn="ctr">
+                      <a:solidFill>
+                        <a:srgbClr val="D5DAE3"/>
+                      </a:solidFill>
+                      <a:prstDash val="solid"/>
+                      <a:round/>
+                      <a:headEnd type="none" w="med" len="med"/>
+                      <a:tailEnd type="none" w="med" len="med"/>
+                    </a:lnB>
+                  </a:tcPr>
+                </a:tc>
+                <a:tc>
+                  <a:txBody>
+                    <a:bodyPr/>
+                    <a:lstStyle/>
+                    <a:p>
+                      <a:pPr indent="0" marL="0">
+                        <a:buNone/>
+                      </a:pPr>
+                      <a:r>
+                        <a:rPr lang="en-US" sz="1600" dirty="0">
+                          <a:solidFill>
+                            <a:schemeClr val="tx2"/>
+                          </a:solidFill>
+                        </a:rPr>
+                        <a:t>$123,834 · 9 round trips</a:t>
+                      </a:r>
+                      <a:endParaRPr lang="en-US" sz="1600" dirty="0"/>
+                    </a:p>
+                  </a:txBody>
+                  <a:tcPr marL="109728" marR="109728" marT="54864" marB="54864" anchor="ctr">
+                    <a:lnL w="9525" cap="flat" cmpd="sng" algn="ctr">
+                      <a:solidFill>
+                        <a:srgbClr val="D5DAE3"/>
+                      </a:solidFill>
+                      <a:prstDash val="solid"/>
+                      <a:round/>
+                      <a:headEnd type="none" w="med" len="med"/>
+                      <a:tailEnd type="none" w="med" len="med"/>
+                    </a:lnL>
+                    <a:lnR w="9525" cap="flat" cmpd="sng" algn="ctr">
+                      <a:solidFill>
+                        <a:srgbClr val="D5DAE3"/>
+                      </a:solidFill>
+                      <a:prstDash val="solid"/>
+                      <a:round/>
+                      <a:headEnd type="none" w="med" len="med"/>
+                      <a:tailEnd type="none" w="med" len="med"/>
+                    </a:lnR>
+                    <a:lnT w="9525" cap="flat" cmpd="sng" algn="ctr">
+                      <a:solidFill>
+                        <a:srgbClr val="D5DAE3"/>
+                      </a:solidFill>
+                      <a:prstDash val="solid"/>
+                      <a:round/>
+                      <a:headEnd type="none" w="med" len="med"/>
+                      <a:tailEnd type="none" w="med" len="med"/>
+                    </a:lnT>
+                    <a:lnB w="9525" cap="flat" cmpd="sng" algn="ctr">
+                      <a:solidFill>
+                        <a:srgbClr val="D5DAE3"/>
+                      </a:solidFill>
+                      <a:prstDash val="solid"/>
+                      <a:round/>
+                      <a:headEnd type="none" w="med" len="med"/>
+                      <a:tailEnd type="none" w="med" len="med"/>
+                    </a:lnB>
+                  </a:tcPr>
+                </a:tc>
+                <a:tc>
+                  <a:txBody>
+                    <a:bodyPr/>
+                    <a:lstStyle/>
+                    <a:p>
+                      <a:pPr indent="0" marL="0">
+                        <a:buNone/>
+                      </a:pPr>
+                      <a:r>
+                        <a:rPr lang="en-US" sz="1600" dirty="0">
+                          <a:solidFill>
+                            <a:schemeClr val="tx2"/>
+                          </a:solidFill>
+                        </a:rPr>
+                        <a:t>$156,546</a:t>
+                      </a:r>
+                      <a:endParaRPr lang="en-US" sz="1600" dirty="0"/>
+                    </a:p>
+                  </a:txBody>
+                  <a:tcPr marL="109728" marR="109728" marT="54864" marB="54864" anchor="ctr">
+                    <a:lnL w="9525" cap="flat" cmpd="sng" algn="ctr">
+                      <a:solidFill>
+                        <a:srgbClr val="D5DAE3"/>
+                      </a:solidFill>
+                      <a:prstDash val="solid"/>
+                      <a:round/>
+                      <a:headEnd type="none" w="med" len="med"/>
+                      <a:tailEnd type="none" w="med" len="med"/>
+                    </a:lnL>
+                    <a:lnR w="9525" cap="flat" cmpd="sng" algn="ctr">
+                      <a:solidFill>
+                        <a:srgbClr val="D5DAE3"/>
+                      </a:solidFill>
+                      <a:prstDash val="solid"/>
+                      <a:round/>
+                      <a:headEnd type="none" w="med" len="med"/>
+                      <a:tailEnd type="none" w="med" len="med"/>
+                    </a:lnR>
+                    <a:lnT w="9525" cap="flat" cmpd="sng" algn="ctr">
+                      <a:solidFill>
+                        <a:srgbClr val="D5DAE3"/>
+                      </a:solidFill>
+                      <a:prstDash val="solid"/>
+                      <a:round/>
+                      <a:headEnd type="none" w="med" len="med"/>
+                      <a:tailEnd type="none" w="med" len="med"/>
+                    </a:lnT>
+                    <a:lnB w="9525" cap="flat" cmpd="sng" algn="ctr">
+                      <a:solidFill>
+                        <a:srgbClr val="D5DAE3"/>
+                      </a:solidFill>
+                      <a:prstDash val="solid"/>
+                      <a:round/>
+                      <a:headEnd type="none" w="med" len="med"/>
+                      <a:tailEnd type="none" w="med" len="med"/>
+                    </a:lnB>
+                  </a:tcPr>
+                </a:tc>
+              </a:tr>
+              <a:tr h="566928">
+                <a:tc>
+                  <a:txBody>
+                    <a:bodyPr/>
+                    <a:lstStyle/>
+                    <a:p>
+                      <a:pPr indent="0" marL="0">
+                        <a:buNone/>
+                      </a:pPr>
+                      <a:r>
+                        <a:rPr lang="en-US" sz="1600" dirty="0">
+                          <a:solidFill>
+                            <a:schemeClr val="tx2"/>
+                          </a:solidFill>
+                        </a:rPr>
+                        <a:t>Version 3</a:t>
+                      </a:r>
+                      <a:endParaRPr lang="en-US" sz="1600" dirty="0"/>
+                    </a:p>
+                  </a:txBody>
+                  <a:tcPr marL="109728" marR="109728" marT="54864" marB="54864" anchor="ctr">
+                    <a:lnL w="9525" cap="flat" cmpd="sng" algn="ctr">
+                      <a:solidFill>
+                        <a:srgbClr val="D5DAE3"/>
+                      </a:solidFill>
+                      <a:prstDash val="solid"/>
+                      <a:round/>
+                      <a:headEnd type="none" w="med" len="med"/>
+                      <a:tailEnd type="none" w="med" len="med"/>
+                    </a:lnL>
+                    <a:lnR w="9525" cap="flat" cmpd="sng" algn="ctr">
+                      <a:solidFill>
+                        <a:srgbClr val="D5DAE3"/>
+                      </a:solidFill>
+                      <a:prstDash val="solid"/>
+                      <a:round/>
+                      <a:headEnd type="none" w="med" len="med"/>
+                      <a:tailEnd type="none" w="med" len="med"/>
+                    </a:lnR>
+                    <a:lnT w="9525" cap="flat" cmpd="sng" algn="ctr">
+                      <a:solidFill>
+                        <a:srgbClr val="D5DAE3"/>
+                      </a:solidFill>
+                      <a:prstDash val="solid"/>
+                      <a:round/>
+                      <a:headEnd type="none" w="med" len="med"/>
+                      <a:tailEnd type="none" w="med" len="med"/>
+                    </a:lnT>
+                    <a:lnB w="9525" cap="flat" cmpd="sng" algn="ctr">
+                      <a:solidFill>
+                        <a:srgbClr val="D5DAE3"/>
+                      </a:solidFill>
+                      <a:prstDash val="solid"/>
+                      <a:round/>
+                      <a:headEnd type="none" w="med" len="med"/>
+                      <a:tailEnd type="none" w="med" len="med"/>
+                    </a:lnB>
+                  </a:tcPr>
+                </a:tc>
+                <a:tc>
+                  <a:txBody>
+                    <a:bodyPr/>
+                    <a:lstStyle/>
+                    <a:p>
+                      <a:pPr indent="0" marL="0">
+                        <a:buNone/>
+                      </a:pPr>
+                      <a:r>
+                        <a:rPr lang="en-US" sz="1600" dirty="0">
+                          <a:solidFill>
+                            <a:schemeClr val="tx2"/>
+                          </a:solidFill>
+                        </a:rPr>
+                        <a:t>never trades</a:t>
+                      </a:r>
+                      <a:endParaRPr lang="en-US" sz="1600" dirty="0"/>
+                    </a:p>
+                  </a:txBody>
+                  <a:tcPr marL="109728" marR="109728" marT="54864" marB="54864" anchor="ctr">
+                    <a:lnL w="9525" cap="flat" cmpd="sng" algn="ctr">
+                      <a:solidFill>
+                        <a:srgbClr val="D5DAE3"/>
+                      </a:solidFill>
+                      <a:prstDash val="solid"/>
+                      <a:round/>
+                      <a:headEnd type="none" w="med" len="med"/>
+                      <a:tailEnd type="none" w="med" len="med"/>
+                    </a:lnL>
+                    <a:lnR w="9525" cap="flat" cmpd="sng" algn="ctr">
+                      <a:solidFill>
+                        <a:srgbClr val="D5DAE3"/>
+                      </a:solidFill>
+                      <a:prstDash val="solid"/>
+                      <a:round/>
+                      <a:headEnd type="none" w="med" len="med"/>
+                      <a:tailEnd type="none" w="med" len="med"/>
+                    </a:lnR>
+                    <a:lnT w="9525" cap="flat" cmpd="sng" algn="ctr">
+                      <a:solidFill>
+                        <a:srgbClr val="D5DAE3"/>
+                      </a:solidFill>
+                      <a:prstDash val="solid"/>
+                      <a:round/>
+                      <a:headEnd type="none" w="med" len="med"/>
+                      <a:tailEnd type="none" w="med" len="med"/>
+                    </a:lnT>
+                    <a:lnB w="9525" cap="flat" cmpd="sng" algn="ctr">
+                      <a:solidFill>
+                        <a:srgbClr val="D5DAE3"/>
+                      </a:solidFill>
+                      <a:prstDash val="solid"/>
+                      <a:round/>
+                      <a:headEnd type="none" w="med" len="med"/>
+                      <a:tailEnd type="none" w="med" len="med"/>
+                    </a:lnB>
+                  </a:tcPr>
+                </a:tc>
+                <a:tc>
+                  <a:txBody>
+                    <a:bodyPr/>
+                    <a:lstStyle/>
+                    <a:p>
+                      <a:pPr indent="0" marL="0">
+                        <a:buNone/>
+                      </a:pPr>
+                      <a:r>
+                        <a:rPr lang="en-US" sz="1600" dirty="0">
+                          <a:solidFill>
+                            <a:schemeClr val="tx2"/>
+                          </a:solidFill>
+                        </a:rPr>
+                        <a:t>never trades</a:t>
+                      </a:r>
+                      <a:endParaRPr lang="en-US" sz="1600" dirty="0"/>
+                    </a:p>
+                  </a:txBody>
+                  <a:tcPr marL="109728" marR="109728" marT="54864" marB="54864" anchor="ctr">
+                    <a:lnL w="9525" cap="flat" cmpd="sng" algn="ctr">
+                      <a:solidFill>
+                        <a:srgbClr val="D5DAE3"/>
+                      </a:solidFill>
+                      <a:prstDash val="solid"/>
+                      <a:round/>
+                      <a:headEnd type="none" w="med" len="med"/>
+                      <a:tailEnd type="none" w="med" len="med"/>
+                    </a:lnL>
+                    <a:lnR w="9525" cap="flat" cmpd="sng" algn="ctr">
+                      <a:solidFill>
+                        <a:srgbClr val="D5DAE3"/>
+                      </a:solidFill>
+                      <a:prstDash val="solid"/>
+                      <a:round/>
+                      <a:headEnd type="none" w="med" len="med"/>
+                      <a:tailEnd type="none" w="med" len="med"/>
+                    </a:lnR>
+                    <a:lnT w="9525" cap="flat" cmpd="sng" algn="ctr">
+                      <a:solidFill>
+                        <a:srgbClr val="D5DAE3"/>
+                      </a:solidFill>
+                      <a:prstDash val="solid"/>
+                      <a:round/>
+                      <a:headEnd type="none" w="med" len="med"/>
+                      <a:tailEnd type="none" w="med" len="med"/>
+                    </a:lnT>
+                    <a:lnB w="9525" cap="flat" cmpd="sng" algn="ctr">
+                      <a:solidFill>
+                        <a:srgbClr val="D5DAE3"/>
+                      </a:solidFill>
+                      <a:prstDash val="solid"/>
+                      <a:round/>
+                      <a:headEnd type="none" w="med" len="med"/>
+                      <a:tailEnd type="none" w="med" len="med"/>
+                    </a:lnB>
+                  </a:tcPr>
+                </a:tc>
+                <a:tc>
+                  <a:txBody>
+                    <a:bodyPr/>
+                    <a:lstStyle/>
+                    <a:p>
+                      <a:pPr indent="0" marL="0">
+                        <a:buNone/>
+                      </a:pPr>
+                      <a:r>
+                        <a:rPr lang="en-US" sz="1600" dirty="0">
+                          <a:solidFill>
+                            <a:schemeClr val="tx2"/>
+                          </a:solidFill>
+                        </a:rPr>
+                        <a:t>$156,546</a:t>
+                      </a:r>
+                      <a:endParaRPr lang="en-US" sz="1600" dirty="0"/>
+                    </a:p>
+                  </a:txBody>
+                  <a:tcPr marL="109728" marR="109728" marT="54864" marB="54864" anchor="ctr">
+                    <a:lnL w="9525" cap="flat" cmpd="sng" algn="ctr">
+                      <a:solidFill>
+                        <a:srgbClr val="D5DAE3"/>
+                      </a:solidFill>
+                      <a:prstDash val="solid"/>
+                      <a:round/>
+                      <a:headEnd type="none" w="med" len="med"/>
+                      <a:tailEnd type="none" w="med" len="med"/>
+                    </a:lnL>
+                    <a:lnR w="9525" cap="flat" cmpd="sng" algn="ctr">
+                      <a:solidFill>
+                        <a:srgbClr val="D5DAE3"/>
+                      </a:solidFill>
+                      <a:prstDash val="solid"/>
+                      <a:round/>
+                      <a:headEnd type="none" w="med" len="med"/>
+                      <a:tailEnd type="none" w="med" len="med"/>
+                    </a:lnR>
+                    <a:lnT w="9525" cap="flat" cmpd="sng" algn="ctr">
+                      <a:solidFill>
+                        <a:srgbClr val="D5DAE3"/>
+                      </a:solidFill>
+                      <a:prstDash val="solid"/>
+                      <a:round/>
+                      <a:headEnd type="none" w="med" len="med"/>
+                      <a:tailEnd type="none" w="med" len="med"/>
+                    </a:lnT>
+                    <a:lnB w="9525" cap="flat" cmpd="sng" algn="ctr">
+                      <a:solidFill>
+                        <a:srgbClr val="D5DAE3"/>
+                      </a:solidFill>
+                      <a:prstDash val="solid"/>
+                      <a:round/>
+                      <a:headEnd type="none" w="med" len="med"/>
+                      <a:tailEnd type="none" w="med" len="med"/>
+                    </a:lnB>
+                  </a:tcPr>
+                </a:tc>
+              </a:tr>
+            </a:tbl>
+          </a:graphicData>
+        </a:graphic>
+      </p:graphicFrame>
+      <p:sp>
+        <p:nvSpPr>
+          <p:cNvPr id="4" name="Text 1"/>
+          <p:cNvSpPr txBox="1"/>
+          <p:nvPr/>
+        </p:nvSpPr>
+        <p:spPr>
+          <a:xfrm>
+            <a:off x="548640" y="3794760"/>
+            <a:ext cx="11094415" cy="548640"/>
+          </a:xfrm>
+          <a:prstGeom prst="rect">
+            <a:avLst/>
+          </a:prstGeom>
+          <a:noFill/>
+          <a:ln/>
+        </p:spPr>
+        <p:txBody>
+          <a:bodyPr wrap="square" lIns="0" tIns="0" rIns="0" bIns="0" rtlCol="0" anchor="t"/>
+          <a:lstStyle/>
+          <a:p>
+            <a:pPr indent="0" marL="0">
+              <a:buNone/>
+            </a:pPr>
+            <a:r>
+              <a:rPr lang="en-US" sz="1400" i="1" dirty="0">
+                <a:solidFill>
+                  <a:schemeClr val="accent3"/>
+                </a:solidFill>
+              </a:rPr>
+              <a:t>Each Friday after the close: predict Buy, Hold or Sell for the next 5 trading days, trade at Monday’s open, hold all week. Same frozen models; checked after the test results were known.</a:t>
+            </a:r>
+            <a:endParaRPr lang="en-US" sz="1400" dirty="0"/>
+          </a:p>
+        </p:txBody>
+      </p:sp>
+      <p:sp>
+        <p:nvSpPr>
+          <p:cNvPr id="5" name="Shape 2"/>
           <p:cNvSpPr/>
           <p:nvPr/>
         </p:nvSpPr>
         <p:spPr>
           <a:xfrm>
-            <a:off x="548640" y="1417320"/>
-            <a:ext cx="5468112" cy="2103120"/>
+            <a:off x="548640" y="4434840"/>
+            <a:ext cx="3593592" cy="1463040"/>
           </a:xfrm>
           <a:prstGeom prst="roundRect">
             <a:avLst>
-              <a:gd name="adj" fmla="val 5217"/>
+              <a:gd name="adj" fmla="val 7500"/>
             </a:avLst>
           </a:prstGeom>
           <a:solidFill>
@@ -21350,39 +22456,14 @@
       </p:sp>
       <p:sp>
         <p:nvSpPr>
-          <p:cNvPr id="4" name="Shape 2"/>
-          <p:cNvSpPr/>
-          <p:nvPr/>
-        </p:nvSpPr>
-        <p:spPr>
-          <a:xfrm>
-            <a:off x="777240" y="1645920"/>
-            <a:ext cx="438912" cy="438912"/>
-          </a:xfrm>
-          <a:prstGeom prst="ellipse">
-            <a:avLst/>
-          </a:prstGeom>
-          <a:solidFill>
-            <a:schemeClr val="accent1"/>
-          </a:solidFill>
-          <a:ln w="12700">
-            <a:solidFill>
-              <a:schemeClr val="accent1"/>
-            </a:solidFill>
-            <a:prstDash val="solid"/>
-          </a:ln>
-        </p:spPr>
-      </p:sp>
-      <p:sp>
-        <p:nvSpPr>
-          <p:cNvPr id="5" name="Text 3"/>
+          <p:cNvPr id="6" name="Text 3"/>
           <p:cNvSpPr txBox="1"/>
           <p:nvPr/>
         </p:nvSpPr>
         <p:spPr>
           <a:xfrm>
-            <a:off x="777240" y="1645920"/>
-            <a:ext cx="438912" cy="438912"/>
+            <a:off x="777240" y="4663440"/>
+            <a:ext cx="3136392" cy="438912"/>
           </a:xfrm>
           <a:prstGeom prst="rect">
             <a:avLst/>
@@ -21394,47 +22475,11 @@
           <a:bodyPr wrap="square" lIns="0" tIns="0" rIns="0" bIns="0" rtlCol="0" anchor="ctr"/>
           <a:lstStyle/>
           <a:p>
-            <a:pPr algn="ctr" indent="0" marL="0">
-              <a:buNone/>
-            </a:pPr>
-            <a:r>
-              <a:rPr lang="en-US" sz="1600" b="1" dirty="0">
-                <a:solidFill>
-                  <a:schemeClr val="bg1"/>
-                </a:solidFill>
-              </a:rPr>
-              <a:t>1</a:t>
-            </a:r>
-            <a:endParaRPr lang="en-US" sz="1600" dirty="0"/>
-          </a:p>
-        </p:txBody>
-      </p:sp>
-      <p:sp>
-        <p:nvSpPr>
-          <p:cNvPr id="6" name="Text 4"/>
-          <p:cNvSpPr txBox="1"/>
-          <p:nvPr/>
-        </p:nvSpPr>
-        <p:spPr>
-          <a:xfrm>
-            <a:off x="1371600" y="1645920"/>
-            <a:ext cx="4416552" cy="438912"/>
-          </a:xfrm>
-          <a:prstGeom prst="rect">
-            <a:avLst/>
-          </a:prstGeom>
-          <a:noFill/>
-          <a:ln/>
-        </p:spPr>
-        <p:txBody>
-          <a:bodyPr wrap="square" lIns="0" tIns="0" rIns="0" bIns="0" rtlCol="0" anchor="ctr"/>
-          <a:lstStyle/>
-          <a:p>
             <a:pPr indent="0" marL="0">
               <a:buNone/>
             </a:pPr>
             <a:r>
-              <a:rPr lang="en-US" sz="1800" b="1" dirty="0">
+              <a:rPr lang="en-US" sz="1700" b="1" dirty="0">
                 <a:solidFill>
                   <a:schemeClr val="tx1"/>
                 </a:solidFill>
@@ -21442,22 +22487,22 @@
                 <a:ea typeface="Cambria" pitchFamily="34" charset="-122"/>
                 <a:cs typeface="Cambria" pitchFamily="34" charset="-120"/>
               </a:rPr>
-              <a:t>Plans written before code</a:t>
-            </a:r>
-            <a:endParaRPr lang="en-US" sz="1800" dirty="0"/>
-          </a:p>
-        </p:txBody>
-      </p:sp>
-      <p:sp>
-        <p:nvSpPr>
-          <p:cNvPr id="7" name="Text 5"/>
+              <a:t>Half the trades</a:t>
+            </a:r>
+            <a:endParaRPr lang="en-US" sz="1700" dirty="0"/>
+          </a:p>
+        </p:txBody>
+      </p:sp>
+      <p:sp>
+        <p:nvSpPr>
+          <p:cNvPr id="7" name="Text 4"/>
           <p:cNvSpPr txBox="1"/>
           <p:nvPr/>
         </p:nvSpPr>
         <p:spPr>
           <a:xfrm>
-            <a:off x="777240" y="2194560"/>
-            <a:ext cx="5010912" cy="1143000"/>
+            <a:off x="777240" y="5212080"/>
+            <a:ext cx="3136392" cy="502920"/>
           </a:xfrm>
           <a:prstGeom prst="rect">
             <a:avLst/>
@@ -21473,31 +22518,133 @@
               <a:buNone/>
             </a:pPr>
             <a:r>
-              <a:rPr lang="en-US" sz="1500" dirty="0">
+              <a:rPr lang="en-US" sz="1400" dirty="0">
                 <a:solidFill>
                   <a:schemeClr val="tx2"/>
                 </a:solidFill>
               </a:rPr>
-              <a:t>Each version’s design was committed before any code or result existed, with a digital fingerprint (SHA-256) so later edits would show.</a:t>
-            </a:r>
-            <a:endParaRPr lang="en-US" sz="1500" dirty="0"/>
-          </a:p>
-        </p:txBody>
-      </p:sp>
-      <p:sp>
-        <p:nvSpPr>
-          <p:cNvPr id="8" name="Shape 6"/>
+              <a:t>Fewer, longer positions roughly halve trading costs.</a:t>
+            </a:r>
+            <a:endParaRPr lang="en-US" sz="1400" dirty="0"/>
+          </a:p>
+        </p:txBody>
+      </p:sp>
+      <p:sp>
+        <p:nvSpPr>
+          <p:cNvPr id="8" name="Shape 5"/>
           <p:cNvSpPr/>
           <p:nvPr/>
         </p:nvSpPr>
         <p:spPr>
           <a:xfrm>
-            <a:off x="6172200" y="1417320"/>
-            <a:ext cx="5468112" cy="2103120"/>
+            <a:off x="4297680" y="4434840"/>
+            <a:ext cx="3593592" cy="1463040"/>
           </a:xfrm>
           <a:prstGeom prst="roundRect">
             <a:avLst>
-              <a:gd name="adj" fmla="val 5217"/>
+              <a:gd name="adj" fmla="val 7500"/>
+            </a:avLst>
+          </a:prstGeom>
+          <a:solidFill>
+            <a:srgbClr val="FBEDE4"/>
+          </a:solidFill>
+          <a:ln w="12700">
+            <a:solidFill>
+              <a:srgbClr val="FBEDE4"/>
+            </a:solidFill>
+            <a:prstDash val="solid"/>
+          </a:ln>
+        </p:spPr>
+      </p:sp>
+      <p:sp>
+        <p:nvSpPr>
+          <p:cNvPr id="9" name="Text 6"/>
+          <p:cNvSpPr txBox="1"/>
+          <p:nvPr/>
+        </p:nvSpPr>
+        <p:spPr>
+          <a:xfrm>
+            <a:off x="4526280" y="4663440"/>
+            <a:ext cx="3136392" cy="438912"/>
+          </a:xfrm>
+          <a:prstGeom prst="rect">
+            <a:avLst/>
+          </a:prstGeom>
+          <a:noFill/>
+          <a:ln/>
+        </p:spPr>
+        <p:txBody>
+          <a:bodyPr wrap="square" lIns="0" tIns="0" rIns="0" bIns="0" rtlCol="0" anchor="ctr"/>
+          <a:lstStyle/>
+          <a:p>
+            <a:pPr indent="0" marL="0">
+              <a:buNone/>
+            </a:pPr>
+            <a:r>
+              <a:rPr lang="en-US" sz="1700" b="1" dirty="0">
+                <a:solidFill>
+                  <a:schemeClr val="tx1"/>
+                </a:solidFill>
+                <a:latin typeface="Cambria" pitchFamily="34" charset="0"/>
+                <a:ea typeface="Cambria" pitchFamily="34" charset="-122"/>
+                <a:cs typeface="Cambria" pitchFamily="34" charset="-120"/>
+              </a:rPr>
+              <a:t>Same conclusion</a:t>
+            </a:r>
+            <a:endParaRPr lang="en-US" sz="1700" dirty="0"/>
+          </a:p>
+        </p:txBody>
+      </p:sp>
+      <p:sp>
+        <p:nvSpPr>
+          <p:cNvPr id="10" name="Text 7"/>
+          <p:cNvSpPr txBox="1"/>
+          <p:nvPr/>
+        </p:nvSpPr>
+        <p:spPr>
+          <a:xfrm>
+            <a:off x="4526280" y="5212080"/>
+            <a:ext cx="3136392" cy="502920"/>
+          </a:xfrm>
+          <a:prstGeom prst="rect">
+            <a:avLst/>
+          </a:prstGeom>
+          <a:noFill/>
+          <a:ln/>
+        </p:spPr>
+        <p:txBody>
+          <a:bodyPr wrap="square" lIns="0" tIns="0" rIns="0" bIns="0" rtlCol="0" anchor="t"/>
+          <a:lstStyle/>
+          <a:p>
+            <a:pPr indent="0" marL="0">
+              <a:buNone/>
+            </a:pPr>
+            <a:r>
+              <a:rPr lang="en-US" sz="1400" dirty="0">
+                <a:solidFill>
+                  <a:schemeClr val="tx2"/>
+                </a:solidFill>
+              </a:rPr>
+              <a:t>Still about $32,000 behind Buy &amp; Hold on 2023–24.</a:t>
+            </a:r>
+            <a:endParaRPr lang="en-US" sz="1400" dirty="0"/>
+          </a:p>
+        </p:txBody>
+      </p:sp>
+      <p:sp>
+        <p:nvSpPr>
+          <p:cNvPr id="11" name="Shape 8"/>
+          <p:cNvSpPr/>
+          <p:nvPr/>
+        </p:nvSpPr>
+        <p:spPr>
+          <a:xfrm>
+            <a:off x="8046720" y="4434840"/>
+            <a:ext cx="3593592" cy="1463040"/>
+          </a:xfrm>
+          <a:prstGeom prst="roundRect">
+            <a:avLst>
+              <a:gd name="adj" fmla="val 7500"/>
             </a:avLst>
           </a:prstGeom>
           <a:solidFill>
@@ -21513,39 +22660,14 @@
       </p:sp>
       <p:sp>
         <p:nvSpPr>
-          <p:cNvPr id="9" name="Shape 7"/>
-          <p:cNvSpPr/>
-          <p:nvPr/>
-        </p:nvSpPr>
-        <p:spPr>
-          <a:xfrm>
-            <a:off x="6400800" y="1645920"/>
-            <a:ext cx="438912" cy="438912"/>
-          </a:xfrm>
-          <a:prstGeom prst="ellipse">
-            <a:avLst/>
-          </a:prstGeom>
-          <a:solidFill>
-            <a:schemeClr val="accent1"/>
-          </a:solidFill>
-          <a:ln w="12700">
-            <a:solidFill>
-              <a:schemeClr val="accent1"/>
-            </a:solidFill>
-            <a:prstDash val="solid"/>
-          </a:ln>
-        </p:spPr>
-      </p:sp>
-      <p:sp>
-        <p:nvSpPr>
-          <p:cNvPr id="10" name="Text 8"/>
+          <p:cNvPr id="12" name="Text 9"/>
           <p:cNvSpPr txBox="1"/>
           <p:nvPr/>
         </p:nvSpPr>
         <p:spPr>
           <a:xfrm>
-            <a:off x="6400800" y="1645920"/>
-            <a:ext cx="438912" cy="438912"/>
+            <a:off x="8275320" y="4663440"/>
+            <a:ext cx="3136392" cy="438912"/>
           </a:xfrm>
           <a:prstGeom prst="rect">
             <a:avLst/>
@@ -21557,47 +22679,11 @@
           <a:bodyPr wrap="square" lIns="0" tIns="0" rIns="0" bIns="0" rtlCol="0" anchor="ctr"/>
           <a:lstStyle/>
           <a:p>
-            <a:pPr algn="ctr" indent="0" marL="0">
-              <a:buNone/>
-            </a:pPr>
-            <a:r>
-              <a:rPr lang="en-US" sz="1600" b="1" dirty="0">
-                <a:solidFill>
-                  <a:schemeClr val="bg1"/>
-                </a:solidFill>
-              </a:rPr>
-              <a:t>2</a:t>
-            </a:r>
-            <a:endParaRPr lang="en-US" sz="1600" dirty="0"/>
-          </a:p>
-        </p:txBody>
-      </p:sp>
-      <p:sp>
-        <p:nvSpPr>
-          <p:cNvPr id="11" name="Text 9"/>
-          <p:cNvSpPr txBox="1"/>
-          <p:nvPr/>
-        </p:nvSpPr>
-        <p:spPr>
-          <a:xfrm>
-            <a:off x="6995160" y="1645920"/>
-            <a:ext cx="4416552" cy="438912"/>
-          </a:xfrm>
-          <a:prstGeom prst="rect">
-            <a:avLst/>
-          </a:prstGeom>
-          <a:noFill/>
-          <a:ln/>
-        </p:spPr>
-        <p:txBody>
-          <a:bodyPr wrap="square" lIns="0" tIns="0" rIns="0" bIns="0" rtlCol="0" anchor="ctr"/>
-          <a:lstStyle/>
-          <a:p>
             <a:pPr indent="0" marL="0">
               <a:buNone/>
             </a:pPr>
             <a:r>
-              <a:rPr lang="en-US" sz="1800" b="1" dirty="0">
+              <a:rPr lang="en-US" sz="1700" b="1" dirty="0">
                 <a:solidFill>
                   <a:schemeClr val="tx1"/>
                 </a:solidFill>
@@ -21605,22 +22691,22 @@
                 <a:ea typeface="Cambria" pitchFamily="34" charset="-122"/>
                 <a:cs typeface="Cambria" pitchFamily="34" charset="-120"/>
               </a:rPr>
-              <a:t>Final exam opened once</a:t>
-            </a:r>
-            <a:endParaRPr lang="en-US" sz="1800" dirty="0"/>
-          </a:p>
-        </p:txBody>
-      </p:sp>
-      <p:sp>
-        <p:nvSpPr>
-          <p:cNvPr id="12" name="Text 10"/>
+              <a:t>Slower, not smarter</a:t>
+            </a:r>
+            <a:endParaRPr lang="en-US" sz="1700" dirty="0"/>
+          </a:p>
+        </p:txBody>
+      </p:sp>
+      <p:sp>
+        <p:nvSpPr>
+          <p:cNvPr id="13" name="Text 10"/>
           <p:cNvSpPr txBox="1"/>
           <p:nvPr/>
         </p:nvSpPr>
         <p:spPr>
           <a:xfrm>
-            <a:off x="6400800" y="2194560"/>
-            <a:ext cx="5010912" cy="1143000"/>
+            <a:off x="8275320" y="5212080"/>
+            <a:ext cx="3136392" cy="502920"/>
           </a:xfrm>
           <a:prstGeom prst="rect">
             <a:avLst/>
@@ -21636,340 +22722,14 @@
               <a:buNone/>
             </a:pPr>
             <a:r>
-              <a:rPr lang="en-US" sz="1500" dirty="0">
+              <a:rPr lang="en-US" sz="1400" dirty="0">
                 <a:solidFill>
                   <a:schemeClr val="tx2"/>
                 </a:solidFill>
               </a:rPr>
-              <a:t>Each version picked its model on earlier data, locked it, and only then saw the test years.</a:t>
-            </a:r>
-            <a:endParaRPr lang="en-US" sz="1500" dirty="0"/>
-          </a:p>
-        </p:txBody>
-      </p:sp>
-      <p:sp>
-        <p:nvSpPr>
-          <p:cNvPr id="13" name="Shape 11"/>
-          <p:cNvSpPr/>
-          <p:nvPr/>
-        </p:nvSpPr>
-        <p:spPr>
-          <a:xfrm>
-            <a:off x="548640" y="3703320"/>
-            <a:ext cx="5468112" cy="2103120"/>
-          </a:xfrm>
-          <a:prstGeom prst="roundRect">
-            <a:avLst>
-              <a:gd name="adj" fmla="val 5217"/>
-            </a:avLst>
-          </a:prstGeom>
-          <a:solidFill>
-            <a:schemeClr val="bg2"/>
-          </a:solidFill>
-          <a:ln w="12700">
-            <a:solidFill>
-              <a:schemeClr val="bg2"/>
-            </a:solidFill>
-            <a:prstDash val="solid"/>
-          </a:ln>
-        </p:spPr>
-      </p:sp>
-      <p:sp>
-        <p:nvSpPr>
-          <p:cNvPr id="14" name="Shape 12"/>
-          <p:cNvSpPr/>
-          <p:nvPr/>
-        </p:nvSpPr>
-        <p:spPr>
-          <a:xfrm>
-            <a:off x="777240" y="3931920"/>
-            <a:ext cx="438912" cy="438912"/>
-          </a:xfrm>
-          <a:prstGeom prst="ellipse">
-            <a:avLst/>
-          </a:prstGeom>
-          <a:solidFill>
-            <a:schemeClr val="accent1"/>
-          </a:solidFill>
-          <a:ln w="12700">
-            <a:solidFill>
-              <a:schemeClr val="accent1"/>
-            </a:solidFill>
-            <a:prstDash val="solid"/>
-          </a:ln>
-        </p:spPr>
-      </p:sp>
-      <p:sp>
-        <p:nvSpPr>
-          <p:cNvPr id="15" name="Text 13"/>
-          <p:cNvSpPr txBox="1"/>
-          <p:nvPr/>
-        </p:nvSpPr>
-        <p:spPr>
-          <a:xfrm>
-            <a:off x="777240" y="3931920"/>
-            <a:ext cx="438912" cy="438912"/>
-          </a:xfrm>
-          <a:prstGeom prst="rect">
-            <a:avLst/>
-          </a:prstGeom>
-          <a:noFill/>
-          <a:ln/>
-        </p:spPr>
-        <p:txBody>
-          <a:bodyPr wrap="square" lIns="0" tIns="0" rIns="0" bIns="0" rtlCol="0" anchor="ctr"/>
-          <a:lstStyle/>
-          <a:p>
-            <a:pPr algn="ctr" indent="0" marL="0">
-              <a:buNone/>
-            </a:pPr>
-            <a:r>
-              <a:rPr lang="en-US" sz="1600" b="1" dirty="0">
-                <a:solidFill>
-                  <a:schemeClr val="bg1"/>
-                </a:solidFill>
-              </a:rPr>
-              <a:t>3</a:t>
-            </a:r>
-            <a:endParaRPr lang="en-US" sz="1600" dirty="0"/>
-          </a:p>
-        </p:txBody>
-      </p:sp>
-      <p:sp>
-        <p:nvSpPr>
-          <p:cNvPr id="16" name="Text 14"/>
-          <p:cNvSpPr txBox="1"/>
-          <p:nvPr/>
-        </p:nvSpPr>
-        <p:spPr>
-          <a:xfrm>
-            <a:off x="1371600" y="3931920"/>
-            <a:ext cx="4416552" cy="438912"/>
-          </a:xfrm>
-          <a:prstGeom prst="rect">
-            <a:avLst/>
-          </a:prstGeom>
-          <a:noFill/>
-          <a:ln/>
-        </p:spPr>
-        <p:txBody>
-          <a:bodyPr wrap="square" lIns="0" tIns="0" rIns="0" bIns="0" rtlCol="0" anchor="ctr"/>
-          <a:lstStyle/>
-          <a:p>
-            <a:pPr indent="0" marL="0">
-              <a:buNone/>
-            </a:pPr>
-            <a:r>
-              <a:rPr lang="en-US" sz="1800" b="1" dirty="0">
-                <a:solidFill>
-                  <a:schemeClr val="tx1"/>
-                </a:solidFill>
-                <a:latin typeface="Cambria" pitchFamily="34" charset="0"/>
-                <a:ea typeface="Cambria" pitchFamily="34" charset="-122"/>
-                <a:cs typeface="Cambria" pitchFamily="34" charset="-120"/>
-              </a:rPr>
-              <a:t>46 automated tests</a:t>
-            </a:r>
-            <a:endParaRPr lang="en-US" sz="1800" dirty="0"/>
-          </a:p>
-        </p:txBody>
-      </p:sp>
-      <p:sp>
-        <p:nvSpPr>
-          <p:cNvPr id="17" name="Text 15"/>
-          <p:cNvSpPr txBox="1"/>
-          <p:nvPr/>
-        </p:nvSpPr>
-        <p:spPr>
-          <a:xfrm>
-            <a:off x="777240" y="4480560"/>
-            <a:ext cx="5010912" cy="1143000"/>
-          </a:xfrm>
-          <a:prstGeom prst="rect">
-            <a:avLst/>
-          </a:prstGeom>
-          <a:noFill/>
-          <a:ln/>
-        </p:spPr>
-        <p:txBody>
-          <a:bodyPr wrap="square" lIns="0" tIns="0" rIns="0" bIns="0" rtlCol="0" anchor="t"/>
-          <a:lstStyle/>
-          <a:p>
-            <a:pPr indent="0" marL="0">
-              <a:buNone/>
-            </a:pPr>
-            <a:r>
-              <a:rPr lang="en-US" sz="1500" dirty="0">
-                <a:solidFill>
-                  <a:schemeClr val="tx2"/>
-                </a:solidFill>
-              </a:rPr>
-              <a:t>They check the model never sees the future, e.g. scrambling future data must not change any prediction.</a:t>
-            </a:r>
-            <a:endParaRPr lang="en-US" sz="1500" dirty="0"/>
-          </a:p>
-        </p:txBody>
-      </p:sp>
-      <p:sp>
-        <p:nvSpPr>
-          <p:cNvPr id="18" name="Shape 16"/>
-          <p:cNvSpPr/>
-          <p:nvPr/>
-        </p:nvSpPr>
-        <p:spPr>
-          <a:xfrm>
-            <a:off x="6172200" y="3703320"/>
-            <a:ext cx="5468112" cy="2103120"/>
-          </a:xfrm>
-          <a:prstGeom prst="roundRect">
-            <a:avLst>
-              <a:gd name="adj" fmla="val 5217"/>
-            </a:avLst>
-          </a:prstGeom>
-          <a:solidFill>
-            <a:schemeClr val="bg2"/>
-          </a:solidFill>
-          <a:ln w="12700">
-            <a:solidFill>
-              <a:schemeClr val="bg2"/>
-            </a:solidFill>
-            <a:prstDash val="solid"/>
-          </a:ln>
-        </p:spPr>
-      </p:sp>
-      <p:sp>
-        <p:nvSpPr>
-          <p:cNvPr id="19" name="Shape 17"/>
-          <p:cNvSpPr/>
-          <p:nvPr/>
-        </p:nvSpPr>
-        <p:spPr>
-          <a:xfrm>
-            <a:off x="6400800" y="3931920"/>
-            <a:ext cx="438912" cy="438912"/>
-          </a:xfrm>
-          <a:prstGeom prst="ellipse">
-            <a:avLst/>
-          </a:prstGeom>
-          <a:solidFill>
-            <a:schemeClr val="accent1"/>
-          </a:solidFill>
-          <a:ln w="12700">
-            <a:solidFill>
-              <a:schemeClr val="accent1"/>
-            </a:solidFill>
-            <a:prstDash val="solid"/>
-          </a:ln>
-        </p:spPr>
-      </p:sp>
-      <p:sp>
-        <p:nvSpPr>
-          <p:cNvPr id="20" name="Text 18"/>
-          <p:cNvSpPr txBox="1"/>
-          <p:nvPr/>
-        </p:nvSpPr>
-        <p:spPr>
-          <a:xfrm>
-            <a:off x="6400800" y="3931920"/>
-            <a:ext cx="438912" cy="438912"/>
-          </a:xfrm>
-          <a:prstGeom prst="rect">
-            <a:avLst/>
-          </a:prstGeom>
-          <a:noFill/>
-          <a:ln/>
-        </p:spPr>
-        <p:txBody>
-          <a:bodyPr wrap="square" lIns="0" tIns="0" rIns="0" bIns="0" rtlCol="0" anchor="ctr"/>
-          <a:lstStyle/>
-          <a:p>
-            <a:pPr algn="ctr" indent="0" marL="0">
-              <a:buNone/>
-            </a:pPr>
-            <a:r>
-              <a:rPr lang="en-US" sz="1600" b="1" dirty="0">
-                <a:solidFill>
-                  <a:schemeClr val="bg1"/>
-                </a:solidFill>
-              </a:rPr>
-              <a:t>4</a:t>
-            </a:r>
-            <a:endParaRPr lang="en-US" sz="1600" dirty="0"/>
-          </a:p>
-        </p:txBody>
-      </p:sp>
-      <p:sp>
-        <p:nvSpPr>
-          <p:cNvPr id="21" name="Text 19"/>
-          <p:cNvSpPr txBox="1"/>
-          <p:nvPr/>
-        </p:nvSpPr>
-        <p:spPr>
-          <a:xfrm>
-            <a:off x="6995160" y="3931920"/>
-            <a:ext cx="4416552" cy="438912"/>
-          </a:xfrm>
-          <a:prstGeom prst="rect">
-            <a:avLst/>
-          </a:prstGeom>
-          <a:noFill/>
-          <a:ln/>
-        </p:spPr>
-        <p:txBody>
-          <a:bodyPr wrap="square" lIns="0" tIns="0" rIns="0" bIns="0" rtlCol="0" anchor="ctr"/>
-          <a:lstStyle/>
-          <a:p>
-            <a:pPr indent="0" marL="0">
-              <a:buNone/>
-            </a:pPr>
-            <a:r>
-              <a:rPr lang="en-US" sz="1800" b="1" dirty="0">
-                <a:solidFill>
-                  <a:schemeClr val="tx1"/>
-                </a:solidFill>
-                <a:latin typeface="Cambria" pitchFamily="34" charset="0"/>
-                <a:ea typeface="Cambria" pitchFamily="34" charset="-122"/>
-                <a:cs typeface="Cambria" pitchFamily="34" charset="-120"/>
-              </a:rPr>
-              <a:t>Failures reported, not hidden</a:t>
-            </a:r>
-            <a:endParaRPr lang="en-US" sz="1800" dirty="0"/>
-          </a:p>
-        </p:txBody>
-      </p:sp>
-      <p:sp>
-        <p:nvSpPr>
-          <p:cNvPr id="22" name="Text 20"/>
-          <p:cNvSpPr txBox="1"/>
-          <p:nvPr/>
-        </p:nvSpPr>
-        <p:spPr>
-          <a:xfrm>
-            <a:off x="6400800" y="4480560"/>
-            <a:ext cx="5010912" cy="1143000"/>
-          </a:xfrm>
-          <a:prstGeom prst="rect">
-            <a:avLst/>
-          </a:prstGeom>
-          <a:noFill/>
-          <a:ln/>
-        </p:spPr>
-        <p:txBody>
-          <a:bodyPr wrap="square" lIns="0" tIns="0" rIns="0" bIns="0" rtlCol="0" anchor="t"/>
-          <a:lstStyle/>
-          <a:p>
-            <a:pPr indent="0" marL="0">
-              <a:buNone/>
-            </a:pPr>
-            <a:r>
-              <a:rPr lang="en-US" sz="1500" dirty="0">
-                <a:solidFill>
-                  <a:schemeClr val="tx2"/>
-                </a:solidFill>
-              </a:rPr>
-              <a:t>Every change after results is logged, including a one-day overlap we found in v1’s work and v3 failing its own calibration test.</a:t>
-            </a:r>
-            <a:endParaRPr lang="en-US" sz="1500" dirty="0"/>
+              <a:t>Over 2013–24, weekly v2 made $167,581 vs $179,977 daily.</a:t>
+            </a:r>
+            <a:endParaRPr lang="en-US" sz="1400" dirty="0"/>
           </a:p>
         </p:txBody>
       </p:sp>
@@ -22078,7 +22838,7 @@
                 <a:ea typeface="Cambria" pitchFamily="34" charset="-122"/>
                 <a:cs typeface="Cambria" pitchFamily="34" charset="-120"/>
               </a:rPr>
-              <a:t>A flaw of machine learning, or of the question?</a:t>
+              <a:t>How we kept the test honest</a:t>
             </a:r>
             <a:endParaRPr lang="en-US" sz="3200" dirty="0"/>
           </a:p>
@@ -22092,114 +22852,12 @@
         </p:nvSpPr>
         <p:spPr>
           <a:xfrm>
-            <a:off x="548640" y="1371600"/>
-            <a:ext cx="11094415" cy="1024128"/>
+            <a:off x="548640" y="1417320"/>
+            <a:ext cx="5468112" cy="2103120"/>
           </a:xfrm>
           <a:prstGeom prst="roundRect">
             <a:avLst>
-              <a:gd name="adj" fmla="val 8929"/>
-            </a:avLst>
-          </a:prstGeom>
-          <a:solidFill>
-            <a:srgbClr val="FBEDE4"/>
-          </a:solidFill>
-          <a:ln w="12700">
-            <a:solidFill>
-              <a:srgbClr val="FBEDE4"/>
-            </a:solidFill>
-            <a:prstDash val="solid"/>
-          </a:ln>
-        </p:spPr>
-      </p:sp>
-      <p:sp>
-        <p:nvSpPr>
-          <p:cNvPr id="4" name="Text 2"/>
-          <p:cNvSpPr txBox="1"/>
-          <p:nvPr/>
-        </p:nvSpPr>
-        <p:spPr>
-          <a:xfrm>
-            <a:off x="822960" y="1371600"/>
-            <a:ext cx="3291840" cy="1024128"/>
-          </a:xfrm>
-          <a:prstGeom prst="rect">
-            <a:avLst/>
-          </a:prstGeom>
-          <a:noFill/>
-          <a:ln/>
-        </p:spPr>
-        <p:txBody>
-          <a:bodyPr wrap="square" lIns="0" tIns="0" rIns="0" bIns="0" rtlCol="0" anchor="ctr"/>
-          <a:lstStyle/>
-          <a:p>
-            <a:pPr indent="0" marL="0">
-              <a:buNone/>
-            </a:pPr>
-            <a:r>
-              <a:rPr lang="en-US" sz="1900" b="1" dirty="0">
-                <a:solidFill>
-                  <a:schemeClr val="tx1"/>
-                </a:solidFill>
-                <a:latin typeface="Cambria" pitchFamily="34" charset="0"/>
-                <a:ea typeface="Cambria" pitchFamily="34" charset="-122"/>
-                <a:cs typeface="Cambria" pitchFamily="34" charset="-120"/>
-              </a:rPr>
-              <a:t>Mostly the question</a:t>
-            </a:r>
-            <a:endParaRPr lang="en-US" sz="1900" dirty="0"/>
-          </a:p>
-        </p:txBody>
-      </p:sp>
-      <p:sp>
-        <p:nvSpPr>
-          <p:cNvPr id="5" name="Text 3"/>
-          <p:cNvSpPr txBox="1"/>
-          <p:nvPr/>
-        </p:nvSpPr>
-        <p:spPr>
-          <a:xfrm>
-            <a:off x="4297680" y="1371600"/>
-            <a:ext cx="7116775" cy="1024128"/>
-          </a:xfrm>
-          <a:prstGeom prst="rect">
-            <a:avLst/>
-          </a:prstGeom>
-          <a:noFill/>
-          <a:ln/>
-        </p:spPr>
-        <p:txBody>
-          <a:bodyPr wrap="square" lIns="0" tIns="0" rIns="0" bIns="0" rtlCol="0" anchor="ctr"/>
-          <a:lstStyle/>
-          <a:p>
-            <a:pPr indent="0" marL="0">
-              <a:buNone/>
-            </a:pPr>
-            <a:r>
-              <a:rPr lang="en-US" sz="1600" dirty="0">
-                <a:solidFill>
-                  <a:schemeClr val="tx2"/>
-                </a:solidFill>
-              </a:rPr>
-              <a:t>We asked for next week’s direction of the world’s most-watched fund, using only its own public price history. Simple patterns there get traded away, and no algorithm can find information that isn’t in the data.</a:t>
-            </a:r>
-            <a:endParaRPr lang="en-US" sz="1600" dirty="0"/>
-          </a:p>
-        </p:txBody>
-      </p:sp>
-      <p:sp>
-        <p:nvSpPr>
-          <p:cNvPr id="6" name="Shape 4"/>
-          <p:cNvSpPr/>
-          <p:nvPr/>
-        </p:nvSpPr>
-        <p:spPr>
-          <a:xfrm>
-            <a:off x="548640" y="2514600"/>
-            <a:ext cx="11094415" cy="1024128"/>
-          </a:xfrm>
-          <a:prstGeom prst="roundRect">
-            <a:avLst>
-              <a:gd name="adj" fmla="val 8929"/>
+              <a:gd name="adj" fmla="val 5217"/>
             </a:avLst>
           </a:prstGeom>
           <a:solidFill>
@@ -22215,14 +22873,39 @@
       </p:sp>
       <p:sp>
         <p:nvSpPr>
-          <p:cNvPr id="7" name="Text 5"/>
+          <p:cNvPr id="4" name="Shape 2"/>
+          <p:cNvSpPr/>
+          <p:nvPr/>
+        </p:nvSpPr>
+        <p:spPr>
+          <a:xfrm>
+            <a:off x="777240" y="1645920"/>
+            <a:ext cx="438912" cy="438912"/>
+          </a:xfrm>
+          <a:prstGeom prst="ellipse">
+            <a:avLst/>
+          </a:prstGeom>
+          <a:solidFill>
+            <a:schemeClr val="accent1"/>
+          </a:solidFill>
+          <a:ln w="12700">
+            <a:solidFill>
+              <a:schemeClr val="accent1"/>
+            </a:solidFill>
+            <a:prstDash val="solid"/>
+          </a:ln>
+        </p:spPr>
+      </p:sp>
+      <p:sp>
+        <p:nvSpPr>
+          <p:cNvPr id="5" name="Text 3"/>
           <p:cNvSpPr txBox="1"/>
           <p:nvPr/>
         </p:nvSpPr>
         <p:spPr>
           <a:xfrm>
-            <a:off x="822960" y="2514600"/>
-            <a:ext cx="3291840" cy="1024128"/>
+            <a:off x="777240" y="1645920"/>
+            <a:ext cx="438912" cy="438912"/>
           </a:xfrm>
           <a:prstGeom prst="rect">
             <a:avLst/>
@@ -22234,11 +22917,47 @@
           <a:bodyPr wrap="square" lIns="0" tIns="0" rIns="0" bIns="0" rtlCol="0" anchor="ctr"/>
           <a:lstStyle/>
           <a:p>
+            <a:pPr algn="ctr" indent="0" marL="0">
+              <a:buNone/>
+            </a:pPr>
+            <a:r>
+              <a:rPr lang="en-US" sz="1600" b="1" dirty="0">
+                <a:solidFill>
+                  <a:schemeClr val="bg1"/>
+                </a:solidFill>
+              </a:rPr>
+              <a:t>1</a:t>
+            </a:r>
+            <a:endParaRPr lang="en-US" sz="1600" dirty="0"/>
+          </a:p>
+        </p:txBody>
+      </p:sp>
+      <p:sp>
+        <p:nvSpPr>
+          <p:cNvPr id="6" name="Text 4"/>
+          <p:cNvSpPr txBox="1"/>
+          <p:nvPr/>
+        </p:nvSpPr>
+        <p:spPr>
+          <a:xfrm>
+            <a:off x="1371600" y="1645920"/>
+            <a:ext cx="4416552" cy="438912"/>
+          </a:xfrm>
+          <a:prstGeom prst="rect">
+            <a:avLst/>
+          </a:prstGeom>
+          <a:noFill/>
+          <a:ln/>
+        </p:spPr>
+        <p:txBody>
+          <a:bodyPr wrap="square" lIns="0" tIns="0" rIns="0" bIns="0" rtlCol="0" anchor="ctr"/>
+          <a:lstStyle/>
+          <a:p>
             <a:pPr indent="0" marL="0">
               <a:buNone/>
             </a:pPr>
             <a:r>
-              <a:rPr lang="en-US" sz="1900" b="1" dirty="0">
+              <a:rPr lang="en-US" sz="1800" b="1" dirty="0">
                 <a:solidFill>
                   <a:schemeClr val="tx1"/>
                 </a:solidFill>
@@ -22246,22 +22965,22 @@
                 <a:ea typeface="Cambria" pitchFamily="34" charset="-122"/>
                 <a:cs typeface="Cambria" pitchFamily="34" charset="-120"/>
               </a:rPr>
-              <a:t>Partly our own limits</a:t>
-            </a:r>
-            <a:endParaRPr lang="en-US" sz="1900" dirty="0"/>
-          </a:p>
-        </p:txBody>
-      </p:sp>
-      <p:sp>
-        <p:nvSpPr>
-          <p:cNvPr id="8" name="Text 6"/>
+              <a:t>Plans written before code</a:t>
+            </a:r>
+            <a:endParaRPr lang="en-US" sz="1800" dirty="0"/>
+          </a:p>
+        </p:txBody>
+      </p:sp>
+      <p:sp>
+        <p:nvSpPr>
+          <p:cNvPr id="7" name="Text 5"/>
           <p:cNvSpPr txBox="1"/>
           <p:nvPr/>
         </p:nvSpPr>
         <p:spPr>
           <a:xfrm>
-            <a:off x="4297680" y="2514600"/>
-            <a:ext cx="7116775" cy="1024128"/>
+            <a:off x="777240" y="2194560"/>
+            <a:ext cx="5010912" cy="1143000"/>
           </a:xfrm>
           <a:prstGeom prst="rect">
             <a:avLst/>
@@ -22270,38 +22989,38 @@
           <a:ln/>
         </p:spPr>
         <p:txBody>
-          <a:bodyPr wrap="square" lIns="0" tIns="0" rIns="0" bIns="0" rtlCol="0" anchor="ctr"/>
+          <a:bodyPr wrap="square" lIns="0" tIns="0" rIns="0" bIns="0" rtlCol="0" anchor="t"/>
           <a:lstStyle/>
           <a:p>
             <a:pPr indent="0" marL="0">
               <a:buNone/>
             </a:pPr>
             <a:r>
-              <a:rPr lang="en-US" sz="1600" dirty="0">
+              <a:rPr lang="en-US" sz="1500" dirty="0">
                 <a:solidFill>
                   <a:schemeClr val="tx2"/>
                 </a:solidFill>
               </a:rPr>
-              <a:t>One fund, all in or all out, price data only, a one-week horizon. Lifting these makes the task easier, but wouldn’t flip the result: even with zero fees, v1 still lost.</a:t>
-            </a:r>
-            <a:endParaRPr lang="en-US" sz="1600" dirty="0"/>
-          </a:p>
-        </p:txBody>
-      </p:sp>
-      <p:sp>
-        <p:nvSpPr>
-          <p:cNvPr id="9" name="Shape 7"/>
+              <a:t>Each version’s design was committed before any code or result existed, with a digital fingerprint (SHA-256) so later edits would show.</a:t>
+            </a:r>
+            <a:endParaRPr lang="en-US" sz="1500" dirty="0"/>
+          </a:p>
+        </p:txBody>
+      </p:sp>
+      <p:sp>
+        <p:nvSpPr>
+          <p:cNvPr id="8" name="Shape 6"/>
           <p:cNvSpPr/>
           <p:nvPr/>
         </p:nvSpPr>
         <p:spPr>
           <a:xfrm>
-            <a:off x="548640" y="3657600"/>
-            <a:ext cx="11094415" cy="1024128"/>
+            <a:off x="6172200" y="1417320"/>
+            <a:ext cx="5468112" cy="2103120"/>
           </a:xfrm>
           <a:prstGeom prst="roundRect">
             <a:avLst>
-              <a:gd name="adj" fmla="val 8929"/>
+              <a:gd name="adj" fmla="val 5217"/>
             </a:avLst>
           </a:prstGeom>
           <a:solidFill>
@@ -22317,14 +23036,39 @@
       </p:sp>
       <p:sp>
         <p:nvSpPr>
+          <p:cNvPr id="9" name="Shape 7"/>
+          <p:cNvSpPr/>
+          <p:nvPr/>
+        </p:nvSpPr>
+        <p:spPr>
+          <a:xfrm>
+            <a:off x="6400800" y="1645920"/>
+            <a:ext cx="438912" cy="438912"/>
+          </a:xfrm>
+          <a:prstGeom prst="ellipse">
+            <a:avLst/>
+          </a:prstGeom>
+          <a:solidFill>
+            <a:schemeClr val="accent1"/>
+          </a:solidFill>
+          <a:ln w="12700">
+            <a:solidFill>
+              <a:schemeClr val="accent1"/>
+            </a:solidFill>
+            <a:prstDash val="solid"/>
+          </a:ln>
+        </p:spPr>
+      </p:sp>
+      <p:sp>
+        <p:nvSpPr>
           <p:cNvPr id="10" name="Text 8"/>
           <p:cNvSpPr txBox="1"/>
           <p:nvPr/>
         </p:nvSpPr>
         <p:spPr>
           <a:xfrm>
-            <a:off x="822960" y="3657600"/>
-            <a:ext cx="3291840" cy="1024128"/>
+            <a:off x="6400800" y="1645920"/>
+            <a:ext cx="438912" cy="438912"/>
           </a:xfrm>
           <a:prstGeom prst="rect">
             <a:avLst/>
@@ -22336,11 +23080,47 @@
           <a:bodyPr wrap="square" lIns="0" tIns="0" rIns="0" bIns="0" rtlCol="0" anchor="ctr"/>
           <a:lstStyle/>
           <a:p>
+            <a:pPr algn="ctr" indent="0" marL="0">
+              <a:buNone/>
+            </a:pPr>
+            <a:r>
+              <a:rPr lang="en-US" sz="1600" b="1" dirty="0">
+                <a:solidFill>
+                  <a:schemeClr val="bg1"/>
+                </a:solidFill>
+              </a:rPr>
+              <a:t>2</a:t>
+            </a:r>
+            <a:endParaRPr lang="en-US" sz="1600" dirty="0"/>
+          </a:p>
+        </p:txBody>
+      </p:sp>
+      <p:sp>
+        <p:nvSpPr>
+          <p:cNvPr id="11" name="Text 9"/>
+          <p:cNvSpPr txBox="1"/>
+          <p:nvPr/>
+        </p:nvSpPr>
+        <p:spPr>
+          <a:xfrm>
+            <a:off x="6995160" y="1645920"/>
+            <a:ext cx="4416552" cy="438912"/>
+          </a:xfrm>
+          <a:prstGeom prst="rect">
+            <a:avLst/>
+          </a:prstGeom>
+          <a:noFill/>
+          <a:ln/>
+        </p:spPr>
+        <p:txBody>
+          <a:bodyPr wrap="square" lIns="0" tIns="0" rIns="0" bIns="0" rtlCol="0" anchor="ctr"/>
+          <a:lstStyle/>
+          <a:p>
             <a:pPr indent="0" marL="0">
               <a:buNone/>
             </a:pPr>
             <a:r>
-              <a:rPr lang="en-US" sz="1900" b="1" dirty="0">
+              <a:rPr lang="en-US" sz="1800" b="1" dirty="0">
                 <a:solidFill>
                   <a:schemeClr val="tx1"/>
                 </a:solidFill>
@@ -22348,22 +23128,22 @@
                 <a:ea typeface="Cambria" pitchFamily="34" charset="-122"/>
                 <a:cs typeface="Cambria" pitchFamily="34" charset="-120"/>
               </a:rPr>
-              <a:t>Where machine learning does help</a:t>
-            </a:r>
-            <a:endParaRPr lang="en-US" sz="1900" dirty="0"/>
-          </a:p>
-        </p:txBody>
-      </p:sp>
-      <p:sp>
-        <p:nvSpPr>
-          <p:cNvPr id="11" name="Text 9"/>
+              <a:t>Final exam opened once</a:t>
+            </a:r>
+            <a:endParaRPr lang="en-US" sz="1800" dirty="0"/>
+          </a:p>
+        </p:txBody>
+      </p:sp>
+      <p:sp>
+        <p:nvSpPr>
+          <p:cNvPr id="12" name="Text 10"/>
           <p:cNvSpPr txBox="1"/>
           <p:nvPr/>
         </p:nvSpPr>
         <p:spPr>
           <a:xfrm>
-            <a:off x="4297680" y="3657600"/>
-            <a:ext cx="7116775" cy="1024128"/>
+            <a:off x="6400800" y="2194560"/>
+            <a:ext cx="5010912" cy="1143000"/>
           </a:xfrm>
           <a:prstGeom prst="rect">
             <a:avLst/>
@@ -22372,38 +23152,38 @@
           <a:ln/>
         </p:spPr>
         <p:txBody>
-          <a:bodyPr wrap="square" lIns="0" tIns="0" rIns="0" bIns="0" rtlCol="0" anchor="ctr"/>
+          <a:bodyPr wrap="square" lIns="0" tIns="0" rIns="0" bIns="0" rtlCol="0" anchor="t"/>
           <a:lstStyle/>
           <a:p>
             <a:pPr indent="0" marL="0">
               <a:buNone/>
             </a:pPr>
             <a:r>
-              <a:rPr lang="en-US" sz="1600" dirty="0">
+              <a:rPr lang="en-US" sz="1500" dirty="0">
                 <a:solidFill>
                   <a:schemeClr val="tx2"/>
                 </a:solidFill>
               </a:rPr>
-              <a:t>Ranking many assets against each other, forecasting risk to size positions, and using data most people don’t have. Even there the edges are usually small and shrink after costs.</a:t>
-            </a:r>
-            <a:endParaRPr lang="en-US" sz="1600" dirty="0"/>
-          </a:p>
-        </p:txBody>
-      </p:sp>
-      <p:sp>
-        <p:nvSpPr>
-          <p:cNvPr id="12" name="Shape 10"/>
+              <a:t>Each version picked its model on earlier data, locked it, and only then saw the test years.</a:t>
+            </a:r>
+            <a:endParaRPr lang="en-US" sz="1500" dirty="0"/>
+          </a:p>
+        </p:txBody>
+      </p:sp>
+      <p:sp>
+        <p:nvSpPr>
+          <p:cNvPr id="13" name="Shape 11"/>
           <p:cNvSpPr/>
           <p:nvPr/>
         </p:nvSpPr>
         <p:spPr>
           <a:xfrm>
-            <a:off x="548640" y="4800600"/>
-            <a:ext cx="11094415" cy="1024128"/>
+            <a:off x="548640" y="3703320"/>
+            <a:ext cx="5468112" cy="2103120"/>
           </a:xfrm>
           <a:prstGeom prst="roundRect">
             <a:avLst>
-              <a:gd name="adj" fmla="val 8929"/>
+              <a:gd name="adj" fmla="val 5217"/>
             </a:avLst>
           </a:prstGeom>
           <a:solidFill>
@@ -22419,14 +23199,39 @@
       </p:sp>
       <p:sp>
         <p:nvSpPr>
-          <p:cNvPr id="13" name="Text 11"/>
+          <p:cNvPr id="14" name="Shape 12"/>
+          <p:cNvSpPr/>
+          <p:nvPr/>
+        </p:nvSpPr>
+        <p:spPr>
+          <a:xfrm>
+            <a:off x="777240" y="3931920"/>
+            <a:ext cx="438912" cy="438912"/>
+          </a:xfrm>
+          <a:prstGeom prst="ellipse">
+            <a:avLst/>
+          </a:prstGeom>
+          <a:solidFill>
+            <a:schemeClr val="accent1"/>
+          </a:solidFill>
+          <a:ln w="12700">
+            <a:solidFill>
+              <a:schemeClr val="accent1"/>
+            </a:solidFill>
+            <a:prstDash val="solid"/>
+          </a:ln>
+        </p:spPr>
+      </p:sp>
+      <p:sp>
+        <p:nvSpPr>
+          <p:cNvPr id="15" name="Text 13"/>
           <p:cNvSpPr txBox="1"/>
           <p:nvPr/>
         </p:nvSpPr>
         <p:spPr>
           <a:xfrm>
-            <a:off x="822960" y="4800600"/>
-            <a:ext cx="3291840" cy="1024128"/>
+            <a:off x="777240" y="3931920"/>
+            <a:ext cx="438912" cy="438912"/>
           </a:xfrm>
           <a:prstGeom prst="rect">
             <a:avLst/>
@@ -22438,11 +23243,47 @@
           <a:bodyPr wrap="square" lIns="0" tIns="0" rIns="0" bIns="0" rtlCol="0" anchor="ctr"/>
           <a:lstStyle/>
           <a:p>
+            <a:pPr algn="ctr" indent="0" marL="0">
+              <a:buNone/>
+            </a:pPr>
+            <a:r>
+              <a:rPr lang="en-US" sz="1600" b="1" dirty="0">
+                <a:solidFill>
+                  <a:schemeClr val="bg1"/>
+                </a:solidFill>
+              </a:rPr>
+              <a:t>3</a:t>
+            </a:r>
+            <a:endParaRPr lang="en-US" sz="1600" dirty="0"/>
+          </a:p>
+        </p:txBody>
+      </p:sp>
+      <p:sp>
+        <p:nvSpPr>
+          <p:cNvPr id="16" name="Text 14"/>
+          <p:cNvSpPr txBox="1"/>
+          <p:nvPr/>
+        </p:nvSpPr>
+        <p:spPr>
+          <a:xfrm>
+            <a:off x="1371600" y="3931920"/>
+            <a:ext cx="4416552" cy="438912"/>
+          </a:xfrm>
+          <a:prstGeom prst="rect">
+            <a:avLst/>
+          </a:prstGeom>
+          <a:noFill/>
+          <a:ln/>
+        </p:spPr>
+        <p:txBody>
+          <a:bodyPr wrap="square" lIns="0" tIns="0" rIns="0" bIns="0" rtlCol="0" anchor="ctr"/>
+          <a:lstStyle/>
+          <a:p>
             <a:pPr indent="0" marL="0">
               <a:buNone/>
             </a:pPr>
             <a:r>
-              <a:rPr lang="en-US" sz="1900" b="1" dirty="0">
+              <a:rPr lang="en-US" sz="1800" b="1" dirty="0">
                 <a:solidFill>
                   <a:schemeClr val="tx1"/>
                 </a:solidFill>
@@ -22450,22 +23291,22 @@
                 <a:ea typeface="Cambria" pitchFamily="34" charset="-122"/>
                 <a:cs typeface="Cambria" pitchFamily="34" charset="-120"/>
               </a:rPr>
-              <a:t>The fair bar</a:t>
-            </a:r>
-            <a:endParaRPr lang="en-US" sz="1900" dirty="0"/>
-          </a:p>
-        </p:txBody>
-      </p:sp>
-      <p:sp>
-        <p:nvSpPr>
-          <p:cNvPr id="14" name="Text 12"/>
+              <a:t>50 automated tests</a:t>
+            </a:r>
+            <a:endParaRPr lang="en-US" sz="1800" dirty="0"/>
+          </a:p>
+        </p:txBody>
+      </p:sp>
+      <p:sp>
+        <p:nvSpPr>
+          <p:cNvPr id="17" name="Text 15"/>
           <p:cNvSpPr txBox="1"/>
           <p:nvPr/>
         </p:nvSpPr>
         <p:spPr>
           <a:xfrm>
-            <a:off x="4297680" y="4800600"/>
-            <a:ext cx="7116775" cy="1024128"/>
+            <a:off x="777240" y="4480560"/>
+            <a:ext cx="5010912" cy="1143000"/>
           </a:xfrm>
           <a:prstGeom prst="rect">
             <a:avLst/>
@@ -22474,21 +23315,184 @@
           <a:ln/>
         </p:spPr>
         <p:txBody>
+          <a:bodyPr wrap="square" lIns="0" tIns="0" rIns="0" bIns="0" rtlCol="0" anchor="t"/>
+          <a:lstStyle/>
+          <a:p>
+            <a:pPr indent="0" marL="0">
+              <a:buNone/>
+            </a:pPr>
+            <a:r>
+              <a:rPr lang="en-US" sz="1500" dirty="0">
+                <a:solidFill>
+                  <a:schemeClr val="tx2"/>
+                </a:solidFill>
+              </a:rPr>
+              <a:t>They check the model never sees the future, e.g. scrambling future data must not change any prediction.</a:t>
+            </a:r>
+            <a:endParaRPr lang="en-US" sz="1500" dirty="0"/>
+          </a:p>
+        </p:txBody>
+      </p:sp>
+      <p:sp>
+        <p:nvSpPr>
+          <p:cNvPr id="18" name="Shape 16"/>
+          <p:cNvSpPr/>
+          <p:nvPr/>
+        </p:nvSpPr>
+        <p:spPr>
+          <a:xfrm>
+            <a:off x="6172200" y="3703320"/>
+            <a:ext cx="5468112" cy="2103120"/>
+          </a:xfrm>
+          <a:prstGeom prst="roundRect">
+            <a:avLst>
+              <a:gd name="adj" fmla="val 5217"/>
+            </a:avLst>
+          </a:prstGeom>
+          <a:solidFill>
+            <a:schemeClr val="bg2"/>
+          </a:solidFill>
+          <a:ln w="12700">
+            <a:solidFill>
+              <a:schemeClr val="bg2"/>
+            </a:solidFill>
+            <a:prstDash val="solid"/>
+          </a:ln>
+        </p:spPr>
+      </p:sp>
+      <p:sp>
+        <p:nvSpPr>
+          <p:cNvPr id="19" name="Shape 17"/>
+          <p:cNvSpPr/>
+          <p:nvPr/>
+        </p:nvSpPr>
+        <p:spPr>
+          <a:xfrm>
+            <a:off x="6400800" y="3931920"/>
+            <a:ext cx="438912" cy="438912"/>
+          </a:xfrm>
+          <a:prstGeom prst="ellipse">
+            <a:avLst/>
+          </a:prstGeom>
+          <a:solidFill>
+            <a:schemeClr val="accent1"/>
+          </a:solidFill>
+          <a:ln w="12700">
+            <a:solidFill>
+              <a:schemeClr val="accent1"/>
+            </a:solidFill>
+            <a:prstDash val="solid"/>
+          </a:ln>
+        </p:spPr>
+      </p:sp>
+      <p:sp>
+        <p:nvSpPr>
+          <p:cNvPr id="20" name="Text 18"/>
+          <p:cNvSpPr txBox="1"/>
+          <p:nvPr/>
+        </p:nvSpPr>
+        <p:spPr>
+          <a:xfrm>
+            <a:off x="6400800" y="3931920"/>
+            <a:ext cx="438912" cy="438912"/>
+          </a:xfrm>
+          <a:prstGeom prst="rect">
+            <a:avLst/>
+          </a:prstGeom>
+          <a:noFill/>
+          <a:ln/>
+        </p:spPr>
+        <p:txBody>
           <a:bodyPr wrap="square" lIns="0" tIns="0" rIns="0" bIns="0" rtlCol="0" anchor="ctr"/>
           <a:lstStyle/>
           <a:p>
+            <a:pPr algn="ctr" indent="0" marL="0">
+              <a:buNone/>
+            </a:pPr>
+            <a:r>
+              <a:rPr lang="en-US" sz="1600" b="1" dirty="0">
+                <a:solidFill>
+                  <a:schemeClr val="bg1"/>
+                </a:solidFill>
+              </a:rPr>
+              <a:t>4</a:t>
+            </a:r>
+            <a:endParaRPr lang="en-US" sz="1600" dirty="0"/>
+          </a:p>
+        </p:txBody>
+      </p:sp>
+      <p:sp>
+        <p:nvSpPr>
+          <p:cNvPr id="21" name="Text 19"/>
+          <p:cNvSpPr txBox="1"/>
+          <p:nvPr/>
+        </p:nvSpPr>
+        <p:spPr>
+          <a:xfrm>
+            <a:off x="6995160" y="3931920"/>
+            <a:ext cx="4416552" cy="438912"/>
+          </a:xfrm>
+          <a:prstGeom prst="rect">
+            <a:avLst/>
+          </a:prstGeom>
+          <a:noFill/>
+          <a:ln/>
+        </p:spPr>
+        <p:txBody>
+          <a:bodyPr wrap="square" lIns="0" tIns="0" rIns="0" bIns="0" rtlCol="0" anchor="ctr"/>
+          <a:lstStyle/>
+          <a:p>
             <a:pPr indent="0" marL="0">
               <a:buNone/>
             </a:pPr>
             <a:r>
-              <a:rPr lang="en-US" sz="1600" dirty="0">
+              <a:rPr lang="en-US" sz="1800" b="1" dirty="0">
+                <a:solidFill>
+                  <a:schemeClr val="tx1"/>
+                </a:solidFill>
+                <a:latin typeface="Cambria" pitchFamily="34" charset="0"/>
+                <a:ea typeface="Cambria" pitchFamily="34" charset="-122"/>
+                <a:cs typeface="Cambria" pitchFamily="34" charset="-120"/>
+              </a:rPr>
+              <a:t>Failures reported, not hidden</a:t>
+            </a:r>
+            <a:endParaRPr lang="en-US" sz="1800" dirty="0"/>
+          </a:p>
+        </p:txBody>
+      </p:sp>
+      <p:sp>
+        <p:nvSpPr>
+          <p:cNvPr id="22" name="Text 20"/>
+          <p:cNvSpPr txBox="1"/>
+          <p:nvPr/>
+        </p:nvSpPr>
+        <p:spPr>
+          <a:xfrm>
+            <a:off x="6400800" y="4480560"/>
+            <a:ext cx="5010912" cy="1143000"/>
+          </a:xfrm>
+          <a:prstGeom prst="rect">
+            <a:avLst/>
+          </a:prstGeom>
+          <a:noFill/>
+          <a:ln/>
+        </p:spPr>
+        <p:txBody>
+          <a:bodyPr wrap="square" lIns="0" tIns="0" rIns="0" bIns="0" rtlCol="0" anchor="t"/>
+          <a:lstStyle/>
+          <a:p>
+            <a:pPr indent="0" marL="0">
+              <a:buNone/>
+            </a:pPr>
+            <a:r>
+              <a:rPr lang="en-US" sz="1500" dirty="0">
                 <a:solidFill>
                   <a:schemeClr val="tx2"/>
                 </a:solidFill>
               </a:rPr>
-              <a:t>Return for the risk taken, and beating random timing — not simply “more money than Buy &amp; Hold”. That is how we judged every version.</a:t>
-            </a:r>
-            <a:endParaRPr lang="en-US" sz="1600" dirty="0"/>
+              <a:t>Every change after results is logged, including a one-day overlap we found in v1’s work and v3 failing its own calibration test.</a:t>
+            </a:r>
+            <a:endParaRPr lang="en-US" sz="1500" dirty="0"/>
           </a:p>
         </p:txBody>
       </p:sp>
@@ -22597,7 +23601,7 @@
                 <a:ea typeface="Cambria" pitchFamily="34" charset="-122"/>
                 <a:cs typeface="Cambria" pitchFamily="34" charset="-120"/>
               </a:rPr>
-              <a:t>What we learned</a:t>
+              <a:t>A flaw of machine learning, or of the question?</a:t>
             </a:r>
             <a:endParaRPr lang="en-US" sz="3200" dirty="0"/>
           </a:p>
@@ -22611,12 +23615,114 @@
         </p:nvSpPr>
         <p:spPr>
           <a:xfrm>
-            <a:off x="548640" y="1417320"/>
-            <a:ext cx="5468112" cy="2103120"/>
+            <a:off x="548640" y="1371600"/>
+            <a:ext cx="11094415" cy="1024128"/>
           </a:xfrm>
           <a:prstGeom prst="roundRect">
             <a:avLst>
-              <a:gd name="adj" fmla="val 5217"/>
+              <a:gd name="adj" fmla="val 8929"/>
+            </a:avLst>
+          </a:prstGeom>
+          <a:solidFill>
+            <a:srgbClr val="FBEDE4"/>
+          </a:solidFill>
+          <a:ln w="12700">
+            <a:solidFill>
+              <a:srgbClr val="FBEDE4"/>
+            </a:solidFill>
+            <a:prstDash val="solid"/>
+          </a:ln>
+        </p:spPr>
+      </p:sp>
+      <p:sp>
+        <p:nvSpPr>
+          <p:cNvPr id="4" name="Text 2"/>
+          <p:cNvSpPr txBox="1"/>
+          <p:nvPr/>
+        </p:nvSpPr>
+        <p:spPr>
+          <a:xfrm>
+            <a:off x="822960" y="1371600"/>
+            <a:ext cx="3291840" cy="1024128"/>
+          </a:xfrm>
+          <a:prstGeom prst="rect">
+            <a:avLst/>
+          </a:prstGeom>
+          <a:noFill/>
+          <a:ln/>
+        </p:spPr>
+        <p:txBody>
+          <a:bodyPr wrap="square" lIns="0" tIns="0" rIns="0" bIns="0" rtlCol="0" anchor="ctr"/>
+          <a:lstStyle/>
+          <a:p>
+            <a:pPr indent="0" marL="0">
+              <a:buNone/>
+            </a:pPr>
+            <a:r>
+              <a:rPr lang="en-US" sz="1900" b="1" dirty="0">
+                <a:solidFill>
+                  <a:schemeClr val="tx1"/>
+                </a:solidFill>
+                <a:latin typeface="Cambria" pitchFamily="34" charset="0"/>
+                <a:ea typeface="Cambria" pitchFamily="34" charset="-122"/>
+                <a:cs typeface="Cambria" pitchFamily="34" charset="-120"/>
+              </a:rPr>
+              <a:t>Mostly the question</a:t>
+            </a:r>
+            <a:endParaRPr lang="en-US" sz="1900" dirty="0"/>
+          </a:p>
+        </p:txBody>
+      </p:sp>
+      <p:sp>
+        <p:nvSpPr>
+          <p:cNvPr id="5" name="Text 3"/>
+          <p:cNvSpPr txBox="1"/>
+          <p:nvPr/>
+        </p:nvSpPr>
+        <p:spPr>
+          <a:xfrm>
+            <a:off x="4297680" y="1371600"/>
+            <a:ext cx="7116775" cy="1024128"/>
+          </a:xfrm>
+          <a:prstGeom prst="rect">
+            <a:avLst/>
+          </a:prstGeom>
+          <a:noFill/>
+          <a:ln/>
+        </p:spPr>
+        <p:txBody>
+          <a:bodyPr wrap="square" lIns="0" tIns="0" rIns="0" bIns="0" rtlCol="0" anchor="ctr"/>
+          <a:lstStyle/>
+          <a:p>
+            <a:pPr indent="0" marL="0">
+              <a:buNone/>
+            </a:pPr>
+            <a:r>
+              <a:rPr lang="en-US" sz="1600" dirty="0">
+                <a:solidFill>
+                  <a:schemeClr val="tx2"/>
+                </a:solidFill>
+              </a:rPr>
+              <a:t>We asked for next week’s direction of the world’s most-watched fund, using only its own public price history. Simple patterns there get traded away, and no algorithm can find information that isn’t in the data.</a:t>
+            </a:r>
+            <a:endParaRPr lang="en-US" sz="1600" dirty="0"/>
+          </a:p>
+        </p:txBody>
+      </p:sp>
+      <p:sp>
+        <p:nvSpPr>
+          <p:cNvPr id="6" name="Shape 4"/>
+          <p:cNvSpPr/>
+          <p:nvPr/>
+        </p:nvSpPr>
+        <p:spPr>
+          <a:xfrm>
+            <a:off x="548640" y="2514600"/>
+            <a:ext cx="11094415" cy="1024128"/>
+          </a:xfrm>
+          <a:prstGeom prst="roundRect">
+            <a:avLst>
+              <a:gd name="adj" fmla="val 8929"/>
             </a:avLst>
           </a:prstGeom>
           <a:solidFill>
@@ -22632,39 +23738,14 @@
       </p:sp>
       <p:sp>
         <p:nvSpPr>
-          <p:cNvPr id="4" name="Shape 2"/>
-          <p:cNvSpPr/>
-          <p:nvPr/>
-        </p:nvSpPr>
-        <p:spPr>
-          <a:xfrm>
-            <a:off x="777240" y="1645920"/>
-            <a:ext cx="438912" cy="438912"/>
-          </a:xfrm>
-          <a:prstGeom prst="ellipse">
-            <a:avLst/>
-          </a:prstGeom>
-          <a:solidFill>
-            <a:schemeClr val="accent1"/>
-          </a:solidFill>
-          <a:ln w="12700">
-            <a:solidFill>
-              <a:schemeClr val="accent1"/>
-            </a:solidFill>
-            <a:prstDash val="solid"/>
-          </a:ln>
-        </p:spPr>
-      </p:sp>
-      <p:sp>
-        <p:nvSpPr>
-          <p:cNvPr id="5" name="Text 3"/>
+          <p:cNvPr id="7" name="Text 5"/>
           <p:cNvSpPr txBox="1"/>
           <p:nvPr/>
         </p:nvSpPr>
         <p:spPr>
           <a:xfrm>
-            <a:off x="777240" y="1645920"/>
-            <a:ext cx="438912" cy="438912"/>
+            <a:off x="822960" y="2514600"/>
+            <a:ext cx="3291840" cy="1024128"/>
           </a:xfrm>
           <a:prstGeom prst="rect">
             <a:avLst/>
@@ -22676,47 +23757,11 @@
           <a:bodyPr wrap="square" lIns="0" tIns="0" rIns="0" bIns="0" rtlCol="0" anchor="ctr"/>
           <a:lstStyle/>
           <a:p>
-            <a:pPr algn="ctr" indent="0" marL="0">
-              <a:buNone/>
-            </a:pPr>
-            <a:r>
-              <a:rPr lang="en-US" sz="1600" b="1" dirty="0">
-                <a:solidFill>
-                  <a:schemeClr val="bg1"/>
-                </a:solidFill>
-              </a:rPr>
-              <a:t>1</a:t>
-            </a:r>
-            <a:endParaRPr lang="en-US" sz="1600" dirty="0"/>
-          </a:p>
-        </p:txBody>
-      </p:sp>
-      <p:sp>
-        <p:nvSpPr>
-          <p:cNvPr id="6" name="Text 4"/>
-          <p:cNvSpPr txBox="1"/>
-          <p:nvPr/>
-        </p:nvSpPr>
-        <p:spPr>
-          <a:xfrm>
-            <a:off x="1371600" y="1645920"/>
-            <a:ext cx="4416552" cy="594360"/>
-          </a:xfrm>
-          <a:prstGeom prst="rect">
-            <a:avLst/>
-          </a:prstGeom>
-          <a:noFill/>
-          <a:ln/>
-        </p:spPr>
-        <p:txBody>
-          <a:bodyPr wrap="square" lIns="0" tIns="0" rIns="0" bIns="0" rtlCol="0" anchor="ctr"/>
-          <a:lstStyle/>
-          <a:p>
             <a:pPr indent="0" marL="0">
               <a:buNone/>
             </a:pPr>
             <a:r>
-              <a:rPr lang="en-US" sz="1800" b="1" dirty="0">
+              <a:rPr lang="en-US" sz="1900" b="1" dirty="0">
                 <a:solidFill>
                   <a:schemeClr val="tx1"/>
                 </a:solidFill>
@@ -22724,22 +23769,22 @@
                 <a:ea typeface="Cambria" pitchFamily="34" charset="-122"/>
                 <a:cs typeface="Cambria" pitchFamily="34" charset="-120"/>
               </a:rPr>
-              <a:t>Size is predictable; direction isn’t</a:t>
-            </a:r>
-            <a:endParaRPr lang="en-US" sz="1800" dirty="0"/>
-          </a:p>
-        </p:txBody>
-      </p:sp>
-      <p:sp>
-        <p:nvSpPr>
-          <p:cNvPr id="7" name="Text 5"/>
+              <a:t>Partly our own limits</a:t>
+            </a:r>
+            <a:endParaRPr lang="en-US" sz="1900" dirty="0"/>
+          </a:p>
+        </p:txBody>
+      </p:sp>
+      <p:sp>
+        <p:nvSpPr>
+          <p:cNvPr id="8" name="Text 6"/>
           <p:cNvSpPr txBox="1"/>
           <p:nvPr/>
         </p:nvSpPr>
         <p:spPr>
           <a:xfrm>
-            <a:off x="777240" y="2350008"/>
-            <a:ext cx="5010912" cy="987552"/>
+            <a:off x="4297680" y="2514600"/>
+            <a:ext cx="7116775" cy="1024128"/>
           </a:xfrm>
           <a:prstGeom prst="rect">
             <a:avLst/>
@@ -22748,7 +23793,7 @@
           <a:ln/>
         </p:spPr>
         <p:txBody>
-          <a:bodyPr wrap="square" lIns="0" tIns="0" rIns="0" bIns="0" rtlCol="0" anchor="t"/>
+          <a:bodyPr wrap="square" lIns="0" tIns="0" rIns="0" bIns="0" rtlCol="0" anchor="ctr"/>
           <a:lstStyle/>
           <a:p>
             <a:pPr indent="0" marL="0">
@@ -22760,7 +23805,7 @@
                   <a:schemeClr val="tx2"/>
                 </a:solidFill>
               </a:rPr>
-              <a:t>Big-move weeks cluster together, so the model can see them coming. Which way they go is close to a coin flip.</a:t>
+              <a:t>One fund, all in or all out, price data only, a one-week horizon. Lifting these makes the task easier, but wouldn’t flip the result: even with zero fees, v1 still lost.</a:t>
             </a:r>
             <a:endParaRPr lang="en-US" sz="1600" dirty="0"/>
           </a:p>
@@ -22768,18 +23813,18 @@
       </p:sp>
       <p:sp>
         <p:nvSpPr>
-          <p:cNvPr id="8" name="Shape 6"/>
+          <p:cNvPr id="9" name="Shape 7"/>
           <p:cNvSpPr/>
           <p:nvPr/>
         </p:nvSpPr>
         <p:spPr>
           <a:xfrm>
-            <a:off x="6172200" y="1417320"/>
-            <a:ext cx="5468112" cy="2103120"/>
+            <a:off x="548640" y="3657600"/>
+            <a:ext cx="11094415" cy="1024128"/>
           </a:xfrm>
           <a:prstGeom prst="roundRect">
             <a:avLst>
-              <a:gd name="adj" fmla="val 5217"/>
+              <a:gd name="adj" fmla="val 8929"/>
             </a:avLst>
           </a:prstGeom>
           <a:solidFill>
@@ -22795,39 +23840,14 @@
       </p:sp>
       <p:sp>
         <p:nvSpPr>
-          <p:cNvPr id="9" name="Shape 7"/>
-          <p:cNvSpPr/>
-          <p:nvPr/>
-        </p:nvSpPr>
-        <p:spPr>
-          <a:xfrm>
-            <a:off x="6400800" y="1645920"/>
-            <a:ext cx="438912" cy="438912"/>
-          </a:xfrm>
-          <a:prstGeom prst="ellipse">
-            <a:avLst/>
-          </a:prstGeom>
-          <a:solidFill>
-            <a:schemeClr val="accent1"/>
-          </a:solidFill>
-          <a:ln w="12700">
-            <a:solidFill>
-              <a:schemeClr val="accent1"/>
-            </a:solidFill>
-            <a:prstDash val="solid"/>
-          </a:ln>
-        </p:spPr>
-      </p:sp>
-      <p:sp>
-        <p:nvSpPr>
           <p:cNvPr id="10" name="Text 8"/>
           <p:cNvSpPr txBox="1"/>
           <p:nvPr/>
         </p:nvSpPr>
         <p:spPr>
           <a:xfrm>
-            <a:off x="6400800" y="1645920"/>
-            <a:ext cx="438912" cy="438912"/>
+            <a:off x="822960" y="3657600"/>
+            <a:ext cx="3291840" cy="1024128"/>
           </a:xfrm>
           <a:prstGeom prst="rect">
             <a:avLst/>
@@ -22839,47 +23859,11 @@
           <a:bodyPr wrap="square" lIns="0" tIns="0" rIns="0" bIns="0" rtlCol="0" anchor="ctr"/>
           <a:lstStyle/>
           <a:p>
-            <a:pPr algn="ctr" indent="0" marL="0">
-              <a:buNone/>
-            </a:pPr>
-            <a:r>
-              <a:rPr lang="en-US" sz="1600" b="1" dirty="0">
-                <a:solidFill>
-                  <a:schemeClr val="bg1"/>
-                </a:solidFill>
-              </a:rPr>
-              <a:t>2</a:t>
-            </a:r>
-            <a:endParaRPr lang="en-US" sz="1600" dirty="0"/>
-          </a:p>
-        </p:txBody>
-      </p:sp>
-      <p:sp>
-        <p:nvSpPr>
-          <p:cNvPr id="11" name="Text 9"/>
-          <p:cNvSpPr txBox="1"/>
-          <p:nvPr/>
-        </p:nvSpPr>
-        <p:spPr>
-          <a:xfrm>
-            <a:off x="6995160" y="1645920"/>
-            <a:ext cx="4416552" cy="438912"/>
-          </a:xfrm>
-          <a:prstGeom prst="rect">
-            <a:avLst/>
-          </a:prstGeom>
-          <a:noFill/>
-          <a:ln/>
-        </p:spPr>
-        <p:txBody>
-          <a:bodyPr wrap="square" lIns="0" tIns="0" rIns="0" bIns="0" rtlCol="0" anchor="ctr"/>
-          <a:lstStyle/>
-          <a:p>
             <a:pPr indent="0" marL="0">
               <a:buNone/>
             </a:pPr>
             <a:r>
-              <a:rPr lang="en-US" sz="1800" b="1" dirty="0">
+              <a:rPr lang="en-US" sz="1900" b="1" dirty="0">
                 <a:solidFill>
                   <a:schemeClr val="tx1"/>
                 </a:solidFill>
@@ -22887,22 +23871,22 @@
                 <a:ea typeface="Cambria" pitchFamily="34" charset="-122"/>
                 <a:cs typeface="Cambria" pitchFamily="34" charset="-120"/>
               </a:rPr>
-              <a:t>Sitting in cash has a cost</a:t>
-            </a:r>
-            <a:endParaRPr lang="en-US" sz="1800" dirty="0"/>
-          </a:p>
-        </p:txBody>
-      </p:sp>
-      <p:sp>
-        <p:nvSpPr>
-          <p:cNvPr id="12" name="Text 10"/>
+              <a:t>Where machine learning does help</a:t>
+            </a:r>
+            <a:endParaRPr lang="en-US" sz="1900" dirty="0"/>
+          </a:p>
+        </p:txBody>
+      </p:sp>
+      <p:sp>
+        <p:nvSpPr>
+          <p:cNvPr id="11" name="Text 9"/>
           <p:cNvSpPr txBox="1"/>
           <p:nvPr/>
         </p:nvSpPr>
         <p:spPr>
           <a:xfrm>
-            <a:off x="6400800" y="2194560"/>
-            <a:ext cx="5010912" cy="1143000"/>
+            <a:off x="4297680" y="3657600"/>
+            <a:ext cx="7116775" cy="1024128"/>
           </a:xfrm>
           <a:prstGeom prst="rect">
             <a:avLst/>
@@ -22911,7 +23895,7 @@
           <a:ln/>
         </p:spPr>
         <p:txBody>
-          <a:bodyPr wrap="square" lIns="0" tIns="0" rIns="0" bIns="0" rtlCol="0" anchor="t"/>
+          <a:bodyPr wrap="square" lIns="0" tIns="0" rIns="0" bIns="0" rtlCol="0" anchor="ctr"/>
           <a:lstStyle/>
           <a:p>
             <a:pPr indent="0" marL="0">
@@ -22923,7 +23907,7 @@
                   <a:schemeClr val="tx2"/>
                 </a:solidFill>
               </a:rPr>
-              <a:t>The market mostly goes up. Without real timing skill, every day out of the market loses money on average.</a:t>
+              <a:t>Ranking many assets against each other, forecasting risk to size positions, and using data most people don’t have. Even there the edges are usually small and shrink after costs.</a:t>
             </a:r>
             <a:endParaRPr lang="en-US" sz="1600" dirty="0"/>
           </a:p>
@@ -22931,18 +23915,18 @@
       </p:sp>
       <p:sp>
         <p:nvSpPr>
-          <p:cNvPr id="13" name="Shape 11"/>
+          <p:cNvPr id="12" name="Shape 10"/>
           <p:cNvSpPr/>
           <p:nvPr/>
         </p:nvSpPr>
         <p:spPr>
           <a:xfrm>
-            <a:off x="548640" y="3703320"/>
-            <a:ext cx="5468112" cy="2103120"/>
+            <a:off x="548640" y="4800600"/>
+            <a:ext cx="11094415" cy="1024128"/>
           </a:xfrm>
           <a:prstGeom prst="roundRect">
             <a:avLst>
-              <a:gd name="adj" fmla="val 5217"/>
+              <a:gd name="adj" fmla="val 8929"/>
             </a:avLst>
           </a:prstGeom>
           <a:solidFill>
@@ -22958,39 +23942,14 @@
       </p:sp>
       <p:sp>
         <p:nvSpPr>
-          <p:cNvPr id="14" name="Shape 12"/>
-          <p:cNvSpPr/>
-          <p:nvPr/>
-        </p:nvSpPr>
-        <p:spPr>
-          <a:xfrm>
-            <a:off x="777240" y="3931920"/>
-            <a:ext cx="438912" cy="438912"/>
-          </a:xfrm>
-          <a:prstGeom prst="ellipse">
-            <a:avLst/>
-          </a:prstGeom>
-          <a:solidFill>
-            <a:schemeClr val="accent1"/>
-          </a:solidFill>
-          <a:ln w="12700">
-            <a:solidFill>
-              <a:schemeClr val="accent1"/>
-            </a:solidFill>
-            <a:prstDash val="solid"/>
-          </a:ln>
-        </p:spPr>
-      </p:sp>
-      <p:sp>
-        <p:nvSpPr>
-          <p:cNvPr id="15" name="Text 13"/>
+          <p:cNvPr id="13" name="Text 11"/>
           <p:cNvSpPr txBox="1"/>
           <p:nvPr/>
         </p:nvSpPr>
         <p:spPr>
           <a:xfrm>
-            <a:off x="777240" y="3931920"/>
-            <a:ext cx="438912" cy="438912"/>
+            <a:off x="822960" y="4800600"/>
+            <a:ext cx="3291840" cy="1024128"/>
           </a:xfrm>
           <a:prstGeom prst="rect">
             <a:avLst/>
@@ -23002,47 +23961,11 @@
           <a:bodyPr wrap="square" lIns="0" tIns="0" rIns="0" bIns="0" rtlCol="0" anchor="ctr"/>
           <a:lstStyle/>
           <a:p>
-            <a:pPr algn="ctr" indent="0" marL="0">
-              <a:buNone/>
-            </a:pPr>
-            <a:r>
-              <a:rPr lang="en-US" sz="1600" b="1" dirty="0">
-                <a:solidFill>
-                  <a:schemeClr val="bg1"/>
-                </a:solidFill>
-              </a:rPr>
-              <a:t>3</a:t>
-            </a:r>
-            <a:endParaRPr lang="en-US" sz="1600" dirty="0"/>
-          </a:p>
-        </p:txBody>
-      </p:sp>
-      <p:sp>
-        <p:nvSpPr>
-          <p:cNvPr id="16" name="Text 14"/>
-          <p:cNvSpPr txBox="1"/>
-          <p:nvPr/>
-        </p:nvSpPr>
-        <p:spPr>
-          <a:xfrm>
-            <a:off x="1371600" y="3931920"/>
-            <a:ext cx="4416552" cy="438912"/>
-          </a:xfrm>
-          <a:prstGeom prst="rect">
-            <a:avLst/>
-          </a:prstGeom>
-          <a:noFill/>
-          <a:ln/>
-        </p:spPr>
-        <p:txBody>
-          <a:bodyPr wrap="square" lIns="0" tIns="0" rIns="0" bIns="0" rtlCol="0" anchor="ctr"/>
-          <a:lstStyle/>
-          <a:p>
             <a:pPr indent="0" marL="0">
               <a:buNone/>
             </a:pPr>
             <a:r>
-              <a:rPr lang="en-US" sz="1800" b="1" dirty="0">
+              <a:rPr lang="en-US" sz="1900" b="1" dirty="0">
                 <a:solidFill>
                   <a:schemeClr val="tx1"/>
                 </a:solidFill>
@@ -23050,22 +23973,22 @@
                 <a:ea typeface="Cambria" pitchFamily="34" charset="-122"/>
                 <a:cs typeface="Cambria" pitchFamily="34" charset="-120"/>
               </a:rPr>
-              <a:t>The past changes</a:t>
-            </a:r>
-            <a:endParaRPr lang="en-US" sz="1800" dirty="0"/>
-          </a:p>
-        </p:txBody>
-      </p:sp>
-      <p:sp>
-        <p:nvSpPr>
-          <p:cNvPr id="17" name="Text 15"/>
+              <a:t>The fair bar</a:t>
+            </a:r>
+            <a:endParaRPr lang="en-US" sz="1900" dirty="0"/>
+          </a:p>
+        </p:txBody>
+      </p:sp>
+      <p:sp>
+        <p:nvSpPr>
+          <p:cNvPr id="14" name="Text 12"/>
           <p:cNvSpPr txBox="1"/>
           <p:nvPr/>
         </p:nvSpPr>
         <p:spPr>
           <a:xfrm>
-            <a:off x="777240" y="4480560"/>
-            <a:ext cx="5010912" cy="1143000"/>
+            <a:off x="4297680" y="4800600"/>
+            <a:ext cx="7116775" cy="1024128"/>
           </a:xfrm>
           <a:prstGeom prst="rect">
             <a:avLst/>
@@ -23074,7 +23997,7 @@
           <a:ln/>
         </p:spPr>
         <p:txBody>
-          <a:bodyPr wrap="square" lIns="0" tIns="0" rIns="0" bIns="0" rtlCol="0" anchor="t"/>
+          <a:bodyPr wrap="square" lIns="0" tIns="0" rIns="0" bIns="0" rtlCol="0" anchor="ctr"/>
           <a:lstStyle/>
           <a:p>
             <a:pPr indent="0" marL="0">
@@ -23086,170 +24009,7 @@
                   <a:schemeClr val="tx2"/>
                 </a:solidFill>
               </a:rPr>
-              <a:t>A signal that helped from 2010 to 2020 actually misled the model in 2022.</a:t>
-            </a:r>
-            <a:endParaRPr lang="en-US" sz="1600" dirty="0"/>
-          </a:p>
-        </p:txBody>
-      </p:sp>
-      <p:sp>
-        <p:nvSpPr>
-          <p:cNvPr id="18" name="Shape 16"/>
-          <p:cNvSpPr/>
-          <p:nvPr/>
-        </p:nvSpPr>
-        <p:spPr>
-          <a:xfrm>
-            <a:off x="6172200" y="3703320"/>
-            <a:ext cx="5468112" cy="2103120"/>
-          </a:xfrm>
-          <a:prstGeom prst="roundRect">
-            <a:avLst>
-              <a:gd name="adj" fmla="val 5217"/>
-            </a:avLst>
-          </a:prstGeom>
-          <a:solidFill>
-            <a:schemeClr val="bg2"/>
-          </a:solidFill>
-          <a:ln w="12700">
-            <a:solidFill>
-              <a:schemeClr val="bg2"/>
-            </a:solidFill>
-            <a:prstDash val="solid"/>
-          </a:ln>
-        </p:spPr>
-      </p:sp>
-      <p:sp>
-        <p:nvSpPr>
-          <p:cNvPr id="19" name="Shape 17"/>
-          <p:cNvSpPr/>
-          <p:nvPr/>
-        </p:nvSpPr>
-        <p:spPr>
-          <a:xfrm>
-            <a:off x="6400800" y="3931920"/>
-            <a:ext cx="438912" cy="438912"/>
-          </a:xfrm>
-          <a:prstGeom prst="ellipse">
-            <a:avLst/>
-          </a:prstGeom>
-          <a:solidFill>
-            <a:schemeClr val="accent1"/>
-          </a:solidFill>
-          <a:ln w="12700">
-            <a:solidFill>
-              <a:schemeClr val="accent1"/>
-            </a:solidFill>
-            <a:prstDash val="solid"/>
-          </a:ln>
-        </p:spPr>
-      </p:sp>
-      <p:sp>
-        <p:nvSpPr>
-          <p:cNvPr id="20" name="Text 18"/>
-          <p:cNvSpPr txBox="1"/>
-          <p:nvPr/>
-        </p:nvSpPr>
-        <p:spPr>
-          <a:xfrm>
-            <a:off x="6400800" y="3931920"/>
-            <a:ext cx="438912" cy="438912"/>
-          </a:xfrm>
-          <a:prstGeom prst="rect">
-            <a:avLst/>
-          </a:prstGeom>
-          <a:noFill/>
-          <a:ln/>
-        </p:spPr>
-        <p:txBody>
-          <a:bodyPr wrap="square" lIns="0" tIns="0" rIns="0" bIns="0" rtlCol="0" anchor="ctr"/>
-          <a:lstStyle/>
-          <a:p>
-            <a:pPr algn="ctr" indent="0" marL="0">
-              <a:buNone/>
-            </a:pPr>
-            <a:r>
-              <a:rPr lang="en-US" sz="1600" b="1" dirty="0">
-                <a:solidFill>
-                  <a:schemeClr val="bg1"/>
-                </a:solidFill>
-              </a:rPr>
-              <a:t>4</a:t>
-            </a:r>
-            <a:endParaRPr lang="en-US" sz="1600" dirty="0"/>
-          </a:p>
-        </p:txBody>
-      </p:sp>
-      <p:sp>
-        <p:nvSpPr>
-          <p:cNvPr id="21" name="Text 19"/>
-          <p:cNvSpPr txBox="1"/>
-          <p:nvPr/>
-        </p:nvSpPr>
-        <p:spPr>
-          <a:xfrm>
-            <a:off x="6995160" y="3931920"/>
-            <a:ext cx="4416552" cy="438912"/>
-          </a:xfrm>
-          <a:prstGeom prst="rect">
-            <a:avLst/>
-          </a:prstGeom>
-          <a:noFill/>
-          <a:ln/>
-        </p:spPr>
-        <p:txBody>
-          <a:bodyPr wrap="square" lIns="0" tIns="0" rIns="0" bIns="0" rtlCol="0" anchor="ctr"/>
-          <a:lstStyle/>
-          <a:p>
-            <a:pPr indent="0" marL="0">
-              <a:buNone/>
-            </a:pPr>
-            <a:r>
-              <a:rPr lang="en-US" sz="1800" b="1" dirty="0">
-                <a:solidFill>
-                  <a:schemeClr val="tx1"/>
-                </a:solidFill>
-                <a:latin typeface="Cambria" pitchFamily="34" charset="0"/>
-                <a:ea typeface="Cambria" pitchFamily="34" charset="-122"/>
-                <a:cs typeface="Cambria" pitchFamily="34" charset="-120"/>
-              </a:rPr>
-              <a:t>Good predictions ≠ good trades</a:t>
-            </a:r>
-            <a:endParaRPr lang="en-US" sz="1800" dirty="0"/>
-          </a:p>
-        </p:txBody>
-      </p:sp>
-      <p:sp>
-        <p:nvSpPr>
-          <p:cNvPr id="22" name="Text 20"/>
-          <p:cNvSpPr txBox="1"/>
-          <p:nvPr/>
-        </p:nvSpPr>
-        <p:spPr>
-          <a:xfrm>
-            <a:off x="6400800" y="4480560"/>
-            <a:ext cx="5010912" cy="1143000"/>
-          </a:xfrm>
-          <a:prstGeom prst="rect">
-            <a:avLst/>
-          </a:prstGeom>
-          <a:noFill/>
-          <a:ln/>
-        </p:spPr>
-        <p:txBody>
-          <a:bodyPr wrap="square" lIns="0" tIns="0" rIns="0" bIns="0" rtlCol="0" anchor="t"/>
-          <a:lstStyle/>
-          <a:p>
-            <a:pPr indent="0" marL="0">
-              <a:buNone/>
-            </a:pPr>
-            <a:r>
-              <a:rPr lang="en-US" sz="1600" dirty="0">
-                <a:solidFill>
-                  <a:schemeClr val="tx2"/>
-                </a:solidFill>
-              </a:rPr>
-              <a:t>Settings that improve the prediction score can distort the odds a trading rule relies on. With honest odds (v3), the best rule was not to trade.</a:t>
+              <a:t>Return for the risk taken, and beating random timing — not simply “more money than Buy &amp; Hold”. That is how we judged every version.</a:t>
             </a:r>
             <a:endParaRPr lang="en-US" sz="1600" dirty="0"/>
           </a:p>
@@ -23335,8 +24095,8 @@
         </p:nvSpPr>
         <p:spPr>
           <a:xfrm>
-            <a:off x="548640" y="1097280"/>
-            <a:ext cx="10789920" cy="2560320"/>
+            <a:off x="548640" y="365760"/>
+            <a:ext cx="11094415" cy="822960"/>
           </a:xfrm>
           <a:prstGeom prst="rect">
             <a:avLst/>
@@ -23345,39 +24105,89 @@
           <a:ln/>
         </p:spPr>
         <p:txBody>
-          <a:bodyPr wrap="square" rtlCol="0" anchor="b"/>
+          <a:bodyPr wrap="square" rtlCol="0" anchor="ctr"/>
           <a:lstStyle/>
           <a:p>
             <a:pPr indent="0" marL="0">
               <a:buNone/>
             </a:pPr>
             <a:r>
-              <a:rPr lang="en-US" sz="4000" b="1" dirty="0">
-                <a:solidFill>
-                  <a:schemeClr val="bg1"/>
+              <a:rPr lang="en-US" sz="3200" b="1" dirty="0">
+                <a:solidFill>
+                  <a:schemeClr val="tx1"/>
                 </a:solidFill>
                 <a:latin typeface="Cambria" pitchFamily="34" charset="0"/>
                 <a:ea typeface="Cambria" pitchFamily="34" charset="-122"/>
                 <a:cs typeface="Cambria" pitchFamily="34" charset="-120"/>
               </a:rPr>
-              <a:t>Questions?</a:t>
-            </a:r>
-            <a:endParaRPr lang="en-US" sz="4000" dirty="0"/>
-          </a:p>
-        </p:txBody>
-      </p:sp>
-      <p:sp>
-        <p:nvSpPr>
-          <p:cNvPr id="3" name="Text 0"/>
+              <a:t>What we learned</a:t>
+            </a:r>
+            <a:endParaRPr lang="en-US" sz="3200" dirty="0"/>
+          </a:p>
+        </p:txBody>
+      </p:sp>
+      <p:sp>
+        <p:nvSpPr>
+          <p:cNvPr id="3" name="Shape 1"/>
           <p:cNvSpPr/>
-          <p:nvPr>
-            <p:ph idx="101" type="body" hasCustomPrompt="1"/>
-          </p:nvPr>
-        </p:nvSpPr>
-        <p:spPr>
-          <a:xfrm>
-            <a:off x="548640" y="3931920"/>
-            <a:ext cx="10424160" cy="2103120"/>
+          <p:nvPr/>
+        </p:nvSpPr>
+        <p:spPr>
+          <a:xfrm>
+            <a:off x="548640" y="1417320"/>
+            <a:ext cx="5468112" cy="2103120"/>
+          </a:xfrm>
+          <a:prstGeom prst="roundRect">
+            <a:avLst>
+              <a:gd name="adj" fmla="val 5217"/>
+            </a:avLst>
+          </a:prstGeom>
+          <a:solidFill>
+            <a:schemeClr val="bg2"/>
+          </a:solidFill>
+          <a:ln w="12700">
+            <a:solidFill>
+              <a:schemeClr val="bg2"/>
+            </a:solidFill>
+            <a:prstDash val="solid"/>
+          </a:ln>
+        </p:spPr>
+      </p:sp>
+      <p:sp>
+        <p:nvSpPr>
+          <p:cNvPr id="4" name="Shape 2"/>
+          <p:cNvSpPr/>
+          <p:nvPr/>
+        </p:nvSpPr>
+        <p:spPr>
+          <a:xfrm>
+            <a:off x="777240" y="1645920"/>
+            <a:ext cx="438912" cy="438912"/>
+          </a:xfrm>
+          <a:prstGeom prst="ellipse">
+            <a:avLst/>
+          </a:prstGeom>
+          <a:solidFill>
+            <a:schemeClr val="accent1"/>
+          </a:solidFill>
+          <a:ln w="12700">
+            <a:solidFill>
+              <a:schemeClr val="accent1"/>
+            </a:solidFill>
+            <a:prstDash val="solid"/>
+          </a:ln>
+        </p:spPr>
+      </p:sp>
+      <p:sp>
+        <p:nvSpPr>
+          <p:cNvPr id="5" name="Text 3"/>
+          <p:cNvSpPr txBox="1"/>
+          <p:nvPr/>
+        </p:nvSpPr>
+        <p:spPr>
+          <a:xfrm>
+            <a:off x="777240" y="1645920"/>
+            <a:ext cx="438912" cy="438912"/>
           </a:xfrm>
           <a:prstGeom prst="rect">
             <a:avLst/>
@@ -23386,49 +24196,585 @@
           <a:ln/>
         </p:spPr>
         <p:txBody>
-          <a:bodyPr wrap="square" rtlCol="0" anchor="t"/>
+          <a:bodyPr wrap="square" lIns="0" tIns="0" rIns="0" bIns="0" rtlCol="0" anchor="ctr"/>
+          <a:lstStyle/>
+          <a:p>
+            <a:pPr algn="ctr" indent="0" marL="0">
+              <a:buNone/>
+            </a:pPr>
+            <a:r>
+              <a:rPr lang="en-US" sz="1600" b="1" dirty="0">
+                <a:solidFill>
+                  <a:schemeClr val="bg1"/>
+                </a:solidFill>
+              </a:rPr>
+              <a:t>1</a:t>
+            </a:r>
+            <a:endParaRPr lang="en-US" sz="1600" dirty="0"/>
+          </a:p>
+        </p:txBody>
+      </p:sp>
+      <p:sp>
+        <p:nvSpPr>
+          <p:cNvPr id="6" name="Text 4"/>
+          <p:cNvSpPr txBox="1"/>
+          <p:nvPr/>
+        </p:nvSpPr>
+        <p:spPr>
+          <a:xfrm>
+            <a:off x="1371600" y="1645920"/>
+            <a:ext cx="4416552" cy="594360"/>
+          </a:xfrm>
+          <a:prstGeom prst="rect">
+            <a:avLst/>
+          </a:prstGeom>
+          <a:noFill/>
+          <a:ln/>
+        </p:spPr>
+        <p:txBody>
+          <a:bodyPr wrap="square" lIns="0" tIns="0" rIns="0" bIns="0" rtlCol="0" anchor="ctr"/>
           <a:lstStyle/>
           <a:p>
             <a:pPr indent="0" marL="0">
               <a:buNone/>
             </a:pPr>
             <a:r>
-              <a:rPr lang="en-US" sz="2100" dirty="0">
-                <a:solidFill>
-                  <a:schemeClr val="bg2"/>
-                </a:solidFill>
+              <a:rPr lang="en-US" sz="1800" b="1" dirty="0">
+                <a:solidFill>
+                  <a:schemeClr val="tx1"/>
+                </a:solidFill>
+                <a:latin typeface="Cambria" pitchFamily="34" charset="0"/>
+                <a:ea typeface="Cambria" pitchFamily="34" charset="-122"/>
+                <a:cs typeface="Cambria" pitchFamily="34" charset="-120"/>
               </a:rPr>
-              <a:t>$100,000 in 2023–24 → $156,546 by waiting, $123,714 with v1, $121,812 with v2. With honest odds, v3’s best rule is not to trade.</a:t>
-            </a:r>
-            <a:endParaRPr lang="en-US" sz="2100" dirty="0"/>
-          </a:p>
+              <a:t>Size is predictable; direction isn’t</a:t>
+            </a:r>
+            <a:endParaRPr lang="en-US" sz="1800" dirty="0"/>
+          </a:p>
+        </p:txBody>
+      </p:sp>
+      <p:sp>
+        <p:nvSpPr>
+          <p:cNvPr id="7" name="Text 5"/>
+          <p:cNvSpPr txBox="1"/>
+          <p:nvPr/>
+        </p:nvSpPr>
+        <p:spPr>
+          <a:xfrm>
+            <a:off x="777240" y="2350008"/>
+            <a:ext cx="5010912" cy="987552"/>
+          </a:xfrm>
+          <a:prstGeom prst="rect">
+            <a:avLst/>
+          </a:prstGeom>
+          <a:noFill/>
+          <a:ln/>
+        </p:spPr>
+        <p:txBody>
+          <a:bodyPr wrap="square" lIns="0" tIns="0" rIns="0" bIns="0" rtlCol="0" anchor="t"/>
+          <a:lstStyle/>
           <a:p>
             <a:pPr indent="0" marL="0">
               <a:buNone/>
             </a:pPr>
             <a:r>
-              <a:rPr lang="en-US" sz="2100" dirty="0">
-                <a:solidFill>
-                  <a:schemeClr val="bg2"/>
+              <a:rPr lang="en-US" sz="1600" dirty="0">
+                <a:solidFill>
+                  <a:schemeClr val="tx2"/>
                 </a:solidFill>
               </a:rPr>
-              <a:t> </a:t>
-            </a:r>
-            <a:endParaRPr lang="en-US" sz="2100" dirty="0"/>
-          </a:p>
+              <a:t>Big-move weeks cluster together, so the model can see them coming. Which way they go is close to a coin flip.</a:t>
+            </a:r>
+            <a:endParaRPr lang="en-US" sz="1600" dirty="0"/>
+          </a:p>
+        </p:txBody>
+      </p:sp>
+      <p:sp>
+        <p:nvSpPr>
+          <p:cNvPr id="8" name="Shape 6"/>
+          <p:cNvSpPr/>
+          <p:nvPr/>
+        </p:nvSpPr>
+        <p:spPr>
+          <a:xfrm>
+            <a:off x="6172200" y="1417320"/>
+            <a:ext cx="5468112" cy="2103120"/>
+          </a:xfrm>
+          <a:prstGeom prst="roundRect">
+            <a:avLst>
+              <a:gd name="adj" fmla="val 5217"/>
+            </a:avLst>
+          </a:prstGeom>
+          <a:solidFill>
+            <a:schemeClr val="bg2"/>
+          </a:solidFill>
+          <a:ln w="12700">
+            <a:solidFill>
+              <a:schemeClr val="bg2"/>
+            </a:solidFill>
+            <a:prstDash val="solid"/>
+          </a:ln>
+        </p:spPr>
+      </p:sp>
+      <p:sp>
+        <p:nvSpPr>
+          <p:cNvPr id="9" name="Shape 7"/>
+          <p:cNvSpPr/>
+          <p:nvPr/>
+        </p:nvSpPr>
+        <p:spPr>
+          <a:xfrm>
+            <a:off x="6400800" y="1645920"/>
+            <a:ext cx="438912" cy="438912"/>
+          </a:xfrm>
+          <a:prstGeom prst="ellipse">
+            <a:avLst/>
+          </a:prstGeom>
+          <a:solidFill>
+            <a:schemeClr val="accent1"/>
+          </a:solidFill>
+          <a:ln w="12700">
+            <a:solidFill>
+              <a:schemeClr val="accent1"/>
+            </a:solidFill>
+            <a:prstDash val="solid"/>
+          </a:ln>
+        </p:spPr>
+      </p:sp>
+      <p:sp>
+        <p:nvSpPr>
+          <p:cNvPr id="10" name="Text 8"/>
+          <p:cNvSpPr txBox="1"/>
+          <p:nvPr/>
+        </p:nvSpPr>
+        <p:spPr>
+          <a:xfrm>
+            <a:off x="6400800" y="1645920"/>
+            <a:ext cx="438912" cy="438912"/>
+          </a:xfrm>
+          <a:prstGeom prst="rect">
+            <a:avLst/>
+          </a:prstGeom>
+          <a:noFill/>
+          <a:ln/>
+        </p:spPr>
+        <p:txBody>
+          <a:bodyPr wrap="square" lIns="0" tIns="0" rIns="0" bIns="0" rtlCol="0" anchor="ctr"/>
+          <a:lstStyle/>
+          <a:p>
+            <a:pPr algn="ctr" indent="0" marL="0">
+              <a:buNone/>
+            </a:pPr>
+            <a:r>
+              <a:rPr lang="en-US" sz="1600" b="1" dirty="0">
+                <a:solidFill>
+                  <a:schemeClr val="bg1"/>
+                </a:solidFill>
+              </a:rPr>
+              <a:t>2</a:t>
+            </a:r>
+            <a:endParaRPr lang="en-US" sz="1600" dirty="0"/>
+          </a:p>
+        </p:txBody>
+      </p:sp>
+      <p:sp>
+        <p:nvSpPr>
+          <p:cNvPr id="11" name="Text 9"/>
+          <p:cNvSpPr txBox="1"/>
+          <p:nvPr/>
+        </p:nvSpPr>
+        <p:spPr>
+          <a:xfrm>
+            <a:off x="6995160" y="1645920"/>
+            <a:ext cx="4416552" cy="438912"/>
+          </a:xfrm>
+          <a:prstGeom prst="rect">
+            <a:avLst/>
+          </a:prstGeom>
+          <a:noFill/>
+          <a:ln/>
+        </p:spPr>
+        <p:txBody>
+          <a:bodyPr wrap="square" lIns="0" tIns="0" rIns="0" bIns="0" rtlCol="0" anchor="ctr"/>
+          <a:lstStyle/>
           <a:p>
             <a:pPr indent="0" marL="0">
               <a:buNone/>
             </a:pPr>
             <a:r>
-              <a:rPr lang="en-US" sz="1800" dirty="0">
-                <a:solidFill>
-                  <a:schemeClr val="accent4"/>
-                </a:solidFill>
+              <a:rPr lang="en-US" sz="1800" b="1" dirty="0">
+                <a:solidFill>
+                  <a:schemeClr val="tx1"/>
+                </a:solidFill>
+                <a:latin typeface="Cambria" pitchFamily="34" charset="0"/>
+                <a:ea typeface="Cambria" pitchFamily="34" charset="-122"/>
+                <a:cs typeface="Cambria" pitchFamily="34" charset="-120"/>
               </a:rPr>
-              <a:t>github.com/TKCH121/spy</a:t>
-            </a:r>
-            <a:endParaRPr lang="en-US" sz="2100" dirty="0"/>
+              <a:t>Sitting in cash has a cost</a:t>
+            </a:r>
+            <a:endParaRPr lang="en-US" sz="1800" dirty="0"/>
+          </a:p>
+        </p:txBody>
+      </p:sp>
+      <p:sp>
+        <p:nvSpPr>
+          <p:cNvPr id="12" name="Text 10"/>
+          <p:cNvSpPr txBox="1"/>
+          <p:nvPr/>
+        </p:nvSpPr>
+        <p:spPr>
+          <a:xfrm>
+            <a:off x="6400800" y="2194560"/>
+            <a:ext cx="5010912" cy="1143000"/>
+          </a:xfrm>
+          <a:prstGeom prst="rect">
+            <a:avLst/>
+          </a:prstGeom>
+          <a:noFill/>
+          <a:ln/>
+        </p:spPr>
+        <p:txBody>
+          <a:bodyPr wrap="square" lIns="0" tIns="0" rIns="0" bIns="0" rtlCol="0" anchor="t"/>
+          <a:lstStyle/>
+          <a:p>
+            <a:pPr indent="0" marL="0">
+              <a:buNone/>
+            </a:pPr>
+            <a:r>
+              <a:rPr lang="en-US" sz="1600" dirty="0">
+                <a:solidFill>
+                  <a:schemeClr val="tx2"/>
+                </a:solidFill>
+              </a:rPr>
+              <a:t>The market mostly goes up. Without real timing skill, every day out of the market loses money on average.</a:t>
+            </a:r>
+            <a:endParaRPr lang="en-US" sz="1600" dirty="0"/>
+          </a:p>
+        </p:txBody>
+      </p:sp>
+      <p:sp>
+        <p:nvSpPr>
+          <p:cNvPr id="13" name="Shape 11"/>
+          <p:cNvSpPr/>
+          <p:nvPr/>
+        </p:nvSpPr>
+        <p:spPr>
+          <a:xfrm>
+            <a:off x="548640" y="3703320"/>
+            <a:ext cx="5468112" cy="2103120"/>
+          </a:xfrm>
+          <a:prstGeom prst="roundRect">
+            <a:avLst>
+              <a:gd name="adj" fmla="val 5217"/>
+            </a:avLst>
+          </a:prstGeom>
+          <a:solidFill>
+            <a:schemeClr val="bg2"/>
+          </a:solidFill>
+          <a:ln w="12700">
+            <a:solidFill>
+              <a:schemeClr val="bg2"/>
+            </a:solidFill>
+            <a:prstDash val="solid"/>
+          </a:ln>
+        </p:spPr>
+      </p:sp>
+      <p:sp>
+        <p:nvSpPr>
+          <p:cNvPr id="14" name="Shape 12"/>
+          <p:cNvSpPr/>
+          <p:nvPr/>
+        </p:nvSpPr>
+        <p:spPr>
+          <a:xfrm>
+            <a:off x="777240" y="3931920"/>
+            <a:ext cx="438912" cy="438912"/>
+          </a:xfrm>
+          <a:prstGeom prst="ellipse">
+            <a:avLst/>
+          </a:prstGeom>
+          <a:solidFill>
+            <a:schemeClr val="accent1"/>
+          </a:solidFill>
+          <a:ln w="12700">
+            <a:solidFill>
+              <a:schemeClr val="accent1"/>
+            </a:solidFill>
+            <a:prstDash val="solid"/>
+          </a:ln>
+        </p:spPr>
+      </p:sp>
+      <p:sp>
+        <p:nvSpPr>
+          <p:cNvPr id="15" name="Text 13"/>
+          <p:cNvSpPr txBox="1"/>
+          <p:nvPr/>
+        </p:nvSpPr>
+        <p:spPr>
+          <a:xfrm>
+            <a:off x="777240" y="3931920"/>
+            <a:ext cx="438912" cy="438912"/>
+          </a:xfrm>
+          <a:prstGeom prst="rect">
+            <a:avLst/>
+          </a:prstGeom>
+          <a:noFill/>
+          <a:ln/>
+        </p:spPr>
+        <p:txBody>
+          <a:bodyPr wrap="square" lIns="0" tIns="0" rIns="0" bIns="0" rtlCol="0" anchor="ctr"/>
+          <a:lstStyle/>
+          <a:p>
+            <a:pPr algn="ctr" indent="0" marL="0">
+              <a:buNone/>
+            </a:pPr>
+            <a:r>
+              <a:rPr lang="en-US" sz="1600" b="1" dirty="0">
+                <a:solidFill>
+                  <a:schemeClr val="bg1"/>
+                </a:solidFill>
+              </a:rPr>
+              <a:t>3</a:t>
+            </a:r>
+            <a:endParaRPr lang="en-US" sz="1600" dirty="0"/>
+          </a:p>
+        </p:txBody>
+      </p:sp>
+      <p:sp>
+        <p:nvSpPr>
+          <p:cNvPr id="16" name="Text 14"/>
+          <p:cNvSpPr txBox="1"/>
+          <p:nvPr/>
+        </p:nvSpPr>
+        <p:spPr>
+          <a:xfrm>
+            <a:off x="1371600" y="3931920"/>
+            <a:ext cx="4416552" cy="438912"/>
+          </a:xfrm>
+          <a:prstGeom prst="rect">
+            <a:avLst/>
+          </a:prstGeom>
+          <a:noFill/>
+          <a:ln/>
+        </p:spPr>
+        <p:txBody>
+          <a:bodyPr wrap="square" lIns="0" tIns="0" rIns="0" bIns="0" rtlCol="0" anchor="ctr"/>
+          <a:lstStyle/>
+          <a:p>
+            <a:pPr indent="0" marL="0">
+              <a:buNone/>
+            </a:pPr>
+            <a:r>
+              <a:rPr lang="en-US" sz="1800" b="1" dirty="0">
+                <a:solidFill>
+                  <a:schemeClr val="tx1"/>
+                </a:solidFill>
+                <a:latin typeface="Cambria" pitchFamily="34" charset="0"/>
+                <a:ea typeface="Cambria" pitchFamily="34" charset="-122"/>
+                <a:cs typeface="Cambria" pitchFamily="34" charset="-120"/>
+              </a:rPr>
+              <a:t>The past changes</a:t>
+            </a:r>
+            <a:endParaRPr lang="en-US" sz="1800" dirty="0"/>
+          </a:p>
+        </p:txBody>
+      </p:sp>
+      <p:sp>
+        <p:nvSpPr>
+          <p:cNvPr id="17" name="Text 15"/>
+          <p:cNvSpPr txBox="1"/>
+          <p:nvPr/>
+        </p:nvSpPr>
+        <p:spPr>
+          <a:xfrm>
+            <a:off x="777240" y="4480560"/>
+            <a:ext cx="5010912" cy="1143000"/>
+          </a:xfrm>
+          <a:prstGeom prst="rect">
+            <a:avLst/>
+          </a:prstGeom>
+          <a:noFill/>
+          <a:ln/>
+        </p:spPr>
+        <p:txBody>
+          <a:bodyPr wrap="square" lIns="0" tIns="0" rIns="0" bIns="0" rtlCol="0" anchor="t"/>
+          <a:lstStyle/>
+          <a:p>
+            <a:pPr indent="0" marL="0">
+              <a:buNone/>
+            </a:pPr>
+            <a:r>
+              <a:rPr lang="en-US" sz="1600" dirty="0">
+                <a:solidFill>
+                  <a:schemeClr val="tx2"/>
+                </a:solidFill>
+              </a:rPr>
+              <a:t>A signal that helped from 2010 to 2020 actually misled the model in 2022.</a:t>
+            </a:r>
+            <a:endParaRPr lang="en-US" sz="1600" dirty="0"/>
+          </a:p>
+        </p:txBody>
+      </p:sp>
+      <p:sp>
+        <p:nvSpPr>
+          <p:cNvPr id="18" name="Shape 16"/>
+          <p:cNvSpPr/>
+          <p:nvPr/>
+        </p:nvSpPr>
+        <p:spPr>
+          <a:xfrm>
+            <a:off x="6172200" y="3703320"/>
+            <a:ext cx="5468112" cy="2103120"/>
+          </a:xfrm>
+          <a:prstGeom prst="roundRect">
+            <a:avLst>
+              <a:gd name="adj" fmla="val 5217"/>
+            </a:avLst>
+          </a:prstGeom>
+          <a:solidFill>
+            <a:schemeClr val="bg2"/>
+          </a:solidFill>
+          <a:ln w="12700">
+            <a:solidFill>
+              <a:schemeClr val="bg2"/>
+            </a:solidFill>
+            <a:prstDash val="solid"/>
+          </a:ln>
+        </p:spPr>
+      </p:sp>
+      <p:sp>
+        <p:nvSpPr>
+          <p:cNvPr id="19" name="Shape 17"/>
+          <p:cNvSpPr/>
+          <p:nvPr/>
+        </p:nvSpPr>
+        <p:spPr>
+          <a:xfrm>
+            <a:off x="6400800" y="3931920"/>
+            <a:ext cx="438912" cy="438912"/>
+          </a:xfrm>
+          <a:prstGeom prst="ellipse">
+            <a:avLst/>
+          </a:prstGeom>
+          <a:solidFill>
+            <a:schemeClr val="accent1"/>
+          </a:solidFill>
+          <a:ln w="12700">
+            <a:solidFill>
+              <a:schemeClr val="accent1"/>
+            </a:solidFill>
+            <a:prstDash val="solid"/>
+          </a:ln>
+        </p:spPr>
+      </p:sp>
+      <p:sp>
+        <p:nvSpPr>
+          <p:cNvPr id="20" name="Text 18"/>
+          <p:cNvSpPr txBox="1"/>
+          <p:nvPr/>
+        </p:nvSpPr>
+        <p:spPr>
+          <a:xfrm>
+            <a:off x="6400800" y="3931920"/>
+            <a:ext cx="438912" cy="438912"/>
+          </a:xfrm>
+          <a:prstGeom prst="rect">
+            <a:avLst/>
+          </a:prstGeom>
+          <a:noFill/>
+          <a:ln/>
+        </p:spPr>
+        <p:txBody>
+          <a:bodyPr wrap="square" lIns="0" tIns="0" rIns="0" bIns="0" rtlCol="0" anchor="ctr"/>
+          <a:lstStyle/>
+          <a:p>
+            <a:pPr algn="ctr" indent="0" marL="0">
+              <a:buNone/>
+            </a:pPr>
+            <a:r>
+              <a:rPr lang="en-US" sz="1600" b="1" dirty="0">
+                <a:solidFill>
+                  <a:schemeClr val="bg1"/>
+                </a:solidFill>
+              </a:rPr>
+              <a:t>4</a:t>
+            </a:r>
+            <a:endParaRPr lang="en-US" sz="1600" dirty="0"/>
+          </a:p>
+        </p:txBody>
+      </p:sp>
+      <p:sp>
+        <p:nvSpPr>
+          <p:cNvPr id="21" name="Text 19"/>
+          <p:cNvSpPr txBox="1"/>
+          <p:nvPr/>
+        </p:nvSpPr>
+        <p:spPr>
+          <a:xfrm>
+            <a:off x="6995160" y="3931920"/>
+            <a:ext cx="4416552" cy="438912"/>
+          </a:xfrm>
+          <a:prstGeom prst="rect">
+            <a:avLst/>
+          </a:prstGeom>
+          <a:noFill/>
+          <a:ln/>
+        </p:spPr>
+        <p:txBody>
+          <a:bodyPr wrap="square" lIns="0" tIns="0" rIns="0" bIns="0" rtlCol="0" anchor="ctr"/>
+          <a:lstStyle/>
+          <a:p>
+            <a:pPr indent="0" marL="0">
+              <a:buNone/>
+            </a:pPr>
+            <a:r>
+              <a:rPr lang="en-US" sz="1800" b="1" dirty="0">
+                <a:solidFill>
+                  <a:schemeClr val="tx1"/>
+                </a:solidFill>
+                <a:latin typeface="Cambria" pitchFamily="34" charset="0"/>
+                <a:ea typeface="Cambria" pitchFamily="34" charset="-122"/>
+                <a:cs typeface="Cambria" pitchFamily="34" charset="-120"/>
+              </a:rPr>
+              <a:t>Good predictions ≠ good trades</a:t>
+            </a:r>
+            <a:endParaRPr lang="en-US" sz="1800" dirty="0"/>
+          </a:p>
+        </p:txBody>
+      </p:sp>
+      <p:sp>
+        <p:nvSpPr>
+          <p:cNvPr id="22" name="Text 20"/>
+          <p:cNvSpPr txBox="1"/>
+          <p:nvPr/>
+        </p:nvSpPr>
+        <p:spPr>
+          <a:xfrm>
+            <a:off x="6400800" y="4480560"/>
+            <a:ext cx="5010912" cy="1143000"/>
+          </a:xfrm>
+          <a:prstGeom prst="rect">
+            <a:avLst/>
+          </a:prstGeom>
+          <a:noFill/>
+          <a:ln/>
+        </p:spPr>
+        <p:txBody>
+          <a:bodyPr wrap="square" lIns="0" tIns="0" rIns="0" bIns="0" rtlCol="0" anchor="t"/>
+          <a:lstStyle/>
+          <a:p>
+            <a:pPr indent="0" marL="0">
+              <a:buNone/>
+            </a:pPr>
+            <a:r>
+              <a:rPr lang="en-US" sz="1600" dirty="0">
+                <a:solidFill>
+                  <a:schemeClr val="tx2"/>
+                </a:solidFill>
+              </a:rPr>
+              <a:t>Settings that improve the prediction score can distort the odds a trading rule relies on. With honest odds (v3), the best rule was not to trade.</a:t>
+            </a:r>
+            <a:endParaRPr lang="en-US" sz="1600" dirty="0"/>
           </a:p>
         </p:txBody>
       </p:sp>
@@ -23725,7 +25071,7 @@
                 <a:ea typeface="Cambria" pitchFamily="34" charset="-122"/>
                 <a:cs typeface="Cambria" pitchFamily="34" charset="-120"/>
               </a:rPr>
-              <a:t>Option B · Let the model decide</a:t>
+              <a:t>Option B · Follow the model</a:t>
             </a:r>
             <a:endParaRPr lang="en-US" sz="2200" dirty="0"/>
           </a:p>
@@ -23761,7 +25107,7 @@
                   <a:schemeClr val="tx2"/>
                 </a:solidFill>
               </a:rPr>
-              <a:t>Every evening, a computer model decides whether the money should be in the market or safely in cash the next day.</a:t>
+              <a:t>Every evening, a model predicts the best action for the next 5 trading days: Buy, Hold or Sell. We trade on it the next morning.</a:t>
             </a:r>
             <a:endParaRPr lang="en-US" sz="1700" dirty="0"/>
           </a:p>
@@ -23781,7 +25127,7 @@
                   <a:schemeClr val="tx2"/>
                 </a:solidFill>
               </a:rPr>
-              <a:t>Every switch costs a small fee.</a:t>
+              <a:t>Every trade costs a small fee.</a:t>
             </a:r>
             <a:endParaRPr lang="en-US" sz="1700" dirty="0"/>
           </a:p>
@@ -23866,6 +25212,183 @@
             <a:fld id="{F7021451-1387-4CA6-816F-3879F97B5CBC}" type="slidenum">
               <a:rPr b="0" lang="en-US"/>
               <a:t>3</a:t>
+            </a:fld>
+            <a:endParaRPr lang="en-US"/>
+          </a:p>
+        </p:txBody>
+      </p:sp>
+    </p:spTree>
+  </p:cSld>
+  <p:clrMapOvr>
+    <a:masterClrMapping/>
+  </p:clrMapOvr>
+</p:sld>
+</file>
+
+<file path=ppt/slides/slide30.xml><?xml version="1.0" encoding="utf-8"?>
+<p:sld xmlns:a="http://schemas.openxmlformats.org/drawingml/2006/main" xmlns:r="http://schemas.openxmlformats.org/officeDocument/2006/relationships" xmlns:p="http://schemas.openxmlformats.org/presentationml/2006/main">
+  <p:cSld name="Slide 30">
+    <p:spTree>
+      <p:nvGrpSpPr>
+        <p:cNvPr id="1" name=""/>
+        <p:cNvGrpSpPr/>
+        <p:nvPr/>
+      </p:nvGrpSpPr>
+      <p:grpSpPr>
+        <a:xfrm>
+          <a:off x="0" y="0"/>
+          <a:ext cx="0" cy="0"/>
+          <a:chOff x="0" y="0"/>
+          <a:chExt cx="0" cy="0"/>
+        </a:xfrm>
+      </p:grpSpPr>
+      <p:sp>
+        <p:nvSpPr>
+          <p:cNvPr id="2" name="Text 0"/>
+          <p:cNvSpPr/>
+          <p:nvPr>
+            <p:ph idx="100" type="title" hasCustomPrompt="1"/>
+          </p:nvPr>
+        </p:nvSpPr>
+        <p:spPr>
+          <a:xfrm>
+            <a:off x="548640" y="1097280"/>
+            <a:ext cx="10789920" cy="2560320"/>
+          </a:xfrm>
+          <a:prstGeom prst="rect">
+            <a:avLst/>
+          </a:prstGeom>
+          <a:noFill/>
+          <a:ln/>
+        </p:spPr>
+        <p:txBody>
+          <a:bodyPr wrap="square" rtlCol="0" anchor="b"/>
+          <a:lstStyle/>
+          <a:p>
+            <a:pPr indent="0" marL="0">
+              <a:buNone/>
+            </a:pPr>
+            <a:r>
+              <a:rPr lang="en-US" sz="4000" b="1" dirty="0">
+                <a:solidFill>
+                  <a:schemeClr val="bg1"/>
+                </a:solidFill>
+                <a:latin typeface="Cambria" pitchFamily="34" charset="0"/>
+                <a:ea typeface="Cambria" pitchFamily="34" charset="-122"/>
+                <a:cs typeface="Cambria" pitchFamily="34" charset="-120"/>
+              </a:rPr>
+              <a:t>Questions?</a:t>
+            </a:r>
+            <a:endParaRPr lang="en-US" sz="4000" dirty="0"/>
+          </a:p>
+        </p:txBody>
+      </p:sp>
+      <p:sp>
+        <p:nvSpPr>
+          <p:cNvPr id="3" name="Text 0"/>
+          <p:cNvSpPr/>
+          <p:nvPr>
+            <p:ph idx="101" type="body" hasCustomPrompt="1"/>
+          </p:nvPr>
+        </p:nvSpPr>
+        <p:spPr>
+          <a:xfrm>
+            <a:off x="548640" y="3931920"/>
+            <a:ext cx="10424160" cy="2103120"/>
+          </a:xfrm>
+          <a:prstGeom prst="rect">
+            <a:avLst/>
+          </a:prstGeom>
+          <a:noFill/>
+          <a:ln/>
+        </p:spPr>
+        <p:txBody>
+          <a:bodyPr wrap="square" rtlCol="0" anchor="t"/>
+          <a:lstStyle/>
+          <a:p>
+            <a:pPr indent="0" marL="0">
+              <a:buNone/>
+            </a:pPr>
+            <a:r>
+              <a:rPr lang="en-US" sz="2100" dirty="0">
+                <a:solidFill>
+                  <a:schemeClr val="bg2"/>
+                </a:solidFill>
+              </a:rPr>
+              <a:t>$100,000 in 2023–24 → $156,546 by waiting, $123,714 with v1, $121,812 with v2. With honest odds, v3’s best rule is not to trade.</a:t>
+            </a:r>
+            <a:endParaRPr lang="en-US" sz="2100" dirty="0"/>
+          </a:p>
+          <a:p>
+            <a:pPr indent="0" marL="0">
+              <a:buNone/>
+            </a:pPr>
+            <a:r>
+              <a:rPr lang="en-US" sz="2100" dirty="0">
+                <a:solidFill>
+                  <a:schemeClr val="bg2"/>
+                </a:solidFill>
+              </a:rPr>
+              <a:t> </a:t>
+            </a:r>
+            <a:endParaRPr lang="en-US" sz="2100" dirty="0"/>
+          </a:p>
+          <a:p>
+            <a:pPr indent="0" marL="0">
+              <a:buNone/>
+            </a:pPr>
+            <a:r>
+              <a:rPr lang="en-US" sz="1800" dirty="0">
+                <a:solidFill>
+                  <a:schemeClr val="accent4"/>
+                </a:solidFill>
+              </a:rPr>
+              <a:t>github.com/TKCH121/spy</a:t>
+            </a:r>
+            <a:endParaRPr lang="en-US" sz="2100" dirty="0"/>
+          </a:p>
+        </p:txBody>
+      </p:sp>
+      <p:sp>
+        <p:nvSpPr>
+          <p:cNvPr id="25" name="Slide Number Placeholder 0"/>
+          <p:cNvSpPr>
+            <a:spLocks noGrp="1"/>
+          </p:cNvSpPr>
+          <p:nvPr>
+            <p:ph type="sldNum" sz="quarter" idx="4294967295"/>
+          </p:nvPr>
+        </p:nvSpPr>
+        <p:spPr>
+          <a:xfrm>
+            <a:off x="11155680" y="6355080"/>
+            <a:ext cx="548640" cy="320040"/>
+          </a:xfrm>
+          <a:prstGeom prst="rect">
+            <a:avLst/>
+          </a:prstGeom>
+          <a:extLst>
+            <a:ext uri="{C572A759-6A51-4108-AA02-DFA0A04FC94B}">
+              <ma14:wrappingTextBoxFlag xmlns:ma14="http://schemas.microsoft.com/office/mac/drawingml/2011/main" val="0"/>
+            </a:ext>
+          </a:extLst>
+        </p:spPr>
+        <p:txBody>
+          <a:bodyPr/>
+          <a:lstStyle>
+            <a:lvl1pPr>
+              <a:defRPr sz="1200">
+                <a:solidFill>
+                  <a:schemeClr val="accent3"/>
+                </a:solidFill>
+              </a:defRPr>
+            </a:lvl1pPr>
+          </a:lstStyle>
+          <a:p>
+            <a:pPr algn="r"/>
+            <a:fld id="{F7021451-1387-4CA6-816F-3879F97B5CBC}" type="slidenum">
+              <a:rPr b="0" lang="en-US"/>
+              <a:t>30</a:t>
             </a:fld>
             <a:endParaRPr lang="en-US"/>
           </a:p>
@@ -25756,7 +27279,7 @@
                   <a:schemeClr val="tx2"/>
                 </a:solidFill>
               </a:rPr>
-              <a:t>Will next week be Up (&gt; +1%), Down (&lt; −1%) or Flat?</a:t>
+              <a:t>The action for the next 5 days: Buy (&gt; +1%), Sell (&lt; −1%) or Hold</a:t>
             </a:r>
             <a:endParaRPr lang="en-US" sz="1600" dirty="0"/>
           </a:p>
@@ -25908,7 +27431,7 @@
                 <a:ea typeface="Cambria" pitchFamily="34" charset="-122"/>
                 <a:cs typeface="Cambria" pitchFamily="34" charset="-120"/>
               </a:rPr>
-              <a:t>Decide</a:t>
+              <a:t>Act</a:t>
             </a:r>
             <a:endParaRPr lang="en-US" sz="2000" dirty="0"/>
           </a:p>
@@ -25944,7 +27467,7 @@
                   <a:schemeClr val="tx2"/>
                 </a:solidFill>
               </a:rPr>
-              <a:t>Turn that prediction into: in the market or in cash tomorrow</a:t>
+              <a:t>Buy → be invested · Sell → move to cash · Hold → keep the current position</a:t>
             </a:r>
             <a:endParaRPr lang="en-US" sz="1600" dirty="0"/>
           </a:p>
@@ -26132,7 +27655,7 @@
                   <a:schemeClr val="tx2"/>
                 </a:solidFill>
               </a:rPr>
-              <a:t>If it switches, buy or sell when the market opens, and pay the cost</a:t>
+              <a:t>Any change fills at the next morning’s open, and pays the cost</a:t>
             </a:r>
             <a:endParaRPr lang="en-US" sz="1600" dirty="0"/>
           </a:p>
@@ -27522,7 +29045,7 @@
                 <a:ea typeface="Cambria" pitchFamily="34" charset="-122"/>
                 <a:cs typeface="Cambria" pitchFamily="34" charset="-120"/>
               </a:rPr>
-              <a:t>What the model predicts: what kind of week is next</a:t>
+              <a:t>What the model predicts: Buy, Hold or Sell for 5 days</a:t>
             </a:r>
             <a:endParaRPr lang="en-US" sz="3200" dirty="0"/>
           </a:p>
@@ -27624,7 +29147,7 @@
                 <a:ea typeface="Cambria" pitchFamily="34" charset="-122"/>
                 <a:cs typeface="Cambria" pitchFamily="34" charset="-120"/>
               </a:rPr>
-              <a:t>Down week</a:t>
+              <a:t>Sell · down week</a:t>
             </a:r>
             <a:endParaRPr lang="en-US" sz="2600" dirty="0"/>
           </a:p>
@@ -27762,7 +29285,7 @@
                 <a:ea typeface="Cambria" pitchFamily="34" charset="-122"/>
                 <a:cs typeface="Cambria" pitchFamily="34" charset="-120"/>
               </a:rPr>
-              <a:t>Flat week</a:t>
+              <a:t>Hold · flat week</a:t>
             </a:r>
             <a:endParaRPr lang="en-US" sz="2600" dirty="0"/>
           </a:p>
@@ -27900,7 +29423,7 @@
                 <a:ea typeface="Cambria" pitchFamily="34" charset="-122"/>
                 <a:cs typeface="Cambria" pitchFamily="34" charset="-120"/>
               </a:rPr>
-              <a:t>Up week</a:t>
+              <a:t>Buy · up week</a:t>
             </a:r>
             <a:endParaRPr lang="en-US" sz="2600" dirty="0"/>
           </a:p>

</xml_diff>

<commit_message>
Walk-forward: add v1, split from the holdout, explain it plainly
- Scorecard adds v1w (and v1 daily) to the 2013-24 walk-forward: v1w $164,406, 4.2% a year,
  max drawdown -23.9%, Sharpe 0.28, beats 6% of random-timing paths.
- SUMMARY, weekly report and slide 10: separate walk-forward and holdout tables, one line on
  what each tests, v3 shown once as 'never sells, identical to buy-and-hold'.
- Speaking notes explain the walk-forward in one sentence.

Co-Authored-By: Claude Opus 5.5 <noreply@anthropic.com>
</commit_message>
<xml_diff>
--- a/presentation/SPY_Model_Presentation.pptx
+++ b/presentation/SPY_Model_Presentation.pptx
@@ -124,14 +124,14 @@
   <p:extLst>
     <p:ext uri="{521415D9-36F7-43E2-AB2F-B90AF26B5E84}">
       <p14:sectionLst xmlns:p14="http://schemas.microsoft.com/office/powerpoint/2010/main">
-        <p14:section name="Objective and approach" id="{6112c5d2-fda2-0152-2e17-5ff7aa6da2ed}">
+        <p14:section name="Objective and approach" id="{2f99c676-4715-6e5a-bd38-c3e35d7e1a60}">
           <p14:sldIdLst>
             <p14:sldId id="256"/>
             <p14:sldId id="257"/>
             <p14:sldId id="258"/>
           </p14:sldIdLst>
         </p14:section>
-        <p14:section name="Method" id="{ac6897e2-5870-f1be-14cb-0190cffc69af}">
+        <p14:section name="Method" id="{7e1f47c3-7050-705d-3108-fc5e98f319da}">
           <p14:sldIdLst>
             <p14:sldId id="259"/>
             <p14:sldId id="260"/>
@@ -139,14 +139,14 @@
             <p14:sldId id="262"/>
           </p14:sldIdLst>
         </p14:section>
-        <p14:section name="Results" id="{32f543f4-3a90-0444-f185-e9d22c3499d8}">
+        <p14:section name="Results" id="{28a4d26a-c73e-597d-6789-18eb82bc7c80}">
           <p14:sldIdLst>
             <p14:sldId id="263"/>
             <p14:sldId id="264"/>
             <p14:sldId id="265"/>
           </p14:sldIdLst>
         </p14:section>
-        <p14:section name="Interpretation" id="{b6014e82-1dfd-14e1-9552-2ddaaa694614}">
+        <p14:section name="Interpretation" id="{bf7c321c-47f3-e3b4-7cfe-51082661c6cb}">
           <p14:sldIdLst>
             <p14:sldId id="266"/>
             <p14:sldId id="267"/>
@@ -156,7 +156,7 @@
             <p14:sldId id="271"/>
           </p14:sldIdLst>
         </p14:section>
-        <p14:section name="Appendix" id="{79205446-6d77-4b1f-8f1e-9c70eee9544b}">
+        <p14:section name="Appendix" id="{7981338e-f557-bfee-660f-e45b50fc823b}">
           <p14:sldIdLst>
             <p14:sldId id="272"/>
             <p14:sldId id="273"/>
@@ -5905,6 +5905,53 @@
           </a:p>
         </p:txBody>
       </p:sp>
+      <p:sp>
+        <p:nvSpPr>
+          <p:cNvPr id="3" name="Text 1"/>
+          <p:cNvSpPr txBox="1"/>
+          <p:nvPr/>
+        </p:nvSpPr>
+        <p:spPr>
+          <a:xfrm>
+            <a:off x="548640" y="1234440"/>
+            <a:ext cx="11094415" cy="457200"/>
+          </a:xfrm>
+          <a:prstGeom prst="rect">
+            <a:avLst/>
+          </a:prstGeom>
+          <a:noFill/>
+          <a:ln/>
+        </p:spPr>
+        <p:txBody>
+          <a:bodyPr wrap="square" lIns="0" tIns="0" rIns="0" bIns="0" rtlCol="0" anchor="t"/>
+          <a:lstStyle/>
+          <a:p>
+            <a:pPr indent="0" marL="0">
+              <a:buNone/>
+            </a:pPr>
+            <a:r>
+              <a:rPr lang="en-US" sz="1400" b="1" dirty="0">
+                <a:solidFill>
+                  <a:schemeClr val="tx1"/>
+                </a:solidFill>
+              </a:rPr>
+              <a:t>12-year walk-forward, 2013–2024. </a:t>
+            </a:r>
+            <a:pPr indent="0" marL="0">
+              <a:buNone/>
+            </a:pPr>
+            <a:r>
+              <a:rPr lang="en-US" sz="1400" dirty="0">
+                <a:solidFill>
+                  <a:schemeClr val="tx2"/>
+                </a:solidFill>
+              </a:rPr>
+              <a:t>Retrain every January on all earlier data, trade the following year, repeat; $100,000 chained across the 12 years.</a:t>
+            </a:r>
+            <a:endParaRPr lang="en-US" sz="1400" dirty="0"/>
+          </a:p>
+        </p:txBody>
+      </p:sp>
       <p:graphicFrame>
         <p:nvGraphicFramePr>
           <p:cNvPr id="11" name="Table 0"/>
@@ -5920,7 +5967,7 @@
           </p:nvPr>
         </p:nvGraphicFramePr>
         <p:xfrm>
-          <a:off x="548640" y="1371600"/>
+          <a:off x="548640" y="1737360"/>
           <a:ext cx="11094415" cy="914400"/>
         </p:xfrm>
         <a:graphic>
@@ -5928,15 +5975,14 @@
             <a:tbl>
               <a:tblPr/>
               <a:tblGrid>
-                <a:gridCol w="2377440"/>
-                <a:gridCol w="2377440"/>
-                <a:gridCol w="1463040"/>
-                <a:gridCol w="1463040"/>
-                <a:gridCol w="1463040"/>
-                <a:gridCol w="914400"/>
-                <a:gridCol w="1033272"/>
+                <a:gridCol w="3593592"/>
+                <a:gridCol w="1554480"/>
+                <a:gridCol w="1554480"/>
+                <a:gridCol w="1554480"/>
+                <a:gridCol w="1280160"/>
+                <a:gridCol w="1554480"/>
               </a:tblGrid>
-              <a:tr h="475488">
+              <a:tr h="411480">
                 <a:tc>
                   <a:txBody>
                     <a:bodyPr/>
@@ -5951,73 +5997,12 @@
                             <a:schemeClr val="bg1"/>
                           </a:solidFill>
                         </a:rPr>
-                        <a:t>Period</a:t>
+                        <a:t>Strategy (weekly decisions)</a:t>
                       </a:r>
                       <a:endParaRPr lang="en-US" sz="1400" dirty="0"/>
                     </a:p>
                   </a:txBody>
-                  <a:tcPr marL="91440" marR="91440" marT="45720" marB="45720" anchor="ctr">
-                    <a:lnL w="9525" cap="flat" cmpd="sng" algn="ctr">
-                      <a:solidFill>
-                        <a:srgbClr val="D5DAE3"/>
-                      </a:solidFill>
-                      <a:prstDash val="solid"/>
-                      <a:round/>
-                      <a:headEnd type="none" w="med" len="med"/>
-                      <a:tailEnd type="none" w="med" len="med"/>
-                    </a:lnL>
-                    <a:lnR w="9525" cap="flat" cmpd="sng" algn="ctr">
-                      <a:solidFill>
-                        <a:srgbClr val="D5DAE3"/>
-                      </a:solidFill>
-                      <a:prstDash val="solid"/>
-                      <a:round/>
-                      <a:headEnd type="none" w="med" len="med"/>
-                      <a:tailEnd type="none" w="med" len="med"/>
-                    </a:lnR>
-                    <a:lnT w="9525" cap="flat" cmpd="sng" algn="ctr">
-                      <a:solidFill>
-                        <a:srgbClr val="D5DAE3"/>
-                      </a:solidFill>
-                      <a:prstDash val="solid"/>
-                      <a:round/>
-                      <a:headEnd type="none" w="med" len="med"/>
-                      <a:tailEnd type="none" w="med" len="med"/>
-                    </a:lnT>
-                    <a:lnB w="9525" cap="flat" cmpd="sng" algn="ctr">
-                      <a:solidFill>
-                        <a:srgbClr val="D5DAE3"/>
-                      </a:solidFill>
-                      <a:prstDash val="solid"/>
-                      <a:round/>
-                      <a:headEnd type="none" w="med" len="med"/>
-                      <a:tailEnd type="none" w="med" len="med"/>
-                    </a:lnB>
-                    <a:solidFill>
-                      <a:schemeClr val="tx1"/>
-                    </a:solidFill>
-                  </a:tcPr>
-                </a:tc>
-                <a:tc>
-                  <a:txBody>
-                    <a:bodyPr/>
-                    <a:lstStyle/>
-                    <a:p>
-                      <a:pPr indent="0" marL="0">
-                        <a:buNone/>
-                      </a:pPr>
-                      <a:r>
-                        <a:rPr lang="en-US" sz="1400" b="1" dirty="0">
-                          <a:solidFill>
-                            <a:schemeClr val="bg1"/>
-                          </a:solidFill>
-                        </a:rPr>
-                        <a:t>Strategy</a:t>
-                      </a:r>
-                      <a:endParaRPr lang="en-US" sz="1400" dirty="0"/>
-                    </a:p>
-                  </a:txBody>
-                  <a:tcPr marL="91440" marR="91440" marT="45720" marB="45720" anchor="ctr">
+                  <a:tcPr marL="91440" marR="91440" marT="36576" marB="36576" anchor="ctr">
                     <a:lnL w="9525" cap="flat" cmpd="sng" algn="ctr">
                       <a:solidFill>
                         <a:srgbClr val="D5DAE3"/>
@@ -6078,7 +6063,7 @@
                       <a:endParaRPr lang="en-US" sz="1400" dirty="0"/>
                     </a:p>
                   </a:txBody>
-                  <a:tcPr marL="91440" marR="91440" marT="45720" marB="45720" anchor="ctr">
+                  <a:tcPr marL="91440" marR="91440" marT="36576" marB="36576" anchor="ctr">
                     <a:lnL w="9525" cap="flat" cmpd="sng" algn="ctr">
                       <a:solidFill>
                         <a:srgbClr val="D5DAE3"/>
@@ -6139,7 +6124,7 @@
                       <a:endParaRPr lang="en-US" sz="1400" dirty="0"/>
                     </a:p>
                   </a:txBody>
-                  <a:tcPr marL="91440" marR="91440" marT="45720" marB="45720" anchor="ctr">
+                  <a:tcPr marL="91440" marR="91440" marT="36576" marB="36576" anchor="ctr">
                     <a:lnL w="9525" cap="flat" cmpd="sng" algn="ctr">
                       <a:solidFill>
                         <a:srgbClr val="D5DAE3"/>
@@ -6200,7 +6185,7 @@
                       <a:endParaRPr lang="en-US" sz="1400" dirty="0"/>
                     </a:p>
                   </a:txBody>
-                  <a:tcPr marL="91440" marR="91440" marT="45720" marB="45720" anchor="ctr">
+                  <a:tcPr marL="91440" marR="91440" marT="36576" marB="36576" anchor="ctr">
                     <a:lnL w="9525" cap="flat" cmpd="sng" algn="ctr">
                       <a:solidFill>
                         <a:srgbClr val="D5DAE3"/>
@@ -6261,7 +6246,7 @@
                       <a:endParaRPr lang="en-US" sz="1400" dirty="0"/>
                     </a:p>
                   </a:txBody>
-                  <a:tcPr marL="91440" marR="91440" marT="45720" marB="45720" anchor="ctr">
+                  <a:tcPr marL="91440" marR="91440" marT="36576" marB="36576" anchor="ctr">
                     <a:lnL w="9525" cap="flat" cmpd="sng" algn="ctr">
                       <a:solidFill>
                         <a:srgbClr val="D5DAE3"/>
@@ -6322,7 +6307,7 @@
                       <a:endParaRPr lang="en-US" sz="1400" dirty="0"/>
                     </a:p>
                   </a:txBody>
-                  <a:tcPr marL="91440" marR="91440" marT="45720" marB="45720" anchor="ctr">
+                  <a:tcPr marL="91440" marR="91440" marT="36576" marB="36576" anchor="ctr">
                     <a:lnL w="9525" cap="flat" cmpd="sng" algn="ctr">
                       <a:solidFill>
                         <a:srgbClr val="D5DAE3"/>
@@ -6365,65 +6350,7 @@
                   </a:tcPr>
                 </a:tc>
               </a:tr>
-              <a:tr h="475488">
-                <a:tc>
-                  <a:txBody>
-                    <a:bodyPr/>
-                    <a:lstStyle/>
-                    <a:p>
-                      <a:pPr indent="0" marL="0">
-                        <a:buNone/>
-                      </a:pPr>
-                      <a:r>
-                        <a:rPr lang="en-US" sz="1400" dirty="0">
-                          <a:solidFill>
-                            <a:schemeClr val="tx2"/>
-                          </a:solidFill>
-                        </a:rPr>
-                        <a:t>2013–2024 walk-forward</a:t>
-                      </a:r>
-                      <a:endParaRPr lang="en-US" sz="1400" dirty="0"/>
-                    </a:p>
-                  </a:txBody>
-                  <a:tcPr marL="91440" marR="91440" marT="45720" marB="45720" anchor="ctr">
-                    <a:lnL w="9525" cap="flat" cmpd="sng" algn="ctr">
-                      <a:solidFill>
-                        <a:srgbClr val="D5DAE3"/>
-                      </a:solidFill>
-                      <a:prstDash val="solid"/>
-                      <a:round/>
-                      <a:headEnd type="none" w="med" len="med"/>
-                      <a:tailEnd type="none" w="med" len="med"/>
-                    </a:lnL>
-                    <a:lnR w="9525" cap="flat" cmpd="sng" algn="ctr">
-                      <a:solidFill>
-                        <a:srgbClr val="D5DAE3"/>
-                      </a:solidFill>
-                      <a:prstDash val="solid"/>
-                      <a:round/>
-                      <a:headEnd type="none" w="med" len="med"/>
-                      <a:tailEnd type="none" w="med" len="med"/>
-                    </a:lnR>
-                    <a:lnT w="9525" cap="flat" cmpd="sng" algn="ctr">
-                      <a:solidFill>
-                        <a:srgbClr val="D5DAE3"/>
-                      </a:solidFill>
-                      <a:prstDash val="solid"/>
-                      <a:round/>
-                      <a:headEnd type="none" w="med" len="med"/>
-                      <a:tailEnd type="none" w="med" len="med"/>
-                    </a:lnT>
-                    <a:lnB w="9525" cap="flat" cmpd="sng" algn="ctr">
-                      <a:solidFill>
-                        <a:srgbClr val="D5DAE3"/>
-                      </a:solidFill>
-                      <a:prstDash val="solid"/>
-                      <a:round/>
-                      <a:headEnd type="none" w="med" len="med"/>
-                      <a:tailEnd type="none" w="med" len="med"/>
-                    </a:lnB>
-                  </a:tcPr>
-                </a:tc>
+              <a:tr h="411480">
                 <a:tc>
                   <a:txBody>
                     <a:bodyPr/>
@@ -6443,7 +6370,7 @@
                       <a:endParaRPr lang="en-US" sz="1400" dirty="0"/>
                     </a:p>
                   </a:txBody>
-                  <a:tcPr marL="91440" marR="91440" marT="45720" marB="45720" anchor="ctr">
+                  <a:tcPr marL="91440" marR="91440" marT="36576" marB="36576" anchor="ctr">
                     <a:lnL w="9525" cap="flat" cmpd="sng" algn="ctr">
                       <a:solidFill>
                         <a:srgbClr val="D5DAE3"/>
@@ -6501,7 +6428,7 @@
                       <a:endParaRPr lang="en-US" sz="1400" dirty="0"/>
                     </a:p>
                   </a:txBody>
-                  <a:tcPr marL="91440" marR="91440" marT="45720" marB="45720" anchor="ctr">
+                  <a:tcPr marL="91440" marR="91440" marT="36576" marB="36576" anchor="ctr">
                     <a:lnL w="9525" cap="flat" cmpd="sng" algn="ctr">
                       <a:solidFill>
                         <a:srgbClr val="D5DAE3"/>
@@ -6559,7 +6486,7 @@
                       <a:endParaRPr lang="en-US" sz="1400" dirty="0"/>
                     </a:p>
                   </a:txBody>
-                  <a:tcPr marL="91440" marR="91440" marT="45720" marB="45720" anchor="ctr">
+                  <a:tcPr marL="91440" marR="91440" marT="36576" marB="36576" anchor="ctr">
                     <a:lnL w="9525" cap="flat" cmpd="sng" algn="ctr">
                       <a:solidFill>
                         <a:srgbClr val="D5DAE3"/>
@@ -6617,7 +6544,7 @@
                       <a:endParaRPr lang="en-US" sz="1400" dirty="0"/>
                     </a:p>
                   </a:txBody>
-                  <a:tcPr marL="91440" marR="91440" marT="45720" marB="45720" anchor="ctr">
+                  <a:tcPr marL="91440" marR="91440" marT="36576" marB="36576" anchor="ctr">
                     <a:lnL w="9525" cap="flat" cmpd="sng" algn="ctr">
                       <a:solidFill>
                         <a:srgbClr val="D5DAE3"/>
@@ -6675,7 +6602,7 @@
                       <a:endParaRPr lang="en-US" sz="1400" dirty="0"/>
                     </a:p>
                   </a:txBody>
-                  <a:tcPr marL="91440" marR="91440" marT="45720" marB="45720" anchor="ctr">
+                  <a:tcPr marL="91440" marR="91440" marT="36576" marB="36576" anchor="ctr">
                     <a:lnL w="9525" cap="flat" cmpd="sng" algn="ctr">
                       <a:solidFill>
                         <a:srgbClr val="D5DAE3"/>
@@ -6733,7 +6660,7 @@
                       <a:endParaRPr lang="en-US" sz="1400" dirty="0"/>
                     </a:p>
                   </a:txBody>
-                  <a:tcPr marL="91440" marR="91440" marT="45720" marB="45720" anchor="ctr">
+                  <a:tcPr marL="91440" marR="91440" marT="36576" marB="36576" anchor="ctr">
                     <a:lnL w="9525" cap="flat" cmpd="sng" algn="ctr">
                       <a:solidFill>
                         <a:srgbClr val="D5DAE3"/>
@@ -6773,7 +6700,7 @@
                   </a:tcPr>
                 </a:tc>
               </a:tr>
-              <a:tr h="475488">
+              <a:tr h="411480">
                 <a:tc>
                   <a:txBody>
                     <a:bodyPr/>
@@ -6782,10 +6709,18 @@
                       <a:pPr indent="0" marL="0">
                         <a:buNone/>
                       </a:pPr>
+                      <a:r>
+                        <a:rPr lang="en-US" sz="1400" dirty="0">
+                          <a:solidFill>
+                            <a:schemeClr val="tx2"/>
+                          </a:solidFill>
+                        </a:rPr>
+                        <a:t>v1 · random forest</a:t>
+                      </a:r>
                       <a:endParaRPr lang="en-US" sz="1400" dirty="0"/>
                     </a:p>
                   </a:txBody>
-                  <a:tcPr marL="91440" marR="91440" marT="45720" marB="45720" anchor="ctr">
+                  <a:tcPr marL="91440" marR="91440" marT="36576" marB="36576" anchor="ctr">
                     <a:lnL w="9525" cap="flat" cmpd="sng" algn="ctr">
                       <a:solidFill>
                         <a:srgbClr val="D5DAE3"/>
@@ -6838,12 +6773,304 @@
                             <a:schemeClr val="tx2"/>
                           </a:solidFill>
                         </a:rPr>
-                        <a:t>v2 weekly</a:t>
+                        <a:t>$164,406</a:t>
                       </a:r>
                       <a:endParaRPr lang="en-US" sz="1400" dirty="0"/>
                     </a:p>
                   </a:txBody>
-                  <a:tcPr marL="91440" marR="91440" marT="45720" marB="45720" anchor="ctr">
+                  <a:tcPr marL="91440" marR="91440" marT="36576" marB="36576" anchor="ctr">
+                    <a:lnL w="9525" cap="flat" cmpd="sng" algn="ctr">
+                      <a:solidFill>
+                        <a:srgbClr val="D5DAE3"/>
+                      </a:solidFill>
+                      <a:prstDash val="solid"/>
+                      <a:round/>
+                      <a:headEnd type="none" w="med" len="med"/>
+                      <a:tailEnd type="none" w="med" len="med"/>
+                    </a:lnL>
+                    <a:lnR w="9525" cap="flat" cmpd="sng" algn="ctr">
+                      <a:solidFill>
+                        <a:srgbClr val="D5DAE3"/>
+                      </a:solidFill>
+                      <a:prstDash val="solid"/>
+                      <a:round/>
+                      <a:headEnd type="none" w="med" len="med"/>
+                      <a:tailEnd type="none" w="med" len="med"/>
+                    </a:lnR>
+                    <a:lnT w="9525" cap="flat" cmpd="sng" algn="ctr">
+                      <a:solidFill>
+                        <a:srgbClr val="D5DAE3"/>
+                      </a:solidFill>
+                      <a:prstDash val="solid"/>
+                      <a:round/>
+                      <a:headEnd type="none" w="med" len="med"/>
+                      <a:tailEnd type="none" w="med" len="med"/>
+                    </a:lnT>
+                    <a:lnB w="9525" cap="flat" cmpd="sng" algn="ctr">
+                      <a:solidFill>
+                        <a:srgbClr val="D5DAE3"/>
+                      </a:solidFill>
+                      <a:prstDash val="solid"/>
+                      <a:round/>
+                      <a:headEnd type="none" w="med" len="med"/>
+                      <a:tailEnd type="none" w="med" len="med"/>
+                    </a:lnB>
+                  </a:tcPr>
+                </a:tc>
+                <a:tc>
+                  <a:txBody>
+                    <a:bodyPr/>
+                    <a:lstStyle/>
+                    <a:p>
+                      <a:pPr indent="0" marL="0">
+                        <a:buNone/>
+                      </a:pPr>
+                      <a:r>
+                        <a:rPr lang="en-US" sz="1400" dirty="0">
+                          <a:solidFill>
+                            <a:schemeClr val="tx2"/>
+                          </a:solidFill>
+                        </a:rPr>
+                        <a:t>4.2%</a:t>
+                      </a:r>
+                      <a:endParaRPr lang="en-US" sz="1400" dirty="0"/>
+                    </a:p>
+                  </a:txBody>
+                  <a:tcPr marL="91440" marR="91440" marT="36576" marB="36576" anchor="ctr">
+                    <a:lnL w="9525" cap="flat" cmpd="sng" algn="ctr">
+                      <a:solidFill>
+                        <a:srgbClr val="D5DAE3"/>
+                      </a:solidFill>
+                      <a:prstDash val="solid"/>
+                      <a:round/>
+                      <a:headEnd type="none" w="med" len="med"/>
+                      <a:tailEnd type="none" w="med" len="med"/>
+                    </a:lnL>
+                    <a:lnR w="9525" cap="flat" cmpd="sng" algn="ctr">
+                      <a:solidFill>
+                        <a:srgbClr val="D5DAE3"/>
+                      </a:solidFill>
+                      <a:prstDash val="solid"/>
+                      <a:round/>
+                      <a:headEnd type="none" w="med" len="med"/>
+                      <a:tailEnd type="none" w="med" len="med"/>
+                    </a:lnR>
+                    <a:lnT w="9525" cap="flat" cmpd="sng" algn="ctr">
+                      <a:solidFill>
+                        <a:srgbClr val="D5DAE3"/>
+                      </a:solidFill>
+                      <a:prstDash val="solid"/>
+                      <a:round/>
+                      <a:headEnd type="none" w="med" len="med"/>
+                      <a:tailEnd type="none" w="med" len="med"/>
+                    </a:lnT>
+                    <a:lnB w="9525" cap="flat" cmpd="sng" algn="ctr">
+                      <a:solidFill>
+                        <a:srgbClr val="D5DAE3"/>
+                      </a:solidFill>
+                      <a:prstDash val="solid"/>
+                      <a:round/>
+                      <a:headEnd type="none" w="med" len="med"/>
+                      <a:tailEnd type="none" w="med" len="med"/>
+                    </a:lnB>
+                  </a:tcPr>
+                </a:tc>
+                <a:tc>
+                  <a:txBody>
+                    <a:bodyPr/>
+                    <a:lstStyle/>
+                    <a:p>
+                      <a:pPr indent="0" marL="0">
+                        <a:buNone/>
+                      </a:pPr>
+                      <a:r>
+                        <a:rPr lang="en-US" sz="1400" dirty="0">
+                          <a:solidFill>
+                            <a:schemeClr val="tx2"/>
+                          </a:solidFill>
+                        </a:rPr>
+                        <a:t>-23.9%</a:t>
+                      </a:r>
+                      <a:endParaRPr lang="en-US" sz="1400" dirty="0"/>
+                    </a:p>
+                  </a:txBody>
+                  <a:tcPr marL="91440" marR="91440" marT="36576" marB="36576" anchor="ctr">
+                    <a:lnL w="9525" cap="flat" cmpd="sng" algn="ctr">
+                      <a:solidFill>
+                        <a:srgbClr val="D5DAE3"/>
+                      </a:solidFill>
+                      <a:prstDash val="solid"/>
+                      <a:round/>
+                      <a:headEnd type="none" w="med" len="med"/>
+                      <a:tailEnd type="none" w="med" len="med"/>
+                    </a:lnL>
+                    <a:lnR w="9525" cap="flat" cmpd="sng" algn="ctr">
+                      <a:solidFill>
+                        <a:srgbClr val="D5DAE3"/>
+                      </a:solidFill>
+                      <a:prstDash val="solid"/>
+                      <a:round/>
+                      <a:headEnd type="none" w="med" len="med"/>
+                      <a:tailEnd type="none" w="med" len="med"/>
+                    </a:lnR>
+                    <a:lnT w="9525" cap="flat" cmpd="sng" algn="ctr">
+                      <a:solidFill>
+                        <a:srgbClr val="D5DAE3"/>
+                      </a:solidFill>
+                      <a:prstDash val="solid"/>
+                      <a:round/>
+                      <a:headEnd type="none" w="med" len="med"/>
+                      <a:tailEnd type="none" w="med" len="med"/>
+                    </a:lnT>
+                    <a:lnB w="9525" cap="flat" cmpd="sng" algn="ctr">
+                      <a:solidFill>
+                        <a:srgbClr val="D5DAE3"/>
+                      </a:solidFill>
+                      <a:prstDash val="solid"/>
+                      <a:round/>
+                      <a:headEnd type="none" w="med" len="med"/>
+                      <a:tailEnd type="none" w="med" len="med"/>
+                    </a:lnB>
+                  </a:tcPr>
+                </a:tc>
+                <a:tc>
+                  <a:txBody>
+                    <a:bodyPr/>
+                    <a:lstStyle/>
+                    <a:p>
+                      <a:pPr indent="0" marL="0">
+                        <a:buNone/>
+                      </a:pPr>
+                      <a:r>
+                        <a:rPr lang="en-US" sz="1400" dirty="0">
+                          <a:solidFill>
+                            <a:schemeClr val="tx2"/>
+                          </a:solidFill>
+                        </a:rPr>
+                        <a:t>0.28</a:t>
+                      </a:r>
+                      <a:endParaRPr lang="en-US" sz="1400" dirty="0"/>
+                    </a:p>
+                  </a:txBody>
+                  <a:tcPr marL="91440" marR="91440" marT="36576" marB="36576" anchor="ctr">
+                    <a:lnL w="9525" cap="flat" cmpd="sng" algn="ctr">
+                      <a:solidFill>
+                        <a:srgbClr val="D5DAE3"/>
+                      </a:solidFill>
+                      <a:prstDash val="solid"/>
+                      <a:round/>
+                      <a:headEnd type="none" w="med" len="med"/>
+                      <a:tailEnd type="none" w="med" len="med"/>
+                    </a:lnL>
+                    <a:lnR w="9525" cap="flat" cmpd="sng" algn="ctr">
+                      <a:solidFill>
+                        <a:srgbClr val="D5DAE3"/>
+                      </a:solidFill>
+                      <a:prstDash val="solid"/>
+                      <a:round/>
+                      <a:headEnd type="none" w="med" len="med"/>
+                      <a:tailEnd type="none" w="med" len="med"/>
+                    </a:lnR>
+                    <a:lnT w="9525" cap="flat" cmpd="sng" algn="ctr">
+                      <a:solidFill>
+                        <a:srgbClr val="D5DAE3"/>
+                      </a:solidFill>
+                      <a:prstDash val="solid"/>
+                      <a:round/>
+                      <a:headEnd type="none" w="med" len="med"/>
+                      <a:tailEnd type="none" w="med" len="med"/>
+                    </a:lnT>
+                    <a:lnB w="9525" cap="flat" cmpd="sng" algn="ctr">
+                      <a:solidFill>
+                        <a:srgbClr val="D5DAE3"/>
+                      </a:solidFill>
+                      <a:prstDash val="solid"/>
+                      <a:round/>
+                      <a:headEnd type="none" w="med" len="med"/>
+                      <a:tailEnd type="none" w="med" len="med"/>
+                    </a:lnB>
+                  </a:tcPr>
+                </a:tc>
+                <a:tc>
+                  <a:txBody>
+                    <a:bodyPr/>
+                    <a:lstStyle/>
+                    <a:p>
+                      <a:pPr indent="0" marL="0">
+                        <a:buNone/>
+                      </a:pPr>
+                      <a:r>
+                        <a:rPr lang="en-US" sz="1400" dirty="0">
+                          <a:solidFill>
+                            <a:schemeClr val="tx2"/>
+                          </a:solidFill>
+                        </a:rPr>
+                        <a:t>62%</a:t>
+                      </a:r>
+                      <a:endParaRPr lang="en-US" sz="1400" dirty="0"/>
+                    </a:p>
+                  </a:txBody>
+                  <a:tcPr marL="91440" marR="91440" marT="36576" marB="36576" anchor="ctr">
+                    <a:lnL w="9525" cap="flat" cmpd="sng" algn="ctr">
+                      <a:solidFill>
+                        <a:srgbClr val="D5DAE3"/>
+                      </a:solidFill>
+                      <a:prstDash val="solid"/>
+                      <a:round/>
+                      <a:headEnd type="none" w="med" len="med"/>
+                      <a:tailEnd type="none" w="med" len="med"/>
+                    </a:lnL>
+                    <a:lnR w="9525" cap="flat" cmpd="sng" algn="ctr">
+                      <a:solidFill>
+                        <a:srgbClr val="D5DAE3"/>
+                      </a:solidFill>
+                      <a:prstDash val="solid"/>
+                      <a:round/>
+                      <a:headEnd type="none" w="med" len="med"/>
+                      <a:tailEnd type="none" w="med" len="med"/>
+                    </a:lnR>
+                    <a:lnT w="9525" cap="flat" cmpd="sng" algn="ctr">
+                      <a:solidFill>
+                        <a:srgbClr val="D5DAE3"/>
+                      </a:solidFill>
+                      <a:prstDash val="solid"/>
+                      <a:round/>
+                      <a:headEnd type="none" w="med" len="med"/>
+                      <a:tailEnd type="none" w="med" len="med"/>
+                    </a:lnT>
+                    <a:lnB w="9525" cap="flat" cmpd="sng" algn="ctr">
+                      <a:solidFill>
+                        <a:srgbClr val="D5DAE3"/>
+                      </a:solidFill>
+                      <a:prstDash val="solid"/>
+                      <a:round/>
+                      <a:headEnd type="none" w="med" len="med"/>
+                      <a:tailEnd type="none" w="med" len="med"/>
+                    </a:lnB>
+                  </a:tcPr>
+                </a:tc>
+              </a:tr>
+              <a:tr h="411480">
+                <a:tc>
+                  <a:txBody>
+                    <a:bodyPr/>
+                    <a:lstStyle/>
+                    <a:p>
+                      <a:pPr indent="0" marL="0">
+                        <a:buNone/>
+                      </a:pPr>
+                      <a:r>
+                        <a:rPr lang="en-US" sz="1400" dirty="0">
+                          <a:solidFill>
+                            <a:schemeClr val="tx2"/>
+                          </a:solidFill>
+                        </a:rPr>
+                        <a:t>v2 · logistic regression</a:t>
+                      </a:r>
+                      <a:endParaRPr lang="en-US" sz="1400" dirty="0"/>
+                    </a:p>
+                  </a:txBody>
+                  <a:tcPr marL="91440" marR="91440" marT="36576" marB="36576" anchor="ctr">
                     <a:lnL w="9525" cap="flat" cmpd="sng" algn="ctr">
                       <a:solidFill>
                         <a:srgbClr val="D5DAE3"/>
@@ -6901,7 +7128,7 @@
                       <a:endParaRPr lang="en-US" sz="1400" dirty="0"/>
                     </a:p>
                   </a:txBody>
-                  <a:tcPr marL="91440" marR="91440" marT="45720" marB="45720" anchor="ctr">
+                  <a:tcPr marL="91440" marR="91440" marT="36576" marB="36576" anchor="ctr">
                     <a:lnL w="9525" cap="flat" cmpd="sng" algn="ctr">
                       <a:solidFill>
                         <a:srgbClr val="D5DAE3"/>
@@ -6959,7 +7186,7 @@
                       <a:endParaRPr lang="en-US" sz="1400" dirty="0"/>
                     </a:p>
                   </a:txBody>
-                  <a:tcPr marL="91440" marR="91440" marT="45720" marB="45720" anchor="ctr">
+                  <a:tcPr marL="91440" marR="91440" marT="36576" marB="36576" anchor="ctr">
                     <a:lnL w="9525" cap="flat" cmpd="sng" algn="ctr">
                       <a:solidFill>
                         <a:srgbClr val="D5DAE3"/>
@@ -7017,7 +7244,7 @@
                       <a:endParaRPr lang="en-US" sz="1400" dirty="0"/>
                     </a:p>
                   </a:txBody>
-                  <a:tcPr marL="91440" marR="91440" marT="45720" marB="45720" anchor="ctr">
+                  <a:tcPr marL="91440" marR="91440" marT="36576" marB="36576" anchor="ctr">
                     <a:lnL w="9525" cap="flat" cmpd="sng" algn="ctr">
                       <a:solidFill>
                         <a:srgbClr val="D5DAE3"/>
@@ -7075,7 +7302,7 @@
                       <a:endParaRPr lang="en-US" sz="1400" dirty="0"/>
                     </a:p>
                   </a:txBody>
-                  <a:tcPr marL="91440" marR="91440" marT="45720" marB="45720" anchor="ctr">
+                  <a:tcPr marL="91440" marR="91440" marT="36576" marB="36576" anchor="ctr">
                     <a:lnL w="9525" cap="flat" cmpd="sng" algn="ctr">
                       <a:solidFill>
                         <a:srgbClr val="D5DAE3"/>
@@ -7133,7 +7360,7 @@
                       <a:endParaRPr lang="en-US" sz="1400" dirty="0"/>
                     </a:p>
                   </a:txBody>
-                  <a:tcPr marL="91440" marR="91440" marT="45720" marB="45720" anchor="ctr">
+                  <a:tcPr marL="91440" marR="91440" marT="36576" marB="36576" anchor="ctr">
                     <a:lnL w="9525" cap="flat" cmpd="sng" algn="ctr">
                       <a:solidFill>
                         <a:srgbClr val="D5DAE3"/>
@@ -7173,57 +7400,7 @@
                   </a:tcPr>
                 </a:tc>
               </a:tr>
-              <a:tr h="475488">
-                <a:tc>
-                  <a:txBody>
-                    <a:bodyPr/>
-                    <a:lstStyle/>
-                    <a:p>
-                      <a:pPr indent="0" marL="0">
-                        <a:buNone/>
-                      </a:pPr>
-                      <a:endParaRPr lang="en-US" sz="1400" dirty="0"/>
-                    </a:p>
-                  </a:txBody>
-                  <a:tcPr marL="91440" marR="91440" marT="45720" marB="45720" anchor="ctr">
-                    <a:lnL w="9525" cap="flat" cmpd="sng" algn="ctr">
-                      <a:solidFill>
-                        <a:srgbClr val="D5DAE3"/>
-                      </a:solidFill>
-                      <a:prstDash val="solid"/>
-                      <a:round/>
-                      <a:headEnd type="none" w="med" len="med"/>
-                      <a:tailEnd type="none" w="med" len="med"/>
-                    </a:lnL>
-                    <a:lnR w="9525" cap="flat" cmpd="sng" algn="ctr">
-                      <a:solidFill>
-                        <a:srgbClr val="D5DAE3"/>
-                      </a:solidFill>
-                      <a:prstDash val="solid"/>
-                      <a:round/>
-                      <a:headEnd type="none" w="med" len="med"/>
-                      <a:tailEnd type="none" w="med" len="med"/>
-                    </a:lnR>
-                    <a:lnT w="9525" cap="flat" cmpd="sng" algn="ctr">
-                      <a:solidFill>
-                        <a:srgbClr val="D5DAE3"/>
-                      </a:solidFill>
-                      <a:prstDash val="solid"/>
-                      <a:round/>
-                      <a:headEnd type="none" w="med" len="med"/>
-                      <a:tailEnd type="none" w="med" len="med"/>
-                    </a:lnT>
-                    <a:lnB w="9525" cap="flat" cmpd="sng" algn="ctr">
-                      <a:solidFill>
-                        <a:srgbClr val="D5DAE3"/>
-                      </a:solidFill>
-                      <a:prstDash val="solid"/>
-                      <a:round/>
-                      <a:headEnd type="none" w="med" len="med"/>
-                      <a:tailEnd type="none" w="med" len="med"/>
-                    </a:lnB>
-                  </a:tcPr>
-                </a:tc>
+              <a:tr h="411480">
                 <a:tc>
                   <a:txBody>
                     <a:bodyPr/>
@@ -7238,12 +7415,12 @@
                             <a:schemeClr val="tx2"/>
                           </a:solidFill>
                         </a:rPr>
-                        <a:t>v3 weekly</a:t>
+                        <a:t>v3 · never sells — identical to buy-and-hold</a:t>
                       </a:r>
                       <a:endParaRPr lang="en-US" sz="1400" dirty="0"/>
                     </a:p>
                   </a:txBody>
-                  <a:tcPr marL="91440" marR="91440" marT="45720" marB="45720" anchor="ctr">
+                  <a:tcPr marL="91440" marR="91440" marT="36576" marB="36576" anchor="ctr">
                     <a:lnL w="9525" cap="flat" cmpd="sng" algn="ctr">
                       <a:solidFill>
                         <a:srgbClr val="D5DAE3"/>
@@ -7290,18 +7467,10 @@
                       <a:pPr indent="0" marL="0">
                         <a:buNone/>
                       </a:pPr>
-                      <a:r>
-                        <a:rPr lang="en-US" sz="1400" dirty="0">
-                          <a:solidFill>
-                            <a:schemeClr val="tx2"/>
-                          </a:solidFill>
-                        </a:rPr>
-                        <a:t>$499,271</a:t>
-                      </a:r>
                       <a:endParaRPr lang="en-US" sz="1400" dirty="0"/>
                     </a:p>
                   </a:txBody>
-                  <a:tcPr marL="91440" marR="91440" marT="45720" marB="45720" anchor="ctr">
+                  <a:tcPr marL="91440" marR="91440" marT="36576" marB="36576" anchor="ctr">
                     <a:lnL w="9525" cap="flat" cmpd="sng" algn="ctr">
                       <a:solidFill>
                         <a:srgbClr val="D5DAE3"/>
@@ -7348,18 +7517,10 @@
                       <a:pPr indent="0" marL="0">
                         <a:buNone/>
                       </a:pPr>
-                      <a:r>
-                        <a:rPr lang="en-US" sz="1400" dirty="0">
-                          <a:solidFill>
-                            <a:schemeClr val="tx2"/>
-                          </a:solidFill>
-                        </a:rPr>
-                        <a:t>14.4%</a:t>
-                      </a:r>
                       <a:endParaRPr lang="en-US" sz="1400" dirty="0"/>
                     </a:p>
                   </a:txBody>
-                  <a:tcPr marL="91440" marR="91440" marT="45720" marB="45720" anchor="ctr">
+                  <a:tcPr marL="91440" marR="91440" marT="36576" marB="36576" anchor="ctr">
                     <a:lnL w="9525" cap="flat" cmpd="sng" algn="ctr">
                       <a:solidFill>
                         <a:srgbClr val="D5DAE3"/>
@@ -7406,18 +7567,10 @@
                       <a:pPr indent="0" marL="0">
                         <a:buNone/>
                       </a:pPr>
-                      <a:r>
-                        <a:rPr lang="en-US" sz="1400" dirty="0">
-                          <a:solidFill>
-                            <a:schemeClr val="tx2"/>
-                          </a:solidFill>
-                        </a:rPr>
-                        <a:t>-33.7%</a:t>
-                      </a:r>
                       <a:endParaRPr lang="en-US" sz="1400" dirty="0"/>
                     </a:p>
                   </a:txBody>
-                  <a:tcPr marL="91440" marR="91440" marT="45720" marB="45720" anchor="ctr">
+                  <a:tcPr marL="91440" marR="91440" marT="36576" marB="36576" anchor="ctr">
                     <a:lnL w="9525" cap="flat" cmpd="sng" algn="ctr">
                       <a:solidFill>
                         <a:srgbClr val="D5DAE3"/>
@@ -7464,18 +7617,10 @@
                       <a:pPr indent="0" marL="0">
                         <a:buNone/>
                       </a:pPr>
-                      <a:r>
-                        <a:rPr lang="en-US" sz="1400" dirty="0">
-                          <a:solidFill>
-                            <a:schemeClr val="tx2"/>
-                          </a:solidFill>
-                        </a:rPr>
-                        <a:t>0.80</a:t>
-                      </a:r>
                       <a:endParaRPr lang="en-US" sz="1400" dirty="0"/>
                     </a:p>
                   </a:txBody>
-                  <a:tcPr marL="91440" marR="91440" marT="45720" marB="45720" anchor="ctr">
+                  <a:tcPr marL="91440" marR="91440" marT="36576" marB="36576" anchor="ctr">
                     <a:lnL w="9525" cap="flat" cmpd="sng" algn="ctr">
                       <a:solidFill>
                         <a:srgbClr val="D5DAE3"/>
@@ -7522,426 +7667,10 @@
                       <a:pPr indent="0" marL="0">
                         <a:buNone/>
                       </a:pPr>
-                      <a:r>
-                        <a:rPr lang="en-US" sz="1400" dirty="0">
-                          <a:solidFill>
-                            <a:schemeClr val="tx2"/>
-                          </a:solidFill>
-                        </a:rPr>
-                        <a:t>100%</a:t>
-                      </a:r>
                       <a:endParaRPr lang="en-US" sz="1400" dirty="0"/>
                     </a:p>
                   </a:txBody>
-                  <a:tcPr marL="91440" marR="91440" marT="45720" marB="45720" anchor="ctr">
-                    <a:lnL w="9525" cap="flat" cmpd="sng" algn="ctr">
-                      <a:solidFill>
-                        <a:srgbClr val="D5DAE3"/>
-                      </a:solidFill>
-                      <a:prstDash val="solid"/>
-                      <a:round/>
-                      <a:headEnd type="none" w="med" len="med"/>
-                      <a:tailEnd type="none" w="med" len="med"/>
-                    </a:lnL>
-                    <a:lnR w="9525" cap="flat" cmpd="sng" algn="ctr">
-                      <a:solidFill>
-                        <a:srgbClr val="D5DAE3"/>
-                      </a:solidFill>
-                      <a:prstDash val="solid"/>
-                      <a:round/>
-                      <a:headEnd type="none" w="med" len="med"/>
-                      <a:tailEnd type="none" w="med" len="med"/>
-                    </a:lnR>
-                    <a:lnT w="9525" cap="flat" cmpd="sng" algn="ctr">
-                      <a:solidFill>
-                        <a:srgbClr val="D5DAE3"/>
-                      </a:solidFill>
-                      <a:prstDash val="solid"/>
-                      <a:round/>
-                      <a:headEnd type="none" w="med" len="med"/>
-                      <a:tailEnd type="none" w="med" len="med"/>
-                    </a:lnT>
-                    <a:lnB w="9525" cap="flat" cmpd="sng" algn="ctr">
-                      <a:solidFill>
-                        <a:srgbClr val="D5DAE3"/>
-                      </a:solidFill>
-                      <a:prstDash val="solid"/>
-                      <a:round/>
-                      <a:headEnd type="none" w="med" len="med"/>
-                      <a:tailEnd type="none" w="med" len="med"/>
-                    </a:lnB>
-                  </a:tcPr>
-                </a:tc>
-              </a:tr>
-              <a:tr h="475488">
-                <a:tc>
-                  <a:txBody>
-                    <a:bodyPr/>
-                    <a:lstStyle/>
-                    <a:p>
-                      <a:pPr indent="0" marL="0">
-                        <a:buNone/>
-                      </a:pPr>
-                      <a:r>
-                        <a:rPr lang="en-US" sz="1400" dirty="0">
-                          <a:solidFill>
-                            <a:schemeClr val="tx2"/>
-                          </a:solidFill>
-                        </a:rPr>
-                        <a:t>2025–26 holdout</a:t>
-                      </a:r>
-                      <a:endParaRPr lang="en-US" sz="1400" dirty="0"/>
-                    </a:p>
-                  </a:txBody>
-                  <a:tcPr marL="91440" marR="91440" marT="45720" marB="45720" anchor="ctr">
-                    <a:lnL w="9525" cap="flat" cmpd="sng" algn="ctr">
-                      <a:solidFill>
-                        <a:srgbClr val="D5DAE3"/>
-                      </a:solidFill>
-                      <a:prstDash val="solid"/>
-                      <a:round/>
-                      <a:headEnd type="none" w="med" len="med"/>
-                      <a:tailEnd type="none" w="med" len="med"/>
-                    </a:lnL>
-                    <a:lnR w="9525" cap="flat" cmpd="sng" algn="ctr">
-                      <a:solidFill>
-                        <a:srgbClr val="D5DAE3"/>
-                      </a:solidFill>
-                      <a:prstDash val="solid"/>
-                      <a:round/>
-                      <a:headEnd type="none" w="med" len="med"/>
-                      <a:tailEnd type="none" w="med" len="med"/>
-                    </a:lnR>
-                    <a:lnT w="9525" cap="flat" cmpd="sng" algn="ctr">
-                      <a:solidFill>
-                        <a:srgbClr val="D5DAE3"/>
-                      </a:solidFill>
-                      <a:prstDash val="solid"/>
-                      <a:round/>
-                      <a:headEnd type="none" w="med" len="med"/>
-                      <a:tailEnd type="none" w="med" len="med"/>
-                    </a:lnT>
-                    <a:lnB w="9525" cap="flat" cmpd="sng" algn="ctr">
-                      <a:solidFill>
-                        <a:srgbClr val="D5DAE3"/>
-                      </a:solidFill>
-                      <a:prstDash val="solid"/>
-                      <a:round/>
-                      <a:headEnd type="none" w="med" len="med"/>
-                      <a:tailEnd type="none" w="med" len="med"/>
-                    </a:lnB>
-                  </a:tcPr>
-                </a:tc>
-                <a:tc>
-                  <a:txBody>
-                    <a:bodyPr/>
-                    <a:lstStyle/>
-                    <a:p>
-                      <a:pPr indent="0" marL="0">
-                        <a:buNone/>
-                      </a:pPr>
-                      <a:r>
-                        <a:rPr lang="en-US" sz="1400" dirty="0">
-                          <a:solidFill>
-                            <a:schemeClr val="tx2"/>
-                          </a:solidFill>
-                        </a:rPr>
-                        <a:t>Buy &amp; Hold = v3 weekly</a:t>
-                      </a:r>
-                      <a:endParaRPr lang="en-US" sz="1400" dirty="0"/>
-                    </a:p>
-                  </a:txBody>
-                  <a:tcPr marL="91440" marR="91440" marT="45720" marB="45720" anchor="ctr">
-                    <a:lnL w="9525" cap="flat" cmpd="sng" algn="ctr">
-                      <a:solidFill>
-                        <a:srgbClr val="D5DAE3"/>
-                      </a:solidFill>
-                      <a:prstDash val="solid"/>
-                      <a:round/>
-                      <a:headEnd type="none" w="med" len="med"/>
-                      <a:tailEnd type="none" w="med" len="med"/>
-                    </a:lnL>
-                    <a:lnR w="9525" cap="flat" cmpd="sng" algn="ctr">
-                      <a:solidFill>
-                        <a:srgbClr val="D5DAE3"/>
-                      </a:solidFill>
-                      <a:prstDash val="solid"/>
-                      <a:round/>
-                      <a:headEnd type="none" w="med" len="med"/>
-                      <a:tailEnd type="none" w="med" len="med"/>
-                    </a:lnR>
-                    <a:lnT w="9525" cap="flat" cmpd="sng" algn="ctr">
-                      <a:solidFill>
-                        <a:srgbClr val="D5DAE3"/>
-                      </a:solidFill>
-                      <a:prstDash val="solid"/>
-                      <a:round/>
-                      <a:headEnd type="none" w="med" len="med"/>
-                      <a:tailEnd type="none" w="med" len="med"/>
-                    </a:lnT>
-                    <a:lnB w="9525" cap="flat" cmpd="sng" algn="ctr">
-                      <a:solidFill>
-                        <a:srgbClr val="D5DAE3"/>
-                      </a:solidFill>
-                      <a:prstDash val="solid"/>
-                      <a:round/>
-                      <a:headEnd type="none" w="med" len="med"/>
-                      <a:tailEnd type="none" w="med" len="med"/>
-                    </a:lnB>
-                  </a:tcPr>
-                </a:tc>
-                <a:tc>
-                  <a:txBody>
-                    <a:bodyPr/>
-                    <a:lstStyle/>
-                    <a:p>
-                      <a:pPr indent="0" marL="0">
-                        <a:buNone/>
-                      </a:pPr>
-                      <a:r>
-                        <a:rPr lang="en-US" sz="1400" dirty="0">
-                          <a:solidFill>
-                            <a:schemeClr val="tx2"/>
-                          </a:solidFill>
-                        </a:rPr>
-                        <a:t>$134,410</a:t>
-                      </a:r>
-                      <a:endParaRPr lang="en-US" sz="1400" dirty="0"/>
-                    </a:p>
-                  </a:txBody>
-                  <a:tcPr marL="91440" marR="91440" marT="45720" marB="45720" anchor="ctr">
-                    <a:lnL w="9525" cap="flat" cmpd="sng" algn="ctr">
-                      <a:solidFill>
-                        <a:srgbClr val="D5DAE3"/>
-                      </a:solidFill>
-                      <a:prstDash val="solid"/>
-                      <a:round/>
-                      <a:headEnd type="none" w="med" len="med"/>
-                      <a:tailEnd type="none" w="med" len="med"/>
-                    </a:lnL>
-                    <a:lnR w="9525" cap="flat" cmpd="sng" algn="ctr">
-                      <a:solidFill>
-                        <a:srgbClr val="D5DAE3"/>
-                      </a:solidFill>
-                      <a:prstDash val="solid"/>
-                      <a:round/>
-                      <a:headEnd type="none" w="med" len="med"/>
-                      <a:tailEnd type="none" w="med" len="med"/>
-                    </a:lnR>
-                    <a:lnT w="9525" cap="flat" cmpd="sng" algn="ctr">
-                      <a:solidFill>
-                        <a:srgbClr val="D5DAE3"/>
-                      </a:solidFill>
-                      <a:prstDash val="solid"/>
-                      <a:round/>
-                      <a:headEnd type="none" w="med" len="med"/>
-                      <a:tailEnd type="none" w="med" len="med"/>
-                    </a:lnT>
-                    <a:lnB w="9525" cap="flat" cmpd="sng" algn="ctr">
-                      <a:solidFill>
-                        <a:srgbClr val="D5DAE3"/>
-                      </a:solidFill>
-                      <a:prstDash val="solid"/>
-                      <a:round/>
-                      <a:headEnd type="none" w="med" len="med"/>
-                      <a:tailEnd type="none" w="med" len="med"/>
-                    </a:lnB>
-                  </a:tcPr>
-                </a:tc>
-                <a:tc>
-                  <a:txBody>
-                    <a:bodyPr/>
-                    <a:lstStyle/>
-                    <a:p>
-                      <a:pPr indent="0" marL="0">
-                        <a:buNone/>
-                      </a:pPr>
-                      <a:r>
-                        <a:rPr lang="en-US" sz="1400" dirty="0">
-                          <a:solidFill>
-                            <a:schemeClr val="tx2"/>
-                          </a:solidFill>
-                        </a:rPr>
-                        <a:t>18.2%</a:t>
-                      </a:r>
-                      <a:endParaRPr lang="en-US" sz="1400" dirty="0"/>
-                    </a:p>
-                  </a:txBody>
-                  <a:tcPr marL="91440" marR="91440" marT="45720" marB="45720" anchor="ctr">
-                    <a:lnL w="9525" cap="flat" cmpd="sng" algn="ctr">
-                      <a:solidFill>
-                        <a:srgbClr val="D5DAE3"/>
-                      </a:solidFill>
-                      <a:prstDash val="solid"/>
-                      <a:round/>
-                      <a:headEnd type="none" w="med" len="med"/>
-                      <a:tailEnd type="none" w="med" len="med"/>
-                    </a:lnL>
-                    <a:lnR w="9525" cap="flat" cmpd="sng" algn="ctr">
-                      <a:solidFill>
-                        <a:srgbClr val="D5DAE3"/>
-                      </a:solidFill>
-                      <a:prstDash val="solid"/>
-                      <a:round/>
-                      <a:headEnd type="none" w="med" len="med"/>
-                      <a:tailEnd type="none" w="med" len="med"/>
-                    </a:lnR>
-                    <a:lnT w="9525" cap="flat" cmpd="sng" algn="ctr">
-                      <a:solidFill>
-                        <a:srgbClr val="D5DAE3"/>
-                      </a:solidFill>
-                      <a:prstDash val="solid"/>
-                      <a:round/>
-                      <a:headEnd type="none" w="med" len="med"/>
-                      <a:tailEnd type="none" w="med" len="med"/>
-                    </a:lnT>
-                    <a:lnB w="9525" cap="flat" cmpd="sng" algn="ctr">
-                      <a:solidFill>
-                        <a:srgbClr val="D5DAE3"/>
-                      </a:solidFill>
-                      <a:prstDash val="solid"/>
-                      <a:round/>
-                      <a:headEnd type="none" w="med" len="med"/>
-                      <a:tailEnd type="none" w="med" len="med"/>
-                    </a:lnB>
-                  </a:tcPr>
-                </a:tc>
-                <a:tc>
-                  <a:txBody>
-                    <a:bodyPr/>
-                    <a:lstStyle/>
-                    <a:p>
-                      <a:pPr indent="0" marL="0">
-                        <a:buNone/>
-                      </a:pPr>
-                      <a:r>
-                        <a:rPr lang="en-US" sz="1400" dirty="0">
-                          <a:solidFill>
-                            <a:schemeClr val="tx2"/>
-                          </a:solidFill>
-                        </a:rPr>
-                        <a:t>-18.8%</a:t>
-                      </a:r>
-                      <a:endParaRPr lang="en-US" sz="1400" dirty="0"/>
-                    </a:p>
-                  </a:txBody>
-                  <a:tcPr marL="91440" marR="91440" marT="45720" marB="45720" anchor="ctr">
-                    <a:lnL w="9525" cap="flat" cmpd="sng" algn="ctr">
-                      <a:solidFill>
-                        <a:srgbClr val="D5DAE3"/>
-                      </a:solidFill>
-                      <a:prstDash val="solid"/>
-                      <a:round/>
-                      <a:headEnd type="none" w="med" len="med"/>
-                      <a:tailEnd type="none" w="med" len="med"/>
-                    </a:lnL>
-                    <a:lnR w="9525" cap="flat" cmpd="sng" algn="ctr">
-                      <a:solidFill>
-                        <a:srgbClr val="D5DAE3"/>
-                      </a:solidFill>
-                      <a:prstDash val="solid"/>
-                      <a:round/>
-                      <a:headEnd type="none" w="med" len="med"/>
-                      <a:tailEnd type="none" w="med" len="med"/>
-                    </a:lnR>
-                    <a:lnT w="9525" cap="flat" cmpd="sng" algn="ctr">
-                      <a:solidFill>
-                        <a:srgbClr val="D5DAE3"/>
-                      </a:solidFill>
-                      <a:prstDash val="solid"/>
-                      <a:round/>
-                      <a:headEnd type="none" w="med" len="med"/>
-                      <a:tailEnd type="none" w="med" len="med"/>
-                    </a:lnT>
-                    <a:lnB w="9525" cap="flat" cmpd="sng" algn="ctr">
-                      <a:solidFill>
-                        <a:srgbClr val="D5DAE3"/>
-                      </a:solidFill>
-                      <a:prstDash val="solid"/>
-                      <a:round/>
-                      <a:headEnd type="none" w="med" len="med"/>
-                      <a:tailEnd type="none" w="med" len="med"/>
-                    </a:lnB>
-                  </a:tcPr>
-                </a:tc>
-                <a:tc>
-                  <a:txBody>
-                    <a:bodyPr/>
-                    <a:lstStyle/>
-                    <a:p>
-                      <a:pPr indent="0" marL="0">
-                        <a:buNone/>
-                      </a:pPr>
-                      <a:r>
-                        <a:rPr lang="en-US" sz="1400" dirty="0">
-                          <a:solidFill>
-                            <a:schemeClr val="tx2"/>
-                          </a:solidFill>
-                        </a:rPr>
-                        <a:t>0.84</a:t>
-                      </a:r>
-                      <a:endParaRPr lang="en-US" sz="1400" dirty="0"/>
-                    </a:p>
-                  </a:txBody>
-                  <a:tcPr marL="91440" marR="91440" marT="45720" marB="45720" anchor="ctr">
-                    <a:lnL w="9525" cap="flat" cmpd="sng" algn="ctr">
-                      <a:solidFill>
-                        <a:srgbClr val="D5DAE3"/>
-                      </a:solidFill>
-                      <a:prstDash val="solid"/>
-                      <a:round/>
-                      <a:headEnd type="none" w="med" len="med"/>
-                      <a:tailEnd type="none" w="med" len="med"/>
-                    </a:lnL>
-                    <a:lnR w="9525" cap="flat" cmpd="sng" algn="ctr">
-                      <a:solidFill>
-                        <a:srgbClr val="D5DAE3"/>
-                      </a:solidFill>
-                      <a:prstDash val="solid"/>
-                      <a:round/>
-                      <a:headEnd type="none" w="med" len="med"/>
-                      <a:tailEnd type="none" w="med" len="med"/>
-                    </a:lnR>
-                    <a:lnT w="9525" cap="flat" cmpd="sng" algn="ctr">
-                      <a:solidFill>
-                        <a:srgbClr val="D5DAE3"/>
-                      </a:solidFill>
-                      <a:prstDash val="solid"/>
-                      <a:round/>
-                      <a:headEnd type="none" w="med" len="med"/>
-                      <a:tailEnd type="none" w="med" len="med"/>
-                    </a:lnT>
-                    <a:lnB w="9525" cap="flat" cmpd="sng" algn="ctr">
-                      <a:solidFill>
-                        <a:srgbClr val="D5DAE3"/>
-                      </a:solidFill>
-                      <a:prstDash val="solid"/>
-                      <a:round/>
-                      <a:headEnd type="none" w="med" len="med"/>
-                      <a:tailEnd type="none" w="med" len="med"/>
-                    </a:lnB>
-                  </a:tcPr>
-                </a:tc>
-                <a:tc>
-                  <a:txBody>
-                    <a:bodyPr/>
-                    <a:lstStyle/>
-                    <a:p>
-                      <a:pPr indent="0" marL="0">
-                        <a:buNone/>
-                      </a:pPr>
-                      <a:r>
-                        <a:rPr lang="en-US" sz="1400" dirty="0">
-                          <a:solidFill>
-                            <a:schemeClr val="tx2"/>
-                          </a:solidFill>
-                        </a:rPr>
-                        <a:t>100%</a:t>
-                      </a:r>
-                      <a:endParaRPr lang="en-US" sz="1400" dirty="0"/>
-                    </a:p>
-                  </a:txBody>
-                  <a:tcPr marL="91440" marR="91440" marT="45720" marB="45720" anchor="ctr">
+                  <a:tcPr marL="91440" marR="91440" marT="36576" marB="36576" anchor="ctr">
                     <a:lnL w="9525" cap="flat" cmpd="sng" algn="ctr">
                       <a:solidFill>
                         <a:srgbClr val="D5DAE3"/>
@@ -7987,26 +7716,73 @@
       </p:graphicFrame>
       <p:sp>
         <p:nvSpPr>
-          <p:cNvPr id="4" name="Shape 1"/>
+          <p:cNvPr id="5" name="Text 2"/>
+          <p:cNvSpPr txBox="1"/>
+          <p:nvPr/>
+        </p:nvSpPr>
+        <p:spPr>
+          <a:xfrm>
+            <a:off x="548640" y="3931920"/>
+            <a:ext cx="11094415" cy="640080"/>
+          </a:xfrm>
+          <a:prstGeom prst="rect">
+            <a:avLst/>
+          </a:prstGeom>
+          <a:noFill/>
+          <a:ln/>
+        </p:spPr>
+        <p:txBody>
+          <a:bodyPr wrap="square" lIns="0" tIns="0" rIns="0" bIns="0" rtlCol="0" anchor="t"/>
+          <a:lstStyle/>
+          <a:p>
+            <a:pPr indent="0" marL="0">
+              <a:buNone/>
+            </a:pPr>
+            <a:r>
+              <a:rPr lang="en-US" sz="1400" b="1" dirty="0">
+                <a:solidFill>
+                  <a:schemeClr val="tx1"/>
+                </a:solidFill>
+              </a:rPr>
+              <a:t>Holdout, Jan 2025 – Oct 2026. </a:t>
+            </a:r>
+            <a:pPr indent="0" marL="0">
+              <a:buNone/>
+            </a:pPr>
+            <a:r>
+              <a:rPr lang="en-US" sz="1400" dirty="0">
+                <a:solidFill>
+                  <a:schemeClr val="tx2"/>
+                </a:solidFill>
+              </a:rPr>
+              <a:t>A later period never used for any choice. v3 never sold and matched buy-and-hold: $134,410, 18.2% a year, max drawdown -18.8%.</a:t>
+            </a:r>
+            <a:endParaRPr lang="en-US" sz="1400" dirty="0"/>
+          </a:p>
+        </p:txBody>
+      </p:sp>
+      <p:sp>
+        <p:nvSpPr>
+          <p:cNvPr id="6" name="Shape 3"/>
           <p:cNvSpPr/>
           <p:nvPr/>
         </p:nvSpPr>
         <p:spPr>
           <a:xfrm>
-            <a:off x="548640" y="4023360"/>
-            <a:ext cx="5468112" cy="1828800"/>
+            <a:off x="548640" y="4617720"/>
+            <a:ext cx="11094415" cy="1325880"/>
           </a:xfrm>
           <a:prstGeom prst="roundRect">
             <a:avLst>
-              <a:gd name="adj" fmla="val 5000"/>
+              <a:gd name="adj" fmla="val 6897"/>
             </a:avLst>
           </a:prstGeom>
           <a:solidFill>
-            <a:schemeClr val="bg2"/>
+            <a:srgbClr val="FBEDE4"/>
           </a:solidFill>
           <a:ln w="12700">
             <a:solidFill>
-              <a:schemeClr val="bg2"/>
+              <a:srgbClr val="FBEDE4"/>
             </a:solidFill>
             <a:prstDash val="solid"/>
           </a:ln>
@@ -8014,14 +7790,14 @@
       </p:sp>
       <p:sp>
         <p:nvSpPr>
-          <p:cNvPr id="5" name="Text 2"/>
+          <p:cNvPr id="7" name="Text 4"/>
           <p:cNvSpPr txBox="1"/>
           <p:nvPr/>
         </p:nvSpPr>
         <p:spPr>
           <a:xfrm>
-            <a:off x="777240" y="4206240"/>
-            <a:ext cx="5010912" cy="411480"/>
+            <a:off x="777240" y="4800600"/>
+            <a:ext cx="10637215" cy="411480"/>
           </a:xfrm>
           <a:prstGeom prst="rect">
             <a:avLst/>
@@ -8045,7 +7821,7 @@
                 <a:ea typeface="Cambria" pitchFamily="34" charset="-122"/>
                 <a:cs typeface="Cambria" pitchFamily="34" charset="-120"/>
               </a:rPr>
-              <a:t>v2: low risk, low return</a:t>
+              <a:t>Takeaway</a:t>
             </a:r>
             <a:endParaRPr lang="en-US" sz="1700" dirty="0"/>
           </a:p>
@@ -8053,14 +7829,14 @@
       </p:sp>
       <p:sp>
         <p:nvSpPr>
-          <p:cNvPr id="6" name="Text 3"/>
+          <p:cNvPr id="8" name="Text 5"/>
           <p:cNvSpPr txBox="1"/>
           <p:nvPr/>
         </p:nvSpPr>
         <p:spPr>
           <a:xfrm>
-            <a:off x="777240" y="4709160"/>
-            <a:ext cx="5010912" cy="1005840"/>
+            <a:off x="777240" y="5303520"/>
+            <a:ext cx="10637215" cy="502920"/>
           </a:xfrm>
           <a:prstGeom prst="rect">
             <a:avLst/>
@@ -8081,109 +7857,7 @@
                   <a:schemeClr val="tx2"/>
                 </a:solidFill>
               </a:rPr>
-              <a:t>Invested only 2% of the time over 12 years. Its few trades were well timed, but it earned 2.9% a year against 14.4%.</a:t>
-            </a:r>
-            <a:endParaRPr lang="en-US" sz="1400" dirty="0"/>
-          </a:p>
-        </p:txBody>
-      </p:sp>
-      <p:sp>
-        <p:nvSpPr>
-          <p:cNvPr id="7" name="Shape 4"/>
-          <p:cNvSpPr/>
-          <p:nvPr/>
-        </p:nvSpPr>
-        <p:spPr>
-          <a:xfrm>
-            <a:off x="6172200" y="4023360"/>
-            <a:ext cx="5468112" cy="1828800"/>
-          </a:xfrm>
-          <a:prstGeom prst="roundRect">
-            <a:avLst>
-              <a:gd name="adj" fmla="val 5000"/>
-            </a:avLst>
-          </a:prstGeom>
-          <a:solidFill>
-            <a:srgbClr val="FBEDE4"/>
-          </a:solidFill>
-          <a:ln w="12700">
-            <a:solidFill>
-              <a:srgbClr val="FBEDE4"/>
-            </a:solidFill>
-            <a:prstDash val="solid"/>
-          </a:ln>
-        </p:spPr>
-      </p:sp>
-      <p:sp>
-        <p:nvSpPr>
-          <p:cNvPr id="8" name="Text 5"/>
-          <p:cNvSpPr txBox="1"/>
-          <p:nvPr/>
-        </p:nvSpPr>
-        <p:spPr>
-          <a:xfrm>
-            <a:off x="6400800" y="4206240"/>
-            <a:ext cx="5010912" cy="411480"/>
-          </a:xfrm>
-          <a:prstGeom prst="rect">
-            <a:avLst/>
-          </a:prstGeom>
-          <a:noFill/>
-          <a:ln/>
-        </p:spPr>
-        <p:txBody>
-          <a:bodyPr wrap="square" lIns="0" tIns="0" rIns="0" bIns="0" rtlCol="0" anchor="ctr"/>
-          <a:lstStyle/>
-          <a:p>
-            <a:pPr indent="0" marL="0">
-              <a:buNone/>
-            </a:pPr>
-            <a:r>
-              <a:rPr lang="en-US" sz="1700" b="1" dirty="0">
-                <a:solidFill>
-                  <a:schemeClr val="tx1"/>
-                </a:solidFill>
-                <a:latin typeface="Cambria" pitchFamily="34" charset="0"/>
-                <a:ea typeface="Cambria" pitchFamily="34" charset="-122"/>
-                <a:cs typeface="Cambria" pitchFamily="34" charset="-120"/>
-              </a:rPr>
-              <a:t>v3: no trades</a:t>
-            </a:r>
-            <a:endParaRPr lang="en-US" sz="1700" dirty="0"/>
-          </a:p>
-        </p:txBody>
-      </p:sp>
-      <p:sp>
-        <p:nvSpPr>
-          <p:cNvPr id="9" name="Text 6"/>
-          <p:cNvSpPr txBox="1"/>
-          <p:nvPr/>
-        </p:nvSpPr>
-        <p:spPr>
-          <a:xfrm>
-            <a:off x="6400800" y="4709160"/>
-            <a:ext cx="5010912" cy="1005840"/>
-          </a:xfrm>
-          <a:prstGeom prst="rect">
-            <a:avLst/>
-          </a:prstGeom>
-          <a:noFill/>
-          <a:ln/>
-        </p:spPr>
-        <p:txBody>
-          <a:bodyPr wrap="square" lIns="0" tIns="0" rIns="0" bIns="0" rtlCol="0" anchor="t"/>
-          <a:lstStyle/>
-          <a:p>
-            <a:pPr indent="0" marL="0">
-              <a:buNone/>
-            </a:pPr>
-            <a:r>
-              <a:rPr lang="en-US" sz="1400" dirty="0">
-                <a:solidFill>
-                  <a:schemeClr val="tx2"/>
-                </a:solidFill>
-              </a:rPr>
-              <a:t>With calibrated probabilities, the expected loss never exceeded the cost of trading, so it held throughout every period.</a:t>
+              <a:t>Across 12 years no version beat buy-and-hold. Lower drawdowns came only from time out of the market, at a large cost in return (v1 4.2% and v2 2.9% a year vs 14.4%).</a:t>
             </a:r>
             <a:endParaRPr lang="en-US" sz="1400" dirty="0"/>
           </a:p>

</xml_diff>

<commit_message>
Final model: partial-position strategy test (0/50/100%), planned before running
Same frozen model; 50% when P(large loss) is between a and b. Development: about the same
return-vs-drawdown trade-off as all-in/out. Pick 0.30/0.40: 2013-24 $444,365 (max drawdown
-31.3%, Sharpe 0.77) vs $488,154 all-in/out and $499,271 buy-and-hold; 2023-24 and 2025-26
identical to all-in/out. Not meaningful by the pre-set test: recorded in the v4 report,
one line on the trade-off slide and a row in Appendix A.
src/v2.py: simulate_weights / summarize_weights (match simulate exactly for 0/1 weights);
src/weekly.py: weekly_weights_from_risk; 3 new tests (54 total).

Co-Authored-By: Claude Opus 5.5 <noreply@anthropic.com>
</commit_message>
<xml_diff>
--- a/presentation/SPY_Model_Presentation.pptx
+++ b/presentation/SPY_Model_Presentation.pptx
@@ -128,20 +128,20 @@
   <p:extLst>
     <p:ext uri="{521415D9-36F7-43E2-AB2F-B90AF26B5E84}">
       <p14:sectionLst xmlns:p14="http://schemas.microsoft.com/office/powerpoint/2010/main">
-        <p14:section name="Objective and approach" id="{527139b9-4d1a-2218-7a68-564e438133bf}">
+        <p14:section name="Objective and approach" id="{e2de9093-80c5-f06c-b218-146ff94a17a8}">
           <p14:sldIdLst>
             <p14:sldId id="256"/>
             <p14:sldId id="257"/>
             <p14:sldId id="258"/>
           </p14:sldIdLst>
         </p14:section>
-        <p14:section name="Exploratory analysis" id="{83a310dd-1b7c-834f-2bf2-9b70f6af0d10}">
+        <p14:section name="Exploratory analysis" id="{601ef705-805f-ce6a-93c0-9de02fa5398b}">
           <p14:sldIdLst>
             <p14:sldId id="259"/>
             <p14:sldId id="260"/>
           </p14:sldIdLst>
         </p14:section>
-        <p14:section name="Method" id="{812ec8cc-3055-99c1-fbb2-f2869116fd5a}">
+        <p14:section name="Method" id="{1a439d73-e79c-4cad-d850-228bd6cbed63}">
           <p14:sldIdLst>
             <p14:sldId id="261"/>
             <p14:sldId id="262"/>
@@ -150,14 +150,14 @@
             <p14:sldId id="265"/>
           </p14:sldIdLst>
         </p14:section>
-        <p14:section name="Results" id="{d82aa689-04c9-1467-63c8-3610bf881b2c}">
+        <p14:section name="Results" id="{a57cfb2e-a2c2-ba32-9bbb-4a3333859f06}">
           <p14:sldIdLst>
             <p14:sldId id="266"/>
             <p14:sldId id="267"/>
             <p14:sldId id="268"/>
           </p14:sldIdLst>
         </p14:section>
-        <p14:section name="Interpretation" id="{93cf5678-de24-6005-f418-80e6a9cb3529}">
+        <p14:section name="Interpretation" id="{4a643581-9137-1a72-e125-c7a62d188c85}">
           <p14:sldIdLst>
             <p14:sldId id="269"/>
             <p14:sldId id="270"/>
@@ -167,7 +167,7 @@
             <p14:sldId id="274"/>
           </p14:sldIdLst>
         </p14:section>
-        <p14:section name="Appendix" id="{90002204-aab2-1deb-c6d6-db53d5de1181}">
+        <p14:section name="Appendix" id="{57c9c267-8c7b-0b74-ebae-61ae61a02526}">
           <p14:sldIdLst>
             <p14:sldId id="275"/>
             <p14:sldId id="276"/>
@@ -16942,7 +16942,7 @@
         </p:nvSpPr>
         <p:spPr>
           <a:xfrm>
-            <a:off x="548640" y="4206240"/>
+            <a:off x="548640" y="4160520"/>
             <a:ext cx="11094415" cy="365760"/>
           </a:xfrm>
           <a:prstGeom prst="rect">
@@ -16964,7 +16964,7 @@
                   <a:schemeClr val="accent3"/>
                 </a:solidFill>
               </a:rPr>
-              <a:t>Lower-threshold variants exit more often and cut drawdown further, but give up more return.</a:t>
+              <a:t>Lower thresholds cut drawdown further but give up more return. Holding 50% in uncertain weeks (tested, planned in advance) gave about the same trade-off.</a:t>
             </a:r>
             <a:endParaRPr lang="en-US" sz="1200" dirty="0"/>
           </a:p>
@@ -18574,7 +18574,7 @@
                   <a:schemeClr val="tx2"/>
                 </a:solidFill>
               </a:rPr>
-              <a:t>• 51 automated leakage tests, run on every change</a:t>
+              <a:t>• 54 automated leakage tests, run on every change</a:t>
             </a:r>
             <a:endParaRPr lang="en-US" sz="1400" dirty="0"/>
           </a:p>
@@ -20483,7 +20483,7 @@
                   <a:schemeClr val="accent3"/>
                 </a:solidFill>
               </a:rPr>
-              <a:t>Code, data snapshots and 51 automated tests: github.com/TKCH121/spy</a:t>
+              <a:t>Code, data snapshots and 54 automated tests: github.com/TKCH121/spy</a:t>
             </a:r>
             <a:endParaRPr lang="en-US" sz="1200" dirty="0"/>
           </a:p>
@@ -20629,7 +20629,7 @@
                 <a:gridCol w="1645920"/>
                 <a:gridCol w="2130552"/>
               </a:tblGrid>
-              <a:tr h="411480">
+              <a:tr h="365760">
                 <a:tc>
                   <a:txBody>
                     <a:bodyPr/>
@@ -20936,7 +20936,7 @@
                   </a:tcPr>
                 </a:tc>
               </a:tr>
-              <a:tr h="411480">
+              <a:tr h="365760">
                 <a:tc>
                   <a:txBody>
                     <a:bodyPr/>
@@ -21228,7 +21228,7 @@
                   </a:tcPr>
                 </a:tc>
               </a:tr>
-              <a:tr h="411480">
+              <a:tr h="365760">
                 <a:tc>
                   <a:txBody>
                     <a:bodyPr/>
@@ -21520,7 +21520,7 @@
                   </a:tcPr>
                 </a:tc>
               </a:tr>
-              <a:tr h="411480">
+              <a:tr h="365760">
                 <a:tc>
                   <a:txBody>
                     <a:bodyPr/>
@@ -21812,7 +21812,7 @@
                   </a:tcPr>
                 </a:tc>
               </a:tr>
-              <a:tr h="411480">
+              <a:tr h="365760">
                 <a:tc>
                   <a:txBody>
                     <a:bodyPr/>
@@ -22104,7 +22104,7 @@
                   </a:tcPr>
                 </a:tc>
               </a:tr>
-              <a:tr h="411480">
+              <a:tr h="365760">
                 <a:tc>
                   <a:txBody>
                     <a:bodyPr/>
@@ -22396,7 +22396,299 @@
                   </a:tcPr>
                 </a:tc>
               </a:tr>
-              <a:tr h="411480">
+              <a:tr h="365760">
+                <a:tc>
+                  <a:txBody>
+                    <a:bodyPr/>
+                    <a:lstStyle/>
+                    <a:p>
+                      <a:pPr indent="0" marL="0">
+                        <a:buNone/>
+                      </a:pPr>
+                      <a:r>
+                        <a:rPr lang="en-US" sz="1300" dirty="0">
+                          <a:solidFill>
+                            <a:schemeClr val="tx2"/>
+                          </a:solidFill>
+                        </a:rPr>
+                        <a:t>Final, partial positions (0 / 50 / 100%)</a:t>
+                      </a:r>
+                      <a:endParaRPr lang="en-US" sz="1300" dirty="0"/>
+                    </a:p>
+                  </a:txBody>
+                  <a:tcPr marL="91440" marR="91440" marT="36576" marB="36576" anchor="ctr">
+                    <a:lnL w="9525" cap="flat" cmpd="sng" algn="ctr">
+                      <a:solidFill>
+                        <a:srgbClr val="D5DAE3"/>
+                      </a:solidFill>
+                      <a:prstDash val="solid"/>
+                      <a:round/>
+                      <a:headEnd type="none" w="med" len="med"/>
+                      <a:tailEnd type="none" w="med" len="med"/>
+                    </a:lnL>
+                    <a:lnR w="9525" cap="flat" cmpd="sng" algn="ctr">
+                      <a:solidFill>
+                        <a:srgbClr val="D5DAE3"/>
+                      </a:solidFill>
+                      <a:prstDash val="solid"/>
+                      <a:round/>
+                      <a:headEnd type="none" w="med" len="med"/>
+                      <a:tailEnd type="none" w="med" len="med"/>
+                    </a:lnR>
+                    <a:lnT w="9525" cap="flat" cmpd="sng" algn="ctr">
+                      <a:solidFill>
+                        <a:srgbClr val="D5DAE3"/>
+                      </a:solidFill>
+                      <a:prstDash val="solid"/>
+                      <a:round/>
+                      <a:headEnd type="none" w="med" len="med"/>
+                      <a:tailEnd type="none" w="med" len="med"/>
+                    </a:lnT>
+                    <a:lnB w="9525" cap="flat" cmpd="sng" algn="ctr">
+                      <a:solidFill>
+                        <a:srgbClr val="D5DAE3"/>
+                      </a:solidFill>
+                      <a:prstDash val="solid"/>
+                      <a:round/>
+                      <a:headEnd type="none" w="med" len="med"/>
+                      <a:tailEnd type="none" w="med" len="med"/>
+                    </a:lnB>
+                  </a:tcPr>
+                </a:tc>
+                <a:tc>
+                  <a:txBody>
+                    <a:bodyPr/>
+                    <a:lstStyle/>
+                    <a:p>
+                      <a:pPr indent="0" marL="0">
+                        <a:buNone/>
+                      </a:pPr>
+                      <a:r>
+                        <a:rPr lang="en-US" sz="1300" dirty="0">
+                          <a:solidFill>
+                            <a:schemeClr val="tx2"/>
+                          </a:solidFill>
+                        </a:rPr>
+                        <a:t>weekly</a:t>
+                      </a:r>
+                      <a:endParaRPr lang="en-US" sz="1300" dirty="0"/>
+                    </a:p>
+                  </a:txBody>
+                  <a:tcPr marL="91440" marR="91440" marT="36576" marB="36576" anchor="ctr">
+                    <a:lnL w="9525" cap="flat" cmpd="sng" algn="ctr">
+                      <a:solidFill>
+                        <a:srgbClr val="D5DAE3"/>
+                      </a:solidFill>
+                      <a:prstDash val="solid"/>
+                      <a:round/>
+                      <a:headEnd type="none" w="med" len="med"/>
+                      <a:tailEnd type="none" w="med" len="med"/>
+                    </a:lnL>
+                    <a:lnR w="9525" cap="flat" cmpd="sng" algn="ctr">
+                      <a:solidFill>
+                        <a:srgbClr val="D5DAE3"/>
+                      </a:solidFill>
+                      <a:prstDash val="solid"/>
+                      <a:round/>
+                      <a:headEnd type="none" w="med" len="med"/>
+                      <a:tailEnd type="none" w="med" len="med"/>
+                    </a:lnR>
+                    <a:lnT w="9525" cap="flat" cmpd="sng" algn="ctr">
+                      <a:solidFill>
+                        <a:srgbClr val="D5DAE3"/>
+                      </a:solidFill>
+                      <a:prstDash val="solid"/>
+                      <a:round/>
+                      <a:headEnd type="none" w="med" len="med"/>
+                      <a:tailEnd type="none" w="med" len="med"/>
+                    </a:lnT>
+                    <a:lnB w="9525" cap="flat" cmpd="sng" algn="ctr">
+                      <a:solidFill>
+                        <a:srgbClr val="D5DAE3"/>
+                      </a:solidFill>
+                      <a:prstDash val="solid"/>
+                      <a:round/>
+                      <a:headEnd type="none" w="med" len="med"/>
+                      <a:tailEnd type="none" w="med" len="med"/>
+                    </a:lnB>
+                  </a:tcPr>
+                </a:tc>
+                <a:tc>
+                  <a:txBody>
+                    <a:bodyPr/>
+                    <a:lstStyle/>
+                    <a:p>
+                      <a:pPr indent="0" marL="0">
+                        <a:buNone/>
+                      </a:pPr>
+                      <a:r>
+                        <a:rPr lang="en-US" sz="1300" dirty="0">
+                          <a:solidFill>
+                            <a:schemeClr val="tx2"/>
+                          </a:solidFill>
+                        </a:rPr>
+                        <a:t>$156,546</a:t>
+                      </a:r>
+                      <a:endParaRPr lang="en-US" sz="1300" dirty="0"/>
+                    </a:p>
+                  </a:txBody>
+                  <a:tcPr marL="91440" marR="91440" marT="36576" marB="36576" anchor="ctr">
+                    <a:lnL w="9525" cap="flat" cmpd="sng" algn="ctr">
+                      <a:solidFill>
+                        <a:srgbClr val="D5DAE3"/>
+                      </a:solidFill>
+                      <a:prstDash val="solid"/>
+                      <a:round/>
+                      <a:headEnd type="none" w="med" len="med"/>
+                      <a:tailEnd type="none" w="med" len="med"/>
+                    </a:lnL>
+                    <a:lnR w="9525" cap="flat" cmpd="sng" algn="ctr">
+                      <a:solidFill>
+                        <a:srgbClr val="D5DAE3"/>
+                      </a:solidFill>
+                      <a:prstDash val="solid"/>
+                      <a:round/>
+                      <a:headEnd type="none" w="med" len="med"/>
+                      <a:tailEnd type="none" w="med" len="med"/>
+                    </a:lnR>
+                    <a:lnT w="9525" cap="flat" cmpd="sng" algn="ctr">
+                      <a:solidFill>
+                        <a:srgbClr val="D5DAE3"/>
+                      </a:solidFill>
+                      <a:prstDash val="solid"/>
+                      <a:round/>
+                      <a:headEnd type="none" w="med" len="med"/>
+                      <a:tailEnd type="none" w="med" len="med"/>
+                    </a:lnT>
+                    <a:lnB w="9525" cap="flat" cmpd="sng" algn="ctr">
+                      <a:solidFill>
+                        <a:srgbClr val="D5DAE3"/>
+                      </a:solidFill>
+                      <a:prstDash val="solid"/>
+                      <a:round/>
+                      <a:headEnd type="none" w="med" len="med"/>
+                      <a:tailEnd type="none" w="med" len="med"/>
+                    </a:lnB>
+                  </a:tcPr>
+                </a:tc>
+                <a:tc>
+                  <a:txBody>
+                    <a:bodyPr/>
+                    <a:lstStyle/>
+                    <a:p>
+                      <a:pPr indent="0" marL="0">
+                        <a:buNone/>
+                      </a:pPr>
+                      <a:r>
+                        <a:rPr lang="en-US" sz="1300" dirty="0">
+                          <a:solidFill>
+                            <a:schemeClr val="tx2"/>
+                          </a:solidFill>
+                        </a:rPr>
+                        <a:t>-10.0%</a:t>
+                      </a:r>
+                      <a:endParaRPr lang="en-US" sz="1300" dirty="0"/>
+                    </a:p>
+                  </a:txBody>
+                  <a:tcPr marL="91440" marR="91440" marT="36576" marB="36576" anchor="ctr">
+                    <a:lnL w="9525" cap="flat" cmpd="sng" algn="ctr">
+                      <a:solidFill>
+                        <a:srgbClr val="D5DAE3"/>
+                      </a:solidFill>
+                      <a:prstDash val="solid"/>
+                      <a:round/>
+                      <a:headEnd type="none" w="med" len="med"/>
+                      <a:tailEnd type="none" w="med" len="med"/>
+                    </a:lnL>
+                    <a:lnR w="9525" cap="flat" cmpd="sng" algn="ctr">
+                      <a:solidFill>
+                        <a:srgbClr val="D5DAE3"/>
+                      </a:solidFill>
+                      <a:prstDash val="solid"/>
+                      <a:round/>
+                      <a:headEnd type="none" w="med" len="med"/>
+                      <a:tailEnd type="none" w="med" len="med"/>
+                    </a:lnR>
+                    <a:lnT w="9525" cap="flat" cmpd="sng" algn="ctr">
+                      <a:solidFill>
+                        <a:srgbClr val="D5DAE3"/>
+                      </a:solidFill>
+                      <a:prstDash val="solid"/>
+                      <a:round/>
+                      <a:headEnd type="none" w="med" len="med"/>
+                      <a:tailEnd type="none" w="med" len="med"/>
+                    </a:lnT>
+                    <a:lnB w="9525" cap="flat" cmpd="sng" algn="ctr">
+                      <a:solidFill>
+                        <a:srgbClr val="D5DAE3"/>
+                      </a:solidFill>
+                      <a:prstDash val="solid"/>
+                      <a:round/>
+                      <a:headEnd type="none" w="med" len="med"/>
+                      <a:tailEnd type="none" w="med" len="med"/>
+                    </a:lnB>
+                  </a:tcPr>
+                </a:tc>
+                <a:tc>
+                  <a:txBody>
+                    <a:bodyPr/>
+                    <a:lstStyle/>
+                    <a:p>
+                      <a:pPr indent="0" marL="0">
+                        <a:buNone/>
+                      </a:pPr>
+                      <a:r>
+                        <a:rPr lang="en-US" sz="1300" dirty="0">
+                          <a:solidFill>
+                            <a:schemeClr val="tx2"/>
+                          </a:solidFill>
+                        </a:rPr>
+                        <a:t>$444,365</a:t>
+                      </a:r>
+                      <a:endParaRPr lang="en-US" sz="1300" dirty="0"/>
+                    </a:p>
+                  </a:txBody>
+                  <a:tcPr marL="91440" marR="91440" marT="36576" marB="36576" anchor="ctr">
+                    <a:lnL w="9525" cap="flat" cmpd="sng" algn="ctr">
+                      <a:solidFill>
+                        <a:srgbClr val="D5DAE3"/>
+                      </a:solidFill>
+                      <a:prstDash val="solid"/>
+                      <a:round/>
+                      <a:headEnd type="none" w="med" len="med"/>
+                      <a:tailEnd type="none" w="med" len="med"/>
+                    </a:lnL>
+                    <a:lnR w="9525" cap="flat" cmpd="sng" algn="ctr">
+                      <a:solidFill>
+                        <a:srgbClr val="D5DAE3"/>
+                      </a:solidFill>
+                      <a:prstDash val="solid"/>
+                      <a:round/>
+                      <a:headEnd type="none" w="med" len="med"/>
+                      <a:tailEnd type="none" w="med" len="med"/>
+                    </a:lnR>
+                    <a:lnT w="9525" cap="flat" cmpd="sng" algn="ctr">
+                      <a:solidFill>
+                        <a:srgbClr val="D5DAE3"/>
+                      </a:solidFill>
+                      <a:prstDash val="solid"/>
+                      <a:round/>
+                      <a:headEnd type="none" w="med" len="med"/>
+                      <a:tailEnd type="none" w="med" len="med"/>
+                    </a:lnT>
+                    <a:lnB w="9525" cap="flat" cmpd="sng" algn="ctr">
+                      <a:solidFill>
+                        <a:srgbClr val="D5DAE3"/>
+                      </a:solidFill>
+                      <a:prstDash val="solid"/>
+                      <a:round/>
+                      <a:headEnd type="none" w="med" len="med"/>
+                      <a:tailEnd type="none" w="med" len="med"/>
+                    </a:lnB>
+                  </a:tcPr>
+                </a:tc>
+              </a:tr>
+              <a:tr h="365760">
                 <a:tc>
                   <a:txBody>
                     <a:bodyPr/>
@@ -22688,7 +22980,7 @@
                   </a:tcPr>
                 </a:tc>
               </a:tr>
-              <a:tr h="411480">
+              <a:tr h="365760">
                 <a:tc>
                   <a:txBody>
                     <a:bodyPr/>
@@ -22980,7 +23272,7 @@
                   </a:tcPr>
                 </a:tc>
               </a:tr>
-              <a:tr h="411480">
+              <a:tr h="365760">
                 <a:tc>
                   <a:txBody>
                     <a:bodyPr/>
@@ -35388,7 +35680,7 @@
                   <a:schemeClr val="tx2"/>
                 </a:solidFill>
               </a:rPr>
-              <a:t>51 automated tests: features, labels, splits and every refit are checked for use of future data.</a:t>
+              <a:t>54 automated tests: features, labels, splits and every refit are checked for use of future data.</a:t>
             </a:r>
             <a:endParaRPr lang="en-US" sz="1400" dirty="0"/>
           </a:p>
@@ -38308,7 +38600,7 @@
                   <a:schemeClr val="tx2"/>
                 </a:solidFill>
               </a:rPr>
-              <a:t>periods never overlap (5–6 day buffer at each boundary, also inside cross-validation); scaling and resampling fit on training folds only; selection rules written down before results; 51 automated tests check for any use of future data.</a:t>
+              <a:t>periods never overlap (5–6 day buffer at each boundary, also inside cross-validation); scaling and resampling fit on training folds only; selection rules written down before results; 54 automated tests check for any use of future data.</a:t>
             </a:r>
             <a:endParaRPr lang="en-US" sz="1300" dirty="0"/>
           </a:p>

</xml_diff>